<commit_message>
Presentation: trend slide adds post-silicon final verification and co-opt quality message; neutral grey chart backgrounds; script updated
Co-Authored-By: Claude Fable 5.1 <noreply@anthropic.com>
Claude-Session: https://claude.ai/code/session_01Gd73gUzQvBcmrEGA3YWYHu
</commit_message>
<xml_diff>
--- a/docs/presentation/deck_basic_fonts.pptx
+++ b/docs/presentation/deck_basic_fonts.pptx
@@ -2559,11 +2559,11 @@
             </a:avLst>
           </a:prstGeom>
           <a:solidFill>
-            <a:srgbClr val="F7F6F1"/>
+            <a:srgbClr val="F2F4F7"/>
           </a:solidFill>
           <a:ln w="12700">
             <a:solidFill>
-              <a:srgbClr val="DDD9CC"/>
+              <a:srgbClr val="D9DEE6"/>
             </a:solidFill>
             <a:prstDash val="solid"/>
           </a:ln>
@@ -2586,7 +2586,7 @@
           <a:noFill/>
           <a:ln w="25400">
             <a:solidFill>
-              <a:srgbClr val="B8B4A8"/>
+              <a:srgbClr val="B3B9C4"/>
             </a:solidFill>
             <a:prstDash val="solid"/>
           </a:ln>
@@ -2609,7 +2609,7 @@
           <a:noFill/>
           <a:ln w="25400">
             <a:solidFill>
-              <a:srgbClr val="B8B4A8"/>
+              <a:srgbClr val="B3B9C4"/>
             </a:solidFill>
             <a:prstDash val="solid"/>
           </a:ln>
@@ -2632,7 +2632,7 @@
           <a:noFill/>
           <a:ln w="25400">
             <a:solidFill>
-              <a:srgbClr val="CFCBBF"/>
+              <a:srgbClr val="CBD2DC"/>
             </a:solidFill>
             <a:prstDash val="dash"/>
           </a:ln>
@@ -2655,7 +2655,7 @@
           <a:noFill/>
           <a:ln w="25400">
             <a:solidFill>
-              <a:srgbClr val="CFCBBF"/>
+              <a:srgbClr val="CBD2DC"/>
             </a:solidFill>
             <a:prstDash val="dash"/>
           </a:ln>
@@ -2678,7 +2678,7 @@
           <a:noFill/>
           <a:ln w="25400">
             <a:solidFill>
-              <a:srgbClr val="CFCBBF"/>
+              <a:srgbClr val="CBD2DC"/>
             </a:solidFill>
             <a:prstDash val="dash"/>
           </a:ln>
@@ -3320,7 +3320,7 @@
                   <a:tcPr marL="127000" marR="127000" marT="76200" marB="76200" anchor="ctr">
                     <a:lnL w="9525" cap="flat" cmpd="sng" algn="ctr">
                       <a:solidFill>
-                        <a:srgbClr val="DDD9CC"/>
+                        <a:srgbClr val="D9DEE6"/>
                       </a:solidFill>
                       <a:prstDash val="solid"/>
                       <a:round/>
@@ -3329,7 +3329,7 @@
                     </a:lnL>
                     <a:lnR w="9525" cap="flat" cmpd="sng" algn="ctr">
                       <a:solidFill>
-                        <a:srgbClr val="DDD9CC"/>
+                        <a:srgbClr val="D9DEE6"/>
                       </a:solidFill>
                       <a:prstDash val="solid"/>
                       <a:round/>
@@ -3338,7 +3338,7 @@
                     </a:lnR>
                     <a:lnT w="9525" cap="flat" cmpd="sng" algn="ctr">
                       <a:solidFill>
-                        <a:srgbClr val="DDD9CC"/>
+                        <a:srgbClr val="D9DEE6"/>
                       </a:solidFill>
                       <a:prstDash val="solid"/>
                       <a:round/>
@@ -3347,7 +3347,7 @@
                     </a:lnT>
                     <a:lnB w="9525" cap="flat" cmpd="sng" algn="ctr">
                       <a:solidFill>
-                        <a:srgbClr val="DDD9CC"/>
+                        <a:srgbClr val="D9DEE6"/>
                       </a:solidFill>
                       <a:prstDash val="solid"/>
                       <a:round/>
@@ -3388,7 +3388,7 @@
                   <a:tcPr marL="127000" marR="127000" marT="76200" marB="76200" anchor="ctr">
                     <a:lnL w="9525" cap="flat" cmpd="sng" algn="ctr">
                       <a:solidFill>
-                        <a:srgbClr val="DDD9CC"/>
+                        <a:srgbClr val="D9DEE6"/>
                       </a:solidFill>
                       <a:prstDash val="solid"/>
                       <a:round/>
@@ -3397,7 +3397,7 @@
                     </a:lnL>
                     <a:lnR w="9525" cap="flat" cmpd="sng" algn="ctr">
                       <a:solidFill>
-                        <a:srgbClr val="DDD9CC"/>
+                        <a:srgbClr val="D9DEE6"/>
                       </a:solidFill>
                       <a:prstDash val="solid"/>
                       <a:round/>
@@ -3406,7 +3406,7 @@
                     </a:lnR>
                     <a:lnT w="9525" cap="flat" cmpd="sng" algn="ctr">
                       <a:solidFill>
-                        <a:srgbClr val="DDD9CC"/>
+                        <a:srgbClr val="D9DEE6"/>
                       </a:solidFill>
                       <a:prstDash val="solid"/>
                       <a:round/>
@@ -3415,7 +3415,7 @@
                     </a:lnT>
                     <a:lnB w="9525" cap="flat" cmpd="sng" algn="ctr">
                       <a:solidFill>
-                        <a:srgbClr val="DDD9CC"/>
+                        <a:srgbClr val="D9DEE6"/>
                       </a:solidFill>
                       <a:prstDash val="solid"/>
                       <a:round/>
@@ -3456,7 +3456,7 @@
                   <a:tcPr marL="127000" marR="127000" marT="76200" marB="76200" anchor="ctr">
                     <a:lnL w="9525" cap="flat" cmpd="sng" algn="ctr">
                       <a:solidFill>
-                        <a:srgbClr val="DDD9CC"/>
+                        <a:srgbClr val="D9DEE6"/>
                       </a:solidFill>
                       <a:prstDash val="solid"/>
                       <a:round/>
@@ -3465,7 +3465,7 @@
                     </a:lnL>
                     <a:lnR w="9525" cap="flat" cmpd="sng" algn="ctr">
                       <a:solidFill>
-                        <a:srgbClr val="DDD9CC"/>
+                        <a:srgbClr val="D9DEE6"/>
                       </a:solidFill>
                       <a:prstDash val="solid"/>
                       <a:round/>
@@ -3474,7 +3474,7 @@
                     </a:lnR>
                     <a:lnT w="9525" cap="flat" cmpd="sng" algn="ctr">
                       <a:solidFill>
-                        <a:srgbClr val="DDD9CC"/>
+                        <a:srgbClr val="D9DEE6"/>
                       </a:solidFill>
                       <a:prstDash val="solid"/>
                       <a:round/>
@@ -3483,7 +3483,7 @@
                     </a:lnT>
                     <a:lnB w="9525" cap="flat" cmpd="sng" algn="ctr">
                       <a:solidFill>
-                        <a:srgbClr val="DDD9CC"/>
+                        <a:srgbClr val="D9DEE6"/>
                       </a:solidFill>
                       <a:prstDash val="solid"/>
                       <a:round/>
@@ -3524,7 +3524,7 @@
                   <a:tcPr marL="127000" marR="127000" marT="76200" marB="76200" anchor="ctr">
                     <a:lnL w="9525" cap="flat" cmpd="sng" algn="ctr">
                       <a:solidFill>
-                        <a:srgbClr val="DDD9CC"/>
+                        <a:srgbClr val="D9DEE6"/>
                       </a:solidFill>
                       <a:prstDash val="solid"/>
                       <a:round/>
@@ -3533,7 +3533,7 @@
                     </a:lnL>
                     <a:lnR w="9525" cap="flat" cmpd="sng" algn="ctr">
                       <a:solidFill>
-                        <a:srgbClr val="DDD9CC"/>
+                        <a:srgbClr val="D9DEE6"/>
                       </a:solidFill>
                       <a:prstDash val="solid"/>
                       <a:round/>
@@ -3542,7 +3542,7 @@
                     </a:lnR>
                     <a:lnT w="9525" cap="flat" cmpd="sng" algn="ctr">
                       <a:solidFill>
-                        <a:srgbClr val="DDD9CC"/>
+                        <a:srgbClr val="D9DEE6"/>
                       </a:solidFill>
                       <a:prstDash val="solid"/>
                       <a:round/>
@@ -3551,7 +3551,7 @@
                     </a:lnT>
                     <a:lnB w="9525" cap="flat" cmpd="sng" algn="ctr">
                       <a:solidFill>
-                        <a:srgbClr val="DDD9CC"/>
+                        <a:srgbClr val="D9DEE6"/>
                       </a:solidFill>
                       <a:prstDash val="solid"/>
                       <a:round/>
@@ -3594,7 +3594,7 @@
                   <a:tcPr marL="127000" marR="127000" marT="76200" marB="76200" anchor="ctr">
                     <a:lnL w="9525" cap="flat" cmpd="sng" algn="ctr">
                       <a:solidFill>
-                        <a:srgbClr val="DDD9CC"/>
+                        <a:srgbClr val="D9DEE6"/>
                       </a:solidFill>
                       <a:prstDash val="solid"/>
                       <a:round/>
@@ -3603,7 +3603,7 @@
                     </a:lnL>
                     <a:lnR w="9525" cap="flat" cmpd="sng" algn="ctr">
                       <a:solidFill>
-                        <a:srgbClr val="DDD9CC"/>
+                        <a:srgbClr val="D9DEE6"/>
                       </a:solidFill>
                       <a:prstDash val="solid"/>
                       <a:round/>
@@ -3612,7 +3612,7 @@
                     </a:lnR>
                     <a:lnT w="9525" cap="flat" cmpd="sng" algn="ctr">
                       <a:solidFill>
-                        <a:srgbClr val="DDD9CC"/>
+                        <a:srgbClr val="D9DEE6"/>
                       </a:solidFill>
                       <a:prstDash val="solid"/>
                       <a:round/>
@@ -3621,7 +3621,7 @@
                     </a:lnT>
                     <a:lnB w="9525" cap="flat" cmpd="sng" algn="ctr">
                       <a:solidFill>
-                        <a:srgbClr val="DDD9CC"/>
+                        <a:srgbClr val="D9DEE6"/>
                       </a:solidFill>
                       <a:prstDash val="solid"/>
                       <a:round/>
@@ -3662,7 +3662,7 @@
                   <a:tcPr marL="127000" marR="127000" marT="76200" marB="76200" anchor="ctr">
                     <a:lnL w="9525" cap="flat" cmpd="sng" algn="ctr">
                       <a:solidFill>
-                        <a:srgbClr val="DDD9CC"/>
+                        <a:srgbClr val="D9DEE6"/>
                       </a:solidFill>
                       <a:prstDash val="solid"/>
                       <a:round/>
@@ -3671,7 +3671,7 @@
                     </a:lnL>
                     <a:lnR w="9525" cap="flat" cmpd="sng" algn="ctr">
                       <a:solidFill>
-                        <a:srgbClr val="DDD9CC"/>
+                        <a:srgbClr val="D9DEE6"/>
                       </a:solidFill>
                       <a:prstDash val="solid"/>
                       <a:round/>
@@ -3680,7 +3680,7 @@
                     </a:lnR>
                     <a:lnT w="9525" cap="flat" cmpd="sng" algn="ctr">
                       <a:solidFill>
-                        <a:srgbClr val="DDD9CC"/>
+                        <a:srgbClr val="D9DEE6"/>
                       </a:solidFill>
                       <a:prstDash val="solid"/>
                       <a:round/>
@@ -3689,7 +3689,7 @@
                     </a:lnT>
                     <a:lnB w="9525" cap="flat" cmpd="sng" algn="ctr">
                       <a:solidFill>
-                        <a:srgbClr val="DDD9CC"/>
+                        <a:srgbClr val="D9DEE6"/>
                       </a:solidFill>
                       <a:prstDash val="solid"/>
                       <a:round/>
@@ -3730,7 +3730,7 @@
                   <a:tcPr marL="127000" marR="127000" marT="76200" marB="76200" anchor="ctr">
                     <a:lnL w="9525" cap="flat" cmpd="sng" algn="ctr">
                       <a:solidFill>
-                        <a:srgbClr val="DDD9CC"/>
+                        <a:srgbClr val="D9DEE6"/>
                       </a:solidFill>
                       <a:prstDash val="solid"/>
                       <a:round/>
@@ -3739,7 +3739,7 @@
                     </a:lnL>
                     <a:lnR w="9525" cap="flat" cmpd="sng" algn="ctr">
                       <a:solidFill>
-                        <a:srgbClr val="DDD9CC"/>
+                        <a:srgbClr val="D9DEE6"/>
                       </a:solidFill>
                       <a:prstDash val="solid"/>
                       <a:round/>
@@ -3748,7 +3748,7 @@
                     </a:lnR>
                     <a:lnT w="9525" cap="flat" cmpd="sng" algn="ctr">
                       <a:solidFill>
-                        <a:srgbClr val="DDD9CC"/>
+                        <a:srgbClr val="D9DEE6"/>
                       </a:solidFill>
                       <a:prstDash val="solid"/>
                       <a:round/>
@@ -3757,7 +3757,7 @@
                     </a:lnT>
                     <a:lnB w="9525" cap="flat" cmpd="sng" algn="ctr">
                       <a:solidFill>
-                        <a:srgbClr val="DDD9CC"/>
+                        <a:srgbClr val="D9DEE6"/>
                       </a:solidFill>
                       <a:prstDash val="solid"/>
                       <a:round/>
@@ -3798,7 +3798,7 @@
                   <a:tcPr marL="127000" marR="127000" marT="76200" marB="76200" anchor="ctr">
                     <a:lnL w="9525" cap="flat" cmpd="sng" algn="ctr">
                       <a:solidFill>
-                        <a:srgbClr val="DDD9CC"/>
+                        <a:srgbClr val="D9DEE6"/>
                       </a:solidFill>
                       <a:prstDash val="solid"/>
                       <a:round/>
@@ -3807,7 +3807,7 @@
                     </a:lnL>
                     <a:lnR w="9525" cap="flat" cmpd="sng" algn="ctr">
                       <a:solidFill>
-                        <a:srgbClr val="DDD9CC"/>
+                        <a:srgbClr val="D9DEE6"/>
                       </a:solidFill>
                       <a:prstDash val="solid"/>
                       <a:round/>
@@ -3816,7 +3816,7 @@
                     </a:lnR>
                     <a:lnT w="9525" cap="flat" cmpd="sng" algn="ctr">
                       <a:solidFill>
-                        <a:srgbClr val="DDD9CC"/>
+                        <a:srgbClr val="D9DEE6"/>
                       </a:solidFill>
                       <a:prstDash val="solid"/>
                       <a:round/>
@@ -3825,7 +3825,7 @@
                     </a:lnT>
                     <a:lnB w="9525" cap="flat" cmpd="sng" algn="ctr">
                       <a:solidFill>
-                        <a:srgbClr val="DDD9CC"/>
+                        <a:srgbClr val="D9DEE6"/>
                       </a:solidFill>
                       <a:prstDash val="solid"/>
                       <a:round/>
@@ -3868,7 +3868,7 @@
                   <a:tcPr marL="127000" marR="127000" marT="76200" marB="76200" anchor="ctr">
                     <a:lnL w="9525" cap="flat" cmpd="sng" algn="ctr">
                       <a:solidFill>
-                        <a:srgbClr val="DDD9CC"/>
+                        <a:srgbClr val="D9DEE6"/>
                       </a:solidFill>
                       <a:prstDash val="solid"/>
                       <a:round/>
@@ -3877,7 +3877,7 @@
                     </a:lnL>
                     <a:lnR w="9525" cap="flat" cmpd="sng" algn="ctr">
                       <a:solidFill>
-                        <a:srgbClr val="DDD9CC"/>
+                        <a:srgbClr val="D9DEE6"/>
                       </a:solidFill>
                       <a:prstDash val="solid"/>
                       <a:round/>
@@ -3886,7 +3886,7 @@
                     </a:lnR>
                     <a:lnT w="9525" cap="flat" cmpd="sng" algn="ctr">
                       <a:solidFill>
-                        <a:srgbClr val="DDD9CC"/>
+                        <a:srgbClr val="D9DEE6"/>
                       </a:solidFill>
                       <a:prstDash val="solid"/>
                       <a:round/>
@@ -3895,7 +3895,7 @@
                     </a:lnT>
                     <a:lnB w="9525" cap="flat" cmpd="sng" algn="ctr">
                       <a:solidFill>
-                        <a:srgbClr val="DDD9CC"/>
+                        <a:srgbClr val="D9DEE6"/>
                       </a:solidFill>
                       <a:prstDash val="solid"/>
                       <a:round/>
@@ -3903,7 +3903,7 @@
                       <a:tailEnd type="none" w="med" len="med"/>
                     </a:lnB>
                     <a:solidFill>
-                      <a:srgbClr val="F7F6F1"/>
+                      <a:srgbClr val="F2F4F7"/>
                     </a:solidFill>
                   </a:tcPr>
                 </a:tc>
@@ -3936,7 +3936,7 @@
                   <a:tcPr marL="127000" marR="127000" marT="76200" marB="76200" anchor="ctr">
                     <a:lnL w="9525" cap="flat" cmpd="sng" algn="ctr">
                       <a:solidFill>
-                        <a:srgbClr val="DDD9CC"/>
+                        <a:srgbClr val="D9DEE6"/>
                       </a:solidFill>
                       <a:prstDash val="solid"/>
                       <a:round/>
@@ -3945,7 +3945,7 @@
                     </a:lnL>
                     <a:lnR w="9525" cap="flat" cmpd="sng" algn="ctr">
                       <a:solidFill>
-                        <a:srgbClr val="DDD9CC"/>
+                        <a:srgbClr val="D9DEE6"/>
                       </a:solidFill>
                       <a:prstDash val="solid"/>
                       <a:round/>
@@ -3954,7 +3954,7 @@
                     </a:lnR>
                     <a:lnT w="9525" cap="flat" cmpd="sng" algn="ctr">
                       <a:solidFill>
-                        <a:srgbClr val="DDD9CC"/>
+                        <a:srgbClr val="D9DEE6"/>
                       </a:solidFill>
                       <a:prstDash val="solid"/>
                       <a:round/>
@@ -3963,7 +3963,7 @@
                     </a:lnT>
                     <a:lnB w="9525" cap="flat" cmpd="sng" algn="ctr">
                       <a:solidFill>
-                        <a:srgbClr val="DDD9CC"/>
+                        <a:srgbClr val="D9DEE6"/>
                       </a:solidFill>
                       <a:prstDash val="solid"/>
                       <a:round/>
@@ -3971,7 +3971,7 @@
                       <a:tailEnd type="none" w="med" len="med"/>
                     </a:lnB>
                     <a:solidFill>
-                      <a:srgbClr val="F7F6F1"/>
+                      <a:srgbClr val="F2F4F7"/>
                     </a:solidFill>
                   </a:tcPr>
                 </a:tc>
@@ -4004,7 +4004,7 @@
                   <a:tcPr marL="127000" marR="127000" marT="76200" marB="76200" anchor="ctr">
                     <a:lnL w="9525" cap="flat" cmpd="sng" algn="ctr">
                       <a:solidFill>
-                        <a:srgbClr val="DDD9CC"/>
+                        <a:srgbClr val="D9DEE6"/>
                       </a:solidFill>
                       <a:prstDash val="solid"/>
                       <a:round/>
@@ -4013,7 +4013,7 @@
                     </a:lnL>
                     <a:lnR w="9525" cap="flat" cmpd="sng" algn="ctr">
                       <a:solidFill>
-                        <a:srgbClr val="DDD9CC"/>
+                        <a:srgbClr val="D9DEE6"/>
                       </a:solidFill>
                       <a:prstDash val="solid"/>
                       <a:round/>
@@ -4022,7 +4022,7 @@
                     </a:lnR>
                     <a:lnT w="9525" cap="flat" cmpd="sng" algn="ctr">
                       <a:solidFill>
-                        <a:srgbClr val="DDD9CC"/>
+                        <a:srgbClr val="D9DEE6"/>
                       </a:solidFill>
                       <a:prstDash val="solid"/>
                       <a:round/>
@@ -4031,7 +4031,7 @@
                     </a:lnT>
                     <a:lnB w="9525" cap="flat" cmpd="sng" algn="ctr">
                       <a:solidFill>
-                        <a:srgbClr val="DDD9CC"/>
+                        <a:srgbClr val="D9DEE6"/>
                       </a:solidFill>
                       <a:prstDash val="solid"/>
                       <a:round/>
@@ -4039,7 +4039,7 @@
                       <a:tailEnd type="none" w="med" len="med"/>
                     </a:lnB>
                     <a:solidFill>
-                      <a:srgbClr val="F7F6F1"/>
+                      <a:srgbClr val="F2F4F7"/>
                     </a:solidFill>
                   </a:tcPr>
                 </a:tc>
@@ -4072,7 +4072,7 @@
                   <a:tcPr marL="127000" marR="127000" marT="76200" marB="76200" anchor="ctr">
                     <a:lnL w="9525" cap="flat" cmpd="sng" algn="ctr">
                       <a:solidFill>
-                        <a:srgbClr val="DDD9CC"/>
+                        <a:srgbClr val="D9DEE6"/>
                       </a:solidFill>
                       <a:prstDash val="solid"/>
                       <a:round/>
@@ -4081,7 +4081,7 @@
                     </a:lnL>
                     <a:lnR w="9525" cap="flat" cmpd="sng" algn="ctr">
                       <a:solidFill>
-                        <a:srgbClr val="DDD9CC"/>
+                        <a:srgbClr val="D9DEE6"/>
                       </a:solidFill>
                       <a:prstDash val="solid"/>
                       <a:round/>
@@ -4090,7 +4090,7 @@
                     </a:lnR>
                     <a:lnT w="9525" cap="flat" cmpd="sng" algn="ctr">
                       <a:solidFill>
-                        <a:srgbClr val="DDD9CC"/>
+                        <a:srgbClr val="D9DEE6"/>
                       </a:solidFill>
                       <a:prstDash val="solid"/>
                       <a:round/>
@@ -4099,7 +4099,7 @@
                     </a:lnT>
                     <a:lnB w="9525" cap="flat" cmpd="sng" algn="ctr">
                       <a:solidFill>
-                        <a:srgbClr val="DDD9CC"/>
+                        <a:srgbClr val="D9DEE6"/>
                       </a:solidFill>
                       <a:prstDash val="solid"/>
                       <a:round/>
@@ -4107,7 +4107,7 @@
                       <a:tailEnd type="none" w="med" len="med"/>
                     </a:lnB>
                     <a:solidFill>
-                      <a:srgbClr val="F7F6F1"/>
+                      <a:srgbClr val="F2F4F7"/>
                     </a:solidFill>
                   </a:tcPr>
                 </a:tc>
@@ -4142,7 +4142,7 @@
                   <a:tcPr marL="127000" marR="127000" marT="76200" marB="76200" anchor="ctr">
                     <a:lnL w="9525" cap="flat" cmpd="sng" algn="ctr">
                       <a:solidFill>
-                        <a:srgbClr val="DDD9CC"/>
+                        <a:srgbClr val="D9DEE6"/>
                       </a:solidFill>
                       <a:prstDash val="solid"/>
                       <a:round/>
@@ -4151,7 +4151,7 @@
                     </a:lnL>
                     <a:lnR w="9525" cap="flat" cmpd="sng" algn="ctr">
                       <a:solidFill>
-                        <a:srgbClr val="DDD9CC"/>
+                        <a:srgbClr val="D9DEE6"/>
                       </a:solidFill>
                       <a:prstDash val="solid"/>
                       <a:round/>
@@ -4160,7 +4160,7 @@
                     </a:lnR>
                     <a:lnT w="9525" cap="flat" cmpd="sng" algn="ctr">
                       <a:solidFill>
-                        <a:srgbClr val="DDD9CC"/>
+                        <a:srgbClr val="D9DEE6"/>
                       </a:solidFill>
                       <a:prstDash val="solid"/>
                       <a:round/>
@@ -4169,7 +4169,7 @@
                     </a:lnT>
                     <a:lnB w="9525" cap="flat" cmpd="sng" algn="ctr">
                       <a:solidFill>
-                        <a:srgbClr val="DDD9CC"/>
+                        <a:srgbClr val="D9DEE6"/>
                       </a:solidFill>
                       <a:prstDash val="solid"/>
                       <a:round/>
@@ -4210,7 +4210,7 @@
                   <a:tcPr marL="127000" marR="127000" marT="76200" marB="76200" anchor="ctr">
                     <a:lnL w="9525" cap="flat" cmpd="sng" algn="ctr">
                       <a:solidFill>
-                        <a:srgbClr val="DDD9CC"/>
+                        <a:srgbClr val="D9DEE6"/>
                       </a:solidFill>
                       <a:prstDash val="solid"/>
                       <a:round/>
@@ -4219,7 +4219,7 @@
                     </a:lnL>
                     <a:lnR w="9525" cap="flat" cmpd="sng" algn="ctr">
                       <a:solidFill>
-                        <a:srgbClr val="DDD9CC"/>
+                        <a:srgbClr val="D9DEE6"/>
                       </a:solidFill>
                       <a:prstDash val="solid"/>
                       <a:round/>
@@ -4228,7 +4228,7 @@
                     </a:lnR>
                     <a:lnT w="9525" cap="flat" cmpd="sng" algn="ctr">
                       <a:solidFill>
-                        <a:srgbClr val="DDD9CC"/>
+                        <a:srgbClr val="D9DEE6"/>
                       </a:solidFill>
                       <a:prstDash val="solid"/>
                       <a:round/>
@@ -4237,7 +4237,7 @@
                     </a:lnT>
                     <a:lnB w="9525" cap="flat" cmpd="sng" algn="ctr">
                       <a:solidFill>
-                        <a:srgbClr val="DDD9CC"/>
+                        <a:srgbClr val="D9DEE6"/>
                       </a:solidFill>
                       <a:prstDash val="solid"/>
                       <a:round/>
@@ -4278,7 +4278,7 @@
                   <a:tcPr marL="127000" marR="127000" marT="76200" marB="76200" anchor="ctr">
                     <a:lnL w="9525" cap="flat" cmpd="sng" algn="ctr">
                       <a:solidFill>
-                        <a:srgbClr val="DDD9CC"/>
+                        <a:srgbClr val="D9DEE6"/>
                       </a:solidFill>
                       <a:prstDash val="solid"/>
                       <a:round/>
@@ -4287,7 +4287,7 @@
                     </a:lnL>
                     <a:lnR w="9525" cap="flat" cmpd="sng" algn="ctr">
                       <a:solidFill>
-                        <a:srgbClr val="DDD9CC"/>
+                        <a:srgbClr val="D9DEE6"/>
                       </a:solidFill>
                       <a:prstDash val="solid"/>
                       <a:round/>
@@ -4296,7 +4296,7 @@
                     </a:lnR>
                     <a:lnT w="9525" cap="flat" cmpd="sng" algn="ctr">
                       <a:solidFill>
-                        <a:srgbClr val="DDD9CC"/>
+                        <a:srgbClr val="D9DEE6"/>
                       </a:solidFill>
                       <a:prstDash val="solid"/>
                       <a:round/>
@@ -4305,7 +4305,7 @@
                     </a:lnT>
                     <a:lnB w="9525" cap="flat" cmpd="sng" algn="ctr">
                       <a:solidFill>
-                        <a:srgbClr val="DDD9CC"/>
+                        <a:srgbClr val="D9DEE6"/>
                       </a:solidFill>
                       <a:prstDash val="solid"/>
                       <a:round/>
@@ -4346,7 +4346,7 @@
                   <a:tcPr marL="127000" marR="127000" marT="76200" marB="76200" anchor="ctr">
                     <a:lnL w="9525" cap="flat" cmpd="sng" algn="ctr">
                       <a:solidFill>
-                        <a:srgbClr val="DDD9CC"/>
+                        <a:srgbClr val="D9DEE6"/>
                       </a:solidFill>
                       <a:prstDash val="solid"/>
                       <a:round/>
@@ -4355,7 +4355,7 @@
                     </a:lnL>
                     <a:lnR w="9525" cap="flat" cmpd="sng" algn="ctr">
                       <a:solidFill>
-                        <a:srgbClr val="DDD9CC"/>
+                        <a:srgbClr val="D9DEE6"/>
                       </a:solidFill>
                       <a:prstDash val="solid"/>
                       <a:round/>
@@ -4364,7 +4364,7 @@
                     </a:lnR>
                     <a:lnT w="9525" cap="flat" cmpd="sng" algn="ctr">
                       <a:solidFill>
-                        <a:srgbClr val="DDD9CC"/>
+                        <a:srgbClr val="D9DEE6"/>
                       </a:solidFill>
                       <a:prstDash val="solid"/>
                       <a:round/>
@@ -4373,7 +4373,7 @@
                     </a:lnT>
                     <a:lnB w="9525" cap="flat" cmpd="sng" algn="ctr">
                       <a:solidFill>
-                        <a:srgbClr val="DDD9CC"/>
+                        <a:srgbClr val="D9DEE6"/>
                       </a:solidFill>
                       <a:prstDash val="solid"/>
                       <a:round/>
@@ -4530,11 +4530,11 @@
             </a:avLst>
           </a:prstGeom>
           <a:solidFill>
-            <a:srgbClr val="F7F6F1"/>
+            <a:srgbClr val="F2F4F7"/>
           </a:solidFill>
           <a:ln w="12700">
             <a:solidFill>
-              <a:srgbClr val="DDD9CC"/>
+              <a:srgbClr val="D9DEE6"/>
             </a:solidFill>
             <a:prstDash val="solid"/>
           </a:ln>
@@ -4635,11 +4635,11 @@
             </a:avLst>
           </a:prstGeom>
           <a:solidFill>
-            <a:srgbClr val="F7F6F1"/>
+            <a:srgbClr val="F2F4F7"/>
           </a:solidFill>
           <a:ln w="12700">
             <a:solidFill>
-              <a:srgbClr val="DDD9CC"/>
+              <a:srgbClr val="D9DEE6"/>
             </a:solidFill>
             <a:prstDash val="solid"/>
           </a:ln>
@@ -4740,11 +4740,11 @@
             </a:avLst>
           </a:prstGeom>
           <a:solidFill>
-            <a:srgbClr val="F7F6F1"/>
+            <a:srgbClr val="F2F4F7"/>
           </a:solidFill>
           <a:ln w="12700">
             <a:solidFill>
-              <a:srgbClr val="DDD9CC"/>
+              <a:srgbClr val="D9DEE6"/>
             </a:solidFill>
             <a:prstDash val="solid"/>
           </a:ln>
@@ -5037,11 +5037,11 @@
             </a:avLst>
           </a:prstGeom>
           <a:solidFill>
-            <a:srgbClr val="F7F6F1"/>
+            <a:srgbClr val="F2F4F7"/>
           </a:solidFill>
           <a:ln w="12700">
             <a:solidFill>
-              <a:srgbClr val="DDD9CC"/>
+              <a:srgbClr val="D9DEE6"/>
             </a:solidFill>
             <a:prstDash val="solid"/>
           </a:ln>
@@ -5241,11 +5241,11 @@
             </a:avLst>
           </a:prstGeom>
           <a:solidFill>
-            <a:srgbClr val="F7F6F1"/>
+            <a:srgbClr val="F2F4F7"/>
           </a:solidFill>
           <a:ln w="12700">
             <a:solidFill>
-              <a:srgbClr val="DDD9CC"/>
+              <a:srgbClr val="D9DEE6"/>
             </a:solidFill>
             <a:prstDash val="solid"/>
           </a:ln>
@@ -5445,11 +5445,11 @@
             </a:avLst>
           </a:prstGeom>
           <a:solidFill>
-            <a:srgbClr val="F7F6F1"/>
+            <a:srgbClr val="F2F4F7"/>
           </a:solidFill>
           <a:ln w="12700">
             <a:solidFill>
-              <a:srgbClr val="DDD9CC"/>
+              <a:srgbClr val="D9DEE6"/>
             </a:solidFill>
             <a:prstDash val="solid"/>
           </a:ln>
@@ -5878,7 +5878,7 @@
                   <a:tcPr marL="127000" marR="127000" marT="76200" marB="76200" anchor="ctr">
                     <a:lnL w="9525" cap="flat" cmpd="sng" algn="ctr">
                       <a:solidFill>
-                        <a:srgbClr val="DDD9CC"/>
+                        <a:srgbClr val="D9DEE6"/>
                       </a:solidFill>
                       <a:prstDash val="solid"/>
                       <a:round/>
@@ -5887,7 +5887,7 @@
                     </a:lnL>
                     <a:lnR w="9525" cap="flat" cmpd="sng" algn="ctr">
                       <a:solidFill>
-                        <a:srgbClr val="DDD9CC"/>
+                        <a:srgbClr val="D9DEE6"/>
                       </a:solidFill>
                       <a:prstDash val="solid"/>
                       <a:round/>
@@ -5896,7 +5896,7 @@
                     </a:lnR>
                     <a:lnT w="9525" cap="flat" cmpd="sng" algn="ctr">
                       <a:solidFill>
-                        <a:srgbClr val="DDD9CC"/>
+                        <a:srgbClr val="D9DEE6"/>
                       </a:solidFill>
                       <a:prstDash val="solid"/>
                       <a:round/>
@@ -5905,7 +5905,7 @@
                     </a:lnT>
                     <a:lnB w="9525" cap="flat" cmpd="sng" algn="ctr">
                       <a:solidFill>
-                        <a:srgbClr val="DDD9CC"/>
+                        <a:srgbClr val="D9DEE6"/>
                       </a:solidFill>
                       <a:prstDash val="solid"/>
                       <a:round/>
@@ -5946,7 +5946,7 @@
                   <a:tcPr marL="127000" marR="127000" marT="76200" marB="76200" anchor="ctr">
                     <a:lnL w="9525" cap="flat" cmpd="sng" algn="ctr">
                       <a:solidFill>
-                        <a:srgbClr val="DDD9CC"/>
+                        <a:srgbClr val="D9DEE6"/>
                       </a:solidFill>
                       <a:prstDash val="solid"/>
                       <a:round/>
@@ -5955,7 +5955,7 @@
                     </a:lnL>
                     <a:lnR w="9525" cap="flat" cmpd="sng" algn="ctr">
                       <a:solidFill>
-                        <a:srgbClr val="DDD9CC"/>
+                        <a:srgbClr val="D9DEE6"/>
                       </a:solidFill>
                       <a:prstDash val="solid"/>
                       <a:round/>
@@ -5964,7 +5964,7 @@
                     </a:lnR>
                     <a:lnT w="9525" cap="flat" cmpd="sng" algn="ctr">
                       <a:solidFill>
-                        <a:srgbClr val="DDD9CC"/>
+                        <a:srgbClr val="D9DEE6"/>
                       </a:solidFill>
                       <a:prstDash val="solid"/>
                       <a:round/>
@@ -5973,7 +5973,7 @@
                     </a:lnT>
                     <a:lnB w="9525" cap="flat" cmpd="sng" algn="ctr">
                       <a:solidFill>
-                        <a:srgbClr val="DDD9CC"/>
+                        <a:srgbClr val="D9DEE6"/>
                       </a:solidFill>
                       <a:prstDash val="solid"/>
                       <a:round/>
@@ -6014,7 +6014,7 @@
                   <a:tcPr marL="127000" marR="127000" marT="76200" marB="76200" anchor="ctr">
                     <a:lnL w="9525" cap="flat" cmpd="sng" algn="ctr">
                       <a:solidFill>
-                        <a:srgbClr val="DDD9CC"/>
+                        <a:srgbClr val="D9DEE6"/>
                       </a:solidFill>
                       <a:prstDash val="solid"/>
                       <a:round/>
@@ -6023,7 +6023,7 @@
                     </a:lnL>
                     <a:lnR w="9525" cap="flat" cmpd="sng" algn="ctr">
                       <a:solidFill>
-                        <a:srgbClr val="DDD9CC"/>
+                        <a:srgbClr val="D9DEE6"/>
                       </a:solidFill>
                       <a:prstDash val="solid"/>
                       <a:round/>
@@ -6032,7 +6032,7 @@
                     </a:lnR>
                     <a:lnT w="9525" cap="flat" cmpd="sng" algn="ctr">
                       <a:solidFill>
-                        <a:srgbClr val="DDD9CC"/>
+                        <a:srgbClr val="D9DEE6"/>
                       </a:solidFill>
                       <a:prstDash val="solid"/>
                       <a:round/>
@@ -6041,7 +6041,7 @@
                     </a:lnT>
                     <a:lnB w="9525" cap="flat" cmpd="sng" algn="ctr">
                       <a:solidFill>
-                        <a:srgbClr val="DDD9CC"/>
+                        <a:srgbClr val="D9DEE6"/>
                       </a:solidFill>
                       <a:prstDash val="solid"/>
                       <a:round/>
@@ -6082,7 +6082,7 @@
                   <a:tcPr marL="127000" marR="127000" marT="76200" marB="76200" anchor="ctr">
                     <a:lnL w="9525" cap="flat" cmpd="sng" algn="ctr">
                       <a:solidFill>
-                        <a:srgbClr val="DDD9CC"/>
+                        <a:srgbClr val="D9DEE6"/>
                       </a:solidFill>
                       <a:prstDash val="solid"/>
                       <a:round/>
@@ -6091,7 +6091,7 @@
                     </a:lnL>
                     <a:lnR w="9525" cap="flat" cmpd="sng" algn="ctr">
                       <a:solidFill>
-                        <a:srgbClr val="DDD9CC"/>
+                        <a:srgbClr val="D9DEE6"/>
                       </a:solidFill>
                       <a:prstDash val="solid"/>
                       <a:round/>
@@ -6100,7 +6100,7 @@
                     </a:lnR>
                     <a:lnT w="9525" cap="flat" cmpd="sng" algn="ctr">
                       <a:solidFill>
-                        <a:srgbClr val="DDD9CC"/>
+                        <a:srgbClr val="D9DEE6"/>
                       </a:solidFill>
                       <a:prstDash val="solid"/>
                       <a:round/>
@@ -6109,7 +6109,7 @@
                     </a:lnT>
                     <a:lnB w="9525" cap="flat" cmpd="sng" algn="ctr">
                       <a:solidFill>
-                        <a:srgbClr val="DDD9CC"/>
+                        <a:srgbClr val="D9DEE6"/>
                       </a:solidFill>
                       <a:prstDash val="solid"/>
                       <a:round/>
@@ -6150,7 +6150,7 @@
                   <a:tcPr marL="127000" marR="127000" marT="76200" marB="76200" anchor="ctr">
                     <a:lnL w="9525" cap="flat" cmpd="sng" algn="ctr">
                       <a:solidFill>
-                        <a:srgbClr val="DDD9CC"/>
+                        <a:srgbClr val="D9DEE6"/>
                       </a:solidFill>
                       <a:prstDash val="solid"/>
                       <a:round/>
@@ -6159,7 +6159,7 @@
                     </a:lnL>
                     <a:lnR w="9525" cap="flat" cmpd="sng" algn="ctr">
                       <a:solidFill>
-                        <a:srgbClr val="DDD9CC"/>
+                        <a:srgbClr val="D9DEE6"/>
                       </a:solidFill>
                       <a:prstDash val="solid"/>
                       <a:round/>
@@ -6168,7 +6168,7 @@
                     </a:lnR>
                     <a:lnT w="9525" cap="flat" cmpd="sng" algn="ctr">
                       <a:solidFill>
-                        <a:srgbClr val="DDD9CC"/>
+                        <a:srgbClr val="D9DEE6"/>
                       </a:solidFill>
                       <a:prstDash val="solid"/>
                       <a:round/>
@@ -6177,7 +6177,7 @@
                     </a:lnT>
                     <a:lnB w="9525" cap="flat" cmpd="sng" algn="ctr">
                       <a:solidFill>
-                        <a:srgbClr val="DDD9CC"/>
+                        <a:srgbClr val="D9DEE6"/>
                       </a:solidFill>
                       <a:prstDash val="solid"/>
                       <a:round/>
@@ -6220,7 +6220,7 @@
                   <a:tcPr marL="127000" marR="127000" marT="76200" marB="76200" anchor="ctr">
                     <a:lnL w="9525" cap="flat" cmpd="sng" algn="ctr">
                       <a:solidFill>
-                        <a:srgbClr val="DDD9CC"/>
+                        <a:srgbClr val="D9DEE6"/>
                       </a:solidFill>
                       <a:prstDash val="solid"/>
                       <a:round/>
@@ -6229,7 +6229,7 @@
                     </a:lnL>
                     <a:lnR w="9525" cap="flat" cmpd="sng" algn="ctr">
                       <a:solidFill>
-                        <a:srgbClr val="DDD9CC"/>
+                        <a:srgbClr val="D9DEE6"/>
                       </a:solidFill>
                       <a:prstDash val="solid"/>
                       <a:round/>
@@ -6238,7 +6238,7 @@
                     </a:lnR>
                     <a:lnT w="9525" cap="flat" cmpd="sng" algn="ctr">
                       <a:solidFill>
-                        <a:srgbClr val="DDD9CC"/>
+                        <a:srgbClr val="D9DEE6"/>
                       </a:solidFill>
                       <a:prstDash val="solid"/>
                       <a:round/>
@@ -6247,7 +6247,7 @@
                     </a:lnT>
                     <a:lnB w="9525" cap="flat" cmpd="sng" algn="ctr">
                       <a:solidFill>
-                        <a:srgbClr val="DDD9CC"/>
+                        <a:srgbClr val="D9DEE6"/>
                       </a:solidFill>
                       <a:prstDash val="solid"/>
                       <a:round/>
@@ -6288,7 +6288,7 @@
                   <a:tcPr marL="127000" marR="127000" marT="76200" marB="76200" anchor="ctr">
                     <a:lnL w="9525" cap="flat" cmpd="sng" algn="ctr">
                       <a:solidFill>
-                        <a:srgbClr val="DDD9CC"/>
+                        <a:srgbClr val="D9DEE6"/>
                       </a:solidFill>
                       <a:prstDash val="solid"/>
                       <a:round/>
@@ -6297,7 +6297,7 @@
                     </a:lnL>
                     <a:lnR w="9525" cap="flat" cmpd="sng" algn="ctr">
                       <a:solidFill>
-                        <a:srgbClr val="DDD9CC"/>
+                        <a:srgbClr val="D9DEE6"/>
                       </a:solidFill>
                       <a:prstDash val="solid"/>
                       <a:round/>
@@ -6306,7 +6306,7 @@
                     </a:lnR>
                     <a:lnT w="9525" cap="flat" cmpd="sng" algn="ctr">
                       <a:solidFill>
-                        <a:srgbClr val="DDD9CC"/>
+                        <a:srgbClr val="D9DEE6"/>
                       </a:solidFill>
                       <a:prstDash val="solid"/>
                       <a:round/>
@@ -6315,7 +6315,7 @@
                     </a:lnT>
                     <a:lnB w="9525" cap="flat" cmpd="sng" algn="ctr">
                       <a:solidFill>
-                        <a:srgbClr val="DDD9CC"/>
+                        <a:srgbClr val="D9DEE6"/>
                       </a:solidFill>
                       <a:prstDash val="solid"/>
                       <a:round/>
@@ -6356,7 +6356,7 @@
                   <a:tcPr marL="127000" marR="127000" marT="76200" marB="76200" anchor="ctr">
                     <a:lnL w="9525" cap="flat" cmpd="sng" algn="ctr">
                       <a:solidFill>
-                        <a:srgbClr val="DDD9CC"/>
+                        <a:srgbClr val="D9DEE6"/>
                       </a:solidFill>
                       <a:prstDash val="solid"/>
                       <a:round/>
@@ -6365,7 +6365,7 @@
                     </a:lnL>
                     <a:lnR w="9525" cap="flat" cmpd="sng" algn="ctr">
                       <a:solidFill>
-                        <a:srgbClr val="DDD9CC"/>
+                        <a:srgbClr val="D9DEE6"/>
                       </a:solidFill>
                       <a:prstDash val="solid"/>
                       <a:round/>
@@ -6374,7 +6374,7 @@
                     </a:lnR>
                     <a:lnT w="9525" cap="flat" cmpd="sng" algn="ctr">
                       <a:solidFill>
-                        <a:srgbClr val="DDD9CC"/>
+                        <a:srgbClr val="D9DEE6"/>
                       </a:solidFill>
                       <a:prstDash val="solid"/>
                       <a:round/>
@@ -6383,7 +6383,7 @@
                     </a:lnT>
                     <a:lnB w="9525" cap="flat" cmpd="sng" algn="ctr">
                       <a:solidFill>
-                        <a:srgbClr val="DDD9CC"/>
+                        <a:srgbClr val="D9DEE6"/>
                       </a:solidFill>
                       <a:prstDash val="solid"/>
                       <a:round/>
@@ -6424,7 +6424,7 @@
                   <a:tcPr marL="127000" marR="127000" marT="76200" marB="76200" anchor="ctr">
                     <a:lnL w="9525" cap="flat" cmpd="sng" algn="ctr">
                       <a:solidFill>
-                        <a:srgbClr val="DDD9CC"/>
+                        <a:srgbClr val="D9DEE6"/>
                       </a:solidFill>
                       <a:prstDash val="solid"/>
                       <a:round/>
@@ -6433,7 +6433,7 @@
                     </a:lnL>
                     <a:lnR w="9525" cap="flat" cmpd="sng" algn="ctr">
                       <a:solidFill>
-                        <a:srgbClr val="DDD9CC"/>
+                        <a:srgbClr val="D9DEE6"/>
                       </a:solidFill>
                       <a:prstDash val="solid"/>
                       <a:round/>
@@ -6442,7 +6442,7 @@
                     </a:lnR>
                     <a:lnT w="9525" cap="flat" cmpd="sng" algn="ctr">
                       <a:solidFill>
-                        <a:srgbClr val="DDD9CC"/>
+                        <a:srgbClr val="D9DEE6"/>
                       </a:solidFill>
                       <a:prstDash val="solid"/>
                       <a:round/>
@@ -6451,7 +6451,7 @@
                     </a:lnT>
                     <a:lnB w="9525" cap="flat" cmpd="sng" algn="ctr">
                       <a:solidFill>
-                        <a:srgbClr val="DDD9CC"/>
+                        <a:srgbClr val="D9DEE6"/>
                       </a:solidFill>
                       <a:prstDash val="solid"/>
                       <a:round/>
@@ -6492,7 +6492,7 @@
                   <a:tcPr marL="127000" marR="127000" marT="76200" marB="76200" anchor="ctr">
                     <a:lnL w="9525" cap="flat" cmpd="sng" algn="ctr">
                       <a:solidFill>
-                        <a:srgbClr val="DDD9CC"/>
+                        <a:srgbClr val="D9DEE6"/>
                       </a:solidFill>
                       <a:prstDash val="solid"/>
                       <a:round/>
@@ -6501,7 +6501,7 @@
                     </a:lnL>
                     <a:lnR w="9525" cap="flat" cmpd="sng" algn="ctr">
                       <a:solidFill>
-                        <a:srgbClr val="DDD9CC"/>
+                        <a:srgbClr val="D9DEE6"/>
                       </a:solidFill>
                       <a:prstDash val="solid"/>
                       <a:round/>
@@ -6510,7 +6510,7 @@
                     </a:lnR>
                     <a:lnT w="9525" cap="flat" cmpd="sng" algn="ctr">
                       <a:solidFill>
-                        <a:srgbClr val="DDD9CC"/>
+                        <a:srgbClr val="D9DEE6"/>
                       </a:solidFill>
                       <a:prstDash val="solid"/>
                       <a:round/>
@@ -6519,7 +6519,7 @@
                     </a:lnT>
                     <a:lnB w="9525" cap="flat" cmpd="sng" algn="ctr">
                       <a:solidFill>
-                        <a:srgbClr val="DDD9CC"/>
+                        <a:srgbClr val="D9DEE6"/>
                       </a:solidFill>
                       <a:prstDash val="solid"/>
                       <a:round/>
@@ -6562,7 +6562,7 @@
                   <a:tcPr marL="127000" marR="127000" marT="76200" marB="76200" anchor="ctr">
                     <a:lnL w="9525" cap="flat" cmpd="sng" algn="ctr">
                       <a:solidFill>
-                        <a:srgbClr val="DDD9CC"/>
+                        <a:srgbClr val="D9DEE6"/>
                       </a:solidFill>
                       <a:prstDash val="solid"/>
                       <a:round/>
@@ -6571,7 +6571,7 @@
                     </a:lnL>
                     <a:lnR w="9525" cap="flat" cmpd="sng" algn="ctr">
                       <a:solidFill>
-                        <a:srgbClr val="DDD9CC"/>
+                        <a:srgbClr val="D9DEE6"/>
                       </a:solidFill>
                       <a:prstDash val="solid"/>
                       <a:round/>
@@ -6580,7 +6580,7 @@
                     </a:lnR>
                     <a:lnT w="9525" cap="flat" cmpd="sng" algn="ctr">
                       <a:solidFill>
-                        <a:srgbClr val="DDD9CC"/>
+                        <a:srgbClr val="D9DEE6"/>
                       </a:solidFill>
                       <a:prstDash val="solid"/>
                       <a:round/>
@@ -6589,7 +6589,7 @@
                     </a:lnT>
                     <a:lnB w="9525" cap="flat" cmpd="sng" algn="ctr">
                       <a:solidFill>
-                        <a:srgbClr val="DDD9CC"/>
+                        <a:srgbClr val="D9DEE6"/>
                       </a:solidFill>
                       <a:prstDash val="solid"/>
                       <a:round/>
@@ -6597,7 +6597,7 @@
                       <a:tailEnd type="none" w="med" len="med"/>
                     </a:lnB>
                     <a:solidFill>
-                      <a:srgbClr val="F7F6F1"/>
+                      <a:srgbClr val="F2F4F7"/>
                     </a:solidFill>
                   </a:tcPr>
                 </a:tc>
@@ -6630,7 +6630,7 @@
                   <a:tcPr marL="127000" marR="127000" marT="76200" marB="76200" anchor="ctr">
                     <a:lnL w="9525" cap="flat" cmpd="sng" algn="ctr">
                       <a:solidFill>
-                        <a:srgbClr val="DDD9CC"/>
+                        <a:srgbClr val="D9DEE6"/>
                       </a:solidFill>
                       <a:prstDash val="solid"/>
                       <a:round/>
@@ -6639,7 +6639,7 @@
                     </a:lnL>
                     <a:lnR w="9525" cap="flat" cmpd="sng" algn="ctr">
                       <a:solidFill>
-                        <a:srgbClr val="DDD9CC"/>
+                        <a:srgbClr val="D9DEE6"/>
                       </a:solidFill>
                       <a:prstDash val="solid"/>
                       <a:round/>
@@ -6648,7 +6648,7 @@
                     </a:lnR>
                     <a:lnT w="9525" cap="flat" cmpd="sng" algn="ctr">
                       <a:solidFill>
-                        <a:srgbClr val="DDD9CC"/>
+                        <a:srgbClr val="D9DEE6"/>
                       </a:solidFill>
                       <a:prstDash val="solid"/>
                       <a:round/>
@@ -6657,7 +6657,7 @@
                     </a:lnT>
                     <a:lnB w="9525" cap="flat" cmpd="sng" algn="ctr">
                       <a:solidFill>
-                        <a:srgbClr val="DDD9CC"/>
+                        <a:srgbClr val="D9DEE6"/>
                       </a:solidFill>
                       <a:prstDash val="solid"/>
                       <a:round/>
@@ -6665,7 +6665,7 @@
                       <a:tailEnd type="none" w="med" len="med"/>
                     </a:lnB>
                     <a:solidFill>
-                      <a:srgbClr val="F7F6F1"/>
+                      <a:srgbClr val="F2F4F7"/>
                     </a:solidFill>
                   </a:tcPr>
                 </a:tc>
@@ -6698,7 +6698,7 @@
                   <a:tcPr marL="127000" marR="127000" marT="76200" marB="76200" anchor="ctr">
                     <a:lnL w="9525" cap="flat" cmpd="sng" algn="ctr">
                       <a:solidFill>
-                        <a:srgbClr val="DDD9CC"/>
+                        <a:srgbClr val="D9DEE6"/>
                       </a:solidFill>
                       <a:prstDash val="solid"/>
                       <a:round/>
@@ -6707,7 +6707,7 @@
                     </a:lnL>
                     <a:lnR w="9525" cap="flat" cmpd="sng" algn="ctr">
                       <a:solidFill>
-                        <a:srgbClr val="DDD9CC"/>
+                        <a:srgbClr val="D9DEE6"/>
                       </a:solidFill>
                       <a:prstDash val="solid"/>
                       <a:round/>
@@ -6716,7 +6716,7 @@
                     </a:lnR>
                     <a:lnT w="9525" cap="flat" cmpd="sng" algn="ctr">
                       <a:solidFill>
-                        <a:srgbClr val="DDD9CC"/>
+                        <a:srgbClr val="D9DEE6"/>
                       </a:solidFill>
                       <a:prstDash val="solid"/>
                       <a:round/>
@@ -6725,7 +6725,7 @@
                     </a:lnT>
                     <a:lnB w="9525" cap="flat" cmpd="sng" algn="ctr">
                       <a:solidFill>
-                        <a:srgbClr val="DDD9CC"/>
+                        <a:srgbClr val="D9DEE6"/>
                       </a:solidFill>
                       <a:prstDash val="solid"/>
                       <a:round/>
@@ -6733,7 +6733,7 @@
                       <a:tailEnd type="none" w="med" len="med"/>
                     </a:lnB>
                     <a:solidFill>
-                      <a:srgbClr val="F7F6F1"/>
+                      <a:srgbClr val="F2F4F7"/>
                     </a:solidFill>
                   </a:tcPr>
                 </a:tc>
@@ -6766,7 +6766,7 @@
                   <a:tcPr marL="127000" marR="127000" marT="76200" marB="76200" anchor="ctr">
                     <a:lnL w="9525" cap="flat" cmpd="sng" algn="ctr">
                       <a:solidFill>
-                        <a:srgbClr val="DDD9CC"/>
+                        <a:srgbClr val="D9DEE6"/>
                       </a:solidFill>
                       <a:prstDash val="solid"/>
                       <a:round/>
@@ -6775,7 +6775,7 @@
                     </a:lnL>
                     <a:lnR w="9525" cap="flat" cmpd="sng" algn="ctr">
                       <a:solidFill>
-                        <a:srgbClr val="DDD9CC"/>
+                        <a:srgbClr val="D9DEE6"/>
                       </a:solidFill>
                       <a:prstDash val="solid"/>
                       <a:round/>
@@ -6784,7 +6784,7 @@
                     </a:lnR>
                     <a:lnT w="9525" cap="flat" cmpd="sng" algn="ctr">
                       <a:solidFill>
-                        <a:srgbClr val="DDD9CC"/>
+                        <a:srgbClr val="D9DEE6"/>
                       </a:solidFill>
                       <a:prstDash val="solid"/>
                       <a:round/>
@@ -6793,7 +6793,7 @@
                     </a:lnT>
                     <a:lnB w="9525" cap="flat" cmpd="sng" algn="ctr">
                       <a:solidFill>
-                        <a:srgbClr val="DDD9CC"/>
+                        <a:srgbClr val="D9DEE6"/>
                       </a:solidFill>
                       <a:prstDash val="solid"/>
                       <a:round/>
@@ -6801,7 +6801,7 @@
                       <a:tailEnd type="none" w="med" len="med"/>
                     </a:lnB>
                     <a:solidFill>
-                      <a:srgbClr val="F7F6F1"/>
+                      <a:srgbClr val="F2F4F7"/>
                     </a:solidFill>
                   </a:tcPr>
                 </a:tc>
@@ -6834,7 +6834,7 @@
                   <a:tcPr marL="127000" marR="127000" marT="76200" marB="76200" anchor="ctr">
                     <a:lnL w="9525" cap="flat" cmpd="sng" algn="ctr">
                       <a:solidFill>
-                        <a:srgbClr val="DDD9CC"/>
+                        <a:srgbClr val="D9DEE6"/>
                       </a:solidFill>
                       <a:prstDash val="solid"/>
                       <a:round/>
@@ -6843,7 +6843,7 @@
                     </a:lnL>
                     <a:lnR w="9525" cap="flat" cmpd="sng" algn="ctr">
                       <a:solidFill>
-                        <a:srgbClr val="DDD9CC"/>
+                        <a:srgbClr val="D9DEE6"/>
                       </a:solidFill>
                       <a:prstDash val="solid"/>
                       <a:round/>
@@ -6852,7 +6852,7 @@
                     </a:lnR>
                     <a:lnT w="9525" cap="flat" cmpd="sng" algn="ctr">
                       <a:solidFill>
-                        <a:srgbClr val="DDD9CC"/>
+                        <a:srgbClr val="D9DEE6"/>
                       </a:solidFill>
                       <a:prstDash val="solid"/>
                       <a:round/>
@@ -6861,7 +6861,7 @@
                     </a:lnT>
                     <a:lnB w="9525" cap="flat" cmpd="sng" algn="ctr">
                       <a:solidFill>
-                        <a:srgbClr val="DDD9CC"/>
+                        <a:srgbClr val="D9DEE6"/>
                       </a:solidFill>
                       <a:prstDash val="solid"/>
                       <a:round/>
@@ -6869,7 +6869,7 @@
                       <a:tailEnd type="none" w="med" len="med"/>
                     </a:lnB>
                     <a:solidFill>
-                      <a:srgbClr val="F7F6F1"/>
+                      <a:srgbClr val="F2F4F7"/>
                     </a:solidFill>
                   </a:tcPr>
                 </a:tc>
@@ -6904,7 +6904,7 @@
                   <a:tcPr marL="127000" marR="127000" marT="76200" marB="76200" anchor="ctr">
                     <a:lnL w="9525" cap="flat" cmpd="sng" algn="ctr">
                       <a:solidFill>
-                        <a:srgbClr val="DDD9CC"/>
+                        <a:srgbClr val="D9DEE6"/>
                       </a:solidFill>
                       <a:prstDash val="solid"/>
                       <a:round/>
@@ -6913,7 +6913,7 @@
                     </a:lnL>
                     <a:lnR w="9525" cap="flat" cmpd="sng" algn="ctr">
                       <a:solidFill>
-                        <a:srgbClr val="DDD9CC"/>
+                        <a:srgbClr val="D9DEE6"/>
                       </a:solidFill>
                       <a:prstDash val="solid"/>
                       <a:round/>
@@ -6922,7 +6922,7 @@
                     </a:lnR>
                     <a:lnT w="9525" cap="flat" cmpd="sng" algn="ctr">
                       <a:solidFill>
-                        <a:srgbClr val="DDD9CC"/>
+                        <a:srgbClr val="D9DEE6"/>
                       </a:solidFill>
                       <a:prstDash val="solid"/>
                       <a:round/>
@@ -6931,7 +6931,7 @@
                     </a:lnT>
                     <a:lnB w="9525" cap="flat" cmpd="sng" algn="ctr">
                       <a:solidFill>
-                        <a:srgbClr val="DDD9CC"/>
+                        <a:srgbClr val="D9DEE6"/>
                       </a:solidFill>
                       <a:prstDash val="solid"/>
                       <a:round/>
@@ -6972,7 +6972,7 @@
                   <a:tcPr marL="127000" marR="127000" marT="76200" marB="76200" anchor="ctr">
                     <a:lnL w="9525" cap="flat" cmpd="sng" algn="ctr">
                       <a:solidFill>
-                        <a:srgbClr val="DDD9CC"/>
+                        <a:srgbClr val="D9DEE6"/>
                       </a:solidFill>
                       <a:prstDash val="solid"/>
                       <a:round/>
@@ -6981,7 +6981,7 @@
                     </a:lnL>
                     <a:lnR w="9525" cap="flat" cmpd="sng" algn="ctr">
                       <a:solidFill>
-                        <a:srgbClr val="DDD9CC"/>
+                        <a:srgbClr val="D9DEE6"/>
                       </a:solidFill>
                       <a:prstDash val="solid"/>
                       <a:round/>
@@ -6990,7 +6990,7 @@
                     </a:lnR>
                     <a:lnT w="9525" cap="flat" cmpd="sng" algn="ctr">
                       <a:solidFill>
-                        <a:srgbClr val="DDD9CC"/>
+                        <a:srgbClr val="D9DEE6"/>
                       </a:solidFill>
                       <a:prstDash val="solid"/>
                       <a:round/>
@@ -6999,7 +6999,7 @@
                     </a:lnT>
                     <a:lnB w="9525" cap="flat" cmpd="sng" algn="ctr">
                       <a:solidFill>
-                        <a:srgbClr val="DDD9CC"/>
+                        <a:srgbClr val="D9DEE6"/>
                       </a:solidFill>
                       <a:prstDash val="solid"/>
                       <a:round/>
@@ -7040,7 +7040,7 @@
                   <a:tcPr marL="127000" marR="127000" marT="76200" marB="76200" anchor="ctr">
                     <a:lnL w="9525" cap="flat" cmpd="sng" algn="ctr">
                       <a:solidFill>
-                        <a:srgbClr val="DDD9CC"/>
+                        <a:srgbClr val="D9DEE6"/>
                       </a:solidFill>
                       <a:prstDash val="solid"/>
                       <a:round/>
@@ -7049,7 +7049,7 @@
                     </a:lnL>
                     <a:lnR w="9525" cap="flat" cmpd="sng" algn="ctr">
                       <a:solidFill>
-                        <a:srgbClr val="DDD9CC"/>
+                        <a:srgbClr val="D9DEE6"/>
                       </a:solidFill>
                       <a:prstDash val="solid"/>
                       <a:round/>
@@ -7058,7 +7058,7 @@
                     </a:lnR>
                     <a:lnT w="9525" cap="flat" cmpd="sng" algn="ctr">
                       <a:solidFill>
-                        <a:srgbClr val="DDD9CC"/>
+                        <a:srgbClr val="D9DEE6"/>
                       </a:solidFill>
                       <a:prstDash val="solid"/>
                       <a:round/>
@@ -7067,7 +7067,7 @@
                     </a:lnT>
                     <a:lnB w="9525" cap="flat" cmpd="sng" algn="ctr">
                       <a:solidFill>
-                        <a:srgbClr val="DDD9CC"/>
+                        <a:srgbClr val="D9DEE6"/>
                       </a:solidFill>
                       <a:prstDash val="solid"/>
                       <a:round/>
@@ -7108,7 +7108,7 @@
                   <a:tcPr marL="127000" marR="127000" marT="76200" marB="76200" anchor="ctr">
                     <a:lnL w="9525" cap="flat" cmpd="sng" algn="ctr">
                       <a:solidFill>
-                        <a:srgbClr val="DDD9CC"/>
+                        <a:srgbClr val="D9DEE6"/>
                       </a:solidFill>
                       <a:prstDash val="solid"/>
                       <a:round/>
@@ -7117,7 +7117,7 @@
                     </a:lnL>
                     <a:lnR w="9525" cap="flat" cmpd="sng" algn="ctr">
                       <a:solidFill>
-                        <a:srgbClr val="DDD9CC"/>
+                        <a:srgbClr val="D9DEE6"/>
                       </a:solidFill>
                       <a:prstDash val="solid"/>
                       <a:round/>
@@ -7126,7 +7126,7 @@
                     </a:lnR>
                     <a:lnT w="9525" cap="flat" cmpd="sng" algn="ctr">
                       <a:solidFill>
-                        <a:srgbClr val="DDD9CC"/>
+                        <a:srgbClr val="D9DEE6"/>
                       </a:solidFill>
                       <a:prstDash val="solid"/>
                       <a:round/>
@@ -7135,7 +7135,7 @@
                     </a:lnT>
                     <a:lnB w="9525" cap="flat" cmpd="sng" algn="ctr">
                       <a:solidFill>
-                        <a:srgbClr val="DDD9CC"/>
+                        <a:srgbClr val="D9DEE6"/>
                       </a:solidFill>
                       <a:prstDash val="solid"/>
                       <a:round/>
@@ -7176,7 +7176,7 @@
                   <a:tcPr marL="127000" marR="127000" marT="76200" marB="76200" anchor="ctr">
                     <a:lnL w="9525" cap="flat" cmpd="sng" algn="ctr">
                       <a:solidFill>
-                        <a:srgbClr val="DDD9CC"/>
+                        <a:srgbClr val="D9DEE6"/>
                       </a:solidFill>
                       <a:prstDash val="solid"/>
                       <a:round/>
@@ -7185,7 +7185,7 @@
                     </a:lnL>
                     <a:lnR w="9525" cap="flat" cmpd="sng" algn="ctr">
                       <a:solidFill>
-                        <a:srgbClr val="DDD9CC"/>
+                        <a:srgbClr val="D9DEE6"/>
                       </a:solidFill>
                       <a:prstDash val="solid"/>
                       <a:round/>
@@ -7194,7 +7194,7 @@
                     </a:lnR>
                     <a:lnT w="9525" cap="flat" cmpd="sng" algn="ctr">
                       <a:solidFill>
-                        <a:srgbClr val="DDD9CC"/>
+                        <a:srgbClr val="D9DEE6"/>
                       </a:solidFill>
                       <a:prstDash val="solid"/>
                       <a:round/>
@@ -7203,7 +7203,7 @@
                     </a:lnT>
                     <a:lnB w="9525" cap="flat" cmpd="sng" algn="ctr">
                       <a:solidFill>
-                        <a:srgbClr val="DDD9CC"/>
+                        <a:srgbClr val="D9DEE6"/>
                       </a:solidFill>
                       <a:prstDash val="solid"/>
                       <a:round/>
@@ -7246,7 +7246,7 @@
                   <a:tcPr marL="127000" marR="127000" marT="76200" marB="76200" anchor="ctr">
                     <a:lnL w="9525" cap="flat" cmpd="sng" algn="ctr">
                       <a:solidFill>
-                        <a:srgbClr val="DDD9CC"/>
+                        <a:srgbClr val="D9DEE6"/>
                       </a:solidFill>
                       <a:prstDash val="solid"/>
                       <a:round/>
@@ -7255,7 +7255,7 @@
                     </a:lnL>
                     <a:lnR w="9525" cap="flat" cmpd="sng" algn="ctr">
                       <a:solidFill>
-                        <a:srgbClr val="DDD9CC"/>
+                        <a:srgbClr val="D9DEE6"/>
                       </a:solidFill>
                       <a:prstDash val="solid"/>
                       <a:round/>
@@ -7264,7 +7264,7 @@
                     </a:lnR>
                     <a:lnT w="9525" cap="flat" cmpd="sng" algn="ctr">
                       <a:solidFill>
-                        <a:srgbClr val="DDD9CC"/>
+                        <a:srgbClr val="D9DEE6"/>
                       </a:solidFill>
                       <a:prstDash val="solid"/>
                       <a:round/>
@@ -7273,7 +7273,7 @@
                     </a:lnT>
                     <a:lnB w="9525" cap="flat" cmpd="sng" algn="ctr">
                       <a:solidFill>
-                        <a:srgbClr val="DDD9CC"/>
+                        <a:srgbClr val="D9DEE6"/>
                       </a:solidFill>
                       <a:prstDash val="solid"/>
                       <a:round/>
@@ -7281,7 +7281,7 @@
                       <a:tailEnd type="none" w="med" len="med"/>
                     </a:lnB>
                     <a:solidFill>
-                      <a:srgbClr val="F7F6F1"/>
+                      <a:srgbClr val="F2F4F7"/>
                     </a:solidFill>
                   </a:tcPr>
                 </a:tc>
@@ -7314,7 +7314,7 @@
                   <a:tcPr marL="127000" marR="127000" marT="76200" marB="76200" anchor="ctr">
                     <a:lnL w="9525" cap="flat" cmpd="sng" algn="ctr">
                       <a:solidFill>
-                        <a:srgbClr val="DDD9CC"/>
+                        <a:srgbClr val="D9DEE6"/>
                       </a:solidFill>
                       <a:prstDash val="solid"/>
                       <a:round/>
@@ -7323,7 +7323,7 @@
                     </a:lnL>
                     <a:lnR w="9525" cap="flat" cmpd="sng" algn="ctr">
                       <a:solidFill>
-                        <a:srgbClr val="DDD9CC"/>
+                        <a:srgbClr val="D9DEE6"/>
                       </a:solidFill>
                       <a:prstDash val="solid"/>
                       <a:round/>
@@ -7332,7 +7332,7 @@
                     </a:lnR>
                     <a:lnT w="9525" cap="flat" cmpd="sng" algn="ctr">
                       <a:solidFill>
-                        <a:srgbClr val="DDD9CC"/>
+                        <a:srgbClr val="D9DEE6"/>
                       </a:solidFill>
                       <a:prstDash val="solid"/>
                       <a:round/>
@@ -7341,7 +7341,7 @@
                     </a:lnT>
                     <a:lnB w="9525" cap="flat" cmpd="sng" algn="ctr">
                       <a:solidFill>
-                        <a:srgbClr val="DDD9CC"/>
+                        <a:srgbClr val="D9DEE6"/>
                       </a:solidFill>
                       <a:prstDash val="solid"/>
                       <a:round/>
@@ -7349,7 +7349,7 @@
                       <a:tailEnd type="none" w="med" len="med"/>
                     </a:lnB>
                     <a:solidFill>
-                      <a:srgbClr val="F7F6F1"/>
+                      <a:srgbClr val="F2F4F7"/>
                     </a:solidFill>
                   </a:tcPr>
                 </a:tc>
@@ -7382,7 +7382,7 @@
                   <a:tcPr marL="127000" marR="127000" marT="76200" marB="76200" anchor="ctr">
                     <a:lnL w="9525" cap="flat" cmpd="sng" algn="ctr">
                       <a:solidFill>
-                        <a:srgbClr val="DDD9CC"/>
+                        <a:srgbClr val="D9DEE6"/>
                       </a:solidFill>
                       <a:prstDash val="solid"/>
                       <a:round/>
@@ -7391,7 +7391,7 @@
                     </a:lnL>
                     <a:lnR w="9525" cap="flat" cmpd="sng" algn="ctr">
                       <a:solidFill>
-                        <a:srgbClr val="DDD9CC"/>
+                        <a:srgbClr val="D9DEE6"/>
                       </a:solidFill>
                       <a:prstDash val="solid"/>
                       <a:round/>
@@ -7400,7 +7400,7 @@
                     </a:lnR>
                     <a:lnT w="9525" cap="flat" cmpd="sng" algn="ctr">
                       <a:solidFill>
-                        <a:srgbClr val="DDD9CC"/>
+                        <a:srgbClr val="D9DEE6"/>
                       </a:solidFill>
                       <a:prstDash val="solid"/>
                       <a:round/>
@@ -7409,7 +7409,7 @@
                     </a:lnT>
                     <a:lnB w="9525" cap="flat" cmpd="sng" algn="ctr">
                       <a:solidFill>
-                        <a:srgbClr val="DDD9CC"/>
+                        <a:srgbClr val="D9DEE6"/>
                       </a:solidFill>
                       <a:prstDash val="solid"/>
                       <a:round/>
@@ -7417,7 +7417,7 @@
                       <a:tailEnd type="none" w="med" len="med"/>
                     </a:lnB>
                     <a:solidFill>
-                      <a:srgbClr val="F7F6F1"/>
+                      <a:srgbClr val="F2F4F7"/>
                     </a:solidFill>
                   </a:tcPr>
                 </a:tc>
@@ -7450,7 +7450,7 @@
                   <a:tcPr marL="127000" marR="127000" marT="76200" marB="76200" anchor="ctr">
                     <a:lnL w="9525" cap="flat" cmpd="sng" algn="ctr">
                       <a:solidFill>
-                        <a:srgbClr val="DDD9CC"/>
+                        <a:srgbClr val="D9DEE6"/>
                       </a:solidFill>
                       <a:prstDash val="solid"/>
                       <a:round/>
@@ -7459,7 +7459,7 @@
                     </a:lnL>
                     <a:lnR w="9525" cap="flat" cmpd="sng" algn="ctr">
                       <a:solidFill>
-                        <a:srgbClr val="DDD9CC"/>
+                        <a:srgbClr val="D9DEE6"/>
                       </a:solidFill>
                       <a:prstDash val="solid"/>
                       <a:round/>
@@ -7468,7 +7468,7 @@
                     </a:lnR>
                     <a:lnT w="9525" cap="flat" cmpd="sng" algn="ctr">
                       <a:solidFill>
-                        <a:srgbClr val="DDD9CC"/>
+                        <a:srgbClr val="D9DEE6"/>
                       </a:solidFill>
                       <a:prstDash val="solid"/>
                       <a:round/>
@@ -7477,7 +7477,7 @@
                     </a:lnT>
                     <a:lnB w="9525" cap="flat" cmpd="sng" algn="ctr">
                       <a:solidFill>
-                        <a:srgbClr val="DDD9CC"/>
+                        <a:srgbClr val="D9DEE6"/>
                       </a:solidFill>
                       <a:prstDash val="solid"/>
                       <a:round/>
@@ -7485,7 +7485,7 @@
                       <a:tailEnd type="none" w="med" len="med"/>
                     </a:lnB>
                     <a:solidFill>
-                      <a:srgbClr val="F7F6F1"/>
+                      <a:srgbClr val="F2F4F7"/>
                     </a:solidFill>
                   </a:tcPr>
                 </a:tc>
@@ -7518,7 +7518,7 @@
                   <a:tcPr marL="127000" marR="127000" marT="76200" marB="76200" anchor="ctr">
                     <a:lnL w="9525" cap="flat" cmpd="sng" algn="ctr">
                       <a:solidFill>
-                        <a:srgbClr val="DDD9CC"/>
+                        <a:srgbClr val="D9DEE6"/>
                       </a:solidFill>
                       <a:prstDash val="solid"/>
                       <a:round/>
@@ -7527,7 +7527,7 @@
                     </a:lnL>
                     <a:lnR w="9525" cap="flat" cmpd="sng" algn="ctr">
                       <a:solidFill>
-                        <a:srgbClr val="DDD9CC"/>
+                        <a:srgbClr val="D9DEE6"/>
                       </a:solidFill>
                       <a:prstDash val="solid"/>
                       <a:round/>
@@ -7536,7 +7536,7 @@
                     </a:lnR>
                     <a:lnT w="9525" cap="flat" cmpd="sng" algn="ctr">
                       <a:solidFill>
-                        <a:srgbClr val="DDD9CC"/>
+                        <a:srgbClr val="D9DEE6"/>
                       </a:solidFill>
                       <a:prstDash val="solid"/>
                       <a:round/>
@@ -7545,7 +7545,7 @@
                     </a:lnT>
                     <a:lnB w="9525" cap="flat" cmpd="sng" algn="ctr">
                       <a:solidFill>
-                        <a:srgbClr val="DDD9CC"/>
+                        <a:srgbClr val="D9DEE6"/>
                       </a:solidFill>
                       <a:prstDash val="solid"/>
                       <a:round/>
@@ -7553,7 +7553,7 @@
                       <a:tailEnd type="none" w="med" len="med"/>
                     </a:lnB>
                     <a:solidFill>
-                      <a:srgbClr val="F7F6F1"/>
+                      <a:srgbClr val="F2F4F7"/>
                     </a:solidFill>
                   </a:tcPr>
                 </a:tc>
@@ -7588,7 +7588,7 @@
                   <a:tcPr marL="127000" marR="127000" marT="76200" marB="76200" anchor="ctr">
                     <a:lnL w="9525" cap="flat" cmpd="sng" algn="ctr">
                       <a:solidFill>
-                        <a:srgbClr val="DDD9CC"/>
+                        <a:srgbClr val="D9DEE6"/>
                       </a:solidFill>
                       <a:prstDash val="solid"/>
                       <a:round/>
@@ -7597,7 +7597,7 @@
                     </a:lnL>
                     <a:lnR w="9525" cap="flat" cmpd="sng" algn="ctr">
                       <a:solidFill>
-                        <a:srgbClr val="DDD9CC"/>
+                        <a:srgbClr val="D9DEE6"/>
                       </a:solidFill>
                       <a:prstDash val="solid"/>
                       <a:round/>
@@ -7606,7 +7606,7 @@
                     </a:lnR>
                     <a:lnT w="9525" cap="flat" cmpd="sng" algn="ctr">
                       <a:solidFill>
-                        <a:srgbClr val="DDD9CC"/>
+                        <a:srgbClr val="D9DEE6"/>
                       </a:solidFill>
                       <a:prstDash val="solid"/>
                       <a:round/>
@@ -7615,7 +7615,7 @@
                     </a:lnT>
                     <a:lnB w="9525" cap="flat" cmpd="sng" algn="ctr">
                       <a:solidFill>
-                        <a:srgbClr val="DDD9CC"/>
+                        <a:srgbClr val="D9DEE6"/>
                       </a:solidFill>
                       <a:prstDash val="solid"/>
                       <a:round/>
@@ -7656,7 +7656,7 @@
                   <a:tcPr marL="127000" marR="127000" marT="76200" marB="76200" anchor="ctr">
                     <a:lnL w="9525" cap="flat" cmpd="sng" algn="ctr">
                       <a:solidFill>
-                        <a:srgbClr val="DDD9CC"/>
+                        <a:srgbClr val="D9DEE6"/>
                       </a:solidFill>
                       <a:prstDash val="solid"/>
                       <a:round/>
@@ -7665,7 +7665,7 @@
                     </a:lnL>
                     <a:lnR w="9525" cap="flat" cmpd="sng" algn="ctr">
                       <a:solidFill>
-                        <a:srgbClr val="DDD9CC"/>
+                        <a:srgbClr val="D9DEE6"/>
                       </a:solidFill>
                       <a:prstDash val="solid"/>
                       <a:round/>
@@ -7674,7 +7674,7 @@
                     </a:lnR>
                     <a:lnT w="9525" cap="flat" cmpd="sng" algn="ctr">
                       <a:solidFill>
-                        <a:srgbClr val="DDD9CC"/>
+                        <a:srgbClr val="D9DEE6"/>
                       </a:solidFill>
                       <a:prstDash val="solid"/>
                       <a:round/>
@@ -7683,7 +7683,7 @@
                     </a:lnT>
                     <a:lnB w="9525" cap="flat" cmpd="sng" algn="ctr">
                       <a:solidFill>
-                        <a:srgbClr val="DDD9CC"/>
+                        <a:srgbClr val="D9DEE6"/>
                       </a:solidFill>
                       <a:prstDash val="solid"/>
                       <a:round/>
@@ -7724,7 +7724,7 @@
                   <a:tcPr marL="127000" marR="127000" marT="76200" marB="76200" anchor="ctr">
                     <a:lnL w="9525" cap="flat" cmpd="sng" algn="ctr">
                       <a:solidFill>
-                        <a:srgbClr val="DDD9CC"/>
+                        <a:srgbClr val="D9DEE6"/>
                       </a:solidFill>
                       <a:prstDash val="solid"/>
                       <a:round/>
@@ -7733,7 +7733,7 @@
                     </a:lnL>
                     <a:lnR w="9525" cap="flat" cmpd="sng" algn="ctr">
                       <a:solidFill>
-                        <a:srgbClr val="DDD9CC"/>
+                        <a:srgbClr val="D9DEE6"/>
                       </a:solidFill>
                       <a:prstDash val="solid"/>
                       <a:round/>
@@ -7742,7 +7742,7 @@
                     </a:lnR>
                     <a:lnT w="9525" cap="flat" cmpd="sng" algn="ctr">
                       <a:solidFill>
-                        <a:srgbClr val="DDD9CC"/>
+                        <a:srgbClr val="D9DEE6"/>
                       </a:solidFill>
                       <a:prstDash val="solid"/>
                       <a:round/>
@@ -7751,7 +7751,7 @@
                     </a:lnT>
                     <a:lnB w="9525" cap="flat" cmpd="sng" algn="ctr">
                       <a:solidFill>
-                        <a:srgbClr val="DDD9CC"/>
+                        <a:srgbClr val="D9DEE6"/>
                       </a:solidFill>
                       <a:prstDash val="solid"/>
                       <a:round/>
@@ -7792,7 +7792,7 @@
                   <a:tcPr marL="127000" marR="127000" marT="76200" marB="76200" anchor="ctr">
                     <a:lnL w="9525" cap="flat" cmpd="sng" algn="ctr">
                       <a:solidFill>
-                        <a:srgbClr val="DDD9CC"/>
+                        <a:srgbClr val="D9DEE6"/>
                       </a:solidFill>
                       <a:prstDash val="solid"/>
                       <a:round/>
@@ -7801,7 +7801,7 @@
                     </a:lnL>
                     <a:lnR w="9525" cap="flat" cmpd="sng" algn="ctr">
                       <a:solidFill>
-                        <a:srgbClr val="DDD9CC"/>
+                        <a:srgbClr val="D9DEE6"/>
                       </a:solidFill>
                       <a:prstDash val="solid"/>
                       <a:round/>
@@ -7810,7 +7810,7 @@
                     </a:lnR>
                     <a:lnT w="9525" cap="flat" cmpd="sng" algn="ctr">
                       <a:solidFill>
-                        <a:srgbClr val="DDD9CC"/>
+                        <a:srgbClr val="D9DEE6"/>
                       </a:solidFill>
                       <a:prstDash val="solid"/>
                       <a:round/>
@@ -7819,7 +7819,7 @@
                     </a:lnT>
                     <a:lnB w="9525" cap="flat" cmpd="sng" algn="ctr">
                       <a:solidFill>
-                        <a:srgbClr val="DDD9CC"/>
+                        <a:srgbClr val="D9DEE6"/>
                       </a:solidFill>
                       <a:prstDash val="solid"/>
                       <a:round/>
@@ -7860,7 +7860,7 @@
                   <a:tcPr marL="127000" marR="127000" marT="76200" marB="76200" anchor="ctr">
                     <a:lnL w="9525" cap="flat" cmpd="sng" algn="ctr">
                       <a:solidFill>
-                        <a:srgbClr val="DDD9CC"/>
+                        <a:srgbClr val="D9DEE6"/>
                       </a:solidFill>
                       <a:prstDash val="solid"/>
                       <a:round/>
@@ -7869,7 +7869,7 @@
                     </a:lnL>
                     <a:lnR w="9525" cap="flat" cmpd="sng" algn="ctr">
                       <a:solidFill>
-                        <a:srgbClr val="DDD9CC"/>
+                        <a:srgbClr val="D9DEE6"/>
                       </a:solidFill>
                       <a:prstDash val="solid"/>
                       <a:round/>
@@ -7878,7 +7878,7 @@
                     </a:lnR>
                     <a:lnT w="9525" cap="flat" cmpd="sng" algn="ctr">
                       <a:solidFill>
-                        <a:srgbClr val="DDD9CC"/>
+                        <a:srgbClr val="D9DEE6"/>
                       </a:solidFill>
                       <a:prstDash val="solid"/>
                       <a:round/>
@@ -7887,7 +7887,7 @@
                     </a:lnT>
                     <a:lnB w="9525" cap="flat" cmpd="sng" algn="ctr">
                       <a:solidFill>
-                        <a:srgbClr val="DDD9CC"/>
+                        <a:srgbClr val="D9DEE6"/>
                       </a:solidFill>
                       <a:prstDash val="solid"/>
                       <a:round/>
@@ -8096,11 +8096,11 @@
             </a:avLst>
           </a:prstGeom>
           <a:solidFill>
-            <a:srgbClr val="F7F6F1"/>
+            <a:srgbClr val="F2F4F7"/>
           </a:solidFill>
           <a:ln w="12700">
             <a:solidFill>
-              <a:srgbClr val="DDD9CC"/>
+              <a:srgbClr val="D9DEE6"/>
             </a:solidFill>
             <a:prstDash val="solid"/>
           </a:ln>
@@ -8123,7 +8123,7 @@
           <a:noFill/>
           <a:ln w="31750">
             <a:solidFill>
-              <a:srgbClr val="B8B4A8"/>
+              <a:srgbClr val="B3B9C4"/>
             </a:solidFill>
             <a:prstDash val="solid"/>
             <a:tailEnd type="triangle"/>
@@ -8147,7 +8147,7 @@
           <a:noFill/>
           <a:ln w="31750">
             <a:solidFill>
-              <a:srgbClr val="B8B4A8"/>
+              <a:srgbClr val="B3B9C4"/>
             </a:solidFill>
             <a:prstDash val="solid"/>
             <a:tailEnd type="triangle"/>
@@ -9333,7 +9333,7 @@
                 <a:ea typeface="Arial" pitchFamily="34" charset="-122"/>
                 <a:cs typeface="Arial" pitchFamily="34" charset="-120"/>
               </a:rPr>
-              <a:t> 끝내야 합니다</a:t>
+              <a:t> — 더 빨리, 더 좋은 제품으로</a:t>
             </a:r>
             <a:endParaRPr lang="en-US" sz="2800" dirty="0"/>
           </a:p>
@@ -9356,11 +9356,11 @@
             </a:avLst>
           </a:prstGeom>
           <a:solidFill>
-            <a:srgbClr val="F7F6F1"/>
+            <a:srgbClr val="F2F4F7"/>
           </a:solidFill>
           <a:ln w="12700">
             <a:solidFill>
-              <a:srgbClr val="DDD9CC"/>
+              <a:srgbClr val="D9DEE6"/>
             </a:solidFill>
             <a:prstDash val="solid"/>
           </a:ln>
@@ -9383,7 +9383,7 @@
           <a:noFill/>
           <a:ln w="19050">
             <a:solidFill>
-              <a:srgbClr val="E4E0D4"/>
+              <a:srgbClr val="DFE4EB"/>
             </a:solidFill>
             <a:prstDash val="solid"/>
           </a:ln>
@@ -9406,7 +9406,7 @@
           <a:noFill/>
           <a:ln w="19050">
             <a:solidFill>
-              <a:srgbClr val="E4E0D4"/>
+              <a:srgbClr val="DFE4EB"/>
             </a:solidFill>
             <a:prstDash val="solid"/>
           </a:ln>
@@ -9830,7 +9830,7 @@
             </a:avLst>
           </a:prstGeom>
           <a:solidFill>
-            <a:srgbClr val="B8B4A8"/>
+            <a:srgbClr val="B3B9C4"/>
           </a:solidFill>
           <a:ln/>
         </p:spPr>
@@ -9891,7 +9891,7 @@
             </a:avLst>
           </a:prstGeom>
           <a:solidFill>
-            <a:srgbClr val="B8B4A8"/>
+            <a:srgbClr val="B3B9C4"/>
           </a:solidFill>
           <a:ln/>
         </p:spPr>
@@ -9966,8 +9966,8 @@
         </p:nvSpPr>
         <p:spPr>
           <a:xfrm>
-            <a:off x="9346997" y="2400300"/>
-            <a:ext cx="381305" cy="190195"/>
+            <a:off x="9346997" y="2311603"/>
+            <a:ext cx="952805" cy="381305"/>
           </a:xfrm>
           <a:prstGeom prst="rect">
             <a:avLst/>
@@ -9980,6 +9980,9 @@
           <a:lstStyle/>
           <a:p>
             <a:pPr algn="l" indent="0" marL="0">
+              <a:lnSpc>
+                <a:spcPct val="115000"/>
+              </a:lnSpc>
               <a:buNone/>
             </a:pPr>
             <a:r>
@@ -9992,6 +9995,26 @@
                 <a:cs typeface="Arial" pitchFamily="34" charset="-120"/>
               </a:rPr>
               <a:t>완성</a:t>
+            </a:r>
+            <a:endParaRPr lang="en-US" sz="1100" dirty="0"/>
+          </a:p>
+          <a:p>
+            <a:pPr algn="l" indent="0" marL="0">
+              <a:lnSpc>
+                <a:spcPct val="115000"/>
+              </a:lnSpc>
+              <a:buNone/>
+            </a:pPr>
+            <a:r>
+              <a:rPr lang="en-US" sz="950" dirty="0">
+                <a:solidFill>
+                  <a:srgbClr val="6B7280"/>
+                </a:solidFill>
+                <a:latin typeface="Arial" pitchFamily="34" charset="0"/>
+                <a:ea typeface="Arial" pitchFamily="34" charset="-122"/>
+                <a:cs typeface="Arial" pitchFamily="34" charset="-120"/>
+              </a:rPr>
+              <a:t>SW만 최적</a:t>
             </a:r>
             <a:endParaRPr lang="en-US" sz="1100" dirty="0"/>
           </a:p>
@@ -10005,8 +10028,8 @@
         </p:nvSpPr>
         <p:spPr>
           <a:xfrm>
-            <a:off x="9778594" y="2311603"/>
-            <a:ext cx="1777594" cy="381305"/>
+            <a:off x="10159898" y="2311603"/>
+            <a:ext cx="1397203" cy="381305"/>
           </a:xfrm>
           <a:prstGeom prst="rect">
             <a:avLst/>
@@ -10033,7 +10056,7 @@
                 <a:ea typeface="Arial" pitchFamily="34" charset="-122"/>
                 <a:cs typeface="Arial" pitchFamily="34" charset="-120"/>
               </a:rPr>
-              <a:t>SW는 실리콘 뒤에 시작</a:t>
+              <a:t>SW는 실리콘 뒤에</a:t>
             </a:r>
             <a:endParaRPr lang="en-US" sz="1150" dirty="0"/>
           </a:p>
@@ -10137,7 +10160,7 @@
             </a:avLst>
           </a:prstGeom>
           <a:solidFill>
-            <a:srgbClr val="B8B4A8"/>
+            <a:srgbClr val="B3B9C4"/>
           </a:solidFill>
           <a:ln/>
         </p:spPr>
@@ -10212,8 +10235,8 @@
         </p:nvSpPr>
         <p:spPr>
           <a:xfrm>
-            <a:off x="7188098" y="3226003"/>
-            <a:ext cx="381305" cy="190195"/>
+            <a:off x="7188098" y="3136392"/>
+            <a:ext cx="952805" cy="381305"/>
           </a:xfrm>
           <a:prstGeom prst="rect">
             <a:avLst/>
@@ -10226,6 +10249,9 @@
           <a:lstStyle/>
           <a:p>
             <a:pPr algn="l" indent="0" marL="0">
+              <a:lnSpc>
+                <a:spcPct val="115000"/>
+              </a:lnSpc>
               <a:buNone/>
             </a:pPr>
             <a:r>
@@ -10238,6 +10264,26 @@
                 <a:cs typeface="Arial" pitchFamily="34" charset="-120"/>
               </a:rPr>
               <a:t>완성</a:t>
+            </a:r>
+            <a:endParaRPr lang="en-US" sz="1100" dirty="0"/>
+          </a:p>
+          <a:p>
+            <a:pPr algn="l" indent="0" marL="0">
+              <a:lnSpc>
+                <a:spcPct val="115000"/>
+              </a:lnSpc>
+              <a:buNone/>
+            </a:pPr>
+            <a:r>
+              <a:rPr lang="en-US" sz="950" dirty="0">
+                <a:solidFill>
+                  <a:srgbClr val="6B7280"/>
+                </a:solidFill>
+                <a:latin typeface="Arial" pitchFamily="34" charset="0"/>
+                <a:ea typeface="Arial" pitchFamily="34" charset="-122"/>
+                <a:cs typeface="Arial" pitchFamily="34" charset="-120"/>
+              </a:rPr>
+              <a:t>SW만 최적</a:t>
             </a:r>
             <a:endParaRPr lang="en-US" sz="1100" dirty="0"/>
           </a:p>
@@ -10251,8 +10297,8 @@
         </p:nvSpPr>
         <p:spPr>
           <a:xfrm>
-            <a:off x="7746797" y="3174797"/>
-            <a:ext cx="3810305" cy="405994"/>
+            <a:off x="8001000" y="3174797"/>
+            <a:ext cx="3556102" cy="405994"/>
           </a:xfrm>
           <a:prstGeom prst="rect">
             <a:avLst/>
@@ -10316,7 +10362,7 @@
                 <a:ea typeface="Arial" pitchFamily="34" charset="-122"/>
                 <a:cs typeface="Arial" pitchFamily="34" charset="-120"/>
               </a:rPr>
-              <a:t>관찰 지점마다 프로브 삽입 · 구조 변경마다 재합성 · 장비 공유</a:t>
+              <a:t>관찰마다 프로브 삽입 · 변경마다 재합성 · 장비 공유</a:t>
             </a:r>
             <a:endParaRPr lang="en-US" sz="1150" dirty="0"/>
           </a:p>
@@ -10452,7 +10498,68 @@
         </p:nvSpPr>
         <p:spPr>
           <a:xfrm>
-            <a:off x="5346497" y="4101998"/>
+            <a:off x="5333695" y="4101998"/>
+            <a:ext cx="1143000" cy="330098"/>
+          </a:xfrm>
+          <a:prstGeom prst="roundRect">
+            <a:avLst>
+              <a:gd name="adj" fmla="val 15512"/>
+            </a:avLst>
+          </a:prstGeom>
+          <a:solidFill>
+            <a:srgbClr val="B3B9C4"/>
+          </a:solidFill>
+          <a:ln/>
+        </p:spPr>
+      </p:sp>
+      <p:sp>
+        <p:nvSpPr>
+          <p:cNvPr id="40" name="Text 37"/>
+          <p:cNvSpPr txBox="1"/>
+          <p:nvPr/>
+        </p:nvSpPr>
+        <p:spPr>
+          <a:xfrm>
+            <a:off x="5333695" y="4101998"/>
+            <a:ext cx="1143000" cy="330098"/>
+          </a:xfrm>
+          <a:prstGeom prst="rect">
+            <a:avLst/>
+          </a:prstGeom>
+          <a:noFill/>
+          <a:ln/>
+        </p:spPr>
+        <p:txBody>
+          <a:bodyPr wrap="square" lIns="0" tIns="0" rIns="0" bIns="0" rtlCol="0" anchor="ctr"/>
+          <a:lstStyle/>
+          <a:p>
+            <a:pPr algn="ctr" indent="0" marL="0">
+              <a:buNone/>
+            </a:pPr>
+            <a:r>
+              <a:rPr lang="en-US" sz="1100" b="1" dirty="0">
+                <a:solidFill>
+                  <a:srgbClr val="FFFFFF"/>
+                </a:solidFill>
+                <a:latin typeface="Arial" pitchFamily="34" charset="0"/>
+                <a:ea typeface="Arial" pitchFamily="34" charset="-122"/>
+                <a:cs typeface="Arial" pitchFamily="34" charset="-120"/>
+              </a:rPr>
+              <a:t>실리콘 최종 검증</a:t>
+            </a:r>
+            <a:endParaRPr lang="en-US" sz="1100" dirty="0"/>
+          </a:p>
+        </p:txBody>
+      </p:sp>
+      <p:sp>
+        <p:nvSpPr>
+          <p:cNvPr id="41" name="Shape 38"/>
+          <p:cNvSpPr/>
+          <p:nvPr/>
+        </p:nvSpPr>
+        <p:spPr>
+          <a:xfrm>
+            <a:off x="6616598" y="4101998"/>
             <a:ext cx="0" cy="330098"/>
           </a:xfrm>
           <a:prstGeom prst="line">
@@ -10469,14 +10576,14 @@
       </p:sp>
       <p:sp>
         <p:nvSpPr>
-          <p:cNvPr id="40" name="Text 37"/>
+          <p:cNvPr id="42" name="Text 39"/>
           <p:cNvSpPr txBox="1"/>
           <p:nvPr/>
         </p:nvSpPr>
         <p:spPr>
           <a:xfrm>
-            <a:off x="5410505" y="4177894"/>
-            <a:ext cx="381305" cy="190195"/>
+            <a:off x="6679692" y="4089197"/>
+            <a:ext cx="952805" cy="381305"/>
           </a:xfrm>
           <a:prstGeom prst="rect">
             <a:avLst/>
@@ -10489,6 +10596,9 @@
           <a:lstStyle/>
           <a:p>
             <a:pPr algn="l" indent="0" marL="0">
+              <a:lnSpc>
+                <a:spcPct val="115000"/>
+              </a:lnSpc>
               <a:buNone/>
             </a:pPr>
             <a:r>
@@ -10504,18 +10614,38 @@
             </a:r>
             <a:endParaRPr lang="en-US" sz="1100" dirty="0"/>
           </a:p>
-        </p:txBody>
-      </p:sp>
-      <p:sp>
-        <p:nvSpPr>
-          <p:cNvPr id="41" name="Text 38"/>
+          <a:p>
+            <a:pPr algn="l" indent="0" marL="0">
+              <a:lnSpc>
+                <a:spcPct val="115000"/>
+              </a:lnSpc>
+              <a:buNone/>
+            </a:pPr>
+            <a:r>
+              <a:rPr lang="en-US" sz="950" b="1" dirty="0">
+                <a:solidFill>
+                  <a:srgbClr val="B8791F"/>
+                </a:solidFill>
+                <a:latin typeface="Arial" pitchFamily="34" charset="0"/>
+                <a:ea typeface="Arial" pitchFamily="34" charset="-122"/>
+                <a:cs typeface="Arial" pitchFamily="34" charset="-120"/>
+              </a:rPr>
+              <a:t>HW+SW 최적</a:t>
+            </a:r>
+            <a:endParaRPr lang="en-US" sz="1100" dirty="0"/>
+          </a:p>
+        </p:txBody>
+      </p:sp>
+      <p:sp>
+        <p:nvSpPr>
+          <p:cNvPr id="43" name="Text 40"/>
           <p:cNvSpPr txBox="1"/>
           <p:nvPr/>
         </p:nvSpPr>
         <p:spPr>
           <a:xfrm>
-            <a:off x="5969203" y="4140403"/>
-            <a:ext cx="3683203" cy="609905"/>
+            <a:off x="7619695" y="4101998"/>
+            <a:ext cx="3936492" cy="609905"/>
           </a:xfrm>
           <a:prstGeom prst="rect">
             <a:avLst/>
@@ -10596,7 +10726,7 @@
                 <a:ea typeface="Arial" pitchFamily="34" charset="-122"/>
                 <a:cs typeface="Arial" pitchFamily="34" charset="-120"/>
               </a:rPr>
-              <a:t>기존 도구는 그대로 — 역할은 </a:t>
+              <a:t>기존 도구는 그대로, 역할은 </a:t>
             </a:r>
             <a:pPr algn="l" indent="0" marL="0">
               <a:lnSpc>
@@ -10625,15 +10755,15 @@
               <a:buNone/>
             </a:pPr>
             <a:r>
-              <a:rPr lang="en-US" sz="1150" dirty="0">
-                <a:solidFill>
-                  <a:srgbClr val="4A5568"/>
-                </a:solidFill>
-                <a:latin typeface="Arial" pitchFamily="34" charset="0"/>
-                <a:ea typeface="Arial" pitchFamily="34" charset="-122"/>
-                <a:cs typeface="Arial" pitchFamily="34" charset="-120"/>
-              </a:rPr>
-              <a:t>실리콘 이후에 남는 일이 줄어 완성이 앞으로</a:t>
+              <a:rPr lang="en-US" sz="1150" b="1" dirty="0">
+                <a:solidFill>
+                  <a:srgbClr val="B8791F"/>
+                </a:solidFill>
+                <a:latin typeface="Arial" pitchFamily="34" charset="0"/>
+                <a:ea typeface="Arial" pitchFamily="34" charset="-122"/>
+                <a:cs typeface="Arial" pitchFamily="34" charset="-120"/>
+              </a:rPr>
+              <a:t>→ 같은 면적에 더 빠르게, 같은 성능에 더 작게</a:t>
             </a:r>
             <a:endParaRPr lang="en-US" sz="1150" dirty="0"/>
           </a:p>
@@ -10641,14 +10771,14 @@
       </p:sp>
       <p:sp>
         <p:nvSpPr>
-          <p:cNvPr id="42" name="Text 39"/>
+          <p:cNvPr id="44" name="Text 41"/>
           <p:cNvSpPr txBox="1"/>
           <p:nvPr/>
         </p:nvSpPr>
         <p:spPr>
           <a:xfrm>
-            <a:off x="9778594" y="4140403"/>
-            <a:ext cx="1777594" cy="381305"/>
+            <a:off x="7619695" y="4839005"/>
+            <a:ext cx="3936492" cy="190195"/>
           </a:xfrm>
           <a:prstGeom prst="rect">
             <a:avLst/>
@@ -10658,6 +10788,111 @@
         </p:spPr>
         <p:txBody>
           <a:bodyPr wrap="square" lIns="0" tIns="0" rIns="0" bIns="0" rtlCol="0" anchor="t"/>
+          <a:lstStyle/>
+          <a:p>
+            <a:pPr algn="l" indent="0" marL="0">
+              <a:buNone/>
+            </a:pPr>
+            <a:r>
+              <a:rPr lang="en-US" sz="1050" dirty="0">
+                <a:solidFill>
+                  <a:srgbClr val="6B7280"/>
+                </a:solidFill>
+                <a:latin typeface="Arial" pitchFamily="34" charset="0"/>
+                <a:ea typeface="Arial" pitchFamily="34" charset="-122"/>
+                <a:cs typeface="Arial" pitchFamily="34" charset="-120"/>
+              </a:rPr>
+              <a:t>가로축 = 시간 (개념도) · 세로 점선 = 실리콘 시점</a:t>
+            </a:r>
+            <a:endParaRPr lang="en-US" sz="1050" dirty="0"/>
+          </a:p>
+        </p:txBody>
+      </p:sp>
+      <p:sp>
+        <p:nvSpPr>
+          <p:cNvPr id="45" name="Shape 42"/>
+          <p:cNvSpPr/>
+          <p:nvPr/>
+        </p:nvSpPr>
+        <p:spPr>
+          <a:xfrm>
+            <a:off x="508406" y="5397703"/>
+            <a:ext cx="3606394" cy="571500"/>
+          </a:xfrm>
+          <a:prstGeom prst="roundRect">
+            <a:avLst>
+              <a:gd name="adj" fmla="val 13280"/>
+            </a:avLst>
+          </a:prstGeom>
+          <a:solidFill>
+            <a:srgbClr val="F2F4F7"/>
+          </a:solidFill>
+          <a:ln w="12700">
+            <a:solidFill>
+              <a:srgbClr val="D9DEE6"/>
+            </a:solidFill>
+            <a:prstDash val="solid"/>
+          </a:ln>
+        </p:spPr>
+      </p:sp>
+      <p:sp>
+        <p:nvSpPr>
+          <p:cNvPr id="46" name="Text 43"/>
+          <p:cNvSpPr txBox="1"/>
+          <p:nvPr/>
+        </p:nvSpPr>
+        <p:spPr>
+          <a:xfrm>
+            <a:off x="660197" y="5397703"/>
+            <a:ext cx="279806" cy="571500"/>
+          </a:xfrm>
+          <a:prstGeom prst="rect">
+            <a:avLst/>
+          </a:prstGeom>
+          <a:noFill/>
+          <a:ln/>
+        </p:spPr>
+        <p:txBody>
+          <a:bodyPr wrap="square" lIns="0" tIns="0" rIns="0" bIns="0" rtlCol="0" anchor="ctr"/>
+          <a:lstStyle/>
+          <a:p>
+            <a:pPr algn="l" indent="0" marL="0">
+              <a:buNone/>
+            </a:pPr>
+            <a:r>
+              <a:rPr lang="en-US" sz="1700" dirty="0">
+                <a:solidFill>
+                  <a:srgbClr val="1F7F7A"/>
+                </a:solidFill>
+                <a:latin typeface="Arial" pitchFamily="34" charset="0"/>
+                <a:ea typeface="Arial" pitchFamily="34" charset="-122"/>
+                <a:cs typeface="Arial" pitchFamily="34" charset="-120"/>
+              </a:rPr>
+              <a:t>»</a:t>
+            </a:r>
+            <a:endParaRPr lang="en-US" sz="1700" dirty="0"/>
+          </a:p>
+        </p:txBody>
+      </p:sp>
+      <p:sp>
+        <p:nvSpPr>
+          <p:cNvPr id="47" name="Text 44"/>
+          <p:cNvSpPr txBox="1"/>
+          <p:nvPr/>
+        </p:nvSpPr>
+        <p:spPr>
+          <a:xfrm>
+            <a:off x="990295" y="5397703"/>
+            <a:ext cx="2971800" cy="571500"/>
+          </a:xfrm>
+          <a:prstGeom prst="rect">
+            <a:avLst/>
+          </a:prstGeom>
+          <a:noFill/>
+          <a:ln/>
+        </p:spPr>
+        <p:txBody>
+          <a:bodyPr wrap="square" lIns="0" tIns="0" rIns="0" bIns="0" rtlCol="0" anchor="ctr"/>
           <a:lstStyle/>
           <a:p>
             <a:pPr algn="l" indent="0" marL="0">
@@ -10667,18 +10902,106 @@
               <a:buNone/>
             </a:pPr>
             <a:r>
-              <a:rPr lang="en-US" sz="1050" dirty="0">
-                <a:solidFill>
-                  <a:srgbClr val="6B7280"/>
-                </a:solidFill>
-                <a:latin typeface="Arial" pitchFamily="34" charset="0"/>
-                <a:ea typeface="Arial" pitchFamily="34" charset="-122"/>
-                <a:cs typeface="Arial" pitchFamily="34" charset="-120"/>
-              </a:rPr>
-              <a:t>가로축 = 시간 (개념도)</a:t>
-            </a:r>
-            <a:endParaRPr lang="en-US" sz="1050" dirty="0"/>
-          </a:p>
+              <a:rPr lang="en-US" sz="1250" dirty="0">
+                <a:solidFill>
+                  <a:srgbClr val="0F1B2D"/>
+                </a:solidFill>
+                <a:latin typeface="Arial" pitchFamily="34" charset="0"/>
+                <a:ea typeface="Arial" pitchFamily="34" charset="-122"/>
+                <a:cs typeface="Arial" pitchFamily="34" charset="-120"/>
+              </a:rPr>
+              <a:t>TAT는 계속 줄고, AI가 개발 속도를 한 번 더 끌어올리는 중</a:t>
+            </a:r>
+            <a:endParaRPr lang="en-US" sz="1250" dirty="0"/>
+          </a:p>
+        </p:txBody>
+      </p:sp>
+      <p:sp>
+        <p:nvSpPr>
+          <p:cNvPr id="48" name="Shape 45"/>
+          <p:cNvSpPr/>
+          <p:nvPr/>
+        </p:nvSpPr>
+        <p:spPr>
+          <a:xfrm>
+            <a:off x="4292194" y="5397703"/>
+            <a:ext cx="3606394" cy="571500"/>
+          </a:xfrm>
+          <a:prstGeom prst="roundRect">
+            <a:avLst>
+              <a:gd name="adj" fmla="val 13280"/>
+            </a:avLst>
+          </a:prstGeom>
+          <a:solidFill>
+            <a:srgbClr val="F2F4F7"/>
+          </a:solidFill>
+          <a:ln w="12700">
+            <a:solidFill>
+              <a:srgbClr val="D9DEE6"/>
+            </a:solidFill>
+            <a:prstDash val="solid"/>
+          </a:ln>
+        </p:spPr>
+      </p:sp>
+      <p:sp>
+        <p:nvSpPr>
+          <p:cNvPr id="49" name="Text 46"/>
+          <p:cNvSpPr txBox="1"/>
+          <p:nvPr/>
+        </p:nvSpPr>
+        <p:spPr>
+          <a:xfrm>
+            <a:off x="4444898" y="5397703"/>
+            <a:ext cx="279806" cy="571500"/>
+          </a:xfrm>
+          <a:prstGeom prst="rect">
+            <a:avLst/>
+          </a:prstGeom>
+          <a:noFill/>
+          <a:ln/>
+        </p:spPr>
+        <p:txBody>
+          <a:bodyPr wrap="square" lIns="0" tIns="0" rIns="0" bIns="0" rtlCol="0" anchor="ctr"/>
+          <a:lstStyle/>
+          <a:p>
+            <a:pPr algn="l" indent="0" marL="0">
+              <a:buNone/>
+            </a:pPr>
+            <a:r>
+              <a:rPr lang="en-US" sz="1700" dirty="0">
+                <a:solidFill>
+                  <a:srgbClr val="1F7F7A"/>
+                </a:solidFill>
+                <a:latin typeface="Arial" pitchFamily="34" charset="0"/>
+                <a:ea typeface="Arial" pitchFamily="34" charset="-122"/>
+                <a:cs typeface="Arial" pitchFamily="34" charset="-120"/>
+              </a:rPr>
+              <a:t>○</a:t>
+            </a:r>
+            <a:endParaRPr lang="en-US" sz="1700" dirty="0"/>
+          </a:p>
+        </p:txBody>
+      </p:sp>
+      <p:sp>
+        <p:nvSpPr>
+          <p:cNvPr id="50" name="Text 47"/>
+          <p:cNvSpPr txBox="1"/>
+          <p:nvPr/>
+        </p:nvSpPr>
+        <p:spPr>
+          <a:xfrm>
+            <a:off x="4774997" y="5397703"/>
+            <a:ext cx="2971800" cy="571500"/>
+          </a:xfrm>
+          <a:prstGeom prst="rect">
+            <a:avLst/>
+          </a:prstGeom>
+          <a:noFill/>
+          <a:ln/>
+        </p:spPr>
+        <p:txBody>
+          <a:bodyPr wrap="square" lIns="0" tIns="0" rIns="0" bIns="0" rtlCol="0" anchor="ctr"/>
+          <a:lstStyle/>
           <a:p>
             <a:pPr algn="l" indent="0" marL="0">
               <a:lnSpc>
@@ -10687,29 +11010,29 @@
               <a:buNone/>
             </a:pPr>
             <a:r>
-              <a:rPr lang="en-US" sz="1050" dirty="0">
-                <a:solidFill>
-                  <a:srgbClr val="6B7280"/>
-                </a:solidFill>
-                <a:latin typeface="Arial" pitchFamily="34" charset="0"/>
-                <a:ea typeface="Arial" pitchFamily="34" charset="-122"/>
-                <a:cs typeface="Arial" pitchFamily="34" charset="-120"/>
-              </a:rPr>
-              <a:t>세로 점선 = 실리콘 시점</a:t>
-            </a:r>
-            <a:endParaRPr lang="en-US" sz="1050" dirty="0"/>
-          </a:p>
-        </p:txBody>
-      </p:sp>
-      <p:sp>
-        <p:nvSpPr>
-          <p:cNvPr id="43" name="Shape 40"/>
-          <p:cNvSpPr/>
-          <p:nvPr/>
-        </p:nvSpPr>
-        <p:spPr>
-          <a:xfrm>
-            <a:off x="508406" y="5397703"/>
+              <a:rPr lang="en-US" sz="1250" dirty="0">
+                <a:solidFill>
+                  <a:srgbClr val="0F1B2D"/>
+                </a:solidFill>
+                <a:latin typeface="Arial" pitchFamily="34" charset="0"/>
+                <a:ea typeface="Arial" pitchFamily="34" charset="-122"/>
+                <a:cs typeface="Arial" pitchFamily="34" charset="-120"/>
+              </a:rPr>
+              <a:t>FPGA·에뮬레이터도 안을 볼 수는 있지만, 보고 바꾸는 반복이 느리다</a:t>
+            </a:r>
+            <a:endParaRPr lang="en-US" sz="1250" dirty="0"/>
+          </a:p>
+        </p:txBody>
+      </p:sp>
+      <p:sp>
+        <p:nvSpPr>
+          <p:cNvPr id="51" name="Shape 48"/>
+          <p:cNvSpPr/>
+          <p:nvPr/>
+        </p:nvSpPr>
+        <p:spPr>
+          <a:xfrm>
+            <a:off x="8076895" y="5397703"/>
             <a:ext cx="3606394" cy="571500"/>
           </a:xfrm>
           <a:prstGeom prst="roundRect">
@@ -10718,11 +11041,11 @@
             </a:avLst>
           </a:prstGeom>
           <a:solidFill>
-            <a:srgbClr val="F7F6F1"/>
+            <a:srgbClr val="F2F4F7"/>
           </a:solidFill>
           <a:ln w="12700">
             <a:solidFill>
-              <a:srgbClr val="DDD9CC"/>
+              <a:srgbClr val="D9DEE6"/>
             </a:solidFill>
             <a:prstDash val="solid"/>
           </a:ln>
@@ -10730,223 +11053,7 @@
       </p:sp>
       <p:sp>
         <p:nvSpPr>
-          <p:cNvPr id="44" name="Text 41"/>
-          <p:cNvSpPr txBox="1"/>
-          <p:nvPr/>
-        </p:nvSpPr>
-        <p:spPr>
-          <a:xfrm>
-            <a:off x="660197" y="5397703"/>
-            <a:ext cx="279806" cy="571500"/>
-          </a:xfrm>
-          <a:prstGeom prst="rect">
-            <a:avLst/>
-          </a:prstGeom>
-          <a:noFill/>
-          <a:ln/>
-        </p:spPr>
-        <p:txBody>
-          <a:bodyPr wrap="square" lIns="0" tIns="0" rIns="0" bIns="0" rtlCol="0" anchor="ctr"/>
-          <a:lstStyle/>
-          <a:p>
-            <a:pPr algn="l" indent="0" marL="0">
-              <a:buNone/>
-            </a:pPr>
-            <a:r>
-              <a:rPr lang="en-US" sz="1700" dirty="0">
-                <a:solidFill>
-                  <a:srgbClr val="1F7F7A"/>
-                </a:solidFill>
-                <a:latin typeface="Arial" pitchFamily="34" charset="0"/>
-                <a:ea typeface="Arial" pitchFamily="34" charset="-122"/>
-                <a:cs typeface="Arial" pitchFamily="34" charset="-120"/>
-              </a:rPr>
-              <a:t>»</a:t>
-            </a:r>
-            <a:endParaRPr lang="en-US" sz="1700" dirty="0"/>
-          </a:p>
-        </p:txBody>
-      </p:sp>
-      <p:sp>
-        <p:nvSpPr>
-          <p:cNvPr id="45" name="Text 42"/>
-          <p:cNvSpPr txBox="1"/>
-          <p:nvPr/>
-        </p:nvSpPr>
-        <p:spPr>
-          <a:xfrm>
-            <a:off x="990295" y="5397703"/>
-            <a:ext cx="2971800" cy="571500"/>
-          </a:xfrm>
-          <a:prstGeom prst="rect">
-            <a:avLst/>
-          </a:prstGeom>
-          <a:noFill/>
-          <a:ln/>
-        </p:spPr>
-        <p:txBody>
-          <a:bodyPr wrap="square" lIns="0" tIns="0" rIns="0" bIns="0" rtlCol="0" anchor="ctr"/>
-          <a:lstStyle/>
-          <a:p>
-            <a:pPr algn="l" indent="0" marL="0">
-              <a:lnSpc>
-                <a:spcPct val="130000"/>
-              </a:lnSpc>
-              <a:buNone/>
-            </a:pPr>
-            <a:r>
-              <a:rPr lang="en-US" sz="1250" dirty="0">
-                <a:solidFill>
-                  <a:srgbClr val="0F1B2D"/>
-                </a:solidFill>
-                <a:latin typeface="Arial" pitchFamily="34" charset="0"/>
-                <a:ea typeface="Arial" pitchFamily="34" charset="-122"/>
-                <a:cs typeface="Arial" pitchFamily="34" charset="-120"/>
-              </a:rPr>
-              <a:t>TAT는 계속 줄고, AI가 개발 속도를 한 번 더 끌어올리는 중</a:t>
-            </a:r>
-            <a:endParaRPr lang="en-US" sz="1250" dirty="0"/>
-          </a:p>
-        </p:txBody>
-      </p:sp>
-      <p:sp>
-        <p:nvSpPr>
-          <p:cNvPr id="46" name="Shape 43"/>
-          <p:cNvSpPr/>
-          <p:nvPr/>
-        </p:nvSpPr>
-        <p:spPr>
-          <a:xfrm>
-            <a:off x="4292194" y="5397703"/>
-            <a:ext cx="3606394" cy="571500"/>
-          </a:xfrm>
-          <a:prstGeom prst="roundRect">
-            <a:avLst>
-              <a:gd name="adj" fmla="val 13280"/>
-            </a:avLst>
-          </a:prstGeom>
-          <a:solidFill>
-            <a:srgbClr val="F7F6F1"/>
-          </a:solidFill>
-          <a:ln w="12700">
-            <a:solidFill>
-              <a:srgbClr val="DDD9CC"/>
-            </a:solidFill>
-            <a:prstDash val="solid"/>
-          </a:ln>
-        </p:spPr>
-      </p:sp>
-      <p:sp>
-        <p:nvSpPr>
-          <p:cNvPr id="47" name="Text 44"/>
-          <p:cNvSpPr txBox="1"/>
-          <p:nvPr/>
-        </p:nvSpPr>
-        <p:spPr>
-          <a:xfrm>
-            <a:off x="4444898" y="5397703"/>
-            <a:ext cx="279806" cy="571500"/>
-          </a:xfrm>
-          <a:prstGeom prst="rect">
-            <a:avLst/>
-          </a:prstGeom>
-          <a:noFill/>
-          <a:ln/>
-        </p:spPr>
-        <p:txBody>
-          <a:bodyPr wrap="square" lIns="0" tIns="0" rIns="0" bIns="0" rtlCol="0" anchor="ctr"/>
-          <a:lstStyle/>
-          <a:p>
-            <a:pPr algn="l" indent="0" marL="0">
-              <a:buNone/>
-            </a:pPr>
-            <a:r>
-              <a:rPr lang="en-US" sz="1700" dirty="0">
-                <a:solidFill>
-                  <a:srgbClr val="1F7F7A"/>
-                </a:solidFill>
-                <a:latin typeface="Arial" pitchFamily="34" charset="0"/>
-                <a:ea typeface="Arial" pitchFamily="34" charset="-122"/>
-                <a:cs typeface="Arial" pitchFamily="34" charset="-120"/>
-              </a:rPr>
-              <a:t>○</a:t>
-            </a:r>
-            <a:endParaRPr lang="en-US" sz="1700" dirty="0"/>
-          </a:p>
-        </p:txBody>
-      </p:sp>
-      <p:sp>
-        <p:nvSpPr>
-          <p:cNvPr id="48" name="Text 45"/>
-          <p:cNvSpPr txBox="1"/>
-          <p:nvPr/>
-        </p:nvSpPr>
-        <p:spPr>
-          <a:xfrm>
-            <a:off x="4774997" y="5397703"/>
-            <a:ext cx="2971800" cy="571500"/>
-          </a:xfrm>
-          <a:prstGeom prst="rect">
-            <a:avLst/>
-          </a:prstGeom>
-          <a:noFill/>
-          <a:ln/>
-        </p:spPr>
-        <p:txBody>
-          <a:bodyPr wrap="square" lIns="0" tIns="0" rIns="0" bIns="0" rtlCol="0" anchor="ctr"/>
-          <a:lstStyle/>
-          <a:p>
-            <a:pPr algn="l" indent="0" marL="0">
-              <a:lnSpc>
-                <a:spcPct val="130000"/>
-              </a:lnSpc>
-              <a:buNone/>
-            </a:pPr>
-            <a:r>
-              <a:rPr lang="en-US" sz="1250" dirty="0">
-                <a:solidFill>
-                  <a:srgbClr val="0F1B2D"/>
-                </a:solidFill>
-                <a:latin typeface="Arial" pitchFamily="34" charset="0"/>
-                <a:ea typeface="Arial" pitchFamily="34" charset="-122"/>
-                <a:cs typeface="Arial" pitchFamily="34" charset="-120"/>
-              </a:rPr>
-              <a:t>FPGA·에뮬레이터도 안을 볼 수는 있지만, 보고 바꾸는 반복이 느리다</a:t>
-            </a:r>
-            <a:endParaRPr lang="en-US" sz="1250" dirty="0"/>
-          </a:p>
-        </p:txBody>
-      </p:sp>
-      <p:sp>
-        <p:nvSpPr>
-          <p:cNvPr id="49" name="Shape 46"/>
-          <p:cNvSpPr/>
-          <p:nvPr/>
-        </p:nvSpPr>
-        <p:spPr>
-          <a:xfrm>
-            <a:off x="8076895" y="5397703"/>
-            <a:ext cx="3606394" cy="571500"/>
-          </a:xfrm>
-          <a:prstGeom prst="roundRect">
-            <a:avLst>
-              <a:gd name="adj" fmla="val 13280"/>
-            </a:avLst>
-          </a:prstGeom>
-          <a:solidFill>
-            <a:srgbClr val="F7F6F1"/>
-          </a:solidFill>
-          <a:ln w="12700">
-            <a:solidFill>
-              <a:srgbClr val="DDD9CC"/>
-            </a:solidFill>
-            <a:prstDash val="solid"/>
-          </a:ln>
-        </p:spPr>
-      </p:sp>
-      <p:sp>
-        <p:nvSpPr>
-          <p:cNvPr id="50" name="Text 47"/>
+          <p:cNvPr id="52" name="Text 49"/>
           <p:cNvSpPr txBox="1"/>
           <p:nvPr/>
         </p:nvSpPr>
@@ -10985,7 +11092,7 @@
       </p:sp>
       <p:sp>
         <p:nvSpPr>
-          <p:cNvPr id="51" name="Text 48"/>
+          <p:cNvPr id="53" name="Text 50"/>
           <p:cNvSpPr txBox="1"/>
           <p:nvPr/>
         </p:nvSpPr>
@@ -11195,11 +11302,11 @@
             </a:avLst>
           </a:prstGeom>
           <a:solidFill>
-            <a:srgbClr val="F7F6F1"/>
+            <a:srgbClr val="F2F4F7"/>
           </a:solidFill>
           <a:ln w="12700">
             <a:solidFill>
-              <a:srgbClr val="DDD9CC"/>
+              <a:srgbClr val="D9DEE6"/>
             </a:solidFill>
             <a:prstDash val="solid"/>
           </a:ln>
@@ -11222,7 +11329,7 @@
           <a:noFill/>
           <a:ln w="31750">
             <a:solidFill>
-              <a:srgbClr val="B8B4A8"/>
+              <a:srgbClr val="B3B9C4"/>
             </a:solidFill>
             <a:prstDash val="solid"/>
             <a:tailEnd type="triangle"/>
@@ -11246,7 +11353,7 @@
           <a:noFill/>
           <a:ln w="31750">
             <a:solidFill>
-              <a:srgbClr val="B8B4A8"/>
+              <a:srgbClr val="B3B9C4"/>
             </a:solidFill>
             <a:prstDash val="solid"/>
             <a:tailEnd type="triangle"/>
@@ -15752,11 +15859,11 @@
             </a:avLst>
           </a:prstGeom>
           <a:solidFill>
-            <a:srgbClr val="F7F6F1"/>
+            <a:srgbClr val="F2F4F7"/>
           </a:solidFill>
           <a:ln w="12700">
             <a:solidFill>
-              <a:srgbClr val="DDD9CC"/>
+              <a:srgbClr val="D9DEE6"/>
             </a:solidFill>
             <a:prstDash val="solid"/>
           </a:ln>
@@ -15880,11 +15987,11 @@
             </a:avLst>
           </a:prstGeom>
           <a:solidFill>
-            <a:srgbClr val="F7F6F1"/>
+            <a:srgbClr val="F2F4F7"/>
           </a:solidFill>
           <a:ln w="12700">
             <a:solidFill>
-              <a:srgbClr val="DDD9CC"/>
+              <a:srgbClr val="D9DEE6"/>
             </a:solidFill>
             <a:prstDash val="solid"/>
           </a:ln>
@@ -16008,11 +16115,11 @@
             </a:avLst>
           </a:prstGeom>
           <a:solidFill>
-            <a:srgbClr val="F7F6F1"/>
+            <a:srgbClr val="F2F4F7"/>
           </a:solidFill>
           <a:ln w="12700">
             <a:solidFill>
-              <a:srgbClr val="DDD9CC"/>
+              <a:srgbClr val="D9DEE6"/>
             </a:solidFill>
             <a:prstDash val="solid"/>
           </a:ln>
@@ -16136,11 +16243,11 @@
             </a:avLst>
           </a:prstGeom>
           <a:solidFill>
-            <a:srgbClr val="F7F6F1"/>
+            <a:srgbClr val="F2F4F7"/>
           </a:solidFill>
           <a:ln w="12700">
             <a:solidFill>
-              <a:srgbClr val="DDD9CC"/>
+              <a:srgbClr val="D9DEE6"/>
             </a:solidFill>
             <a:prstDash val="solid"/>
           </a:ln>
@@ -16436,7 +16543,7 @@
             </a:avLst>
           </a:prstGeom>
           <a:solidFill>
-            <a:srgbClr val="F7F6F1"/>
+            <a:srgbClr val="F2F4F7"/>
           </a:solidFill>
           <a:ln w="38100">
             <a:solidFill>
@@ -16623,7 +16730,7 @@
             </a:avLst>
           </a:prstGeom>
           <a:solidFill>
-            <a:srgbClr val="F7F6F1"/>
+            <a:srgbClr val="F2F4F7"/>
           </a:solidFill>
           <a:ln w="38100">
             <a:solidFill>
@@ -16810,7 +16917,7 @@
             </a:avLst>
           </a:prstGeom>
           <a:solidFill>
-            <a:srgbClr val="F7F6F1"/>
+            <a:srgbClr val="F2F4F7"/>
           </a:solidFill>
           <a:ln w="38100">
             <a:solidFill>
@@ -17148,11 +17255,11 @@
             </a:avLst>
           </a:prstGeom>
           <a:solidFill>
-            <a:srgbClr val="F7F6F1"/>
+            <a:srgbClr val="F2F4F7"/>
           </a:solidFill>
           <a:ln w="12700">
             <a:solidFill>
-              <a:srgbClr val="DDD9CC"/>
+              <a:srgbClr val="D9DEE6"/>
             </a:solidFill>
             <a:prstDash val="solid"/>
           </a:ln>
@@ -17256,11 +17363,11 @@
             </a:avLst>
           </a:prstGeom>
           <a:solidFill>
-            <a:srgbClr val="F7F6F1"/>
+            <a:srgbClr val="F2F4F7"/>
           </a:solidFill>
           <a:ln w="12700">
             <a:solidFill>
-              <a:srgbClr val="DDD9CC"/>
+              <a:srgbClr val="D9DEE6"/>
             </a:solidFill>
             <a:prstDash val="solid"/>
           </a:ln>
@@ -17791,11 +17898,11 @@
             </a:avLst>
           </a:prstGeom>
           <a:solidFill>
-            <a:srgbClr val="F7F6F1"/>
+            <a:srgbClr val="F2F4F7"/>
           </a:solidFill>
           <a:ln w="12700">
             <a:solidFill>
-              <a:srgbClr val="DDD9CC"/>
+              <a:srgbClr val="D9DEE6"/>
             </a:solidFill>
             <a:prstDash val="solid"/>
           </a:ln>
@@ -17874,11 +17981,11 @@
             </a:avLst>
           </a:prstGeom>
           <a:solidFill>
-            <a:srgbClr val="F7F6F1"/>
+            <a:srgbClr val="F2F4F7"/>
           </a:solidFill>
           <a:ln w="12700">
             <a:solidFill>
-              <a:srgbClr val="DDD9CC"/>
+              <a:srgbClr val="D9DEE6"/>
             </a:solidFill>
             <a:prstDash val="solid"/>
           </a:ln>
@@ -18069,11 +18176,11 @@
             </a:avLst>
           </a:prstGeom>
           <a:solidFill>
-            <a:srgbClr val="F7F6F1"/>
+            <a:srgbClr val="F2F4F7"/>
           </a:solidFill>
           <a:ln w="12700">
             <a:solidFill>
-              <a:srgbClr val="DDD9CC"/>
+              <a:srgbClr val="D9DEE6"/>
             </a:solidFill>
             <a:prstDash val="solid"/>
           </a:ln>
@@ -18177,11 +18284,11 @@
             </a:avLst>
           </a:prstGeom>
           <a:solidFill>
-            <a:srgbClr val="F7F6F1"/>
+            <a:srgbClr val="F2F4F7"/>
           </a:solidFill>
           <a:ln w="12700">
             <a:solidFill>
-              <a:srgbClr val="DDD9CC"/>
+              <a:srgbClr val="D9DEE6"/>
             </a:solidFill>
             <a:prstDash val="solid"/>
           </a:ln>
@@ -18285,11 +18392,11 @@
             </a:avLst>
           </a:prstGeom>
           <a:solidFill>
-            <a:srgbClr val="F7F6F1"/>
+            <a:srgbClr val="F2F4F7"/>
           </a:solidFill>
           <a:ln w="12700">
             <a:solidFill>
-              <a:srgbClr val="DDD9CC"/>
+              <a:srgbClr val="D9DEE6"/>
             </a:solidFill>
             <a:prstDash val="solid"/>
           </a:ln>
@@ -18526,11 +18633,11 @@
             </a:avLst>
           </a:prstGeom>
           <a:solidFill>
-            <a:srgbClr val="F7F6F1"/>
+            <a:srgbClr val="F2F4F7"/>
           </a:solidFill>
           <a:ln w="12700">
             <a:solidFill>
-              <a:srgbClr val="DDD9CC"/>
+              <a:srgbClr val="D9DEE6"/>
             </a:solidFill>
             <a:prstDash val="solid"/>
           </a:ln>
@@ -18592,7 +18699,7 @@
           <a:noFill/>
           <a:ln w="38100">
             <a:solidFill>
-              <a:srgbClr val="B8B4A8"/>
+              <a:srgbClr val="B3B9C4"/>
             </a:solidFill>
             <a:prstDash val="solid"/>
           </a:ln>
@@ -18615,11 +18722,11 @@
             </a:avLst>
           </a:prstGeom>
           <a:solidFill>
-            <a:srgbClr val="F7F6F1"/>
+            <a:srgbClr val="F2F4F7"/>
           </a:solidFill>
           <a:ln w="12700">
             <a:solidFill>
-              <a:srgbClr val="DDD9CC"/>
+              <a:srgbClr val="D9DEE6"/>
             </a:solidFill>
             <a:prstDash val="solid"/>
           </a:ln>
@@ -18681,7 +18788,7 @@
           <a:noFill/>
           <a:ln w="38100">
             <a:solidFill>
-              <a:srgbClr val="B8B4A8"/>
+              <a:srgbClr val="B3B9C4"/>
             </a:solidFill>
             <a:prstDash val="solid"/>
           </a:ln>
@@ -18704,11 +18811,11 @@
             </a:avLst>
           </a:prstGeom>
           <a:solidFill>
-            <a:srgbClr val="F7F6F1"/>
+            <a:srgbClr val="F2F4F7"/>
           </a:solidFill>
           <a:ln w="12700">
             <a:solidFill>
-              <a:srgbClr val="DDD9CC"/>
+              <a:srgbClr val="D9DEE6"/>
             </a:solidFill>
             <a:prstDash val="solid"/>
           </a:ln>
@@ -18770,7 +18877,7 @@
           <a:noFill/>
           <a:ln w="38100">
             <a:solidFill>
-              <a:srgbClr val="B8B4A8"/>
+              <a:srgbClr val="B3B9C4"/>
             </a:solidFill>
             <a:prstDash val="solid"/>
           </a:ln>
@@ -18793,11 +18900,11 @@
             </a:avLst>
           </a:prstGeom>
           <a:solidFill>
-            <a:srgbClr val="F7F6F1"/>
+            <a:srgbClr val="F2F4F7"/>
           </a:solidFill>
           <a:ln w="12700">
             <a:solidFill>
-              <a:srgbClr val="DDD9CC"/>
+              <a:srgbClr val="D9DEE6"/>
             </a:solidFill>
             <a:prstDash val="solid"/>
           </a:ln>
@@ -18859,7 +18966,7 @@
           <a:noFill/>
           <a:ln w="38100">
             <a:solidFill>
-              <a:srgbClr val="B8B4A8"/>
+              <a:srgbClr val="B3B9C4"/>
             </a:solidFill>
             <a:prstDash val="solid"/>
           </a:ln>
@@ -19886,11 +19993,11 @@
             </a:avLst>
           </a:prstGeom>
           <a:solidFill>
-            <a:srgbClr val="F7F6F1"/>
+            <a:srgbClr val="F2F4F7"/>
           </a:solidFill>
           <a:ln w="12700">
             <a:solidFill>
-              <a:srgbClr val="DDD9CC"/>
+              <a:srgbClr val="D9DEE6"/>
             </a:solidFill>
             <a:prstDash val="solid"/>
           </a:ln>
@@ -19994,11 +20101,11 @@
             </a:avLst>
           </a:prstGeom>
           <a:solidFill>
-            <a:srgbClr val="F7F6F1"/>
+            <a:srgbClr val="F2F4F7"/>
           </a:solidFill>
           <a:ln w="12700">
             <a:solidFill>
-              <a:srgbClr val="DDD9CC"/>
+              <a:srgbClr val="D9DEE6"/>
             </a:solidFill>
             <a:prstDash val="solid"/>
           </a:ln>
@@ -20235,11 +20342,11 @@
             </a:avLst>
           </a:prstGeom>
           <a:solidFill>
-            <a:srgbClr val="F7F6F1"/>
+            <a:srgbClr val="F2F4F7"/>
           </a:solidFill>
           <a:ln w="12700">
             <a:solidFill>
-              <a:srgbClr val="DDD9CC"/>
+              <a:srgbClr val="D9DEE6"/>
             </a:solidFill>
             <a:prstDash val="solid"/>
           </a:ln>
@@ -21417,11 +21524,11 @@
             </a:avLst>
           </a:prstGeom>
           <a:solidFill>
-            <a:srgbClr val="F7F6F1"/>
+            <a:srgbClr val="F2F4F7"/>
           </a:solidFill>
           <a:ln w="12700">
             <a:solidFill>
-              <a:srgbClr val="DDD9CC"/>
+              <a:srgbClr val="D9DEE6"/>
             </a:solidFill>
             <a:prstDash val="solid"/>
           </a:ln>
@@ -21526,11 +21633,11 @@
             </a:avLst>
           </a:prstGeom>
           <a:solidFill>
-            <a:srgbClr val="F7F6F1"/>
+            <a:srgbClr val="F2F4F7"/>
           </a:solidFill>
           <a:ln w="12700">
             <a:solidFill>
-              <a:srgbClr val="DDD9CC"/>
+              <a:srgbClr val="D9DEE6"/>
             </a:solidFill>
             <a:prstDash val="solid"/>
           </a:ln>
@@ -21635,11 +21742,11 @@
             </a:avLst>
           </a:prstGeom>
           <a:solidFill>
-            <a:srgbClr val="F7F6F1"/>
+            <a:srgbClr val="F2F4F7"/>
           </a:solidFill>
           <a:ln w="12700">
             <a:solidFill>
-              <a:srgbClr val="DDD9CC"/>
+              <a:srgbClr val="D9DEE6"/>
             </a:solidFill>
             <a:prstDash val="solid"/>
           </a:ln>
@@ -21948,11 +22055,11 @@
             </a:avLst>
           </a:prstGeom>
           <a:solidFill>
-            <a:srgbClr val="F7F6F1"/>
+            <a:srgbClr val="F2F4F7"/>
           </a:solidFill>
           <a:ln w="12700">
             <a:solidFill>
-              <a:srgbClr val="DDD9CC"/>
+              <a:srgbClr val="D9DEE6"/>
             </a:solidFill>
             <a:prstDash val="solid"/>
           </a:ln>
@@ -22048,11 +22155,11 @@
             </a:avLst>
           </a:prstGeom>
           <a:solidFill>
-            <a:srgbClr val="F7F6F1"/>
+            <a:srgbClr val="F2F4F7"/>
           </a:solidFill>
           <a:ln w="12700">
             <a:solidFill>
-              <a:srgbClr val="DDD9CC"/>
+              <a:srgbClr val="D9DEE6"/>
             </a:solidFill>
             <a:prstDash val="solid"/>
           </a:ln>
@@ -22148,11 +22255,11 @@
             </a:avLst>
           </a:prstGeom>
           <a:solidFill>
-            <a:srgbClr val="F7F6F1"/>
+            <a:srgbClr val="F2F4F7"/>
           </a:solidFill>
           <a:ln w="12700">
             <a:solidFill>
-              <a:srgbClr val="DDD9CC"/>
+              <a:srgbClr val="D9DEE6"/>
             </a:solidFill>
             <a:prstDash val="solid"/>
           </a:ln>

</xml_diff>

<commit_message>
Presentation: PoC architecture diagram (CM4/TCM/I-cache/DMA/MAC over AHB matrix, knob markers); readable WaveScope waveform in PPTX
Co-Authored-By: Claude Fable 5.1 <noreply@anthropic.com>
Claude-Session: https://claude.ai/code/session_01Gd73gUzQvBcmrEGA3YWYHu
</commit_message>
<xml_diff>
--- a/docs/presentation/deck_basic_fonts.pptx
+++ b/docs/presentation/deck_basic_fonts.pptx
@@ -18996,497 +18996,14 @@
       </p:sp>
       <p:sp>
         <p:nvSpPr>
-          <p:cNvPr id="19" name="Shape 16"/>
-          <p:cNvSpPr/>
-          <p:nvPr/>
-        </p:nvSpPr>
-        <p:spPr>
-          <a:xfrm>
-            <a:off x="3873398" y="2825496"/>
-            <a:ext cx="202997" cy="0"/>
-          </a:xfrm>
-          <a:prstGeom prst="line">
-            <a:avLst/>
-          </a:prstGeom>
-          <a:noFill/>
-          <a:ln w="31750">
-            <a:solidFill>
-              <a:srgbClr val="8FA3B8"/>
-            </a:solidFill>
-            <a:prstDash val="solid"/>
-          </a:ln>
-        </p:spPr>
-      </p:sp>
-      <p:sp>
-        <p:nvSpPr>
-          <p:cNvPr id="20" name="Shape 17"/>
-          <p:cNvSpPr/>
-          <p:nvPr/>
-        </p:nvSpPr>
-        <p:spPr>
-          <a:xfrm>
-            <a:off x="4076395" y="2736799"/>
-            <a:ext cx="202997" cy="0"/>
-          </a:xfrm>
-          <a:prstGeom prst="line">
-            <a:avLst/>
-          </a:prstGeom>
-          <a:noFill/>
-          <a:ln w="31750">
-            <a:solidFill>
-              <a:srgbClr val="8FA3B8"/>
-            </a:solidFill>
-            <a:prstDash val="solid"/>
-          </a:ln>
-        </p:spPr>
-      </p:sp>
-      <p:sp>
-        <p:nvSpPr>
-          <p:cNvPr id="21" name="Shape 18"/>
-          <p:cNvSpPr/>
-          <p:nvPr/>
-        </p:nvSpPr>
-        <p:spPr>
-          <a:xfrm>
-            <a:off x="4279392" y="2825496"/>
-            <a:ext cx="202997" cy="0"/>
-          </a:xfrm>
-          <a:prstGeom prst="line">
-            <a:avLst/>
-          </a:prstGeom>
-          <a:noFill/>
-          <a:ln w="31750">
-            <a:solidFill>
-              <a:srgbClr val="8FA3B8"/>
-            </a:solidFill>
-            <a:prstDash val="solid"/>
-          </a:ln>
-        </p:spPr>
-      </p:sp>
-      <p:sp>
-        <p:nvSpPr>
-          <p:cNvPr id="22" name="Shape 19"/>
-          <p:cNvSpPr/>
-          <p:nvPr/>
-        </p:nvSpPr>
-        <p:spPr>
-          <a:xfrm>
-            <a:off x="4483303" y="2736799"/>
-            <a:ext cx="202997" cy="0"/>
-          </a:xfrm>
-          <a:prstGeom prst="line">
-            <a:avLst/>
-          </a:prstGeom>
-          <a:noFill/>
-          <a:ln w="31750">
-            <a:solidFill>
-              <a:srgbClr val="8FA3B8"/>
-            </a:solidFill>
-            <a:prstDash val="solid"/>
-          </a:ln>
-        </p:spPr>
-      </p:sp>
-      <p:sp>
-        <p:nvSpPr>
-          <p:cNvPr id="23" name="Shape 20"/>
-          <p:cNvSpPr/>
-          <p:nvPr/>
-        </p:nvSpPr>
-        <p:spPr>
-          <a:xfrm>
-            <a:off x="4686300" y="2825496"/>
-            <a:ext cx="202997" cy="0"/>
-          </a:xfrm>
-          <a:prstGeom prst="line">
-            <a:avLst/>
-          </a:prstGeom>
-          <a:noFill/>
-          <a:ln w="31750">
-            <a:solidFill>
-              <a:srgbClr val="8FA3B8"/>
-            </a:solidFill>
-            <a:prstDash val="solid"/>
-          </a:ln>
-        </p:spPr>
-      </p:sp>
-      <p:sp>
-        <p:nvSpPr>
-          <p:cNvPr id="24" name="Shape 21"/>
-          <p:cNvSpPr/>
-          <p:nvPr/>
-        </p:nvSpPr>
-        <p:spPr>
-          <a:xfrm>
-            <a:off x="4889297" y="2736799"/>
-            <a:ext cx="202997" cy="0"/>
-          </a:xfrm>
-          <a:prstGeom prst="line">
-            <a:avLst/>
-          </a:prstGeom>
-          <a:noFill/>
-          <a:ln w="31750">
-            <a:solidFill>
-              <a:srgbClr val="8FA3B8"/>
-            </a:solidFill>
-            <a:prstDash val="solid"/>
-          </a:ln>
-        </p:spPr>
-      </p:sp>
-      <p:sp>
-        <p:nvSpPr>
-          <p:cNvPr id="25" name="Shape 22"/>
-          <p:cNvSpPr/>
-          <p:nvPr/>
-        </p:nvSpPr>
-        <p:spPr>
-          <a:xfrm>
-            <a:off x="5092294" y="2825496"/>
-            <a:ext cx="254203" cy="0"/>
-          </a:xfrm>
-          <a:prstGeom prst="line">
-            <a:avLst/>
-          </a:prstGeom>
-          <a:noFill/>
-          <a:ln w="31750">
-            <a:solidFill>
-              <a:srgbClr val="8FA3B8"/>
-            </a:solidFill>
-            <a:prstDash val="solid"/>
-          </a:ln>
-        </p:spPr>
-      </p:sp>
-      <p:sp>
-        <p:nvSpPr>
-          <p:cNvPr id="26" name="Shape 23"/>
-          <p:cNvSpPr/>
-          <p:nvPr/>
-        </p:nvSpPr>
-        <p:spPr>
-          <a:xfrm>
-            <a:off x="3873398" y="3111703"/>
-            <a:ext cx="202997" cy="0"/>
-          </a:xfrm>
-          <a:prstGeom prst="line">
-            <a:avLst/>
-          </a:prstGeom>
-          <a:noFill/>
-          <a:ln w="31750">
-            <a:solidFill>
-              <a:srgbClr val="8FA3B8"/>
-            </a:solidFill>
-            <a:prstDash val="solid"/>
-          </a:ln>
-        </p:spPr>
-      </p:sp>
-      <p:sp>
-        <p:nvSpPr>
-          <p:cNvPr id="27" name="Shape 24"/>
-          <p:cNvSpPr/>
-          <p:nvPr/>
-        </p:nvSpPr>
-        <p:spPr>
-          <a:xfrm>
-            <a:off x="4076395" y="3022092"/>
-            <a:ext cx="202997" cy="0"/>
-          </a:xfrm>
-          <a:prstGeom prst="line">
-            <a:avLst/>
-          </a:prstGeom>
-          <a:noFill/>
-          <a:ln w="31750">
-            <a:solidFill>
-              <a:srgbClr val="8FA3B8"/>
-            </a:solidFill>
-            <a:prstDash val="solid"/>
-          </a:ln>
-        </p:spPr>
-      </p:sp>
-      <p:sp>
-        <p:nvSpPr>
-          <p:cNvPr id="28" name="Shape 25"/>
-          <p:cNvSpPr/>
-          <p:nvPr/>
-        </p:nvSpPr>
-        <p:spPr>
-          <a:xfrm>
-            <a:off x="4279392" y="3111703"/>
-            <a:ext cx="202997" cy="0"/>
-          </a:xfrm>
-          <a:prstGeom prst="line">
-            <a:avLst/>
-          </a:prstGeom>
-          <a:noFill/>
-          <a:ln w="31750">
-            <a:solidFill>
-              <a:srgbClr val="8FA3B8"/>
-            </a:solidFill>
-            <a:prstDash val="solid"/>
-          </a:ln>
-        </p:spPr>
-      </p:sp>
-      <p:sp>
-        <p:nvSpPr>
-          <p:cNvPr id="29" name="Shape 26"/>
-          <p:cNvSpPr/>
-          <p:nvPr/>
-        </p:nvSpPr>
-        <p:spPr>
-          <a:xfrm>
-            <a:off x="4483303" y="3022092"/>
-            <a:ext cx="202997" cy="0"/>
-          </a:xfrm>
-          <a:prstGeom prst="line">
-            <a:avLst/>
-          </a:prstGeom>
-          <a:noFill/>
-          <a:ln w="31750">
-            <a:solidFill>
-              <a:srgbClr val="8FA3B8"/>
-            </a:solidFill>
-            <a:prstDash val="solid"/>
-          </a:ln>
-        </p:spPr>
-      </p:sp>
-      <p:sp>
-        <p:nvSpPr>
-          <p:cNvPr id="30" name="Shape 27"/>
-          <p:cNvSpPr/>
-          <p:nvPr/>
-        </p:nvSpPr>
-        <p:spPr>
-          <a:xfrm>
-            <a:off x="4686300" y="3111703"/>
-            <a:ext cx="202997" cy="0"/>
-          </a:xfrm>
-          <a:prstGeom prst="line">
-            <a:avLst/>
-          </a:prstGeom>
-          <a:noFill/>
-          <a:ln w="31750">
-            <a:solidFill>
-              <a:srgbClr val="8FA3B8"/>
-            </a:solidFill>
-            <a:prstDash val="solid"/>
-          </a:ln>
-        </p:spPr>
-      </p:sp>
-      <p:sp>
-        <p:nvSpPr>
-          <p:cNvPr id="31" name="Shape 28"/>
-          <p:cNvSpPr/>
-          <p:nvPr/>
-        </p:nvSpPr>
-        <p:spPr>
-          <a:xfrm>
-            <a:off x="4889297" y="3022092"/>
-            <a:ext cx="202997" cy="0"/>
-          </a:xfrm>
-          <a:prstGeom prst="line">
-            <a:avLst/>
-          </a:prstGeom>
-          <a:noFill/>
-          <a:ln w="31750">
-            <a:solidFill>
-              <a:srgbClr val="8FA3B8"/>
-            </a:solidFill>
-            <a:prstDash val="solid"/>
-          </a:ln>
-        </p:spPr>
-      </p:sp>
-      <p:sp>
-        <p:nvSpPr>
-          <p:cNvPr id="32" name="Shape 29"/>
-          <p:cNvSpPr/>
-          <p:nvPr/>
-        </p:nvSpPr>
-        <p:spPr>
-          <a:xfrm>
-            <a:off x="5092294" y="3111703"/>
-            <a:ext cx="254203" cy="0"/>
-          </a:xfrm>
-          <a:prstGeom prst="line">
-            <a:avLst/>
-          </a:prstGeom>
-          <a:noFill/>
-          <a:ln w="31750">
-            <a:solidFill>
-              <a:srgbClr val="8FA3B8"/>
-            </a:solidFill>
-            <a:prstDash val="solid"/>
-          </a:ln>
-        </p:spPr>
-      </p:sp>
-      <p:sp>
-        <p:nvSpPr>
-          <p:cNvPr id="33" name="Shape 30"/>
-          <p:cNvSpPr/>
-          <p:nvPr/>
-        </p:nvSpPr>
-        <p:spPr>
-          <a:xfrm>
-            <a:off x="3873398" y="3396996"/>
-            <a:ext cx="202997" cy="0"/>
-          </a:xfrm>
-          <a:prstGeom prst="line">
-            <a:avLst/>
-          </a:prstGeom>
-          <a:noFill/>
-          <a:ln w="31750">
-            <a:solidFill>
-              <a:srgbClr val="8FA3B8"/>
-            </a:solidFill>
-            <a:prstDash val="solid"/>
-          </a:ln>
-        </p:spPr>
-      </p:sp>
-      <p:sp>
-        <p:nvSpPr>
-          <p:cNvPr id="34" name="Shape 31"/>
-          <p:cNvSpPr/>
-          <p:nvPr/>
-        </p:nvSpPr>
-        <p:spPr>
-          <a:xfrm>
-            <a:off x="4076395" y="3308299"/>
-            <a:ext cx="202997" cy="0"/>
-          </a:xfrm>
-          <a:prstGeom prst="line">
-            <a:avLst/>
-          </a:prstGeom>
-          <a:noFill/>
-          <a:ln w="31750">
-            <a:solidFill>
-              <a:srgbClr val="8FA3B8"/>
-            </a:solidFill>
-            <a:prstDash val="solid"/>
-          </a:ln>
-        </p:spPr>
-      </p:sp>
-      <p:sp>
-        <p:nvSpPr>
-          <p:cNvPr id="35" name="Shape 32"/>
-          <p:cNvSpPr/>
-          <p:nvPr/>
-        </p:nvSpPr>
-        <p:spPr>
-          <a:xfrm>
-            <a:off x="4279392" y="3396996"/>
-            <a:ext cx="202997" cy="0"/>
-          </a:xfrm>
-          <a:prstGeom prst="line">
-            <a:avLst/>
-          </a:prstGeom>
-          <a:noFill/>
-          <a:ln w="31750">
-            <a:solidFill>
-              <a:srgbClr val="8FA3B8"/>
-            </a:solidFill>
-            <a:prstDash val="solid"/>
-          </a:ln>
-        </p:spPr>
-      </p:sp>
-      <p:sp>
-        <p:nvSpPr>
-          <p:cNvPr id="36" name="Shape 33"/>
-          <p:cNvSpPr/>
-          <p:nvPr/>
-        </p:nvSpPr>
-        <p:spPr>
-          <a:xfrm>
-            <a:off x="4483303" y="3308299"/>
-            <a:ext cx="202997" cy="0"/>
-          </a:xfrm>
-          <a:prstGeom prst="line">
-            <a:avLst/>
-          </a:prstGeom>
-          <a:noFill/>
-          <a:ln w="31750">
-            <a:solidFill>
-              <a:srgbClr val="8FA3B8"/>
-            </a:solidFill>
-            <a:prstDash val="solid"/>
-          </a:ln>
-        </p:spPr>
-      </p:sp>
-      <p:sp>
-        <p:nvSpPr>
-          <p:cNvPr id="37" name="Shape 34"/>
-          <p:cNvSpPr/>
-          <p:nvPr/>
-        </p:nvSpPr>
-        <p:spPr>
-          <a:xfrm>
-            <a:off x="4686300" y="3396996"/>
-            <a:ext cx="202997" cy="0"/>
-          </a:xfrm>
-          <a:prstGeom prst="line">
-            <a:avLst/>
-          </a:prstGeom>
-          <a:noFill/>
-          <a:ln w="31750">
-            <a:solidFill>
-              <a:srgbClr val="8FA3B8"/>
-            </a:solidFill>
-            <a:prstDash val="solid"/>
-          </a:ln>
-        </p:spPr>
-      </p:sp>
-      <p:sp>
-        <p:nvSpPr>
-          <p:cNvPr id="38" name="Shape 35"/>
-          <p:cNvSpPr/>
-          <p:nvPr/>
-        </p:nvSpPr>
-        <p:spPr>
-          <a:xfrm>
-            <a:off x="4889297" y="3308299"/>
-            <a:ext cx="202997" cy="0"/>
-          </a:xfrm>
-          <a:prstGeom prst="line">
-            <a:avLst/>
-          </a:prstGeom>
-          <a:noFill/>
-          <a:ln w="31750">
-            <a:solidFill>
-              <a:srgbClr val="8FA3B8"/>
-            </a:solidFill>
-            <a:prstDash val="solid"/>
-          </a:ln>
-        </p:spPr>
-      </p:sp>
-      <p:sp>
-        <p:nvSpPr>
-          <p:cNvPr id="39" name="Shape 36"/>
-          <p:cNvSpPr/>
-          <p:nvPr/>
-        </p:nvSpPr>
-        <p:spPr>
-          <a:xfrm>
-            <a:off x="5092294" y="3396996"/>
-            <a:ext cx="254203" cy="0"/>
-          </a:xfrm>
-          <a:prstGeom prst="line">
-            <a:avLst/>
-          </a:prstGeom>
-          <a:noFill/>
-          <a:ln w="31750">
-            <a:solidFill>
-              <a:srgbClr val="8FA3B8"/>
-            </a:solidFill>
-            <a:prstDash val="solid"/>
-          </a:ln>
-        </p:spPr>
-      </p:sp>
-      <p:sp>
-        <p:nvSpPr>
-          <p:cNvPr id="40" name="Text 37"/>
+          <p:cNvPr id="19" name="Text 16"/>
           <p:cNvSpPr txBox="1"/>
           <p:nvPr/>
         </p:nvSpPr>
         <p:spPr>
           <a:xfrm>
-            <a:off x="3746297" y="2324405"/>
-            <a:ext cx="1651406" cy="190195"/>
+            <a:off x="3886200" y="2616098"/>
+            <a:ext cx="381305" cy="152705"/>
           </a:xfrm>
           <a:prstGeom prst="rect">
             <a:avLst/>
@@ -19498,18 +19015,1262 @@
           <a:bodyPr wrap="square" lIns="0" tIns="0" rIns="0" bIns="0" rtlCol="0" anchor="t"/>
           <a:lstStyle/>
           <a:p>
-            <a:pPr algn="ctr" indent="0" marL="0">
-              <a:buNone/>
-            </a:pPr>
-            <a:r>
-              <a:rPr lang="en-US" sz="1150" dirty="0">
-                <a:solidFill>
-                  <a:srgbClr val="4A5568"/>
+            <a:pPr algn="l" indent="0" marL="0">
+              <a:buNone/>
+            </a:pPr>
+            <a:r>
+              <a:rPr lang="en-US" sz="850" dirty="0">
+                <a:solidFill>
+                  <a:srgbClr val="5F7390"/>
                 </a:solidFill>
                 <a:latin typeface="Courier New" pitchFamily="34" charset="0"/>
                 <a:ea typeface="Courier New" pitchFamily="34" charset="-122"/>
                 <a:cs typeface="Courier New" pitchFamily="34" charset="-120"/>
               </a:rPr>
+              <a:t>clk</a:t>
+            </a:r>
+            <a:endParaRPr lang="en-US" sz="850" dirty="0"/>
+          </a:p>
+        </p:txBody>
+      </p:sp>
+      <p:sp>
+        <p:nvSpPr>
+          <p:cNvPr id="20" name="Text 17"/>
+          <p:cNvSpPr txBox="1"/>
+          <p:nvPr/>
+        </p:nvSpPr>
+        <p:spPr>
+          <a:xfrm>
+            <a:off x="3886200" y="3016606"/>
+            <a:ext cx="381305" cy="152705"/>
+          </a:xfrm>
+          <a:prstGeom prst="rect">
+            <a:avLst/>
+          </a:prstGeom>
+          <a:noFill/>
+          <a:ln/>
+        </p:spPr>
+        <p:txBody>
+          <a:bodyPr wrap="square" lIns="0" tIns="0" rIns="0" bIns="0" rtlCol="0" anchor="t"/>
+          <a:lstStyle/>
+          <a:p>
+            <a:pPr algn="l" indent="0" marL="0">
+              <a:buNone/>
+            </a:pPr>
+            <a:r>
+              <a:rPr lang="en-US" sz="850" dirty="0">
+                <a:solidFill>
+                  <a:srgbClr val="5F7390"/>
+                </a:solidFill>
+                <a:latin typeface="Courier New" pitchFamily="34" charset="0"/>
+                <a:ea typeface="Courier New" pitchFamily="34" charset="-122"/>
+                <a:cs typeface="Courier New" pitchFamily="34" charset="-120"/>
+              </a:rPr>
+              <a:t>PC</a:t>
+            </a:r>
+            <a:endParaRPr lang="en-US" sz="850" dirty="0"/>
+          </a:p>
+        </p:txBody>
+      </p:sp>
+      <p:sp>
+        <p:nvSpPr>
+          <p:cNvPr id="21" name="Text 18"/>
+          <p:cNvSpPr txBox="1"/>
+          <p:nvPr/>
+        </p:nvSpPr>
+        <p:spPr>
+          <a:xfrm>
+            <a:off x="3886200" y="3377794"/>
+            <a:ext cx="381305" cy="152705"/>
+          </a:xfrm>
+          <a:prstGeom prst="rect">
+            <a:avLst/>
+          </a:prstGeom>
+          <a:noFill/>
+          <a:ln/>
+        </p:spPr>
+        <p:txBody>
+          <a:bodyPr wrap="square" lIns="0" tIns="0" rIns="0" bIns="0" rtlCol="0" anchor="t"/>
+          <a:lstStyle/>
+          <a:p>
+            <a:pPr algn="l" indent="0" marL="0">
+              <a:buNone/>
+            </a:pPr>
+            <a:r>
+              <a:rPr lang="en-US" sz="850" dirty="0">
+                <a:solidFill>
+                  <a:srgbClr val="5F7390"/>
+                </a:solidFill>
+                <a:latin typeface="Courier New" pitchFamily="34" charset="0"/>
+                <a:ea typeface="Courier New" pitchFamily="34" charset="-122"/>
+                <a:cs typeface="Courier New" pitchFamily="34" charset="-120"/>
+              </a:rPr>
+              <a:t>addr</a:t>
+            </a:r>
+            <a:endParaRPr lang="en-US" sz="850" dirty="0"/>
+          </a:p>
+        </p:txBody>
+      </p:sp>
+      <p:sp>
+        <p:nvSpPr>
+          <p:cNvPr id="22" name="Shape 19"/>
+          <p:cNvSpPr/>
+          <p:nvPr/>
+        </p:nvSpPr>
+        <p:spPr>
+          <a:xfrm>
+            <a:off x="4190695" y="2667305"/>
+            <a:ext cx="66751" cy="0"/>
+          </a:xfrm>
+          <a:prstGeom prst="line">
+            <a:avLst/>
+          </a:prstGeom>
+          <a:noFill/>
+          <a:ln w="25400">
+            <a:solidFill>
+              <a:srgbClr val="2FA6A0"/>
+            </a:solidFill>
+            <a:prstDash val="solid"/>
+          </a:ln>
+        </p:spPr>
+      </p:sp>
+      <p:sp>
+        <p:nvSpPr>
+          <p:cNvPr id="23" name="Shape 20"/>
+          <p:cNvSpPr/>
+          <p:nvPr/>
+        </p:nvSpPr>
+        <p:spPr>
+          <a:xfrm>
+            <a:off x="4257446" y="2667305"/>
+            <a:ext cx="0" cy="101498"/>
+          </a:xfrm>
+          <a:prstGeom prst="line">
+            <a:avLst/>
+          </a:prstGeom>
+          <a:noFill/>
+          <a:ln w="25400">
+            <a:solidFill>
+              <a:srgbClr val="2FA6A0"/>
+            </a:solidFill>
+            <a:prstDash val="solid"/>
+          </a:ln>
+        </p:spPr>
+      </p:sp>
+      <p:sp>
+        <p:nvSpPr>
+          <p:cNvPr id="24" name="Shape 21"/>
+          <p:cNvSpPr/>
+          <p:nvPr/>
+        </p:nvSpPr>
+        <p:spPr>
+          <a:xfrm>
+            <a:off x="4257446" y="2768803"/>
+            <a:ext cx="66751" cy="0"/>
+          </a:xfrm>
+          <a:prstGeom prst="line">
+            <a:avLst/>
+          </a:prstGeom>
+          <a:noFill/>
+          <a:ln w="25400">
+            <a:solidFill>
+              <a:srgbClr val="2FA6A0"/>
+            </a:solidFill>
+            <a:prstDash val="solid"/>
+          </a:ln>
+        </p:spPr>
+      </p:sp>
+      <p:sp>
+        <p:nvSpPr>
+          <p:cNvPr id="25" name="Shape 22"/>
+          <p:cNvSpPr/>
+          <p:nvPr/>
+        </p:nvSpPr>
+        <p:spPr>
+          <a:xfrm flipV="1">
+            <a:off x="4324198" y="2667305"/>
+            <a:ext cx="0" cy="101498"/>
+          </a:xfrm>
+          <a:prstGeom prst="line">
+            <a:avLst/>
+          </a:prstGeom>
+          <a:noFill/>
+          <a:ln w="25400">
+            <a:solidFill>
+              <a:srgbClr val="2FA6A0"/>
+            </a:solidFill>
+            <a:prstDash val="solid"/>
+          </a:ln>
+        </p:spPr>
+      </p:sp>
+      <p:sp>
+        <p:nvSpPr>
+          <p:cNvPr id="26" name="Shape 23"/>
+          <p:cNvSpPr/>
+          <p:nvPr/>
+        </p:nvSpPr>
+        <p:spPr>
+          <a:xfrm>
+            <a:off x="4324198" y="2667305"/>
+            <a:ext cx="66751" cy="0"/>
+          </a:xfrm>
+          <a:prstGeom prst="line">
+            <a:avLst/>
+          </a:prstGeom>
+          <a:noFill/>
+          <a:ln w="25400">
+            <a:solidFill>
+              <a:srgbClr val="2FA6A0"/>
+            </a:solidFill>
+            <a:prstDash val="solid"/>
+          </a:ln>
+        </p:spPr>
+      </p:sp>
+      <p:sp>
+        <p:nvSpPr>
+          <p:cNvPr id="27" name="Shape 24"/>
+          <p:cNvSpPr/>
+          <p:nvPr/>
+        </p:nvSpPr>
+        <p:spPr>
+          <a:xfrm>
+            <a:off x="4390949" y="2667305"/>
+            <a:ext cx="0" cy="101498"/>
+          </a:xfrm>
+          <a:prstGeom prst="line">
+            <a:avLst/>
+          </a:prstGeom>
+          <a:noFill/>
+          <a:ln w="25400">
+            <a:solidFill>
+              <a:srgbClr val="2FA6A0"/>
+            </a:solidFill>
+            <a:prstDash val="solid"/>
+          </a:ln>
+        </p:spPr>
+      </p:sp>
+      <p:sp>
+        <p:nvSpPr>
+          <p:cNvPr id="28" name="Shape 25"/>
+          <p:cNvSpPr/>
+          <p:nvPr/>
+        </p:nvSpPr>
+        <p:spPr>
+          <a:xfrm>
+            <a:off x="4390949" y="2768803"/>
+            <a:ext cx="66751" cy="0"/>
+          </a:xfrm>
+          <a:prstGeom prst="line">
+            <a:avLst/>
+          </a:prstGeom>
+          <a:noFill/>
+          <a:ln w="25400">
+            <a:solidFill>
+              <a:srgbClr val="2FA6A0"/>
+            </a:solidFill>
+            <a:prstDash val="solid"/>
+          </a:ln>
+        </p:spPr>
+      </p:sp>
+      <p:sp>
+        <p:nvSpPr>
+          <p:cNvPr id="29" name="Shape 26"/>
+          <p:cNvSpPr/>
+          <p:nvPr/>
+        </p:nvSpPr>
+        <p:spPr>
+          <a:xfrm flipV="1">
+            <a:off x="4457700" y="2667305"/>
+            <a:ext cx="0" cy="101498"/>
+          </a:xfrm>
+          <a:prstGeom prst="line">
+            <a:avLst/>
+          </a:prstGeom>
+          <a:noFill/>
+          <a:ln w="25400">
+            <a:solidFill>
+              <a:srgbClr val="2FA6A0"/>
+            </a:solidFill>
+            <a:prstDash val="solid"/>
+          </a:ln>
+        </p:spPr>
+      </p:sp>
+      <p:sp>
+        <p:nvSpPr>
+          <p:cNvPr id="30" name="Shape 27"/>
+          <p:cNvSpPr/>
+          <p:nvPr/>
+        </p:nvSpPr>
+        <p:spPr>
+          <a:xfrm>
+            <a:off x="4457700" y="2667305"/>
+            <a:ext cx="66751" cy="0"/>
+          </a:xfrm>
+          <a:prstGeom prst="line">
+            <a:avLst/>
+          </a:prstGeom>
+          <a:noFill/>
+          <a:ln w="25400">
+            <a:solidFill>
+              <a:srgbClr val="2FA6A0"/>
+            </a:solidFill>
+            <a:prstDash val="solid"/>
+          </a:ln>
+        </p:spPr>
+      </p:sp>
+      <p:sp>
+        <p:nvSpPr>
+          <p:cNvPr id="31" name="Shape 28"/>
+          <p:cNvSpPr/>
+          <p:nvPr/>
+        </p:nvSpPr>
+        <p:spPr>
+          <a:xfrm>
+            <a:off x="4524451" y="2667305"/>
+            <a:ext cx="0" cy="101498"/>
+          </a:xfrm>
+          <a:prstGeom prst="line">
+            <a:avLst/>
+          </a:prstGeom>
+          <a:noFill/>
+          <a:ln w="25400">
+            <a:solidFill>
+              <a:srgbClr val="2FA6A0"/>
+            </a:solidFill>
+            <a:prstDash val="solid"/>
+          </a:ln>
+        </p:spPr>
+      </p:sp>
+      <p:sp>
+        <p:nvSpPr>
+          <p:cNvPr id="32" name="Shape 29"/>
+          <p:cNvSpPr/>
+          <p:nvPr/>
+        </p:nvSpPr>
+        <p:spPr>
+          <a:xfrm>
+            <a:off x="4524451" y="2768803"/>
+            <a:ext cx="66751" cy="0"/>
+          </a:xfrm>
+          <a:prstGeom prst="line">
+            <a:avLst/>
+          </a:prstGeom>
+          <a:noFill/>
+          <a:ln w="25400">
+            <a:solidFill>
+              <a:srgbClr val="2FA6A0"/>
+            </a:solidFill>
+            <a:prstDash val="solid"/>
+          </a:ln>
+        </p:spPr>
+      </p:sp>
+      <p:sp>
+        <p:nvSpPr>
+          <p:cNvPr id="33" name="Shape 30"/>
+          <p:cNvSpPr/>
+          <p:nvPr/>
+        </p:nvSpPr>
+        <p:spPr>
+          <a:xfrm flipV="1">
+            <a:off x="4591202" y="2667305"/>
+            <a:ext cx="0" cy="101498"/>
+          </a:xfrm>
+          <a:prstGeom prst="line">
+            <a:avLst/>
+          </a:prstGeom>
+          <a:noFill/>
+          <a:ln w="25400">
+            <a:solidFill>
+              <a:srgbClr val="2FA6A0"/>
+            </a:solidFill>
+            <a:prstDash val="solid"/>
+          </a:ln>
+        </p:spPr>
+      </p:sp>
+      <p:sp>
+        <p:nvSpPr>
+          <p:cNvPr id="34" name="Shape 31"/>
+          <p:cNvSpPr/>
+          <p:nvPr/>
+        </p:nvSpPr>
+        <p:spPr>
+          <a:xfrm>
+            <a:off x="4591202" y="2667305"/>
+            <a:ext cx="66751" cy="0"/>
+          </a:xfrm>
+          <a:prstGeom prst="line">
+            <a:avLst/>
+          </a:prstGeom>
+          <a:noFill/>
+          <a:ln w="25400">
+            <a:solidFill>
+              <a:srgbClr val="2FA6A0"/>
+            </a:solidFill>
+            <a:prstDash val="solid"/>
+          </a:ln>
+        </p:spPr>
+      </p:sp>
+      <p:sp>
+        <p:nvSpPr>
+          <p:cNvPr id="35" name="Shape 32"/>
+          <p:cNvSpPr/>
+          <p:nvPr/>
+        </p:nvSpPr>
+        <p:spPr>
+          <a:xfrm>
+            <a:off x="4657954" y="2667305"/>
+            <a:ext cx="0" cy="101498"/>
+          </a:xfrm>
+          <a:prstGeom prst="line">
+            <a:avLst/>
+          </a:prstGeom>
+          <a:noFill/>
+          <a:ln w="25400">
+            <a:solidFill>
+              <a:srgbClr val="2FA6A0"/>
+            </a:solidFill>
+            <a:prstDash val="solid"/>
+          </a:ln>
+        </p:spPr>
+      </p:sp>
+      <p:sp>
+        <p:nvSpPr>
+          <p:cNvPr id="36" name="Shape 33"/>
+          <p:cNvSpPr/>
+          <p:nvPr/>
+        </p:nvSpPr>
+        <p:spPr>
+          <a:xfrm>
+            <a:off x="4657954" y="2768803"/>
+            <a:ext cx="66751" cy="0"/>
+          </a:xfrm>
+          <a:prstGeom prst="line">
+            <a:avLst/>
+          </a:prstGeom>
+          <a:noFill/>
+          <a:ln w="25400">
+            <a:solidFill>
+              <a:srgbClr val="2FA6A0"/>
+            </a:solidFill>
+            <a:prstDash val="solid"/>
+          </a:ln>
+        </p:spPr>
+      </p:sp>
+      <p:sp>
+        <p:nvSpPr>
+          <p:cNvPr id="37" name="Shape 34"/>
+          <p:cNvSpPr/>
+          <p:nvPr/>
+        </p:nvSpPr>
+        <p:spPr>
+          <a:xfrm flipV="1">
+            <a:off x="4724705" y="2667305"/>
+            <a:ext cx="0" cy="101498"/>
+          </a:xfrm>
+          <a:prstGeom prst="line">
+            <a:avLst/>
+          </a:prstGeom>
+          <a:noFill/>
+          <a:ln w="25400">
+            <a:solidFill>
+              <a:srgbClr val="2FA6A0"/>
+            </a:solidFill>
+            <a:prstDash val="solid"/>
+          </a:ln>
+        </p:spPr>
+      </p:sp>
+      <p:sp>
+        <p:nvSpPr>
+          <p:cNvPr id="38" name="Shape 35"/>
+          <p:cNvSpPr/>
+          <p:nvPr/>
+        </p:nvSpPr>
+        <p:spPr>
+          <a:xfrm>
+            <a:off x="4724705" y="2667305"/>
+            <a:ext cx="66751" cy="0"/>
+          </a:xfrm>
+          <a:prstGeom prst="line">
+            <a:avLst/>
+          </a:prstGeom>
+          <a:noFill/>
+          <a:ln w="25400">
+            <a:solidFill>
+              <a:srgbClr val="2FA6A0"/>
+            </a:solidFill>
+            <a:prstDash val="solid"/>
+          </a:ln>
+        </p:spPr>
+      </p:sp>
+      <p:sp>
+        <p:nvSpPr>
+          <p:cNvPr id="39" name="Shape 36"/>
+          <p:cNvSpPr/>
+          <p:nvPr/>
+        </p:nvSpPr>
+        <p:spPr>
+          <a:xfrm>
+            <a:off x="4790542" y="2667305"/>
+            <a:ext cx="0" cy="101498"/>
+          </a:xfrm>
+          <a:prstGeom prst="line">
+            <a:avLst/>
+          </a:prstGeom>
+          <a:noFill/>
+          <a:ln w="25400">
+            <a:solidFill>
+              <a:srgbClr val="2FA6A0"/>
+            </a:solidFill>
+            <a:prstDash val="solid"/>
+          </a:ln>
+        </p:spPr>
+      </p:sp>
+      <p:sp>
+        <p:nvSpPr>
+          <p:cNvPr id="40" name="Shape 37"/>
+          <p:cNvSpPr/>
+          <p:nvPr/>
+        </p:nvSpPr>
+        <p:spPr>
+          <a:xfrm>
+            <a:off x="4790542" y="2768803"/>
+            <a:ext cx="66751" cy="0"/>
+          </a:xfrm>
+          <a:prstGeom prst="line">
+            <a:avLst/>
+          </a:prstGeom>
+          <a:noFill/>
+          <a:ln w="25400">
+            <a:solidFill>
+              <a:srgbClr val="2FA6A0"/>
+            </a:solidFill>
+            <a:prstDash val="solid"/>
+          </a:ln>
+        </p:spPr>
+      </p:sp>
+      <p:sp>
+        <p:nvSpPr>
+          <p:cNvPr id="41" name="Shape 38"/>
+          <p:cNvSpPr/>
+          <p:nvPr/>
+        </p:nvSpPr>
+        <p:spPr>
+          <a:xfrm flipV="1">
+            <a:off x="4857293" y="2667305"/>
+            <a:ext cx="0" cy="101498"/>
+          </a:xfrm>
+          <a:prstGeom prst="line">
+            <a:avLst/>
+          </a:prstGeom>
+          <a:noFill/>
+          <a:ln w="25400">
+            <a:solidFill>
+              <a:srgbClr val="2FA6A0"/>
+            </a:solidFill>
+            <a:prstDash val="solid"/>
+          </a:ln>
+        </p:spPr>
+      </p:sp>
+      <p:sp>
+        <p:nvSpPr>
+          <p:cNvPr id="42" name="Shape 39"/>
+          <p:cNvSpPr/>
+          <p:nvPr/>
+        </p:nvSpPr>
+        <p:spPr>
+          <a:xfrm>
+            <a:off x="4857293" y="2667305"/>
+            <a:ext cx="66751" cy="0"/>
+          </a:xfrm>
+          <a:prstGeom prst="line">
+            <a:avLst/>
+          </a:prstGeom>
+          <a:noFill/>
+          <a:ln w="25400">
+            <a:solidFill>
+              <a:srgbClr val="2FA6A0"/>
+            </a:solidFill>
+            <a:prstDash val="solid"/>
+          </a:ln>
+        </p:spPr>
+      </p:sp>
+      <p:sp>
+        <p:nvSpPr>
+          <p:cNvPr id="43" name="Shape 40"/>
+          <p:cNvSpPr/>
+          <p:nvPr/>
+        </p:nvSpPr>
+        <p:spPr>
+          <a:xfrm>
+            <a:off x="4924044" y="2667305"/>
+            <a:ext cx="0" cy="101498"/>
+          </a:xfrm>
+          <a:prstGeom prst="line">
+            <a:avLst/>
+          </a:prstGeom>
+          <a:noFill/>
+          <a:ln w="25400">
+            <a:solidFill>
+              <a:srgbClr val="2FA6A0"/>
+            </a:solidFill>
+            <a:prstDash val="solid"/>
+          </a:ln>
+        </p:spPr>
+      </p:sp>
+      <p:sp>
+        <p:nvSpPr>
+          <p:cNvPr id="44" name="Shape 41"/>
+          <p:cNvSpPr/>
+          <p:nvPr/>
+        </p:nvSpPr>
+        <p:spPr>
+          <a:xfrm>
+            <a:off x="4924044" y="2768803"/>
+            <a:ext cx="66751" cy="0"/>
+          </a:xfrm>
+          <a:prstGeom prst="line">
+            <a:avLst/>
+          </a:prstGeom>
+          <a:noFill/>
+          <a:ln w="25400">
+            <a:solidFill>
+              <a:srgbClr val="2FA6A0"/>
+            </a:solidFill>
+            <a:prstDash val="solid"/>
+          </a:ln>
+        </p:spPr>
+      </p:sp>
+      <p:sp>
+        <p:nvSpPr>
+          <p:cNvPr id="45" name="Shape 42"/>
+          <p:cNvSpPr/>
+          <p:nvPr/>
+        </p:nvSpPr>
+        <p:spPr>
+          <a:xfrm flipV="1">
+            <a:off x="4990795" y="2667305"/>
+            <a:ext cx="0" cy="101498"/>
+          </a:xfrm>
+          <a:prstGeom prst="line">
+            <a:avLst/>
+          </a:prstGeom>
+          <a:noFill/>
+          <a:ln w="25400">
+            <a:solidFill>
+              <a:srgbClr val="2FA6A0"/>
+            </a:solidFill>
+            <a:prstDash val="solid"/>
+          </a:ln>
+        </p:spPr>
+      </p:sp>
+      <p:sp>
+        <p:nvSpPr>
+          <p:cNvPr id="46" name="Shape 43"/>
+          <p:cNvSpPr/>
+          <p:nvPr/>
+        </p:nvSpPr>
+        <p:spPr>
+          <a:xfrm>
+            <a:off x="4990795" y="2667305"/>
+            <a:ext cx="66751" cy="0"/>
+          </a:xfrm>
+          <a:prstGeom prst="line">
+            <a:avLst/>
+          </a:prstGeom>
+          <a:noFill/>
+          <a:ln w="25400">
+            <a:solidFill>
+              <a:srgbClr val="2FA6A0"/>
+            </a:solidFill>
+            <a:prstDash val="solid"/>
+          </a:ln>
+        </p:spPr>
+      </p:sp>
+      <p:sp>
+        <p:nvSpPr>
+          <p:cNvPr id="47" name="Shape 44"/>
+          <p:cNvSpPr/>
+          <p:nvPr/>
+        </p:nvSpPr>
+        <p:spPr>
+          <a:xfrm>
+            <a:off x="5057546" y="2667305"/>
+            <a:ext cx="0" cy="101498"/>
+          </a:xfrm>
+          <a:prstGeom prst="line">
+            <a:avLst/>
+          </a:prstGeom>
+          <a:noFill/>
+          <a:ln w="25400">
+            <a:solidFill>
+              <a:srgbClr val="2FA6A0"/>
+            </a:solidFill>
+            <a:prstDash val="solid"/>
+          </a:ln>
+        </p:spPr>
+      </p:sp>
+      <p:sp>
+        <p:nvSpPr>
+          <p:cNvPr id="48" name="Shape 45"/>
+          <p:cNvSpPr/>
+          <p:nvPr/>
+        </p:nvSpPr>
+        <p:spPr>
+          <a:xfrm>
+            <a:off x="5057546" y="2768803"/>
+            <a:ext cx="66751" cy="0"/>
+          </a:xfrm>
+          <a:prstGeom prst="line">
+            <a:avLst/>
+          </a:prstGeom>
+          <a:noFill/>
+          <a:ln w="25400">
+            <a:solidFill>
+              <a:srgbClr val="2FA6A0"/>
+            </a:solidFill>
+            <a:prstDash val="solid"/>
+          </a:ln>
+        </p:spPr>
+      </p:sp>
+      <p:sp>
+        <p:nvSpPr>
+          <p:cNvPr id="49" name="Shape 46"/>
+          <p:cNvSpPr/>
+          <p:nvPr/>
+        </p:nvSpPr>
+        <p:spPr>
+          <a:xfrm flipV="1">
+            <a:off x="5124298" y="2667305"/>
+            <a:ext cx="0" cy="101498"/>
+          </a:xfrm>
+          <a:prstGeom prst="line">
+            <a:avLst/>
+          </a:prstGeom>
+          <a:noFill/>
+          <a:ln w="25400">
+            <a:solidFill>
+              <a:srgbClr val="2FA6A0"/>
+            </a:solidFill>
+            <a:prstDash val="solid"/>
+          </a:ln>
+        </p:spPr>
+      </p:sp>
+      <p:sp>
+        <p:nvSpPr>
+          <p:cNvPr id="50" name="Shape 47"/>
+          <p:cNvSpPr/>
+          <p:nvPr/>
+        </p:nvSpPr>
+        <p:spPr>
+          <a:xfrm>
+            <a:off x="5124298" y="2667305"/>
+            <a:ext cx="66751" cy="0"/>
+          </a:xfrm>
+          <a:prstGeom prst="line">
+            <a:avLst/>
+          </a:prstGeom>
+          <a:noFill/>
+          <a:ln w="25400">
+            <a:solidFill>
+              <a:srgbClr val="2FA6A0"/>
+            </a:solidFill>
+            <a:prstDash val="solid"/>
+          </a:ln>
+        </p:spPr>
+      </p:sp>
+      <p:sp>
+        <p:nvSpPr>
+          <p:cNvPr id="51" name="Shape 48"/>
+          <p:cNvSpPr/>
+          <p:nvPr/>
+        </p:nvSpPr>
+        <p:spPr>
+          <a:xfrm>
+            <a:off x="5191049" y="2667305"/>
+            <a:ext cx="0" cy="101498"/>
+          </a:xfrm>
+          <a:prstGeom prst="line">
+            <a:avLst/>
+          </a:prstGeom>
+          <a:noFill/>
+          <a:ln w="25400">
+            <a:solidFill>
+              <a:srgbClr val="2FA6A0"/>
+            </a:solidFill>
+            <a:prstDash val="solid"/>
+          </a:ln>
+        </p:spPr>
+      </p:sp>
+      <p:sp>
+        <p:nvSpPr>
+          <p:cNvPr id="52" name="Shape 49"/>
+          <p:cNvSpPr/>
+          <p:nvPr/>
+        </p:nvSpPr>
+        <p:spPr>
+          <a:xfrm>
+            <a:off x="5191049" y="2768803"/>
+            <a:ext cx="66751" cy="0"/>
+          </a:xfrm>
+          <a:prstGeom prst="line">
+            <a:avLst/>
+          </a:prstGeom>
+          <a:noFill/>
+          <a:ln w="25400">
+            <a:solidFill>
+              <a:srgbClr val="2FA6A0"/>
+            </a:solidFill>
+            <a:prstDash val="solid"/>
+          </a:ln>
+        </p:spPr>
+      </p:sp>
+      <p:sp>
+        <p:nvSpPr>
+          <p:cNvPr id="53" name="Shape 50"/>
+          <p:cNvSpPr/>
+          <p:nvPr/>
+        </p:nvSpPr>
+        <p:spPr>
+          <a:xfrm>
+            <a:off x="4190695" y="3047695"/>
+            <a:ext cx="192024" cy="0"/>
+          </a:xfrm>
+          <a:prstGeom prst="line">
+            <a:avLst/>
+          </a:prstGeom>
+          <a:noFill/>
+          <a:ln w="31750">
+            <a:solidFill>
+              <a:srgbClr val="8FA3B8"/>
+            </a:solidFill>
+            <a:prstDash val="solid"/>
+          </a:ln>
+        </p:spPr>
+      </p:sp>
+      <p:sp>
+        <p:nvSpPr>
+          <p:cNvPr id="54" name="Shape 51"/>
+          <p:cNvSpPr/>
+          <p:nvPr/>
+        </p:nvSpPr>
+        <p:spPr>
+          <a:xfrm>
+            <a:off x="4382719" y="3047695"/>
+            <a:ext cx="0" cy="101498"/>
+          </a:xfrm>
+          <a:prstGeom prst="line">
+            <a:avLst/>
+          </a:prstGeom>
+          <a:noFill/>
+          <a:ln w="31750">
+            <a:solidFill>
+              <a:srgbClr val="8FA3B8"/>
+            </a:solidFill>
+            <a:prstDash val="solid"/>
+          </a:ln>
+        </p:spPr>
+      </p:sp>
+      <p:sp>
+        <p:nvSpPr>
+          <p:cNvPr id="55" name="Shape 52"/>
+          <p:cNvSpPr/>
+          <p:nvPr/>
+        </p:nvSpPr>
+        <p:spPr>
+          <a:xfrm>
+            <a:off x="4382719" y="3149194"/>
+            <a:ext cx="128016" cy="0"/>
+          </a:xfrm>
+          <a:prstGeom prst="line">
+            <a:avLst/>
+          </a:prstGeom>
+          <a:noFill/>
+          <a:ln w="31750">
+            <a:solidFill>
+              <a:srgbClr val="8FA3B8"/>
+            </a:solidFill>
+            <a:prstDash val="solid"/>
+          </a:ln>
+        </p:spPr>
+      </p:sp>
+      <p:sp>
+        <p:nvSpPr>
+          <p:cNvPr id="56" name="Shape 53"/>
+          <p:cNvSpPr/>
+          <p:nvPr/>
+        </p:nvSpPr>
+        <p:spPr>
+          <a:xfrm>
+            <a:off x="4510735" y="3047695"/>
+            <a:ext cx="0" cy="101498"/>
+          </a:xfrm>
+          <a:prstGeom prst="line">
+            <a:avLst/>
+          </a:prstGeom>
+          <a:noFill/>
+          <a:ln w="31750">
+            <a:solidFill>
+              <a:srgbClr val="8FA3B8"/>
+            </a:solidFill>
+            <a:prstDash val="solid"/>
+          </a:ln>
+        </p:spPr>
+      </p:sp>
+      <p:sp>
+        <p:nvSpPr>
+          <p:cNvPr id="57" name="Shape 54"/>
+          <p:cNvSpPr/>
+          <p:nvPr/>
+        </p:nvSpPr>
+        <p:spPr>
+          <a:xfrm>
+            <a:off x="4510735" y="3047695"/>
+            <a:ext cx="267005" cy="0"/>
+          </a:xfrm>
+          <a:prstGeom prst="line">
+            <a:avLst/>
+          </a:prstGeom>
+          <a:noFill/>
+          <a:ln w="31750">
+            <a:solidFill>
+              <a:srgbClr val="8FA3B8"/>
+            </a:solidFill>
+            <a:prstDash val="solid"/>
+          </a:ln>
+        </p:spPr>
+      </p:sp>
+      <p:sp>
+        <p:nvSpPr>
+          <p:cNvPr id="58" name="Shape 55"/>
+          <p:cNvSpPr/>
+          <p:nvPr/>
+        </p:nvSpPr>
+        <p:spPr>
+          <a:xfrm>
+            <a:off x="4777740" y="3047695"/>
+            <a:ext cx="0" cy="101498"/>
+          </a:xfrm>
+          <a:prstGeom prst="line">
+            <a:avLst/>
+          </a:prstGeom>
+          <a:noFill/>
+          <a:ln w="31750">
+            <a:solidFill>
+              <a:srgbClr val="8FA3B8"/>
+            </a:solidFill>
+            <a:prstDash val="solid"/>
+          </a:ln>
+        </p:spPr>
+      </p:sp>
+      <p:sp>
+        <p:nvSpPr>
+          <p:cNvPr id="59" name="Shape 56"/>
+          <p:cNvSpPr/>
+          <p:nvPr/>
+        </p:nvSpPr>
+        <p:spPr>
+          <a:xfrm>
+            <a:off x="4777740" y="3149194"/>
+            <a:ext cx="160020" cy="0"/>
+          </a:xfrm>
+          <a:prstGeom prst="line">
+            <a:avLst/>
+          </a:prstGeom>
+          <a:noFill/>
+          <a:ln w="31750">
+            <a:solidFill>
+              <a:srgbClr val="8FA3B8"/>
+            </a:solidFill>
+            <a:prstDash val="solid"/>
+          </a:ln>
+        </p:spPr>
+      </p:sp>
+      <p:sp>
+        <p:nvSpPr>
+          <p:cNvPr id="60" name="Shape 57"/>
+          <p:cNvSpPr/>
+          <p:nvPr/>
+        </p:nvSpPr>
+        <p:spPr>
+          <a:xfrm>
+            <a:off x="4937760" y="3047695"/>
+            <a:ext cx="0" cy="101498"/>
+          </a:xfrm>
+          <a:prstGeom prst="line">
+            <a:avLst/>
+          </a:prstGeom>
+          <a:noFill/>
+          <a:ln w="31750">
+            <a:solidFill>
+              <a:srgbClr val="8FA3B8"/>
+            </a:solidFill>
+            <a:prstDash val="solid"/>
+          </a:ln>
+        </p:spPr>
+      </p:sp>
+      <p:sp>
+        <p:nvSpPr>
+          <p:cNvPr id="61" name="Shape 58"/>
+          <p:cNvSpPr/>
+          <p:nvPr/>
+        </p:nvSpPr>
+        <p:spPr>
+          <a:xfrm>
+            <a:off x="4937760" y="3047695"/>
+            <a:ext cx="320040" cy="0"/>
+          </a:xfrm>
+          <a:prstGeom prst="line">
+            <a:avLst/>
+          </a:prstGeom>
+          <a:noFill/>
+          <a:ln w="31750">
+            <a:solidFill>
+              <a:srgbClr val="8FA3B8"/>
+            </a:solidFill>
+            <a:prstDash val="solid"/>
+          </a:ln>
+        </p:spPr>
+      </p:sp>
+      <p:sp>
+        <p:nvSpPr>
+          <p:cNvPr id="62" name="Shape 59"/>
+          <p:cNvSpPr/>
+          <p:nvPr/>
+        </p:nvSpPr>
+        <p:spPr>
+          <a:xfrm>
+            <a:off x="4190695" y="3416198"/>
+            <a:ext cx="320040" cy="0"/>
+          </a:xfrm>
+          <a:prstGeom prst="line">
+            <a:avLst/>
+          </a:prstGeom>
+          <a:noFill/>
+          <a:ln w="31750">
+            <a:solidFill>
+              <a:srgbClr val="8FA3B8"/>
+            </a:solidFill>
+            <a:prstDash val="solid"/>
+          </a:ln>
+        </p:spPr>
+      </p:sp>
+      <p:sp>
+        <p:nvSpPr>
+          <p:cNvPr id="63" name="Shape 60"/>
+          <p:cNvSpPr/>
+          <p:nvPr/>
+        </p:nvSpPr>
+        <p:spPr>
+          <a:xfrm>
+            <a:off x="4510735" y="3416198"/>
+            <a:ext cx="0" cy="101498"/>
+          </a:xfrm>
+          <a:prstGeom prst="line">
+            <a:avLst/>
+          </a:prstGeom>
+          <a:noFill/>
+          <a:ln w="31750">
+            <a:solidFill>
+              <a:srgbClr val="8FA3B8"/>
+            </a:solidFill>
+            <a:prstDash val="solid"/>
+          </a:ln>
+        </p:spPr>
+      </p:sp>
+      <p:sp>
+        <p:nvSpPr>
+          <p:cNvPr id="64" name="Shape 61"/>
+          <p:cNvSpPr/>
+          <p:nvPr/>
+        </p:nvSpPr>
+        <p:spPr>
+          <a:xfrm>
+            <a:off x="4510735" y="3517697"/>
+            <a:ext cx="106985" cy="0"/>
+          </a:xfrm>
+          <a:prstGeom prst="line">
+            <a:avLst/>
+          </a:prstGeom>
+          <a:noFill/>
+          <a:ln w="31750">
+            <a:solidFill>
+              <a:srgbClr val="8FA3B8"/>
+            </a:solidFill>
+            <a:prstDash val="solid"/>
+          </a:ln>
+        </p:spPr>
+      </p:sp>
+      <p:sp>
+        <p:nvSpPr>
+          <p:cNvPr id="65" name="Shape 62"/>
+          <p:cNvSpPr/>
+          <p:nvPr/>
+        </p:nvSpPr>
+        <p:spPr>
+          <a:xfrm>
+            <a:off x="4617720" y="3416198"/>
+            <a:ext cx="0" cy="101498"/>
+          </a:xfrm>
+          <a:prstGeom prst="line">
+            <a:avLst/>
+          </a:prstGeom>
+          <a:noFill/>
+          <a:ln w="31750">
+            <a:solidFill>
+              <a:srgbClr val="8FA3B8"/>
+            </a:solidFill>
+            <a:prstDash val="solid"/>
+          </a:ln>
+        </p:spPr>
+      </p:sp>
+      <p:sp>
+        <p:nvSpPr>
+          <p:cNvPr id="66" name="Shape 63"/>
+          <p:cNvSpPr/>
+          <p:nvPr/>
+        </p:nvSpPr>
+        <p:spPr>
+          <a:xfrm>
+            <a:off x="4617720" y="3416198"/>
+            <a:ext cx="213055" cy="0"/>
+          </a:xfrm>
+          <a:prstGeom prst="line">
+            <a:avLst/>
+          </a:prstGeom>
+          <a:noFill/>
+          <a:ln w="31750">
+            <a:solidFill>
+              <a:srgbClr val="8FA3B8"/>
+            </a:solidFill>
+            <a:prstDash val="solid"/>
+          </a:ln>
+        </p:spPr>
+      </p:sp>
+      <p:sp>
+        <p:nvSpPr>
+          <p:cNvPr id="67" name="Shape 64"/>
+          <p:cNvSpPr/>
+          <p:nvPr/>
+        </p:nvSpPr>
+        <p:spPr>
+          <a:xfrm>
+            <a:off x="4830775" y="3416198"/>
+            <a:ext cx="0" cy="101498"/>
+          </a:xfrm>
+          <a:prstGeom prst="line">
+            <a:avLst/>
+          </a:prstGeom>
+          <a:noFill/>
+          <a:ln w="31750">
+            <a:solidFill>
+              <a:srgbClr val="8FA3B8"/>
+            </a:solidFill>
+            <a:prstDash val="solid"/>
+          </a:ln>
+        </p:spPr>
+      </p:sp>
+      <p:sp>
+        <p:nvSpPr>
+          <p:cNvPr id="68" name="Shape 65"/>
+          <p:cNvSpPr/>
+          <p:nvPr/>
+        </p:nvSpPr>
+        <p:spPr>
+          <a:xfrm>
+            <a:off x="4830775" y="3517697"/>
+            <a:ext cx="267005" cy="0"/>
+          </a:xfrm>
+          <a:prstGeom prst="line">
+            <a:avLst/>
+          </a:prstGeom>
+          <a:noFill/>
+          <a:ln w="31750">
+            <a:solidFill>
+              <a:srgbClr val="8FA3B8"/>
+            </a:solidFill>
+            <a:prstDash val="solid"/>
+          </a:ln>
+        </p:spPr>
+      </p:sp>
+      <p:sp>
+        <p:nvSpPr>
+          <p:cNvPr id="69" name="Shape 66"/>
+          <p:cNvSpPr/>
+          <p:nvPr/>
+        </p:nvSpPr>
+        <p:spPr>
+          <a:xfrm>
+            <a:off x="5097780" y="3416198"/>
+            <a:ext cx="0" cy="101498"/>
+          </a:xfrm>
+          <a:prstGeom prst="line">
+            <a:avLst/>
+          </a:prstGeom>
+          <a:noFill/>
+          <a:ln w="31750">
+            <a:solidFill>
+              <a:srgbClr val="8FA3B8"/>
+            </a:solidFill>
+            <a:prstDash val="solid"/>
+          </a:ln>
+        </p:spPr>
+      </p:sp>
+      <p:sp>
+        <p:nvSpPr>
+          <p:cNvPr id="70" name="Shape 67"/>
+          <p:cNvSpPr/>
+          <p:nvPr/>
+        </p:nvSpPr>
+        <p:spPr>
+          <a:xfrm>
+            <a:off x="5097780" y="3416198"/>
+            <a:ext cx="160020" cy="0"/>
+          </a:xfrm>
+          <a:prstGeom prst="line">
+            <a:avLst/>
+          </a:prstGeom>
+          <a:noFill/>
+          <a:ln w="31750">
+            <a:solidFill>
+              <a:srgbClr val="8FA3B8"/>
+            </a:solidFill>
+            <a:prstDash val="solid"/>
+          </a:ln>
+        </p:spPr>
+      </p:sp>
+      <p:sp>
+        <p:nvSpPr>
+          <p:cNvPr id="71" name="Text 68"/>
+          <p:cNvSpPr txBox="1"/>
+          <p:nvPr/>
+        </p:nvSpPr>
+        <p:spPr>
+          <a:xfrm>
+            <a:off x="3746297" y="2324405"/>
+            <a:ext cx="1651406" cy="190195"/>
+          </a:xfrm>
+          <a:prstGeom prst="rect">
+            <a:avLst/>
+          </a:prstGeom>
+          <a:noFill/>
+          <a:ln/>
+        </p:spPr>
+        <p:txBody>
+          <a:bodyPr wrap="square" lIns="0" tIns="0" rIns="0" bIns="0" rtlCol="0" anchor="t"/>
+          <a:lstStyle/>
+          <a:p>
+            <a:pPr algn="ctr" indent="0" marL="0">
+              <a:buNone/>
+            </a:pPr>
+            <a:r>
+              <a:rPr lang="en-US" sz="1150" dirty="0">
+                <a:solidFill>
+                  <a:srgbClr val="4A5568"/>
+                </a:solidFill>
+                <a:latin typeface="Courier New" pitchFamily="34" charset="0"/>
+                <a:ea typeface="Courier New" pitchFamily="34" charset="-122"/>
+                <a:cs typeface="Courier New" pitchFamily="34" charset="-120"/>
+              </a:rPr>
               <a:t>파형 (clk + PC)</a:t>
             </a:r>
             <a:endParaRPr lang="en-US" sz="1150" dirty="0"/>
@@ -19518,7 +20279,7 @@
       </p:sp>
       <p:sp>
         <p:nvSpPr>
-          <p:cNvPr id="41" name="Text 38"/>
+          <p:cNvPr id="72" name="Text 69"/>
           <p:cNvSpPr txBox="1"/>
           <p:nvPr/>
         </p:nvSpPr>
@@ -19557,7 +20318,7 @@
       </p:sp>
       <p:sp>
         <p:nvSpPr>
-          <p:cNvPr id="42" name="Shape 39"/>
+          <p:cNvPr id="73" name="Shape 70"/>
           <p:cNvSpPr/>
           <p:nvPr/>
         </p:nvSpPr>
@@ -19577,7 +20338,7 @@
       </p:sp>
       <p:sp>
         <p:nvSpPr>
-          <p:cNvPr id="43" name="Shape 40"/>
+          <p:cNvPr id="74" name="Shape 71"/>
           <p:cNvSpPr/>
           <p:nvPr/>
         </p:nvSpPr>
@@ -19599,7 +20360,7 @@
       </p:sp>
       <p:sp>
         <p:nvSpPr>
-          <p:cNvPr id="44" name="Text 41"/>
+          <p:cNvPr id="75" name="Text 72"/>
           <p:cNvSpPr txBox="1"/>
           <p:nvPr/>
         </p:nvSpPr>
@@ -19638,7 +20399,7 @@
       </p:sp>
       <p:sp>
         <p:nvSpPr>
-          <p:cNvPr id="45" name="Text 42"/>
+          <p:cNvPr id="76" name="Text 73"/>
           <p:cNvSpPr txBox="1"/>
           <p:nvPr/>
         </p:nvSpPr>
@@ -19694,7 +20455,7 @@
       </p:sp>
       <p:sp>
         <p:nvSpPr>
-          <p:cNvPr id="46" name="Shape 43"/>
+          <p:cNvPr id="77" name="Shape 74"/>
           <p:cNvSpPr/>
           <p:nvPr/>
         </p:nvSpPr>
@@ -19714,7 +20475,7 @@
       </p:sp>
       <p:sp>
         <p:nvSpPr>
-          <p:cNvPr id="47" name="Shape 44"/>
+          <p:cNvPr id="78" name="Shape 75"/>
           <p:cNvSpPr/>
           <p:nvPr/>
         </p:nvSpPr>
@@ -19736,7 +20497,7 @@
       </p:sp>
       <p:sp>
         <p:nvSpPr>
-          <p:cNvPr id="48" name="Text 45"/>
+          <p:cNvPr id="79" name="Text 76"/>
           <p:cNvSpPr txBox="1"/>
           <p:nvPr/>
         </p:nvSpPr>
@@ -19775,7 +20536,7 @@
       </p:sp>
       <p:sp>
         <p:nvSpPr>
-          <p:cNvPr id="49" name="Text 46"/>
+          <p:cNvPr id="80" name="Text 77"/>
           <p:cNvSpPr txBox="1"/>
           <p:nvPr/>
         </p:nvSpPr>
@@ -19877,7 +20638,7 @@
       </p:sp>
       <p:sp>
         <p:nvSpPr>
-          <p:cNvPr id="50" name="Text 47"/>
+          <p:cNvPr id="81" name="Text 78"/>
           <p:cNvSpPr txBox="1"/>
           <p:nvPr/>
         </p:nvSpPr>
@@ -19939,7 +20700,7 @@
       </p:sp>
       <p:sp>
         <p:nvSpPr>
-          <p:cNvPr id="51" name="Text 48"/>
+          <p:cNvPr id="82" name="Text 79"/>
           <p:cNvSpPr txBox="1"/>
           <p:nvPr/>
         </p:nvSpPr>
@@ -19978,7 +20739,7 @@
       </p:sp>
       <p:sp>
         <p:nvSpPr>
-          <p:cNvPr id="52" name="Shape 49"/>
+          <p:cNvPr id="83" name="Shape 80"/>
           <p:cNvSpPr/>
           <p:nvPr/>
         </p:nvSpPr>
@@ -20005,7 +20766,7 @@
       </p:sp>
       <p:sp>
         <p:nvSpPr>
-          <p:cNvPr id="53" name="Text 50"/>
+          <p:cNvPr id="84" name="Text 81"/>
           <p:cNvSpPr txBox="1"/>
           <p:nvPr/>
         </p:nvSpPr>
@@ -20044,7 +20805,7 @@
       </p:sp>
       <p:sp>
         <p:nvSpPr>
-          <p:cNvPr id="54" name="Text 51"/>
+          <p:cNvPr id="85" name="Text 82"/>
           <p:cNvSpPr txBox="1"/>
           <p:nvPr/>
         </p:nvSpPr>
@@ -20086,7 +20847,7 @@
       </p:sp>
       <p:sp>
         <p:nvSpPr>
-          <p:cNvPr id="55" name="Shape 52"/>
+          <p:cNvPr id="86" name="Shape 83"/>
           <p:cNvSpPr/>
           <p:nvPr/>
         </p:nvSpPr>
@@ -20113,7 +20874,7 @@
       </p:sp>
       <p:sp>
         <p:nvSpPr>
-          <p:cNvPr id="56" name="Text 53"/>
+          <p:cNvPr id="87" name="Text 84"/>
           <p:cNvSpPr txBox="1"/>
           <p:nvPr/>
         </p:nvSpPr>
@@ -20152,7 +20913,7 @@
       </p:sp>
       <p:sp>
         <p:nvSpPr>
-          <p:cNvPr id="57" name="Text 54"/>
+          <p:cNvPr id="88" name="Text 85"/>
           <p:cNvSpPr txBox="1"/>
           <p:nvPr/>
         </p:nvSpPr>
@@ -20334,11 +21095,11 @@
         <p:spPr>
           <a:xfrm>
             <a:off x="508406" y="1841602"/>
-            <a:ext cx="5333695" cy="3556102"/>
+            <a:ext cx="5333695" cy="3619195"/>
           </a:xfrm>
           <a:prstGeom prst="roundRect">
             <a:avLst>
-              <a:gd name="adj" fmla="val 2854"/>
+              <a:gd name="adj" fmla="val 2804"/>
             </a:avLst>
           </a:prstGeom>
           <a:solidFill>
@@ -20360,75 +21121,750 @@
         </p:nvSpPr>
         <p:spPr>
           <a:xfrm>
-            <a:off x="508406" y="1841602"/>
-            <a:ext cx="5333695" cy="3556102"/>
-          </a:xfrm>
-          <a:prstGeom prst="rect">
-            <a:avLst/>
-          </a:prstGeom>
-          <a:noFill/>
-          <a:ln/>
-        </p:spPr>
-        <p:txBody>
-          <a:bodyPr wrap="square" lIns="0" tIns="0" rIns="0" bIns="0" rtlCol="0" anchor="ctr"/>
+            <a:off x="660197" y="1930298"/>
+            <a:ext cx="5079492" cy="190195"/>
+          </a:xfrm>
+          <a:prstGeom prst="rect">
+            <a:avLst/>
+          </a:prstGeom>
+          <a:noFill/>
+          <a:ln/>
+        </p:spPr>
+        <p:txBody>
+          <a:bodyPr wrap="square" lIns="0" tIns="0" rIns="0" bIns="0" rtlCol="0" anchor="t"/>
+          <a:lstStyle/>
+          <a:p>
+            <a:pPr algn="l" indent="0" marL="0">
+              <a:buNone/>
+            </a:pPr>
+            <a:r>
+              <a:rPr lang="en-US" sz="1100" dirty="0">
+                <a:solidFill>
+                  <a:srgbClr val="6B7280"/>
+                </a:solidFill>
+                <a:latin typeface="Courier New" pitchFamily="34" charset="0"/>
+                <a:ea typeface="Courier New" pitchFamily="34" charset="-122"/>
+                <a:cs typeface="Courier New" pitchFamily="34" charset="-120"/>
+              </a:rPr>
+              <a:t>CM4 가상 플랫폼 · JSON config 1장으로 조립</a:t>
+            </a:r>
+            <a:endParaRPr lang="en-US" sz="1100" dirty="0"/>
+          </a:p>
+        </p:txBody>
+      </p:sp>
+      <p:sp>
+        <p:nvSpPr>
+          <p:cNvPr id="8" name="Shape 5"/>
+          <p:cNvSpPr/>
+          <p:nvPr/>
+        </p:nvSpPr>
+        <p:spPr>
+          <a:xfrm>
+            <a:off x="1333195" y="2895905"/>
+            <a:ext cx="0" cy="533095"/>
+          </a:xfrm>
+          <a:prstGeom prst="line">
+            <a:avLst/>
+          </a:prstGeom>
+          <a:noFill/>
+          <a:ln w="38100">
+            <a:solidFill>
+              <a:srgbClr val="6B7280"/>
+            </a:solidFill>
+            <a:prstDash val="solid"/>
+          </a:ln>
+        </p:spPr>
+      </p:sp>
+      <p:sp>
+        <p:nvSpPr>
+          <p:cNvPr id="9" name="Shape 6"/>
+          <p:cNvSpPr/>
+          <p:nvPr/>
+        </p:nvSpPr>
+        <p:spPr>
+          <a:xfrm>
+            <a:off x="3556102" y="2895905"/>
+            <a:ext cx="0" cy="533095"/>
+          </a:xfrm>
+          <a:prstGeom prst="line">
+            <a:avLst/>
+          </a:prstGeom>
+          <a:noFill/>
+          <a:ln w="38100">
+            <a:solidFill>
+              <a:srgbClr val="6B7280"/>
+            </a:solidFill>
+            <a:prstDash val="solid"/>
+          </a:ln>
+        </p:spPr>
+      </p:sp>
+      <p:sp>
+        <p:nvSpPr>
+          <p:cNvPr id="10" name="Shape 7"/>
+          <p:cNvSpPr/>
+          <p:nvPr/>
+        </p:nvSpPr>
+        <p:spPr>
+          <a:xfrm>
+            <a:off x="5048402" y="2895905"/>
+            <a:ext cx="0" cy="533095"/>
+          </a:xfrm>
+          <a:prstGeom prst="line">
+            <a:avLst/>
+          </a:prstGeom>
+          <a:noFill/>
+          <a:ln w="38100">
+            <a:solidFill>
+              <a:srgbClr val="6B7280"/>
+            </a:solidFill>
+            <a:prstDash val="solid"/>
+          </a:ln>
+        </p:spPr>
+      </p:sp>
+      <p:sp>
+        <p:nvSpPr>
+          <p:cNvPr id="11" name="Shape 8"/>
+          <p:cNvSpPr/>
+          <p:nvPr/>
+        </p:nvSpPr>
+        <p:spPr>
+          <a:xfrm>
+            <a:off x="1270102" y="3759098"/>
+            <a:ext cx="0" cy="317297"/>
+          </a:xfrm>
+          <a:prstGeom prst="line">
+            <a:avLst/>
+          </a:prstGeom>
+          <a:noFill/>
+          <a:ln w="38100">
+            <a:solidFill>
+              <a:srgbClr val="6B7280"/>
+            </a:solidFill>
+            <a:prstDash val="solid"/>
+          </a:ln>
+        </p:spPr>
+      </p:sp>
+      <p:sp>
+        <p:nvSpPr>
+          <p:cNvPr id="12" name="Shape 9"/>
+          <p:cNvSpPr/>
+          <p:nvPr/>
+        </p:nvSpPr>
+        <p:spPr>
+          <a:xfrm>
+            <a:off x="2324405" y="3759098"/>
+            <a:ext cx="0" cy="317297"/>
+          </a:xfrm>
+          <a:prstGeom prst="line">
+            <a:avLst/>
+          </a:prstGeom>
+          <a:noFill/>
+          <a:ln w="38100">
+            <a:solidFill>
+              <a:srgbClr val="6B7280"/>
+            </a:solidFill>
+            <a:prstDash val="solid"/>
+          </a:ln>
+        </p:spPr>
+      </p:sp>
+      <p:sp>
+        <p:nvSpPr>
+          <p:cNvPr id="13" name="Shape 10"/>
+          <p:cNvSpPr/>
+          <p:nvPr/>
+        </p:nvSpPr>
+        <p:spPr>
+          <a:xfrm>
+            <a:off x="2831897" y="3759098"/>
+            <a:ext cx="0" cy="317297"/>
+          </a:xfrm>
+          <a:prstGeom prst="line">
+            <a:avLst/>
+          </a:prstGeom>
+          <a:noFill/>
+          <a:ln w="38100">
+            <a:solidFill>
+              <a:srgbClr val="6B7280"/>
+            </a:solidFill>
+            <a:prstDash val="solid"/>
+          </a:ln>
+        </p:spPr>
+      </p:sp>
+      <p:sp>
+        <p:nvSpPr>
+          <p:cNvPr id="14" name="Shape 11"/>
+          <p:cNvSpPr/>
+          <p:nvPr/>
+        </p:nvSpPr>
+        <p:spPr>
+          <a:xfrm>
+            <a:off x="3340303" y="3759098"/>
+            <a:ext cx="0" cy="317297"/>
+          </a:xfrm>
+          <a:prstGeom prst="line">
+            <a:avLst/>
+          </a:prstGeom>
+          <a:noFill/>
+          <a:ln w="38100">
+            <a:solidFill>
+              <a:srgbClr val="6B7280"/>
+            </a:solidFill>
+            <a:prstDash val="solid"/>
+          </a:ln>
+        </p:spPr>
+      </p:sp>
+      <p:sp>
+        <p:nvSpPr>
+          <p:cNvPr id="15" name="Shape 12"/>
+          <p:cNvSpPr/>
+          <p:nvPr/>
+        </p:nvSpPr>
+        <p:spPr>
+          <a:xfrm>
+            <a:off x="3847795" y="3759098"/>
+            <a:ext cx="0" cy="317297"/>
+          </a:xfrm>
+          <a:prstGeom prst="line">
+            <a:avLst/>
+          </a:prstGeom>
+          <a:noFill/>
+          <a:ln w="38100">
+            <a:solidFill>
+              <a:srgbClr val="6B7280"/>
+            </a:solidFill>
+            <a:prstDash val="solid"/>
+          </a:ln>
+        </p:spPr>
+      </p:sp>
+      <p:sp>
+        <p:nvSpPr>
+          <p:cNvPr id="16" name="Shape 13"/>
+          <p:cNvSpPr/>
+          <p:nvPr/>
+        </p:nvSpPr>
+        <p:spPr>
+          <a:xfrm>
+            <a:off x="5016398" y="3759098"/>
+            <a:ext cx="0" cy="317297"/>
+          </a:xfrm>
+          <a:prstGeom prst="line">
+            <a:avLst/>
+          </a:prstGeom>
+          <a:noFill/>
+          <a:ln w="38100">
+            <a:solidFill>
+              <a:srgbClr val="6B7280"/>
+            </a:solidFill>
+            <a:prstDash val="solid"/>
+          </a:ln>
+        </p:spPr>
+      </p:sp>
+      <p:sp>
+        <p:nvSpPr>
+          <p:cNvPr id="17" name="Shape 14"/>
+          <p:cNvSpPr/>
+          <p:nvPr/>
+        </p:nvSpPr>
+        <p:spPr>
+          <a:xfrm>
+            <a:off x="698602" y="2197303"/>
+            <a:ext cx="1270102" cy="698602"/>
+          </a:xfrm>
+          <a:prstGeom prst="roundRect">
+            <a:avLst>
+              <a:gd name="adj" fmla="val 10864"/>
+            </a:avLst>
+          </a:prstGeom>
+          <a:solidFill>
+            <a:srgbClr val="0F1B2D"/>
+          </a:solidFill>
+          <a:ln/>
+        </p:spPr>
+      </p:sp>
+      <p:sp>
+        <p:nvSpPr>
+          <p:cNvPr id="18" name="Text 15"/>
+          <p:cNvSpPr txBox="1"/>
+          <p:nvPr/>
+        </p:nvSpPr>
+        <p:spPr>
+          <a:xfrm>
+            <a:off x="698602" y="2286000"/>
+            <a:ext cx="1270102" cy="254203"/>
+          </a:xfrm>
+          <a:prstGeom prst="rect">
+            <a:avLst/>
+          </a:prstGeom>
+          <a:noFill/>
+          <a:ln/>
+        </p:spPr>
+        <p:txBody>
+          <a:bodyPr wrap="square" lIns="0" tIns="0" rIns="0" bIns="0" rtlCol="0" anchor="t"/>
+          <a:lstStyle/>
+          <a:p>
+            <a:pPr algn="ctr" indent="0" marL="0">
+              <a:buNone/>
+            </a:pPr>
+            <a:r>
+              <a:rPr lang="en-US" sz="1400" b="1" dirty="0">
+                <a:solidFill>
+                  <a:srgbClr val="FFFFFF"/>
+                </a:solidFill>
+                <a:latin typeface="Arial" pitchFamily="34" charset="0"/>
+                <a:ea typeface="Arial" pitchFamily="34" charset="-122"/>
+                <a:cs typeface="Arial" pitchFamily="34" charset="-120"/>
+              </a:rPr>
+              <a:t>Cortex-M4</a:t>
+            </a:r>
+            <a:endParaRPr lang="en-US" sz="1400" dirty="0"/>
+          </a:p>
+        </p:txBody>
+      </p:sp>
+      <p:sp>
+        <p:nvSpPr>
+          <p:cNvPr id="19" name="Text 16"/>
+          <p:cNvSpPr txBox="1"/>
+          <p:nvPr/>
+        </p:nvSpPr>
+        <p:spPr>
+          <a:xfrm>
+            <a:off x="698602" y="2577694"/>
+            <a:ext cx="1270102" cy="190195"/>
+          </a:xfrm>
+          <a:prstGeom prst="rect">
+            <a:avLst/>
+          </a:prstGeom>
+          <a:noFill/>
+          <a:ln/>
+        </p:spPr>
+        <p:txBody>
+          <a:bodyPr wrap="square" lIns="0" tIns="0" rIns="0" bIns="0" rtlCol="0" anchor="t"/>
+          <a:lstStyle/>
+          <a:p>
+            <a:pPr algn="ctr" indent="0" marL="0">
+              <a:buNone/>
+            </a:pPr>
+            <a:r>
+              <a:rPr lang="en-US" sz="1000" dirty="0">
+                <a:solidFill>
+                  <a:srgbClr val="BFD8D5"/>
+                </a:solidFill>
+                <a:latin typeface="Arial" pitchFamily="34" charset="0"/>
+                <a:ea typeface="Arial" pitchFamily="34" charset="-122"/>
+                <a:cs typeface="Arial" pitchFamily="34" charset="-120"/>
+              </a:rPr>
+              <a:t>FPU · NVIC · 3-stage</a:t>
+            </a:r>
+            <a:endParaRPr lang="en-US" sz="1000" dirty="0"/>
+          </a:p>
+        </p:txBody>
+      </p:sp>
+      <p:sp>
+        <p:nvSpPr>
+          <p:cNvPr id="20" name="Shape 17"/>
+          <p:cNvSpPr/>
+          <p:nvPr/>
+        </p:nvSpPr>
+        <p:spPr>
+          <a:xfrm>
+            <a:off x="1968703" y="2361895"/>
+            <a:ext cx="88697" cy="0"/>
+          </a:xfrm>
+          <a:prstGeom prst="line">
+            <a:avLst/>
+          </a:prstGeom>
+          <a:noFill/>
+          <a:ln w="38100">
+            <a:solidFill>
+              <a:srgbClr val="0F1B2D"/>
+            </a:solidFill>
+            <a:prstDash val="solid"/>
+          </a:ln>
+        </p:spPr>
+      </p:sp>
+      <p:sp>
+        <p:nvSpPr>
+          <p:cNvPr id="21" name="Shape 18"/>
+          <p:cNvSpPr/>
+          <p:nvPr/>
+        </p:nvSpPr>
+        <p:spPr>
+          <a:xfrm>
+            <a:off x="1968703" y="2730398"/>
+            <a:ext cx="88697" cy="0"/>
+          </a:xfrm>
+          <a:prstGeom prst="line">
+            <a:avLst/>
+          </a:prstGeom>
+          <a:noFill/>
+          <a:ln w="38100">
+            <a:solidFill>
+              <a:srgbClr val="0F1B2D"/>
+            </a:solidFill>
+            <a:prstDash val="solid"/>
+          </a:ln>
+        </p:spPr>
+      </p:sp>
+      <p:sp>
+        <p:nvSpPr>
+          <p:cNvPr id="22" name="Shape 19"/>
+          <p:cNvSpPr/>
+          <p:nvPr/>
+        </p:nvSpPr>
+        <p:spPr>
+          <a:xfrm>
+            <a:off x="2057400" y="2197303"/>
+            <a:ext cx="672998" cy="330098"/>
+          </a:xfrm>
+          <a:prstGeom prst="roundRect">
+            <a:avLst>
+              <a:gd name="adj" fmla="val 15512"/>
+            </a:avLst>
+          </a:prstGeom>
+          <a:solidFill>
+            <a:srgbClr val="FFFFFF"/>
+          </a:solidFill>
+          <a:ln w="19050">
+            <a:solidFill>
+              <a:srgbClr val="0F1B2D"/>
+            </a:solidFill>
+            <a:prstDash val="solid"/>
+          </a:ln>
+        </p:spPr>
+      </p:sp>
+      <p:sp>
+        <p:nvSpPr>
+          <p:cNvPr id="23" name="Text 20"/>
+          <p:cNvSpPr txBox="1"/>
+          <p:nvPr/>
+        </p:nvSpPr>
+        <p:spPr>
+          <a:xfrm>
+            <a:off x="2057400" y="2216506"/>
+            <a:ext cx="672998" cy="304495"/>
+          </a:xfrm>
+          <a:prstGeom prst="rect">
+            <a:avLst/>
+          </a:prstGeom>
+          <a:noFill/>
+          <a:ln/>
+        </p:spPr>
+        <p:txBody>
+          <a:bodyPr wrap="square" lIns="0" tIns="0" rIns="0" bIns="0" rtlCol="0" anchor="t"/>
           <a:lstStyle/>
           <a:p>
             <a:pPr algn="ctr" indent="0" marL="0">
               <a:lnSpc>
-                <a:spcPct val="140000"/>
+                <a:spcPct val="110000"/>
               </a:lnSpc>
               <a:buNone/>
             </a:pPr>
             <a:r>
-              <a:rPr lang="en-US" sz="1400" dirty="0">
-                <a:solidFill>
-                  <a:srgbClr val="6B7280"/>
-                </a:solidFill>
-                <a:latin typeface="Arial" pitchFamily="34" charset="0"/>
-                <a:ea typeface="Arial" pitchFamily="34" charset="-122"/>
-                <a:cs typeface="Arial" pitchFamily="34" charset="-120"/>
-              </a:rPr>
-              <a:t>[아키텍처 그림 자리]</a:t>
-            </a:r>
-            <a:endParaRPr lang="en-US" sz="1400" dirty="0"/>
+              <a:rPr lang="en-US" sz="950" b="1" dirty="0">
+                <a:solidFill>
+                  <a:srgbClr val="0F1B2D"/>
+                </a:solidFill>
+                <a:latin typeface="Arial" pitchFamily="34" charset="0"/>
+                <a:ea typeface="Arial" pitchFamily="34" charset="-122"/>
+                <a:cs typeface="Arial" pitchFamily="34" charset="-120"/>
+              </a:rPr>
+              <a:t>ITCM</a:t>
+            </a:r>
+            <a:endParaRPr lang="en-US" sz="950" dirty="0"/>
           </a:p>
           <a:p>
             <a:pPr algn="ctr" indent="0" marL="0">
               <a:lnSpc>
-                <a:spcPct val="140000"/>
+                <a:spcPct val="110000"/>
               </a:lnSpc>
               <a:buNone/>
             </a:pPr>
             <a:r>
-              <a:rPr lang="en-US" sz="1400" dirty="0">
-                <a:solidFill>
-                  <a:srgbClr val="6B7280"/>
-                </a:solidFill>
-                <a:latin typeface="Arial" pitchFamily="34" charset="0"/>
-                <a:ea typeface="Arial" pitchFamily="34" charset="-122"/>
-                <a:cs typeface="Arial" pitchFamily="34" charset="-120"/>
-              </a:rPr>
-              <a:t>CM4 + TCM · SRAM 뱅크 · Flash · DMA · MAC</a:t>
-            </a:r>
-            <a:endParaRPr lang="en-US" sz="1400" dirty="0"/>
-          </a:p>
+              <a:rPr lang="en-US" sz="950" dirty="0">
+                <a:solidFill>
+                  <a:srgbClr val="4A5568"/>
+                </a:solidFill>
+                <a:latin typeface="Arial" pitchFamily="34" charset="0"/>
+                <a:ea typeface="Arial" pitchFamily="34" charset="-122"/>
+                <a:cs typeface="Arial" pitchFamily="34" charset="-120"/>
+              </a:rPr>
+              <a:t>16–64 KB</a:t>
+            </a:r>
+            <a:endParaRPr lang="en-US" sz="950" dirty="0"/>
+          </a:p>
+        </p:txBody>
+      </p:sp>
+      <p:sp>
+        <p:nvSpPr>
+          <p:cNvPr id="24" name="Shape 21"/>
+          <p:cNvSpPr/>
+          <p:nvPr/>
+        </p:nvSpPr>
+        <p:spPr>
+          <a:xfrm>
+            <a:off x="2673706" y="2139696"/>
+            <a:ext cx="114300" cy="114300"/>
+          </a:xfrm>
+          <a:prstGeom prst="ellipse">
+            <a:avLst/>
+          </a:prstGeom>
+          <a:solidFill>
+            <a:srgbClr val="E8A33D"/>
+          </a:solidFill>
+          <a:ln/>
+        </p:spPr>
+      </p:sp>
+      <p:sp>
+        <p:nvSpPr>
+          <p:cNvPr id="25" name="Shape 22"/>
+          <p:cNvSpPr/>
+          <p:nvPr/>
+        </p:nvSpPr>
+        <p:spPr>
+          <a:xfrm>
+            <a:off x="2057400" y="2564892"/>
+            <a:ext cx="672998" cy="330098"/>
+          </a:xfrm>
+          <a:prstGeom prst="roundRect">
+            <a:avLst>
+              <a:gd name="adj" fmla="val 15512"/>
+            </a:avLst>
+          </a:prstGeom>
+          <a:solidFill>
+            <a:srgbClr val="FFFFFF"/>
+          </a:solidFill>
+          <a:ln w="19050">
+            <a:solidFill>
+              <a:srgbClr val="0F1B2D"/>
+            </a:solidFill>
+            <a:prstDash val="solid"/>
+          </a:ln>
+        </p:spPr>
+      </p:sp>
+      <p:sp>
+        <p:nvSpPr>
+          <p:cNvPr id="26" name="Text 23"/>
+          <p:cNvSpPr txBox="1"/>
+          <p:nvPr/>
+        </p:nvSpPr>
+        <p:spPr>
+          <a:xfrm>
+            <a:off x="2057400" y="2584094"/>
+            <a:ext cx="672998" cy="304495"/>
+          </a:xfrm>
+          <a:prstGeom prst="rect">
+            <a:avLst/>
+          </a:prstGeom>
+          <a:noFill/>
+          <a:ln/>
+        </p:spPr>
+        <p:txBody>
+          <a:bodyPr wrap="square" lIns="0" tIns="0" rIns="0" bIns="0" rtlCol="0" anchor="t"/>
+          <a:lstStyle/>
           <a:p>
             <a:pPr algn="ctr" indent="0" marL="0">
               <a:lnSpc>
-                <a:spcPct val="140000"/>
+                <a:spcPct val="110000"/>
               </a:lnSpc>
               <a:buNone/>
             </a:pPr>
             <a:r>
-              <a:rPr lang="en-US" sz="1400" dirty="0">
-                <a:solidFill>
-                  <a:srgbClr val="6B7280"/>
-                </a:solidFill>
-                <a:latin typeface="Arial" pitchFamily="34" charset="0"/>
-                <a:ea typeface="Arial" pitchFamily="34" charset="-122"/>
-                <a:cs typeface="Arial" pitchFamily="34" charset="-120"/>
-              </a:rPr>
-              <a:t>AHB 매트릭스 (직접 삽입)</a:t>
+              <a:rPr lang="en-US" sz="950" b="1" dirty="0">
+                <a:solidFill>
+                  <a:srgbClr val="0F1B2D"/>
+                </a:solidFill>
+                <a:latin typeface="Arial" pitchFamily="34" charset="0"/>
+                <a:ea typeface="Arial" pitchFamily="34" charset="-122"/>
+                <a:cs typeface="Arial" pitchFamily="34" charset="-120"/>
+              </a:rPr>
+              <a:t>DTCM</a:t>
+            </a:r>
+            <a:endParaRPr lang="en-US" sz="950" dirty="0"/>
+          </a:p>
+          <a:p>
+            <a:pPr algn="ctr" indent="0" marL="0">
+              <a:lnSpc>
+                <a:spcPct val="110000"/>
+              </a:lnSpc>
+              <a:buNone/>
+            </a:pPr>
+            <a:r>
+              <a:rPr lang="en-US" sz="950" dirty="0">
+                <a:solidFill>
+                  <a:srgbClr val="4A5568"/>
+                </a:solidFill>
+                <a:latin typeface="Arial" pitchFamily="34" charset="0"/>
+                <a:ea typeface="Arial" pitchFamily="34" charset="-122"/>
+                <a:cs typeface="Arial" pitchFamily="34" charset="-120"/>
+              </a:rPr>
+              <a:t>16–64 KB</a:t>
+            </a:r>
+            <a:endParaRPr lang="en-US" sz="950" dirty="0"/>
+          </a:p>
+        </p:txBody>
+      </p:sp>
+      <p:sp>
+        <p:nvSpPr>
+          <p:cNvPr id="27" name="Shape 24"/>
+          <p:cNvSpPr/>
+          <p:nvPr/>
+        </p:nvSpPr>
+        <p:spPr>
+          <a:xfrm>
+            <a:off x="2673706" y="2508199"/>
+            <a:ext cx="114300" cy="114300"/>
+          </a:xfrm>
+          <a:prstGeom prst="ellipse">
+            <a:avLst/>
+          </a:prstGeom>
+          <a:solidFill>
+            <a:srgbClr val="E8A33D"/>
+          </a:solidFill>
+          <a:ln/>
+        </p:spPr>
+      </p:sp>
+      <p:sp>
+        <p:nvSpPr>
+          <p:cNvPr id="28" name="Shape 25"/>
+          <p:cNvSpPr/>
+          <p:nvPr/>
+        </p:nvSpPr>
+        <p:spPr>
+          <a:xfrm>
+            <a:off x="856793" y="3022092"/>
+            <a:ext cx="952805" cy="254203"/>
+          </a:xfrm>
+          <a:prstGeom prst="roundRect">
+            <a:avLst>
+              <a:gd name="adj" fmla="val 50000"/>
+            </a:avLst>
+          </a:prstGeom>
+          <a:solidFill>
+            <a:srgbClr val="FFFFFF"/>
+          </a:solidFill>
+          <a:ln w="19050">
+            <a:solidFill>
+              <a:srgbClr val="0F1B2D"/>
+            </a:solidFill>
+            <a:prstDash val="solid"/>
+          </a:ln>
+        </p:spPr>
+      </p:sp>
+      <p:sp>
+        <p:nvSpPr>
+          <p:cNvPr id="29" name="Text 26"/>
+          <p:cNvSpPr txBox="1"/>
+          <p:nvPr/>
+        </p:nvSpPr>
+        <p:spPr>
+          <a:xfrm>
+            <a:off x="856793" y="3022092"/>
+            <a:ext cx="952805" cy="254203"/>
+          </a:xfrm>
+          <a:prstGeom prst="rect">
+            <a:avLst/>
+          </a:prstGeom>
+          <a:noFill/>
+          <a:ln/>
+        </p:spPr>
+        <p:txBody>
+          <a:bodyPr wrap="square" lIns="0" tIns="0" rIns="0" bIns="0" rtlCol="0" anchor="ctr"/>
+          <a:lstStyle/>
+          <a:p>
+            <a:pPr algn="ctr" indent="0" marL="0">
+              <a:buNone/>
+            </a:pPr>
+            <a:r>
+              <a:rPr lang="en-US" sz="950" b="1" dirty="0">
+                <a:solidFill>
+                  <a:srgbClr val="0F1B2D"/>
+                </a:solidFill>
+                <a:latin typeface="Arial" pitchFamily="34" charset="0"/>
+                <a:ea typeface="Arial" pitchFamily="34" charset="-122"/>
+                <a:cs typeface="Arial" pitchFamily="34" charset="-120"/>
+              </a:rPr>
+              <a:t>I-Cache 0–4 KB</a:t>
+            </a:r>
+            <a:endParaRPr lang="en-US" sz="950" dirty="0"/>
+          </a:p>
+        </p:txBody>
+      </p:sp>
+      <p:sp>
+        <p:nvSpPr>
+          <p:cNvPr id="30" name="Shape 27"/>
+          <p:cNvSpPr/>
+          <p:nvPr/>
+        </p:nvSpPr>
+        <p:spPr>
+          <a:xfrm>
+            <a:off x="1752905" y="2965399"/>
+            <a:ext cx="114300" cy="114300"/>
+          </a:xfrm>
+          <a:prstGeom prst="ellipse">
+            <a:avLst/>
+          </a:prstGeom>
+          <a:solidFill>
+            <a:srgbClr val="E8A33D"/>
+          </a:solidFill>
+          <a:ln/>
+        </p:spPr>
+      </p:sp>
+      <p:sp>
+        <p:nvSpPr>
+          <p:cNvPr id="31" name="Shape 28"/>
+          <p:cNvSpPr/>
+          <p:nvPr/>
+        </p:nvSpPr>
+        <p:spPr>
+          <a:xfrm>
+            <a:off x="3047695" y="2197303"/>
+            <a:ext cx="1015898" cy="698602"/>
+          </a:xfrm>
+          <a:prstGeom prst="roundRect">
+            <a:avLst>
+              <a:gd name="adj" fmla="val 10864"/>
+            </a:avLst>
+          </a:prstGeom>
+          <a:solidFill>
+            <a:srgbClr val="0F1B2D"/>
+          </a:solidFill>
+          <a:ln/>
+        </p:spPr>
+      </p:sp>
+      <p:sp>
+        <p:nvSpPr>
+          <p:cNvPr id="32" name="Text 29"/>
+          <p:cNvSpPr txBox="1"/>
+          <p:nvPr/>
+        </p:nvSpPr>
+        <p:spPr>
+          <a:xfrm>
+            <a:off x="3047695" y="2286000"/>
+            <a:ext cx="1015898" cy="254203"/>
+          </a:xfrm>
+          <a:prstGeom prst="rect">
+            <a:avLst/>
+          </a:prstGeom>
+          <a:noFill/>
+          <a:ln/>
+        </p:spPr>
+        <p:txBody>
+          <a:bodyPr wrap="square" lIns="0" tIns="0" rIns="0" bIns="0" rtlCol="0" anchor="t"/>
+          <a:lstStyle/>
+          <a:p>
+            <a:pPr algn="ctr" indent="0" marL="0">
+              <a:buNone/>
+            </a:pPr>
+            <a:r>
+              <a:rPr lang="en-US" sz="1400" b="1" dirty="0">
+                <a:solidFill>
+                  <a:srgbClr val="FFFFFF"/>
+                </a:solidFill>
+                <a:latin typeface="Arial" pitchFamily="34" charset="0"/>
+                <a:ea typeface="Arial" pitchFamily="34" charset="-122"/>
+                <a:cs typeface="Arial" pitchFamily="34" charset="-120"/>
+              </a:rPr>
+              <a:t>DMA</a:t>
             </a:r>
             <a:endParaRPr lang="en-US" sz="1400" dirty="0"/>
           </a:p>
@@ -20436,7 +21872,990 @@
       </p:sp>
       <p:sp>
         <p:nvSpPr>
-          <p:cNvPr id="8" name="Shape 5"/>
+          <p:cNvPr id="33" name="Text 30"/>
+          <p:cNvSpPr txBox="1"/>
+          <p:nvPr/>
+        </p:nvSpPr>
+        <p:spPr>
+          <a:xfrm>
+            <a:off x="3047695" y="2564892"/>
+            <a:ext cx="1015898" cy="317297"/>
+          </a:xfrm>
+          <a:prstGeom prst="rect">
+            <a:avLst/>
+          </a:prstGeom>
+          <a:noFill/>
+          <a:ln/>
+        </p:spPr>
+        <p:txBody>
+          <a:bodyPr wrap="square" lIns="0" tIns="0" rIns="0" bIns="0" rtlCol="0" anchor="t"/>
+          <a:lstStyle/>
+          <a:p>
+            <a:pPr algn="ctr" indent="0" marL="0">
+              <a:lnSpc>
+                <a:spcPct val="115000"/>
+              </a:lnSpc>
+              <a:buNone/>
+            </a:pPr>
+            <a:r>
+              <a:rPr lang="en-US" sz="1000" dirty="0">
+                <a:solidFill>
+                  <a:srgbClr val="BFD8D5"/>
+                </a:solidFill>
+                <a:latin typeface="Arial" pitchFamily="34" charset="0"/>
+                <a:ea typeface="Arial" pitchFamily="34" charset="-122"/>
+                <a:cs typeface="Arial" pitchFamily="34" charset="-120"/>
+              </a:rPr>
+              <a:t>2ch · burst 1–16</a:t>
+            </a:r>
+            <a:endParaRPr lang="en-US" sz="1000" dirty="0"/>
+          </a:p>
+          <a:p>
+            <a:pPr algn="ctr" indent="0" marL="0">
+              <a:lnSpc>
+                <a:spcPct val="115000"/>
+              </a:lnSpc>
+              <a:buNone/>
+            </a:pPr>
+            <a:r>
+              <a:rPr lang="en-US" sz="1000" dirty="0">
+                <a:solidFill>
+                  <a:srgbClr val="BFD8D5"/>
+                </a:solidFill>
+                <a:latin typeface="Arial" pitchFamily="34" charset="0"/>
+                <a:ea typeface="Arial" pitchFamily="34" charset="-122"/>
+                <a:cs typeface="Arial" pitchFamily="34" charset="-120"/>
+              </a:rPr>
+              <a:t>오디오 → SRAM</a:t>
+            </a:r>
+            <a:endParaRPr lang="en-US" sz="1000" dirty="0"/>
+          </a:p>
+        </p:txBody>
+      </p:sp>
+      <p:sp>
+        <p:nvSpPr>
+          <p:cNvPr id="34" name="Shape 31"/>
+          <p:cNvSpPr/>
+          <p:nvPr/>
+        </p:nvSpPr>
+        <p:spPr>
+          <a:xfrm>
+            <a:off x="4006901" y="2139696"/>
+            <a:ext cx="114300" cy="114300"/>
+          </a:xfrm>
+          <a:prstGeom prst="ellipse">
+            <a:avLst/>
+          </a:prstGeom>
+          <a:solidFill>
+            <a:srgbClr val="E8A33D"/>
+          </a:solidFill>
+          <a:ln/>
+        </p:spPr>
+      </p:sp>
+      <p:sp>
+        <p:nvSpPr>
+          <p:cNvPr id="35" name="Shape 32"/>
+          <p:cNvSpPr/>
+          <p:nvPr/>
+        </p:nvSpPr>
+        <p:spPr>
+          <a:xfrm>
+            <a:off x="4444898" y="2197303"/>
+            <a:ext cx="1206094" cy="698602"/>
+          </a:xfrm>
+          <a:prstGeom prst="roundRect">
+            <a:avLst>
+              <a:gd name="adj" fmla="val 10864"/>
+            </a:avLst>
+          </a:prstGeom>
+          <a:solidFill>
+            <a:srgbClr val="FFFFFF"/>
+          </a:solidFill>
+          <a:ln w="28575">
+            <a:solidFill>
+              <a:srgbClr val="B8791F"/>
+            </a:solidFill>
+            <a:prstDash val="dash"/>
+          </a:ln>
+        </p:spPr>
+      </p:sp>
+      <p:sp>
+        <p:nvSpPr>
+          <p:cNvPr id="36" name="Text 33"/>
+          <p:cNvSpPr txBox="1"/>
+          <p:nvPr/>
+        </p:nvSpPr>
+        <p:spPr>
+          <a:xfrm>
+            <a:off x="4444898" y="2286000"/>
+            <a:ext cx="1206094" cy="254203"/>
+          </a:xfrm>
+          <a:prstGeom prst="rect">
+            <a:avLst/>
+          </a:prstGeom>
+          <a:noFill/>
+          <a:ln/>
+        </p:spPr>
+        <p:txBody>
+          <a:bodyPr wrap="square" lIns="0" tIns="0" rIns="0" bIns="0" rtlCol="0" anchor="t"/>
+          <a:lstStyle/>
+          <a:p>
+            <a:pPr algn="ctr" indent="0" marL="0">
+              <a:buNone/>
+            </a:pPr>
+            <a:r>
+              <a:rPr lang="en-US" sz="1400" b="1" dirty="0">
+                <a:solidFill>
+                  <a:srgbClr val="B8791F"/>
+                </a:solidFill>
+                <a:latin typeface="Arial" pitchFamily="34" charset="0"/>
+                <a:ea typeface="Arial" pitchFamily="34" charset="-122"/>
+                <a:cs typeface="Arial" pitchFamily="34" charset="-120"/>
+              </a:rPr>
+              <a:t>MAC 가속기</a:t>
+            </a:r>
+            <a:endParaRPr lang="en-US" sz="1400" dirty="0"/>
+          </a:p>
+        </p:txBody>
+      </p:sp>
+      <p:sp>
+        <p:nvSpPr>
+          <p:cNvPr id="37" name="Text 34"/>
+          <p:cNvSpPr txBox="1"/>
+          <p:nvPr/>
+        </p:nvSpPr>
+        <p:spPr>
+          <a:xfrm>
+            <a:off x="4444898" y="2553005"/>
+            <a:ext cx="1206094" cy="317297"/>
+          </a:xfrm>
+          <a:prstGeom prst="rect">
+            <a:avLst/>
+          </a:prstGeom>
+          <a:noFill/>
+          <a:ln/>
+        </p:spPr>
+        <p:txBody>
+          <a:bodyPr wrap="square" lIns="0" tIns="0" rIns="0" bIns="0" rtlCol="0" anchor="t"/>
+          <a:lstStyle/>
+          <a:p>
+            <a:pPr algn="ctr" indent="0" marL="0">
+              <a:lnSpc>
+                <a:spcPct val="115000"/>
+              </a:lnSpc>
+              <a:buNone/>
+            </a:pPr>
+            <a:r>
+              <a:rPr lang="en-US" sz="950" dirty="0">
+                <a:solidFill>
+                  <a:srgbClr val="4A5568"/>
+                </a:solidFill>
+                <a:latin typeface="Arial" pitchFamily="34" charset="0"/>
+                <a:ea typeface="Arial" pitchFamily="34" charset="-122"/>
+                <a:cs typeface="Arial" pitchFamily="34" charset="-120"/>
+              </a:rPr>
+              <a:t>INT8 dot-product</a:t>
+            </a:r>
+            <a:endParaRPr lang="en-US" sz="950" dirty="0"/>
+          </a:p>
+          <a:p>
+            <a:pPr algn="ctr" indent="0" marL="0">
+              <a:lnSpc>
+                <a:spcPct val="115000"/>
+              </a:lnSpc>
+              <a:buNone/>
+            </a:pPr>
+            <a:r>
+              <a:rPr lang="en-US" sz="950" dirty="0">
+                <a:solidFill>
+                  <a:srgbClr val="4A5568"/>
+                </a:solidFill>
+                <a:latin typeface="Arial" pitchFamily="34" charset="0"/>
+                <a:ea typeface="Arial" pitchFamily="34" charset="-122"/>
+                <a:cs typeface="Arial" pitchFamily="34" charset="-120"/>
+              </a:rPr>
+              <a:t>옵션 (예산 ≤470)</a:t>
+            </a:r>
+            <a:endParaRPr lang="en-US" sz="950" dirty="0"/>
+          </a:p>
+        </p:txBody>
+      </p:sp>
+      <p:sp>
+        <p:nvSpPr>
+          <p:cNvPr id="38" name="Shape 35"/>
+          <p:cNvSpPr/>
+          <p:nvPr/>
+        </p:nvSpPr>
+        <p:spPr>
+          <a:xfrm>
+            <a:off x="5594299" y="2139696"/>
+            <a:ext cx="114300" cy="114300"/>
+          </a:xfrm>
+          <a:prstGeom prst="ellipse">
+            <a:avLst/>
+          </a:prstGeom>
+          <a:solidFill>
+            <a:srgbClr val="E8A33D"/>
+          </a:solidFill>
+          <a:ln/>
+        </p:spPr>
+      </p:sp>
+      <p:sp>
+        <p:nvSpPr>
+          <p:cNvPr id="39" name="Shape 36"/>
+          <p:cNvSpPr/>
+          <p:nvPr/>
+        </p:nvSpPr>
+        <p:spPr>
+          <a:xfrm>
+            <a:off x="698602" y="3429000"/>
+            <a:ext cx="4953305" cy="330098"/>
+          </a:xfrm>
+          <a:prstGeom prst="roundRect">
+            <a:avLst>
+              <a:gd name="adj" fmla="val 19114"/>
+            </a:avLst>
+          </a:prstGeom>
+          <a:solidFill>
+            <a:srgbClr val="2FA6A0"/>
+          </a:solidFill>
+          <a:ln/>
+        </p:spPr>
+      </p:sp>
+      <p:sp>
+        <p:nvSpPr>
+          <p:cNvPr id="40" name="Text 37"/>
+          <p:cNvSpPr txBox="1"/>
+          <p:nvPr/>
+        </p:nvSpPr>
+        <p:spPr>
+          <a:xfrm>
+            <a:off x="698602" y="3429000"/>
+            <a:ext cx="4953305" cy="330098"/>
+          </a:xfrm>
+          <a:prstGeom prst="rect">
+            <a:avLst/>
+          </a:prstGeom>
+          <a:noFill/>
+          <a:ln/>
+        </p:spPr>
+        <p:txBody>
+          <a:bodyPr wrap="square" lIns="0" tIns="0" rIns="0" bIns="0" rtlCol="0" anchor="ctr"/>
+          <a:lstStyle/>
+          <a:p>
+            <a:pPr algn="ctr" indent="0" marL="0">
+              <a:buNone/>
+            </a:pPr>
+            <a:r>
+              <a:rPr lang="en-US" sz="1200" b="1" dirty="0">
+                <a:solidFill>
+                  <a:srgbClr val="FFFFFF"/>
+                </a:solidFill>
+                <a:latin typeface="Arial" pitchFamily="34" charset="0"/>
+                <a:ea typeface="Arial" pitchFamily="34" charset="-122"/>
+                <a:cs typeface="Arial" pitchFamily="34" charset="-120"/>
+              </a:rPr>
+              <a:t>AHB 매트릭스 · 마스터 3개의 경합을 cycle 단위로 모델링</a:t>
+            </a:r>
+            <a:endParaRPr lang="en-US" sz="1200" dirty="0"/>
+          </a:p>
+        </p:txBody>
+      </p:sp>
+      <p:sp>
+        <p:nvSpPr>
+          <p:cNvPr id="41" name="Shape 38"/>
+          <p:cNvSpPr/>
+          <p:nvPr/>
+        </p:nvSpPr>
+        <p:spPr>
+          <a:xfrm>
+            <a:off x="698602" y="4076395"/>
+            <a:ext cx="1143000" cy="508406"/>
+          </a:xfrm>
+          <a:prstGeom prst="roundRect">
+            <a:avLst>
+              <a:gd name="adj" fmla="val 14928"/>
+            </a:avLst>
+          </a:prstGeom>
+          <a:solidFill>
+            <a:srgbClr val="FFFFFF"/>
+          </a:solidFill>
+          <a:ln w="19050">
+            <a:solidFill>
+              <a:srgbClr val="0F1B2D"/>
+            </a:solidFill>
+            <a:prstDash val="solid"/>
+          </a:ln>
+        </p:spPr>
+      </p:sp>
+      <p:sp>
+        <p:nvSpPr>
+          <p:cNvPr id="42" name="Text 39"/>
+          <p:cNvSpPr txBox="1"/>
+          <p:nvPr/>
+        </p:nvSpPr>
+        <p:spPr>
+          <a:xfrm>
+            <a:off x="698602" y="4127602"/>
+            <a:ext cx="1143000" cy="190195"/>
+          </a:xfrm>
+          <a:prstGeom prst="rect">
+            <a:avLst/>
+          </a:prstGeom>
+          <a:noFill/>
+          <a:ln/>
+        </p:spPr>
+        <p:txBody>
+          <a:bodyPr wrap="square" lIns="0" tIns="0" rIns="0" bIns="0" rtlCol="0" anchor="t"/>
+          <a:lstStyle/>
+          <a:p>
+            <a:pPr algn="ctr" indent="0" marL="0">
+              <a:buNone/>
+            </a:pPr>
+            <a:r>
+              <a:rPr lang="en-US" sz="1100" b="1" dirty="0">
+                <a:solidFill>
+                  <a:srgbClr val="0F1B2D"/>
+                </a:solidFill>
+                <a:latin typeface="Arial" pitchFamily="34" charset="0"/>
+                <a:ea typeface="Arial" pitchFamily="34" charset="-122"/>
+                <a:cs typeface="Arial" pitchFamily="34" charset="-120"/>
+              </a:rPr>
+              <a:t>Flash 512 KB</a:t>
+            </a:r>
+            <a:endParaRPr lang="en-US" sz="1100" dirty="0"/>
+          </a:p>
+        </p:txBody>
+      </p:sp>
+      <p:sp>
+        <p:nvSpPr>
+          <p:cNvPr id="43" name="Text 40"/>
+          <p:cNvSpPr txBox="1"/>
+          <p:nvPr/>
+        </p:nvSpPr>
+        <p:spPr>
+          <a:xfrm>
+            <a:off x="698602" y="4356202"/>
+            <a:ext cx="1143000" cy="177394"/>
+          </a:xfrm>
+          <a:prstGeom prst="rect">
+            <a:avLst/>
+          </a:prstGeom>
+          <a:noFill/>
+          <a:ln/>
+        </p:spPr>
+        <p:txBody>
+          <a:bodyPr wrap="square" lIns="0" tIns="0" rIns="0" bIns="0" rtlCol="0" anchor="t"/>
+          <a:lstStyle/>
+          <a:p>
+            <a:pPr algn="ctr" indent="0" marL="0">
+              <a:buNone/>
+            </a:pPr>
+            <a:r>
+              <a:rPr lang="en-US" sz="950" dirty="0">
+                <a:solidFill>
+                  <a:srgbClr val="4A5568"/>
+                </a:solidFill>
+                <a:latin typeface="Arial" pitchFamily="34" charset="0"/>
+                <a:ea typeface="Arial" pitchFamily="34" charset="-122"/>
+                <a:cs typeface="Arial" pitchFamily="34" charset="-120"/>
+              </a:rPr>
+              <a:t>WS 6→4 · prefetch</a:t>
+            </a:r>
+            <a:endParaRPr lang="en-US" sz="950" dirty="0"/>
+          </a:p>
+        </p:txBody>
+      </p:sp>
+      <p:sp>
+        <p:nvSpPr>
+          <p:cNvPr id="44" name="Shape 41"/>
+          <p:cNvSpPr/>
+          <p:nvPr/>
+        </p:nvSpPr>
+        <p:spPr>
+          <a:xfrm>
+            <a:off x="1783994" y="4019702"/>
+            <a:ext cx="114300" cy="114300"/>
+          </a:xfrm>
+          <a:prstGeom prst="ellipse">
+            <a:avLst/>
+          </a:prstGeom>
+          <a:solidFill>
+            <a:srgbClr val="E8A33D"/>
+          </a:solidFill>
+          <a:ln/>
+        </p:spPr>
+      </p:sp>
+      <p:sp>
+        <p:nvSpPr>
+          <p:cNvPr id="45" name="Shape 42"/>
+          <p:cNvSpPr/>
+          <p:nvPr/>
+        </p:nvSpPr>
+        <p:spPr>
+          <a:xfrm>
+            <a:off x="2095805" y="4076395"/>
+            <a:ext cx="457200" cy="508406"/>
+          </a:xfrm>
+          <a:prstGeom prst="roundRect">
+            <a:avLst>
+              <a:gd name="adj" fmla="val 13800"/>
+            </a:avLst>
+          </a:prstGeom>
+          <a:solidFill>
+            <a:srgbClr val="FFFFFF"/>
+          </a:solidFill>
+          <a:ln w="19050">
+            <a:solidFill>
+              <a:srgbClr val="0F1B2D"/>
+            </a:solidFill>
+            <a:prstDash val="solid"/>
+          </a:ln>
+        </p:spPr>
+      </p:sp>
+      <p:sp>
+        <p:nvSpPr>
+          <p:cNvPr id="46" name="Text 43"/>
+          <p:cNvSpPr txBox="1"/>
+          <p:nvPr/>
+        </p:nvSpPr>
+        <p:spPr>
+          <a:xfrm>
+            <a:off x="2095805" y="4076395"/>
+            <a:ext cx="457200" cy="508406"/>
+          </a:xfrm>
+          <a:prstGeom prst="rect">
+            <a:avLst/>
+          </a:prstGeom>
+          <a:noFill/>
+          <a:ln/>
+        </p:spPr>
+        <p:txBody>
+          <a:bodyPr wrap="square" lIns="0" tIns="0" rIns="0" bIns="0" rtlCol="0" anchor="ctr"/>
+          <a:lstStyle/>
+          <a:p>
+            <a:pPr algn="ctr" indent="0" marL="0">
+              <a:buNone/>
+            </a:pPr>
+            <a:r>
+              <a:rPr lang="en-US" sz="950" b="1" dirty="0">
+                <a:solidFill>
+                  <a:srgbClr val="0F1B2D"/>
+                </a:solidFill>
+                <a:latin typeface="Arial" pitchFamily="34" charset="0"/>
+                <a:ea typeface="Arial" pitchFamily="34" charset="-122"/>
+                <a:cs typeface="Arial" pitchFamily="34" charset="-120"/>
+              </a:rPr>
+              <a:t>SRAM0</a:t>
+            </a:r>
+            <a:endParaRPr lang="en-US" sz="950" dirty="0"/>
+          </a:p>
+        </p:txBody>
+      </p:sp>
+      <p:sp>
+        <p:nvSpPr>
+          <p:cNvPr id="47" name="Shape 44"/>
+          <p:cNvSpPr/>
+          <p:nvPr/>
+        </p:nvSpPr>
+        <p:spPr>
+          <a:xfrm>
+            <a:off x="2603297" y="4076395"/>
+            <a:ext cx="457200" cy="508406"/>
+          </a:xfrm>
+          <a:prstGeom prst="roundRect">
+            <a:avLst>
+              <a:gd name="adj" fmla="val 13800"/>
+            </a:avLst>
+          </a:prstGeom>
+          <a:solidFill>
+            <a:srgbClr val="FFFFFF"/>
+          </a:solidFill>
+          <a:ln w="19050">
+            <a:solidFill>
+              <a:srgbClr val="0F1B2D"/>
+            </a:solidFill>
+            <a:prstDash val="solid"/>
+          </a:ln>
+        </p:spPr>
+      </p:sp>
+      <p:sp>
+        <p:nvSpPr>
+          <p:cNvPr id="48" name="Text 45"/>
+          <p:cNvSpPr txBox="1"/>
+          <p:nvPr/>
+        </p:nvSpPr>
+        <p:spPr>
+          <a:xfrm>
+            <a:off x="2603297" y="4076395"/>
+            <a:ext cx="457200" cy="508406"/>
+          </a:xfrm>
+          <a:prstGeom prst="rect">
+            <a:avLst/>
+          </a:prstGeom>
+          <a:noFill/>
+          <a:ln/>
+        </p:spPr>
+        <p:txBody>
+          <a:bodyPr wrap="square" lIns="0" tIns="0" rIns="0" bIns="0" rtlCol="0" anchor="ctr"/>
+          <a:lstStyle/>
+          <a:p>
+            <a:pPr algn="ctr" indent="0" marL="0">
+              <a:buNone/>
+            </a:pPr>
+            <a:r>
+              <a:rPr lang="en-US" sz="950" b="1" dirty="0">
+                <a:solidFill>
+                  <a:srgbClr val="0F1B2D"/>
+                </a:solidFill>
+                <a:latin typeface="Arial" pitchFamily="34" charset="0"/>
+                <a:ea typeface="Arial" pitchFamily="34" charset="-122"/>
+                <a:cs typeface="Arial" pitchFamily="34" charset="-120"/>
+              </a:rPr>
+              <a:t>SRAM1</a:t>
+            </a:r>
+            <a:endParaRPr lang="en-US" sz="950" dirty="0"/>
+          </a:p>
+        </p:txBody>
+      </p:sp>
+      <p:sp>
+        <p:nvSpPr>
+          <p:cNvPr id="49" name="Shape 46"/>
+          <p:cNvSpPr/>
+          <p:nvPr/>
+        </p:nvSpPr>
+        <p:spPr>
+          <a:xfrm>
+            <a:off x="3111703" y="4076395"/>
+            <a:ext cx="457200" cy="508406"/>
+          </a:xfrm>
+          <a:prstGeom prst="roundRect">
+            <a:avLst>
+              <a:gd name="adj" fmla="val 13800"/>
+            </a:avLst>
+          </a:prstGeom>
+          <a:solidFill>
+            <a:srgbClr val="FFFFFF"/>
+          </a:solidFill>
+          <a:ln w="19050">
+            <a:solidFill>
+              <a:srgbClr val="0F1B2D"/>
+            </a:solidFill>
+            <a:prstDash val="solid"/>
+          </a:ln>
+        </p:spPr>
+      </p:sp>
+      <p:sp>
+        <p:nvSpPr>
+          <p:cNvPr id="50" name="Text 47"/>
+          <p:cNvSpPr txBox="1"/>
+          <p:nvPr/>
+        </p:nvSpPr>
+        <p:spPr>
+          <a:xfrm>
+            <a:off x="3111703" y="4076395"/>
+            <a:ext cx="457200" cy="508406"/>
+          </a:xfrm>
+          <a:prstGeom prst="rect">
+            <a:avLst/>
+          </a:prstGeom>
+          <a:noFill/>
+          <a:ln/>
+        </p:spPr>
+        <p:txBody>
+          <a:bodyPr wrap="square" lIns="0" tIns="0" rIns="0" bIns="0" rtlCol="0" anchor="ctr"/>
+          <a:lstStyle/>
+          <a:p>
+            <a:pPr algn="ctr" indent="0" marL="0">
+              <a:buNone/>
+            </a:pPr>
+            <a:r>
+              <a:rPr lang="en-US" sz="950" b="1" dirty="0">
+                <a:solidFill>
+                  <a:srgbClr val="0F1B2D"/>
+                </a:solidFill>
+                <a:latin typeface="Arial" pitchFamily="34" charset="0"/>
+                <a:ea typeface="Arial" pitchFamily="34" charset="-122"/>
+                <a:cs typeface="Arial" pitchFamily="34" charset="-120"/>
+              </a:rPr>
+              <a:t>SRAM2</a:t>
+            </a:r>
+            <a:endParaRPr lang="en-US" sz="950" dirty="0"/>
+          </a:p>
+        </p:txBody>
+      </p:sp>
+      <p:sp>
+        <p:nvSpPr>
+          <p:cNvPr id="51" name="Shape 48"/>
+          <p:cNvSpPr/>
+          <p:nvPr/>
+        </p:nvSpPr>
+        <p:spPr>
+          <a:xfrm>
+            <a:off x="3619195" y="4076395"/>
+            <a:ext cx="457200" cy="508406"/>
+          </a:xfrm>
+          <a:prstGeom prst="roundRect">
+            <a:avLst>
+              <a:gd name="adj" fmla="val 13800"/>
+            </a:avLst>
+          </a:prstGeom>
+          <a:solidFill>
+            <a:srgbClr val="FFFFFF"/>
+          </a:solidFill>
+          <a:ln w="28575">
+            <a:solidFill>
+              <a:srgbClr val="B8791F"/>
+            </a:solidFill>
+            <a:prstDash val="dash"/>
+          </a:ln>
+        </p:spPr>
+      </p:sp>
+      <p:sp>
+        <p:nvSpPr>
+          <p:cNvPr id="52" name="Text 49"/>
+          <p:cNvSpPr txBox="1"/>
+          <p:nvPr/>
+        </p:nvSpPr>
+        <p:spPr>
+          <a:xfrm>
+            <a:off x="3619195" y="4076395"/>
+            <a:ext cx="457200" cy="508406"/>
+          </a:xfrm>
+          <a:prstGeom prst="rect">
+            <a:avLst/>
+          </a:prstGeom>
+          <a:noFill/>
+          <a:ln/>
+        </p:spPr>
+        <p:txBody>
+          <a:bodyPr wrap="square" lIns="0" tIns="0" rIns="0" bIns="0" rtlCol="0" anchor="ctr"/>
+          <a:lstStyle/>
+          <a:p>
+            <a:pPr algn="ctr" indent="0" marL="0">
+              <a:buNone/>
+            </a:pPr>
+            <a:r>
+              <a:rPr lang="en-US" sz="950" b="1" dirty="0">
+                <a:solidFill>
+                  <a:srgbClr val="B8791F"/>
+                </a:solidFill>
+                <a:latin typeface="Arial" pitchFamily="34" charset="0"/>
+                <a:ea typeface="Arial" pitchFamily="34" charset="-122"/>
+                <a:cs typeface="Arial" pitchFamily="34" charset="-120"/>
+              </a:rPr>
+              <a:t>SRAM3</a:t>
+            </a:r>
+            <a:endParaRPr lang="en-US" sz="950" dirty="0"/>
+          </a:p>
+        </p:txBody>
+      </p:sp>
+      <p:sp>
+        <p:nvSpPr>
+          <p:cNvPr id="53" name="Shape 50"/>
+          <p:cNvSpPr/>
+          <p:nvPr/>
+        </p:nvSpPr>
+        <p:spPr>
+          <a:xfrm>
+            <a:off x="4019702" y="4019702"/>
+            <a:ext cx="114300" cy="114300"/>
+          </a:xfrm>
+          <a:prstGeom prst="ellipse">
+            <a:avLst/>
+          </a:prstGeom>
+          <a:solidFill>
+            <a:srgbClr val="E8A33D"/>
+          </a:solidFill>
+          <a:ln/>
+        </p:spPr>
+      </p:sp>
+      <p:sp>
+        <p:nvSpPr>
+          <p:cNvPr id="54" name="Text 51"/>
+          <p:cNvSpPr txBox="1"/>
+          <p:nvPr/>
+        </p:nvSpPr>
+        <p:spPr>
+          <a:xfrm>
+            <a:off x="2095805" y="4622292"/>
+            <a:ext cx="1981505" cy="177394"/>
+          </a:xfrm>
+          <a:prstGeom prst="rect">
+            <a:avLst/>
+          </a:prstGeom>
+          <a:noFill/>
+          <a:ln/>
+        </p:spPr>
+        <p:txBody>
+          <a:bodyPr wrap="square" lIns="0" tIns="0" rIns="0" bIns="0" rtlCol="0" anchor="t"/>
+          <a:lstStyle/>
+          <a:p>
+            <a:pPr algn="ctr" indent="0" marL="0">
+              <a:buNone/>
+            </a:pPr>
+            <a:r>
+              <a:rPr lang="en-US" sz="950" dirty="0">
+                <a:solidFill>
+                  <a:srgbClr val="4A5568"/>
+                </a:solidFill>
+                <a:latin typeface="Arial" pitchFamily="34" charset="0"/>
+                <a:ea typeface="Arial" pitchFamily="34" charset="-122"/>
+                <a:cs typeface="Arial" pitchFamily="34" charset="-120"/>
+              </a:rPr>
+              <a:t>64 KB 뱅크 × 2–4 · 독립 포트</a:t>
+            </a:r>
+            <a:endParaRPr lang="en-US" sz="950" dirty="0"/>
+          </a:p>
+        </p:txBody>
+      </p:sp>
+      <p:sp>
+        <p:nvSpPr>
+          <p:cNvPr id="55" name="Shape 52"/>
+          <p:cNvSpPr/>
+          <p:nvPr/>
+        </p:nvSpPr>
+        <p:spPr>
+          <a:xfrm>
+            <a:off x="4381805" y="4076395"/>
+            <a:ext cx="1270102" cy="508406"/>
+          </a:xfrm>
+          <a:prstGeom prst="roundRect">
+            <a:avLst>
+              <a:gd name="adj" fmla="val 14928"/>
+            </a:avLst>
+          </a:prstGeom>
+          <a:solidFill>
+            <a:srgbClr val="FFFFFF"/>
+          </a:solidFill>
+          <a:ln w="19050">
+            <a:solidFill>
+              <a:srgbClr val="0F1B2D"/>
+            </a:solidFill>
+            <a:prstDash val="solid"/>
+          </a:ln>
+        </p:spPr>
+      </p:sp>
+      <p:sp>
+        <p:nvSpPr>
+          <p:cNvPr id="56" name="Text 53"/>
+          <p:cNvSpPr txBox="1"/>
+          <p:nvPr/>
+        </p:nvSpPr>
+        <p:spPr>
+          <a:xfrm>
+            <a:off x="4381805" y="4127602"/>
+            <a:ext cx="1270102" cy="190195"/>
+          </a:xfrm>
+          <a:prstGeom prst="rect">
+            <a:avLst/>
+          </a:prstGeom>
+          <a:noFill/>
+          <a:ln/>
+        </p:spPr>
+        <p:txBody>
+          <a:bodyPr wrap="square" lIns="0" tIns="0" rIns="0" bIns="0" rtlCol="0" anchor="t"/>
+          <a:lstStyle/>
+          <a:p>
+            <a:pPr algn="ctr" indent="0" marL="0">
+              <a:buNone/>
+            </a:pPr>
+            <a:r>
+              <a:rPr lang="en-US" sz="1100" b="1" dirty="0">
+                <a:solidFill>
+                  <a:srgbClr val="0F1B2D"/>
+                </a:solidFill>
+                <a:latin typeface="Arial" pitchFamily="34" charset="0"/>
+                <a:ea typeface="Arial" pitchFamily="34" charset="-122"/>
+                <a:cs typeface="Arial" pitchFamily="34" charset="-120"/>
+              </a:rPr>
+              <a:t>주변장치</a:t>
+            </a:r>
+            <a:endParaRPr lang="en-US" sz="1100" dirty="0"/>
+          </a:p>
+        </p:txBody>
+      </p:sp>
+      <p:sp>
+        <p:nvSpPr>
+          <p:cNvPr id="57" name="Text 54"/>
+          <p:cNvSpPr txBox="1"/>
+          <p:nvPr/>
+        </p:nvSpPr>
+        <p:spPr>
+          <a:xfrm>
+            <a:off x="4381805" y="4317797"/>
+            <a:ext cx="1270102" cy="254203"/>
+          </a:xfrm>
+          <a:prstGeom prst="rect">
+            <a:avLst/>
+          </a:prstGeom>
+          <a:noFill/>
+          <a:ln/>
+        </p:spPr>
+        <p:txBody>
+          <a:bodyPr wrap="square" lIns="0" tIns="0" rIns="0" bIns="0" rtlCol="0" anchor="t"/>
+          <a:lstStyle/>
+          <a:p>
+            <a:pPr algn="ctr" indent="0" marL="0">
+              <a:lnSpc>
+                <a:spcPct val="115000"/>
+              </a:lnSpc>
+              <a:buNone/>
+            </a:pPr>
+            <a:r>
+              <a:rPr lang="en-US" sz="800" dirty="0">
+                <a:solidFill>
+                  <a:srgbClr val="4A5568"/>
+                </a:solidFill>
+                <a:latin typeface="Arial" pitchFamily="34" charset="0"/>
+                <a:ea typeface="Arial" pitchFamily="34" charset="-122"/>
+                <a:cs typeface="Arial" pitchFamily="34" charset="-120"/>
+              </a:rPr>
+              <a:t>Timer 1 kHz · Audio in</a:t>
+            </a:r>
+            <a:endParaRPr lang="en-US" sz="800" dirty="0"/>
+          </a:p>
+          <a:p>
+            <a:pPr algn="ctr" indent="0" marL="0">
+              <a:lnSpc>
+                <a:spcPct val="115000"/>
+              </a:lnSpc>
+              <a:buNone/>
+            </a:pPr>
+            <a:r>
+              <a:rPr lang="en-US" sz="800" dirty="0">
+                <a:solidFill>
+                  <a:srgbClr val="4A5568"/>
+                </a:solidFill>
+                <a:latin typeface="Arial" pitchFamily="34" charset="0"/>
+                <a:ea typeface="Arial" pitchFamily="34" charset="-122"/>
+                <a:cs typeface="Arial" pitchFamily="34" charset="-120"/>
+              </a:rPr>
+              <a:t>Sensor · Actuator</a:t>
+            </a:r>
+            <a:endParaRPr lang="en-US" sz="800" dirty="0"/>
+          </a:p>
+        </p:txBody>
+      </p:sp>
+      <p:sp>
+        <p:nvSpPr>
+          <p:cNvPr id="58" name="Text 55"/>
+          <p:cNvSpPr txBox="1"/>
+          <p:nvPr/>
+        </p:nvSpPr>
+        <p:spPr>
+          <a:xfrm>
+            <a:off x="660197" y="4876495"/>
+            <a:ext cx="5079492" cy="571500"/>
+          </a:xfrm>
+          <a:prstGeom prst="rect">
+            <a:avLst/>
+          </a:prstGeom>
+          <a:noFill/>
+          <a:ln/>
+        </p:spPr>
+        <p:txBody>
+          <a:bodyPr wrap="square" lIns="0" tIns="0" rIns="0" bIns="0" rtlCol="0" anchor="t"/>
+          <a:lstStyle/>
+          <a:p>
+            <a:pPr algn="l" indent="0" marL="0">
+              <a:lnSpc>
+                <a:spcPct val="130000"/>
+              </a:lnSpc>
+              <a:buNone/>
+            </a:pPr>
+            <a:r>
+              <a:rPr lang="en-US" sz="1000" dirty="0">
+                <a:solidFill>
+                  <a:srgbClr val="E8A33D"/>
+                </a:solidFill>
+                <a:latin typeface="Arial" pitchFamily="34" charset="0"/>
+                <a:ea typeface="Arial" pitchFamily="34" charset="-122"/>
+                <a:cs typeface="Arial" pitchFamily="34" charset="-120"/>
+              </a:rPr>
+              <a:t>● </a:t>
+            </a:r>
+            <a:pPr algn="l" indent="0" marL="0">
+              <a:lnSpc>
+                <a:spcPct val="130000"/>
+              </a:lnSpc>
+              <a:buNone/>
+            </a:pPr>
+            <a:r>
+              <a:rPr lang="en-US" sz="1000" dirty="0">
+                <a:solidFill>
+                  <a:srgbClr val="4A5568"/>
+                </a:solidFill>
+                <a:latin typeface="Arial" pitchFamily="34" charset="0"/>
+                <a:ea typeface="Arial" pitchFamily="34" charset="-122"/>
+                <a:cs typeface="Arial" pitchFamily="34" charset="-120"/>
+              </a:rPr>
+              <a:t>config knob — 면적 예산 안에서 AI가 선택:</a:t>
+            </a:r>
+            <a:endParaRPr lang="en-US" sz="1000" dirty="0"/>
+          </a:p>
+          <a:p>
+            <a:pPr algn="l" indent="0" marL="0">
+              <a:lnSpc>
+                <a:spcPct val="130000"/>
+              </a:lnSpc>
+              <a:buNone/>
+            </a:pPr>
+            <a:r>
+              <a:rPr lang="en-US" sz="1000" dirty="0">
+                <a:solidFill>
+                  <a:srgbClr val="4A5568"/>
+                </a:solidFill>
+                <a:latin typeface="Arial" pitchFamily="34" charset="0"/>
+                <a:ea typeface="Arial" pitchFamily="34" charset="-122"/>
+                <a:cs typeface="Arial" pitchFamily="34" charset="-120"/>
+              </a:rPr>
+              <a:t>TCM 크기 · SRAM 뱅크 수 · I-Cache · Flash WS/prefetch · DMA burst · MAC 유무</a:t>
+            </a:r>
+            <a:endParaRPr lang="en-US" sz="1000" dirty="0"/>
+          </a:p>
+          <a:p>
+            <a:pPr algn="l" indent="0" marL="0">
+              <a:lnSpc>
+                <a:spcPct val="130000"/>
+              </a:lnSpc>
+              <a:buNone/>
+            </a:pPr>
+            <a:r>
+              <a:rPr lang="en-US" sz="1000" dirty="0">
+                <a:solidFill>
+                  <a:srgbClr val="B8791F"/>
+                </a:solidFill>
+                <a:latin typeface="Arial" pitchFamily="34" charset="0"/>
+                <a:ea typeface="Arial" pitchFamily="34" charset="-122"/>
+                <a:cs typeface="Arial" pitchFamily="34" charset="-120"/>
+              </a:rPr>
+              <a:t>- - </a:t>
+            </a:r>
+            <a:pPr algn="l" indent="0" marL="0">
+              <a:lnSpc>
+                <a:spcPct val="130000"/>
+              </a:lnSpc>
+              <a:buNone/>
+            </a:pPr>
+            <a:r>
+              <a:rPr lang="en-US" sz="1000" dirty="0">
+                <a:solidFill>
+                  <a:srgbClr val="4A5568"/>
+                </a:solidFill>
+                <a:latin typeface="Arial" pitchFamily="34" charset="0"/>
+                <a:ea typeface="Arial" pitchFamily="34" charset="-122"/>
+                <a:cs typeface="Arial" pitchFamily="34" charset="-120"/>
+              </a:rPr>
+              <a:t>점선 = 예산에 따라 있거나 없는 블록 · 바탕 구조는 공통</a:t>
+            </a:r>
+            <a:endParaRPr lang="en-US" sz="1000" dirty="0"/>
+          </a:p>
+        </p:txBody>
+      </p:sp>
+      <p:sp>
+        <p:nvSpPr>
+          <p:cNvPr id="59" name="Shape 56"/>
           <p:cNvSpPr/>
           <p:nvPr/>
         </p:nvSpPr>
@@ -20458,7 +22877,7 @@
       </p:sp>
       <p:sp>
         <p:nvSpPr>
-          <p:cNvPr id="9" name="Text 6"/>
+          <p:cNvPr id="60" name="Text 57"/>
           <p:cNvSpPr txBox="1"/>
           <p:nvPr/>
         </p:nvSpPr>
@@ -20497,7 +22916,7 @@
       </p:sp>
       <p:sp>
         <p:nvSpPr>
-          <p:cNvPr id="10" name="Shape 7"/>
+          <p:cNvPr id="61" name="Shape 58"/>
           <p:cNvSpPr/>
           <p:nvPr/>
         </p:nvSpPr>
@@ -20520,7 +22939,7 @@
       </p:sp>
       <p:sp>
         <p:nvSpPr>
-          <p:cNvPr id="11" name="Shape 8"/>
+          <p:cNvPr id="62" name="Shape 59"/>
           <p:cNvSpPr/>
           <p:nvPr/>
         </p:nvSpPr>
@@ -20543,7 +22962,7 @@
       </p:sp>
       <p:sp>
         <p:nvSpPr>
-          <p:cNvPr id="12" name="Shape 9"/>
+          <p:cNvPr id="63" name="Shape 60"/>
           <p:cNvSpPr/>
           <p:nvPr/>
         </p:nvSpPr>
@@ -20566,7 +22985,7 @@
       </p:sp>
       <p:sp>
         <p:nvSpPr>
-          <p:cNvPr id="13" name="Shape 10"/>
+          <p:cNvPr id="64" name="Shape 61"/>
           <p:cNvSpPr/>
           <p:nvPr/>
         </p:nvSpPr>
@@ -20589,7 +23008,7 @@
       </p:sp>
       <p:sp>
         <p:nvSpPr>
-          <p:cNvPr id="14" name="Shape 11"/>
+          <p:cNvPr id="65" name="Shape 62"/>
           <p:cNvSpPr/>
           <p:nvPr/>
         </p:nvSpPr>
@@ -20612,7 +23031,7 @@
       </p:sp>
       <p:sp>
         <p:nvSpPr>
-          <p:cNvPr id="15" name="Shape 12"/>
+          <p:cNvPr id="66" name="Shape 63"/>
           <p:cNvSpPr/>
           <p:nvPr/>
         </p:nvSpPr>
@@ -20635,7 +23054,7 @@
       </p:sp>
       <p:sp>
         <p:nvSpPr>
-          <p:cNvPr id="16" name="Shape 13"/>
+          <p:cNvPr id="67" name="Shape 64"/>
           <p:cNvSpPr/>
           <p:nvPr/>
         </p:nvSpPr>
@@ -20658,7 +23077,7 @@
       </p:sp>
       <p:sp>
         <p:nvSpPr>
-          <p:cNvPr id="17" name="Shape 14"/>
+          <p:cNvPr id="68" name="Shape 65"/>
           <p:cNvSpPr/>
           <p:nvPr/>
         </p:nvSpPr>
@@ -20681,7 +23100,7 @@
       </p:sp>
       <p:sp>
         <p:nvSpPr>
-          <p:cNvPr id="18" name="Shape 15"/>
+          <p:cNvPr id="69" name="Shape 66"/>
           <p:cNvSpPr/>
           <p:nvPr/>
         </p:nvSpPr>
@@ -20704,7 +23123,7 @@
       </p:sp>
       <p:sp>
         <p:nvSpPr>
-          <p:cNvPr id="19" name="Shape 16"/>
+          <p:cNvPr id="70" name="Shape 67"/>
           <p:cNvSpPr/>
           <p:nvPr/>
         </p:nvSpPr>
@@ -20727,7 +23146,7 @@
       </p:sp>
       <p:sp>
         <p:nvSpPr>
-          <p:cNvPr id="20" name="Shape 17"/>
+          <p:cNvPr id="71" name="Shape 68"/>
           <p:cNvSpPr/>
           <p:nvPr/>
         </p:nvSpPr>
@@ -20750,7 +23169,7 @@
       </p:sp>
       <p:sp>
         <p:nvSpPr>
-          <p:cNvPr id="21" name="Shape 18"/>
+          <p:cNvPr id="72" name="Shape 69"/>
           <p:cNvSpPr/>
           <p:nvPr/>
         </p:nvSpPr>
@@ -20773,7 +23192,7 @@
       </p:sp>
       <p:sp>
         <p:nvSpPr>
-          <p:cNvPr id="22" name="Shape 19"/>
+          <p:cNvPr id="73" name="Shape 70"/>
           <p:cNvSpPr/>
           <p:nvPr/>
         </p:nvSpPr>
@@ -20796,7 +23215,7 @@
       </p:sp>
       <p:sp>
         <p:nvSpPr>
-          <p:cNvPr id="23" name="Shape 20"/>
+          <p:cNvPr id="74" name="Shape 71"/>
           <p:cNvSpPr/>
           <p:nvPr/>
         </p:nvSpPr>
@@ -20819,7 +23238,7 @@
       </p:sp>
       <p:sp>
         <p:nvSpPr>
-          <p:cNvPr id="24" name="Shape 21"/>
+          <p:cNvPr id="75" name="Shape 72"/>
           <p:cNvSpPr/>
           <p:nvPr/>
         </p:nvSpPr>
@@ -20842,7 +23261,7 @@
       </p:sp>
       <p:sp>
         <p:nvSpPr>
-          <p:cNvPr id="25" name="Shape 22"/>
+          <p:cNvPr id="76" name="Shape 73"/>
           <p:cNvSpPr/>
           <p:nvPr/>
         </p:nvSpPr>
@@ -20865,7 +23284,7 @@
       </p:sp>
       <p:sp>
         <p:nvSpPr>
-          <p:cNvPr id="26" name="Shape 23"/>
+          <p:cNvPr id="77" name="Shape 74"/>
           <p:cNvSpPr/>
           <p:nvPr/>
         </p:nvSpPr>
@@ -20888,7 +23307,7 @@
       </p:sp>
       <p:sp>
         <p:nvSpPr>
-          <p:cNvPr id="27" name="Shape 24"/>
+          <p:cNvPr id="78" name="Shape 75"/>
           <p:cNvSpPr/>
           <p:nvPr/>
         </p:nvSpPr>
@@ -20911,7 +23330,7 @@
       </p:sp>
       <p:sp>
         <p:nvSpPr>
-          <p:cNvPr id="28" name="Shape 25"/>
+          <p:cNvPr id="79" name="Shape 76"/>
           <p:cNvSpPr/>
           <p:nvPr/>
         </p:nvSpPr>
@@ -20934,7 +23353,7 @@
       </p:sp>
       <p:sp>
         <p:nvSpPr>
-          <p:cNvPr id="29" name="Shape 26"/>
+          <p:cNvPr id="80" name="Shape 77"/>
           <p:cNvSpPr/>
           <p:nvPr/>
         </p:nvSpPr>
@@ -20957,7 +23376,7 @@
       </p:sp>
       <p:sp>
         <p:nvSpPr>
-          <p:cNvPr id="30" name="Shape 27"/>
+          <p:cNvPr id="81" name="Shape 78"/>
           <p:cNvSpPr/>
           <p:nvPr/>
         </p:nvSpPr>
@@ -20980,7 +23399,7 @@
       </p:sp>
       <p:sp>
         <p:nvSpPr>
-          <p:cNvPr id="31" name="Shape 28"/>
+          <p:cNvPr id="82" name="Shape 79"/>
           <p:cNvSpPr/>
           <p:nvPr/>
         </p:nvSpPr>
@@ -21003,7 +23422,7 @@
       </p:sp>
       <p:sp>
         <p:nvSpPr>
-          <p:cNvPr id="32" name="Shape 29"/>
+          <p:cNvPr id="83" name="Shape 80"/>
           <p:cNvSpPr/>
           <p:nvPr/>
         </p:nvSpPr>
@@ -21026,7 +23445,7 @@
       </p:sp>
       <p:sp>
         <p:nvSpPr>
-          <p:cNvPr id="33" name="Shape 30"/>
+          <p:cNvPr id="84" name="Shape 81"/>
           <p:cNvSpPr/>
           <p:nvPr/>
         </p:nvSpPr>
@@ -21049,7 +23468,7 @@
       </p:sp>
       <p:sp>
         <p:nvSpPr>
-          <p:cNvPr id="34" name="Shape 31"/>
+          <p:cNvPr id="85" name="Shape 82"/>
           <p:cNvSpPr/>
           <p:nvPr/>
         </p:nvSpPr>
@@ -21072,7 +23491,7 @@
       </p:sp>
       <p:sp>
         <p:nvSpPr>
-          <p:cNvPr id="35" name="Shape 32"/>
+          <p:cNvPr id="86" name="Shape 83"/>
           <p:cNvSpPr/>
           <p:nvPr/>
         </p:nvSpPr>
@@ -21095,7 +23514,7 @@
       </p:sp>
       <p:sp>
         <p:nvSpPr>
-          <p:cNvPr id="36" name="Shape 33"/>
+          <p:cNvPr id="87" name="Shape 84"/>
           <p:cNvSpPr/>
           <p:nvPr/>
         </p:nvSpPr>
@@ -21118,7 +23537,7 @@
       </p:sp>
       <p:sp>
         <p:nvSpPr>
-          <p:cNvPr id="37" name="Shape 34"/>
+          <p:cNvPr id="88" name="Shape 85"/>
           <p:cNvSpPr/>
           <p:nvPr/>
         </p:nvSpPr>
@@ -21141,7 +23560,7 @@
       </p:sp>
       <p:sp>
         <p:nvSpPr>
-          <p:cNvPr id="38" name="Shape 35"/>
+          <p:cNvPr id="89" name="Shape 86"/>
           <p:cNvSpPr/>
           <p:nvPr/>
         </p:nvSpPr>
@@ -21164,7 +23583,7 @@
       </p:sp>
       <p:sp>
         <p:nvSpPr>
-          <p:cNvPr id="39" name="Shape 36"/>
+          <p:cNvPr id="90" name="Shape 87"/>
           <p:cNvSpPr/>
           <p:nvPr/>
         </p:nvSpPr>
@@ -21187,7 +23606,7 @@
       </p:sp>
       <p:sp>
         <p:nvSpPr>
-          <p:cNvPr id="40" name="Shape 37"/>
+          <p:cNvPr id="91" name="Shape 88"/>
           <p:cNvSpPr/>
           <p:nvPr/>
         </p:nvSpPr>
@@ -21210,7 +23629,7 @@
       </p:sp>
       <p:sp>
         <p:nvSpPr>
-          <p:cNvPr id="41" name="Shape 38"/>
+          <p:cNvPr id="92" name="Shape 89"/>
           <p:cNvSpPr/>
           <p:nvPr/>
         </p:nvSpPr>
@@ -21233,7 +23652,7 @@
       </p:sp>
       <p:sp>
         <p:nvSpPr>
-          <p:cNvPr id="42" name="Shape 39"/>
+          <p:cNvPr id="93" name="Shape 90"/>
           <p:cNvSpPr/>
           <p:nvPr/>
         </p:nvSpPr>
@@ -21256,7 +23675,7 @@
       </p:sp>
       <p:sp>
         <p:nvSpPr>
-          <p:cNvPr id="43" name="Shape 40"/>
+          <p:cNvPr id="94" name="Shape 91"/>
           <p:cNvSpPr/>
           <p:nvPr/>
         </p:nvSpPr>
@@ -21279,7 +23698,7 @@
       </p:sp>
       <p:sp>
         <p:nvSpPr>
-          <p:cNvPr id="44" name="Shape 41"/>
+          <p:cNvPr id="95" name="Shape 92"/>
           <p:cNvSpPr/>
           <p:nvPr/>
         </p:nvSpPr>
@@ -21302,7 +23721,7 @@
       </p:sp>
       <p:sp>
         <p:nvSpPr>
-          <p:cNvPr id="45" name="Shape 42"/>
+          <p:cNvPr id="96" name="Shape 93"/>
           <p:cNvSpPr/>
           <p:nvPr/>
         </p:nvSpPr>
@@ -21325,7 +23744,7 @@
       </p:sp>
       <p:sp>
         <p:nvSpPr>
-          <p:cNvPr id="46" name="Shape 43"/>
+          <p:cNvPr id="97" name="Shape 94"/>
           <p:cNvSpPr/>
           <p:nvPr/>
         </p:nvSpPr>
@@ -21348,7 +23767,7 @@
       </p:sp>
       <p:sp>
         <p:nvSpPr>
-          <p:cNvPr id="47" name="Shape 44"/>
+          <p:cNvPr id="98" name="Shape 95"/>
           <p:cNvSpPr/>
           <p:nvPr/>
         </p:nvSpPr>
@@ -21371,7 +23790,7 @@
       </p:sp>
       <p:sp>
         <p:nvSpPr>
-          <p:cNvPr id="48" name="Shape 45"/>
+          <p:cNvPr id="99" name="Shape 96"/>
           <p:cNvSpPr/>
           <p:nvPr/>
         </p:nvSpPr>
@@ -21394,7 +23813,7 @@
       </p:sp>
       <p:sp>
         <p:nvSpPr>
-          <p:cNvPr id="49" name="Shape 46"/>
+          <p:cNvPr id="100" name="Shape 97"/>
           <p:cNvSpPr/>
           <p:nvPr/>
         </p:nvSpPr>
@@ -21417,7 +23836,7 @@
       </p:sp>
       <p:sp>
         <p:nvSpPr>
-          <p:cNvPr id="50" name="Shape 47"/>
+          <p:cNvPr id="101" name="Shape 98"/>
           <p:cNvSpPr/>
           <p:nvPr/>
         </p:nvSpPr>
@@ -21440,7 +23859,7 @@
       </p:sp>
       <p:sp>
         <p:nvSpPr>
-          <p:cNvPr id="51" name="Shape 48"/>
+          <p:cNvPr id="102" name="Shape 99"/>
           <p:cNvSpPr/>
           <p:nvPr/>
         </p:nvSpPr>
@@ -21463,7 +23882,7 @@
       </p:sp>
       <p:sp>
         <p:nvSpPr>
-          <p:cNvPr id="52" name="Shape 49"/>
+          <p:cNvPr id="103" name="Shape 100"/>
           <p:cNvSpPr/>
           <p:nvPr/>
         </p:nvSpPr>
@@ -21486,7 +23905,7 @@
       </p:sp>
       <p:sp>
         <p:nvSpPr>
-          <p:cNvPr id="53" name="Shape 50"/>
+          <p:cNvPr id="104" name="Shape 101"/>
           <p:cNvSpPr/>
           <p:nvPr/>
         </p:nvSpPr>
@@ -21509,7 +23928,7 @@
       </p:sp>
       <p:sp>
         <p:nvSpPr>
-          <p:cNvPr id="54" name="Shape 51"/>
+          <p:cNvPr id="105" name="Shape 102"/>
           <p:cNvSpPr/>
           <p:nvPr/>
         </p:nvSpPr>
@@ -21536,7 +23955,7 @@
       </p:sp>
       <p:sp>
         <p:nvSpPr>
-          <p:cNvPr id="55" name="Text 52"/>
+          <p:cNvPr id="106" name="Text 103"/>
           <p:cNvSpPr txBox="1"/>
           <p:nvPr/>
         </p:nvSpPr>
@@ -21598,7 +24017,7 @@
       </p:sp>
       <p:sp>
         <p:nvSpPr>
-          <p:cNvPr id="56" name="Shape 53"/>
+          <p:cNvPr id="107" name="Shape 104"/>
           <p:cNvSpPr/>
           <p:nvPr/>
         </p:nvSpPr>
@@ -21618,7 +24037,7 @@
       </p:sp>
       <p:sp>
         <p:nvSpPr>
-          <p:cNvPr id="57" name="Shape 54"/>
+          <p:cNvPr id="108" name="Shape 105"/>
           <p:cNvSpPr/>
           <p:nvPr/>
         </p:nvSpPr>
@@ -21645,7 +24064,7 @@
       </p:sp>
       <p:sp>
         <p:nvSpPr>
-          <p:cNvPr id="58" name="Text 55"/>
+          <p:cNvPr id="109" name="Text 106"/>
           <p:cNvSpPr txBox="1"/>
           <p:nvPr/>
         </p:nvSpPr>
@@ -21707,7 +24126,7 @@
       </p:sp>
       <p:sp>
         <p:nvSpPr>
-          <p:cNvPr id="59" name="Shape 56"/>
+          <p:cNvPr id="110" name="Shape 107"/>
           <p:cNvSpPr/>
           <p:nvPr/>
         </p:nvSpPr>
@@ -21727,7 +24146,7 @@
       </p:sp>
       <p:sp>
         <p:nvSpPr>
-          <p:cNvPr id="60" name="Shape 57"/>
+          <p:cNvPr id="111" name="Shape 108"/>
           <p:cNvSpPr/>
           <p:nvPr/>
         </p:nvSpPr>
@@ -21754,7 +24173,7 @@
       </p:sp>
       <p:sp>
         <p:nvSpPr>
-          <p:cNvPr id="61" name="Text 58"/>
+          <p:cNvPr id="112" name="Text 109"/>
           <p:cNvSpPr txBox="1"/>
           <p:nvPr/>
         </p:nvSpPr>
@@ -21816,7 +24235,7 @@
       </p:sp>
       <p:sp>
         <p:nvSpPr>
-          <p:cNvPr id="62" name="Shape 59"/>
+          <p:cNvPr id="113" name="Shape 110"/>
           <p:cNvSpPr/>
           <p:nvPr/>
         </p:nvSpPr>
@@ -21840,7 +24259,7 @@
       </p:sp>
       <p:sp>
         <p:nvSpPr>
-          <p:cNvPr id="63" name="Shape 60"/>
+          <p:cNvPr id="114" name="Shape 111"/>
           <p:cNvSpPr/>
           <p:nvPr/>
         </p:nvSpPr>
@@ -21862,7 +24281,7 @@
       </p:sp>
       <p:sp>
         <p:nvSpPr>
-          <p:cNvPr id="64" name="Text 61"/>
+          <p:cNvPr id="115" name="Text 112"/>
           <p:cNvSpPr txBox="1"/>
           <p:nvPr/>
         </p:nvSpPr>
@@ -21901,7 +24320,7 @@
       </p:sp>
       <p:sp>
         <p:nvSpPr>
-          <p:cNvPr id="65" name="Shape 62"/>
+          <p:cNvPr id="116" name="Shape 113"/>
           <p:cNvSpPr/>
           <p:nvPr/>
         </p:nvSpPr>
@@ -21923,7 +24342,7 @@
       </p:sp>
       <p:sp>
         <p:nvSpPr>
-          <p:cNvPr id="66" name="Text 63"/>
+          <p:cNvPr id="117" name="Text 114"/>
           <p:cNvSpPr txBox="1"/>
           <p:nvPr/>
         </p:nvSpPr>
@@ -21962,13 +24381,13 @@
       </p:sp>
       <p:sp>
         <p:nvSpPr>
-          <p:cNvPr id="67" name="Text 64"/>
+          <p:cNvPr id="118" name="Text 115"/>
           <p:cNvSpPr txBox="1"/>
           <p:nvPr/>
         </p:nvSpPr>
         <p:spPr>
           <a:xfrm>
-            <a:off x="7302398" y="4813402"/>
+            <a:off x="7302398" y="4839005"/>
             <a:ext cx="4317797" cy="254203"/>
           </a:xfrm>
           <a:prstGeom prst="rect">
@@ -21985,7 +24404,7 @@
               <a:buNone/>
             </a:pPr>
             <a:r>
-              <a:rPr lang="en-US" sz="1300" dirty="0">
+              <a:rPr lang="en-US" sz="1100" dirty="0">
                 <a:solidFill>
                   <a:srgbClr val="BFD8D5"/>
                 </a:solidFill>
@@ -21995,13 +24414,13 @@
               </a:rPr>
               <a:t>no · up · down · left · right · on · off · stop · go · silence · unknown</a:t>
             </a:r>
-            <a:endParaRPr lang="en-US" sz="1300" dirty="0"/>
-          </a:p>
-        </p:txBody>
-      </p:sp>
-      <p:sp>
-        <p:nvSpPr>
-          <p:cNvPr id="68" name="Text 65"/>
+            <a:endParaRPr lang="en-US" sz="1100" dirty="0"/>
+          </a:p>
+        </p:txBody>
+      </p:sp>
+      <p:sp>
+        <p:nvSpPr>
+          <p:cNvPr id="119" name="Text 116"/>
           <p:cNvSpPr txBox="1"/>
           <p:nvPr/>
         </p:nvSpPr>
@@ -22040,7 +24459,7 @@
       </p:sp>
       <p:sp>
         <p:nvSpPr>
-          <p:cNvPr id="69" name="Shape 66"/>
+          <p:cNvPr id="120" name="Shape 117"/>
           <p:cNvSpPr/>
           <p:nvPr/>
         </p:nvSpPr>
@@ -22067,7 +24486,7 @@
       </p:sp>
       <p:sp>
         <p:nvSpPr>
-          <p:cNvPr id="70" name="Shape 67"/>
+          <p:cNvPr id="121" name="Shape 118"/>
           <p:cNvSpPr/>
           <p:nvPr/>
         </p:nvSpPr>
@@ -22087,7 +24506,7 @@
       </p:sp>
       <p:sp>
         <p:nvSpPr>
-          <p:cNvPr id="71" name="Text 68"/>
+          <p:cNvPr id="122" name="Text 119"/>
           <p:cNvSpPr txBox="1"/>
           <p:nvPr/>
         </p:nvSpPr>
@@ -22140,7 +24559,7 @@
       </p:sp>
       <p:sp>
         <p:nvSpPr>
-          <p:cNvPr id="72" name="Shape 69"/>
+          <p:cNvPr id="123" name="Shape 120"/>
           <p:cNvSpPr/>
           <p:nvPr/>
         </p:nvSpPr>
@@ -22167,7 +24586,7 @@
       </p:sp>
       <p:sp>
         <p:nvSpPr>
-          <p:cNvPr id="73" name="Shape 70"/>
+          <p:cNvPr id="124" name="Shape 121"/>
           <p:cNvSpPr/>
           <p:nvPr/>
         </p:nvSpPr>
@@ -22187,7 +24606,7 @@
       </p:sp>
       <p:sp>
         <p:nvSpPr>
-          <p:cNvPr id="74" name="Text 71"/>
+          <p:cNvPr id="125" name="Text 122"/>
           <p:cNvSpPr txBox="1"/>
           <p:nvPr/>
         </p:nvSpPr>
@@ -22240,7 +24659,7 @@
       </p:sp>
       <p:sp>
         <p:nvSpPr>
-          <p:cNvPr id="75" name="Shape 72"/>
+          <p:cNvPr id="126" name="Shape 123"/>
           <p:cNvSpPr/>
           <p:nvPr/>
         </p:nvSpPr>
@@ -22267,7 +24686,7 @@
       </p:sp>
       <p:sp>
         <p:nvSpPr>
-          <p:cNvPr id="76" name="Shape 73"/>
+          <p:cNvPr id="127" name="Shape 124"/>
           <p:cNvSpPr/>
           <p:nvPr/>
         </p:nvSpPr>
@@ -22287,7 +24706,7 @@
       </p:sp>
       <p:sp>
         <p:nvSpPr>
-          <p:cNvPr id="77" name="Text 74"/>
+          <p:cNvPr id="128" name="Text 125"/>
           <p:cNvSpPr txBox="1"/>
           <p:nvPr/>
         </p:nvSpPr>

</xml_diff>

<commit_message>
Presentation: simpler PoC architecture — Base / +TCM / +MAC tiers color-coded, fewer labels
Co-Authored-By: Claude Fable 5.1 <noreply@anthropic.com>
Claude-Session: https://claude.ai/code/session_01Gd73gUzQvBcmrEGA3YWYHu
</commit_message>
<xml_diff>
--- a/docs/presentation/deck_basic_fonts.pptx
+++ b/docs/presentation/deck_basic_fonts.pptx
@@ -1576,7 +1576,7 @@
           <a:p>
             <a:r>
               <a:rPr lang="en-US" dirty="0"/>
-              <a:t>50초. 오른쪽: '소리가 들어와서 yes라는 답이 나오는 데 몇 cycle 걸리나'가 측정값. 아래 세 칸이 일부러 심은 상충 관계. 면적 예산 3단계(≤170/≤280/≤470), SW 소스 동일.</a:t>
+              <a:t>50초. 왼쪽: Base(검정)에 예산 280부터 TCM(청록 점선), 470부터 MAC(주황 점선)이 더해진다. 주황 점이 AI가 고르는 HW knob. 오른쪽: '소리가 들어와서 yes라는 답이 나오는 데 몇 cycle 걸리나'가 측정값. 아래 세 칸이 일부러 심은 상충 관계. 면적 예산 3단계(≤170/≤280/≤470), SW 소스 동일.</a:t>
             </a:r>
             <a:endParaRPr lang="en-US" dirty="0"/>
           </a:p>
@@ -21121,8 +21121,8 @@
         </p:nvSpPr>
         <p:spPr>
           <a:xfrm>
-            <a:off x="660197" y="1930298"/>
-            <a:ext cx="5079492" cy="190195"/>
+            <a:off x="660197" y="1955902"/>
+            <a:ext cx="2793492" cy="190195"/>
           </a:xfrm>
           <a:prstGeom prst="rect">
             <a:avLst/>
@@ -21146,7 +21146,7 @@
                 <a:ea typeface="Courier New" pitchFamily="34" charset="-122"/>
                 <a:cs typeface="Courier New" pitchFamily="34" charset="-120"/>
               </a:rPr>
-              <a:t>CM4 가상 플랫폼 · JSON config 1장으로 조립</a:t>
+              <a:t>CM4 가상 플랫폼 · 면적 예산 3단계</a:t>
             </a:r>
             <a:endParaRPr lang="en-US" sz="1100" dirty="0"/>
           </a:p>
@@ -21160,219 +21160,12 @@
         </p:nvSpPr>
         <p:spPr>
           <a:xfrm>
-            <a:off x="1333195" y="2895905"/>
-            <a:ext cx="0" cy="533095"/>
-          </a:xfrm>
-          <a:prstGeom prst="line">
-            <a:avLst/>
-          </a:prstGeom>
-          <a:noFill/>
-          <a:ln w="38100">
-            <a:solidFill>
-              <a:srgbClr val="6B7280"/>
-            </a:solidFill>
-            <a:prstDash val="solid"/>
-          </a:ln>
-        </p:spPr>
-      </p:sp>
-      <p:sp>
-        <p:nvSpPr>
-          <p:cNvPr id="9" name="Shape 6"/>
-          <p:cNvSpPr/>
-          <p:nvPr/>
-        </p:nvSpPr>
-        <p:spPr>
-          <a:xfrm>
-            <a:off x="3556102" y="2895905"/>
-            <a:ext cx="0" cy="533095"/>
-          </a:xfrm>
-          <a:prstGeom prst="line">
-            <a:avLst/>
-          </a:prstGeom>
-          <a:noFill/>
-          <a:ln w="38100">
-            <a:solidFill>
-              <a:srgbClr val="6B7280"/>
-            </a:solidFill>
-            <a:prstDash val="solid"/>
-          </a:ln>
-        </p:spPr>
-      </p:sp>
-      <p:sp>
-        <p:nvSpPr>
-          <p:cNvPr id="10" name="Shape 7"/>
-          <p:cNvSpPr/>
-          <p:nvPr/>
-        </p:nvSpPr>
-        <p:spPr>
-          <a:xfrm>
-            <a:off x="5048402" y="2895905"/>
-            <a:ext cx="0" cy="533095"/>
-          </a:xfrm>
-          <a:prstGeom prst="line">
-            <a:avLst/>
-          </a:prstGeom>
-          <a:noFill/>
-          <a:ln w="38100">
-            <a:solidFill>
-              <a:srgbClr val="6B7280"/>
-            </a:solidFill>
-            <a:prstDash val="solid"/>
-          </a:ln>
-        </p:spPr>
-      </p:sp>
-      <p:sp>
-        <p:nvSpPr>
-          <p:cNvPr id="11" name="Shape 8"/>
-          <p:cNvSpPr/>
-          <p:nvPr/>
-        </p:nvSpPr>
-        <p:spPr>
-          <a:xfrm>
-            <a:off x="1270102" y="3759098"/>
-            <a:ext cx="0" cy="317297"/>
-          </a:xfrm>
-          <a:prstGeom prst="line">
-            <a:avLst/>
-          </a:prstGeom>
-          <a:noFill/>
-          <a:ln w="38100">
-            <a:solidFill>
-              <a:srgbClr val="6B7280"/>
-            </a:solidFill>
-            <a:prstDash val="solid"/>
-          </a:ln>
-        </p:spPr>
-      </p:sp>
-      <p:sp>
-        <p:nvSpPr>
-          <p:cNvPr id="12" name="Shape 9"/>
-          <p:cNvSpPr/>
-          <p:nvPr/>
-        </p:nvSpPr>
-        <p:spPr>
-          <a:xfrm>
-            <a:off x="2324405" y="3759098"/>
-            <a:ext cx="0" cy="317297"/>
-          </a:xfrm>
-          <a:prstGeom prst="line">
-            <a:avLst/>
-          </a:prstGeom>
-          <a:noFill/>
-          <a:ln w="38100">
-            <a:solidFill>
-              <a:srgbClr val="6B7280"/>
-            </a:solidFill>
-            <a:prstDash val="solid"/>
-          </a:ln>
-        </p:spPr>
-      </p:sp>
-      <p:sp>
-        <p:nvSpPr>
-          <p:cNvPr id="13" name="Shape 10"/>
-          <p:cNvSpPr/>
-          <p:nvPr/>
-        </p:nvSpPr>
-        <p:spPr>
-          <a:xfrm>
-            <a:off x="2831897" y="3759098"/>
-            <a:ext cx="0" cy="317297"/>
-          </a:xfrm>
-          <a:prstGeom prst="line">
-            <a:avLst/>
-          </a:prstGeom>
-          <a:noFill/>
-          <a:ln w="38100">
-            <a:solidFill>
-              <a:srgbClr val="6B7280"/>
-            </a:solidFill>
-            <a:prstDash val="solid"/>
-          </a:ln>
-        </p:spPr>
-      </p:sp>
-      <p:sp>
-        <p:nvSpPr>
-          <p:cNvPr id="14" name="Shape 11"/>
-          <p:cNvSpPr/>
-          <p:nvPr/>
-        </p:nvSpPr>
-        <p:spPr>
-          <a:xfrm>
-            <a:off x="3340303" y="3759098"/>
-            <a:ext cx="0" cy="317297"/>
-          </a:xfrm>
-          <a:prstGeom prst="line">
-            <a:avLst/>
-          </a:prstGeom>
-          <a:noFill/>
-          <a:ln w="38100">
-            <a:solidFill>
-              <a:srgbClr val="6B7280"/>
-            </a:solidFill>
-            <a:prstDash val="solid"/>
-          </a:ln>
-        </p:spPr>
-      </p:sp>
-      <p:sp>
-        <p:nvSpPr>
-          <p:cNvPr id="15" name="Shape 12"/>
-          <p:cNvSpPr/>
-          <p:nvPr/>
-        </p:nvSpPr>
-        <p:spPr>
-          <a:xfrm>
-            <a:off x="3847795" y="3759098"/>
-            <a:ext cx="0" cy="317297"/>
-          </a:xfrm>
-          <a:prstGeom prst="line">
-            <a:avLst/>
-          </a:prstGeom>
-          <a:noFill/>
-          <a:ln w="38100">
-            <a:solidFill>
-              <a:srgbClr val="6B7280"/>
-            </a:solidFill>
-            <a:prstDash val="solid"/>
-          </a:ln>
-        </p:spPr>
-      </p:sp>
-      <p:sp>
-        <p:nvSpPr>
-          <p:cNvPr id="16" name="Shape 13"/>
-          <p:cNvSpPr/>
-          <p:nvPr/>
-        </p:nvSpPr>
-        <p:spPr>
-          <a:xfrm>
-            <a:off x="5016398" y="3759098"/>
-            <a:ext cx="0" cy="317297"/>
-          </a:xfrm>
-          <a:prstGeom prst="line">
-            <a:avLst/>
-          </a:prstGeom>
-          <a:noFill/>
-          <a:ln w="38100">
-            <a:solidFill>
-              <a:srgbClr val="6B7280"/>
-            </a:solidFill>
-            <a:prstDash val="solid"/>
-          </a:ln>
-        </p:spPr>
-      </p:sp>
-      <p:sp>
-        <p:nvSpPr>
-          <p:cNvPr id="17" name="Shape 14"/>
-          <p:cNvSpPr/>
-          <p:nvPr/>
-        </p:nvSpPr>
-        <p:spPr>
-          <a:xfrm>
-            <a:off x="698602" y="2197303"/>
-            <a:ext cx="1270102" cy="698602"/>
+            <a:off x="3492094" y="1981505"/>
+            <a:ext cx="139903" cy="139903"/>
           </a:xfrm>
           <a:prstGeom prst="roundRect">
             <a:avLst>
-              <a:gd name="adj" fmla="val 10864"/>
+              <a:gd name="adj" fmla="val 18301"/>
             </a:avLst>
           </a:prstGeom>
           <a:solidFill>
@@ -21383,14 +21176,14 @@
       </p:sp>
       <p:sp>
         <p:nvSpPr>
-          <p:cNvPr id="18" name="Text 15"/>
+          <p:cNvPr id="9" name="Text 6"/>
           <p:cNvSpPr txBox="1"/>
           <p:nvPr/>
         </p:nvSpPr>
         <p:spPr>
           <a:xfrm>
-            <a:off x="698602" y="2286000"/>
-            <a:ext cx="1270102" cy="254203"/>
+            <a:off x="3683203" y="1943100"/>
+            <a:ext cx="571500" cy="202997"/>
           </a:xfrm>
           <a:prstGeom prst="rect">
             <a:avLst/>
@@ -21402,123 +21195,908 @@
           <a:bodyPr wrap="square" lIns="0" tIns="0" rIns="0" bIns="0" rtlCol="0" anchor="t"/>
           <a:lstStyle/>
           <a:p>
-            <a:pPr algn="ctr" indent="0" marL="0">
-              <a:buNone/>
-            </a:pPr>
-            <a:r>
-              <a:rPr lang="en-US" sz="1400" b="1" dirty="0">
-                <a:solidFill>
-                  <a:srgbClr val="FFFFFF"/>
-                </a:solidFill>
-                <a:latin typeface="Arial" pitchFamily="34" charset="0"/>
-                <a:ea typeface="Arial" pitchFamily="34" charset="-122"/>
-                <a:cs typeface="Arial" pitchFamily="34" charset="-120"/>
-              </a:rPr>
-              <a:t>Cortex-M4</a:t>
-            </a:r>
-            <a:endParaRPr lang="en-US" sz="1400" dirty="0"/>
-          </a:p>
-        </p:txBody>
-      </p:sp>
-      <p:sp>
-        <p:nvSpPr>
-          <p:cNvPr id="19" name="Text 16"/>
-          <p:cNvSpPr txBox="1"/>
-          <p:nvPr/>
-        </p:nvSpPr>
-        <p:spPr>
-          <a:xfrm>
-            <a:off x="698602" y="2577694"/>
-            <a:ext cx="1270102" cy="190195"/>
-          </a:xfrm>
-          <a:prstGeom prst="rect">
-            <a:avLst/>
-          </a:prstGeom>
-          <a:noFill/>
-          <a:ln/>
-        </p:spPr>
-        <p:txBody>
-          <a:bodyPr wrap="square" lIns="0" tIns="0" rIns="0" bIns="0" rtlCol="0" anchor="t"/>
-          <a:lstStyle/>
-          <a:p>
-            <a:pPr algn="ctr" indent="0" marL="0">
-              <a:buNone/>
-            </a:pPr>
-            <a:r>
-              <a:rPr lang="en-US" sz="1000" dirty="0">
-                <a:solidFill>
-                  <a:srgbClr val="BFD8D5"/>
-                </a:solidFill>
-                <a:latin typeface="Arial" pitchFamily="34" charset="0"/>
-                <a:ea typeface="Arial" pitchFamily="34" charset="-122"/>
-                <a:cs typeface="Arial" pitchFamily="34" charset="-120"/>
-              </a:rPr>
-              <a:t>FPU · NVIC · 3-stage</a:t>
-            </a:r>
-            <a:endParaRPr lang="en-US" sz="1000" dirty="0"/>
-          </a:p>
-        </p:txBody>
-      </p:sp>
-      <p:sp>
-        <p:nvSpPr>
-          <p:cNvPr id="20" name="Shape 17"/>
-          <p:cNvSpPr/>
-          <p:nvPr/>
-        </p:nvSpPr>
-        <p:spPr>
-          <a:xfrm>
-            <a:off x="1968703" y="2361895"/>
-            <a:ext cx="88697" cy="0"/>
-          </a:xfrm>
-          <a:prstGeom prst="line">
-            <a:avLst/>
-          </a:prstGeom>
-          <a:noFill/>
-          <a:ln w="38100">
-            <a:solidFill>
-              <a:srgbClr val="0F1B2D"/>
-            </a:solidFill>
-            <a:prstDash val="solid"/>
-          </a:ln>
-        </p:spPr>
-      </p:sp>
-      <p:sp>
-        <p:nvSpPr>
-          <p:cNvPr id="21" name="Shape 18"/>
-          <p:cNvSpPr/>
-          <p:nvPr/>
-        </p:nvSpPr>
-        <p:spPr>
-          <a:xfrm>
-            <a:off x="1968703" y="2730398"/>
-            <a:ext cx="88697" cy="0"/>
-          </a:xfrm>
-          <a:prstGeom prst="line">
-            <a:avLst/>
-          </a:prstGeom>
-          <a:noFill/>
-          <a:ln w="38100">
-            <a:solidFill>
-              <a:srgbClr val="0F1B2D"/>
-            </a:solidFill>
-            <a:prstDash val="solid"/>
-          </a:ln>
-        </p:spPr>
-      </p:sp>
-      <p:sp>
-        <p:nvSpPr>
-          <p:cNvPr id="22" name="Shape 19"/>
-          <p:cNvSpPr/>
-          <p:nvPr/>
-        </p:nvSpPr>
-        <p:spPr>
-          <a:xfrm>
-            <a:off x="2057400" y="2197303"/>
-            <a:ext cx="672998" cy="330098"/>
+            <a:pPr algn="l" indent="0" marL="0">
+              <a:buNone/>
+            </a:pPr>
+            <a:r>
+              <a:rPr lang="en-US" sz="1100" b="1" dirty="0">
+                <a:solidFill>
+                  <a:srgbClr val="0F1B2D"/>
+                </a:solidFill>
+                <a:latin typeface="Arial" pitchFamily="34" charset="0"/>
+                <a:ea typeface="Arial" pitchFamily="34" charset="-122"/>
+                <a:cs typeface="Arial" pitchFamily="34" charset="-120"/>
+              </a:rPr>
+              <a:t>Base</a:t>
+            </a:r>
+            <a:endParaRPr lang="en-US" sz="1100" dirty="0"/>
+          </a:p>
+        </p:txBody>
+      </p:sp>
+      <p:sp>
+        <p:nvSpPr>
+          <p:cNvPr id="10" name="Shape 7"/>
+          <p:cNvSpPr/>
+          <p:nvPr/>
+        </p:nvSpPr>
+        <p:spPr>
+          <a:xfrm>
+            <a:off x="4254703" y="1981505"/>
+            <a:ext cx="139903" cy="139903"/>
           </a:xfrm>
           <a:prstGeom prst="roundRect">
             <a:avLst>
-              <a:gd name="adj" fmla="val 15512"/>
+              <a:gd name="adj" fmla="val 18301"/>
+            </a:avLst>
+          </a:prstGeom>
+          <a:solidFill>
+            <a:srgbClr val="FFFFFF"/>
+          </a:solidFill>
+          <a:ln w="25400">
+            <a:solidFill>
+              <a:srgbClr val="1F7F7A"/>
+            </a:solidFill>
+            <a:prstDash val="dash"/>
+          </a:ln>
+        </p:spPr>
+      </p:sp>
+      <p:sp>
+        <p:nvSpPr>
+          <p:cNvPr id="11" name="Text 8"/>
+          <p:cNvSpPr txBox="1"/>
+          <p:nvPr/>
+        </p:nvSpPr>
+        <p:spPr>
+          <a:xfrm>
+            <a:off x="4444898" y="1943100"/>
+            <a:ext cx="571500" cy="202997"/>
+          </a:xfrm>
+          <a:prstGeom prst="rect">
+            <a:avLst/>
+          </a:prstGeom>
+          <a:noFill/>
+          <a:ln/>
+        </p:spPr>
+        <p:txBody>
+          <a:bodyPr wrap="square" lIns="0" tIns="0" rIns="0" bIns="0" rtlCol="0" anchor="t"/>
+          <a:lstStyle/>
+          <a:p>
+            <a:pPr algn="l" indent="0" marL="0">
+              <a:buNone/>
+            </a:pPr>
+            <a:r>
+              <a:rPr lang="en-US" sz="1100" b="1" dirty="0">
+                <a:solidFill>
+                  <a:srgbClr val="1F7F7A"/>
+                </a:solidFill>
+                <a:latin typeface="Arial" pitchFamily="34" charset="0"/>
+                <a:ea typeface="Arial" pitchFamily="34" charset="-122"/>
+                <a:cs typeface="Arial" pitchFamily="34" charset="-120"/>
+              </a:rPr>
+              <a:t>+TCM</a:t>
+            </a:r>
+            <a:endParaRPr lang="en-US" sz="1100" dirty="0"/>
+          </a:p>
+        </p:txBody>
+      </p:sp>
+      <p:sp>
+        <p:nvSpPr>
+          <p:cNvPr id="12" name="Shape 9"/>
+          <p:cNvSpPr/>
+          <p:nvPr/>
+        </p:nvSpPr>
+        <p:spPr>
+          <a:xfrm>
+            <a:off x="4953305" y="1981505"/>
+            <a:ext cx="139903" cy="139903"/>
+          </a:xfrm>
+          <a:prstGeom prst="roundRect">
+            <a:avLst>
+              <a:gd name="adj" fmla="val 18301"/>
+            </a:avLst>
+          </a:prstGeom>
+          <a:solidFill>
+            <a:srgbClr val="FFFFFF"/>
+          </a:solidFill>
+          <a:ln w="25400">
+            <a:solidFill>
+              <a:srgbClr val="B8791F"/>
+            </a:solidFill>
+            <a:prstDash val="dash"/>
+          </a:ln>
+        </p:spPr>
+      </p:sp>
+      <p:sp>
+        <p:nvSpPr>
+          <p:cNvPr id="13" name="Text 10"/>
+          <p:cNvSpPr txBox="1"/>
+          <p:nvPr/>
+        </p:nvSpPr>
+        <p:spPr>
+          <a:xfrm>
+            <a:off x="5143500" y="1943100"/>
+            <a:ext cx="571500" cy="202997"/>
+          </a:xfrm>
+          <a:prstGeom prst="rect">
+            <a:avLst/>
+          </a:prstGeom>
+          <a:noFill/>
+          <a:ln/>
+        </p:spPr>
+        <p:txBody>
+          <a:bodyPr wrap="square" lIns="0" tIns="0" rIns="0" bIns="0" rtlCol="0" anchor="t"/>
+          <a:lstStyle/>
+          <a:p>
+            <a:pPr algn="l" indent="0" marL="0">
+              <a:buNone/>
+            </a:pPr>
+            <a:r>
+              <a:rPr lang="en-US" sz="1100" b="1" dirty="0">
+                <a:solidFill>
+                  <a:srgbClr val="B8791F"/>
+                </a:solidFill>
+                <a:latin typeface="Arial" pitchFamily="34" charset="0"/>
+                <a:ea typeface="Arial" pitchFamily="34" charset="-122"/>
+                <a:cs typeface="Arial" pitchFamily="34" charset="-120"/>
+              </a:rPr>
+              <a:t>+MAC</a:t>
+            </a:r>
+            <a:endParaRPr lang="en-US" sz="1100" dirty="0"/>
+          </a:p>
+        </p:txBody>
+      </p:sp>
+      <p:sp>
+        <p:nvSpPr>
+          <p:cNvPr id="14" name="Shape 11"/>
+          <p:cNvSpPr/>
+          <p:nvPr/>
+        </p:nvSpPr>
+        <p:spPr>
+          <a:xfrm>
+            <a:off x="2476195" y="3136392"/>
+            <a:ext cx="0" cy="418795"/>
+          </a:xfrm>
+          <a:prstGeom prst="line">
+            <a:avLst/>
+          </a:prstGeom>
+          <a:noFill/>
+          <a:ln w="44450">
+            <a:solidFill>
+              <a:srgbClr val="6B7280"/>
+            </a:solidFill>
+            <a:prstDash val="solid"/>
+          </a:ln>
+        </p:spPr>
+      </p:sp>
+      <p:sp>
+        <p:nvSpPr>
+          <p:cNvPr id="15" name="Shape 12"/>
+          <p:cNvSpPr/>
+          <p:nvPr/>
+        </p:nvSpPr>
+        <p:spPr>
+          <a:xfrm>
+            <a:off x="3968496" y="3136392"/>
+            <a:ext cx="0" cy="418795"/>
+          </a:xfrm>
+          <a:prstGeom prst="line">
+            <a:avLst/>
+          </a:prstGeom>
+          <a:noFill/>
+          <a:ln w="44450">
+            <a:solidFill>
+              <a:srgbClr val="6B7280"/>
+            </a:solidFill>
+            <a:prstDash val="solid"/>
+          </a:ln>
+        </p:spPr>
+      </p:sp>
+      <p:sp>
+        <p:nvSpPr>
+          <p:cNvPr id="16" name="Shape 13"/>
+          <p:cNvSpPr/>
+          <p:nvPr/>
+        </p:nvSpPr>
+        <p:spPr>
+          <a:xfrm>
+            <a:off x="5143500" y="3136392"/>
+            <a:ext cx="0" cy="418795"/>
+          </a:xfrm>
+          <a:prstGeom prst="line">
+            <a:avLst/>
+          </a:prstGeom>
+          <a:noFill/>
+          <a:ln w="44450">
+            <a:solidFill>
+              <a:srgbClr val="6B7280"/>
+            </a:solidFill>
+            <a:prstDash val="solid"/>
+          </a:ln>
+        </p:spPr>
+      </p:sp>
+      <p:sp>
+        <p:nvSpPr>
+          <p:cNvPr id="17" name="Shape 14"/>
+          <p:cNvSpPr/>
+          <p:nvPr/>
+        </p:nvSpPr>
+        <p:spPr>
+          <a:xfrm>
+            <a:off x="1397203" y="3886200"/>
+            <a:ext cx="0" cy="431597"/>
+          </a:xfrm>
+          <a:prstGeom prst="line">
+            <a:avLst/>
+          </a:prstGeom>
+          <a:noFill/>
+          <a:ln w="44450">
+            <a:solidFill>
+              <a:srgbClr val="6B7280"/>
+            </a:solidFill>
+            <a:prstDash val="solid"/>
+          </a:ln>
+        </p:spPr>
+      </p:sp>
+      <p:sp>
+        <p:nvSpPr>
+          <p:cNvPr id="18" name="Shape 15"/>
+          <p:cNvSpPr/>
+          <p:nvPr/>
+        </p:nvSpPr>
+        <p:spPr>
+          <a:xfrm>
+            <a:off x="3206801" y="3886200"/>
+            <a:ext cx="0" cy="431597"/>
+          </a:xfrm>
+          <a:prstGeom prst="line">
+            <a:avLst/>
+          </a:prstGeom>
+          <a:noFill/>
+          <a:ln w="44450">
+            <a:solidFill>
+              <a:srgbClr val="6B7280"/>
+            </a:solidFill>
+            <a:prstDash val="solid"/>
+          </a:ln>
+        </p:spPr>
+      </p:sp>
+      <p:sp>
+        <p:nvSpPr>
+          <p:cNvPr id="19" name="Shape 16"/>
+          <p:cNvSpPr/>
+          <p:nvPr/>
+        </p:nvSpPr>
+        <p:spPr>
+          <a:xfrm>
+            <a:off x="4984394" y="3886200"/>
+            <a:ext cx="0" cy="431597"/>
+          </a:xfrm>
+          <a:prstGeom prst="line">
+            <a:avLst/>
+          </a:prstGeom>
+          <a:noFill/>
+          <a:ln w="44450">
+            <a:solidFill>
+              <a:srgbClr val="6B7280"/>
+            </a:solidFill>
+            <a:prstDash val="solid"/>
+          </a:ln>
+        </p:spPr>
+      </p:sp>
+      <p:sp>
+        <p:nvSpPr>
+          <p:cNvPr id="20" name="Shape 17"/>
+          <p:cNvSpPr/>
+          <p:nvPr/>
+        </p:nvSpPr>
+        <p:spPr>
+          <a:xfrm>
+            <a:off x="1651406" y="2793492"/>
+            <a:ext cx="127102" cy="0"/>
+          </a:xfrm>
+          <a:prstGeom prst="line">
+            <a:avLst/>
+          </a:prstGeom>
+          <a:noFill/>
+          <a:ln w="76200">
+            <a:solidFill>
+              <a:srgbClr val="1F7F7A"/>
+            </a:solidFill>
+            <a:prstDash val="solid"/>
+          </a:ln>
+        </p:spPr>
+      </p:sp>
+      <p:sp>
+        <p:nvSpPr>
+          <p:cNvPr id="21" name="Shape 18"/>
+          <p:cNvSpPr/>
+          <p:nvPr/>
+        </p:nvSpPr>
+        <p:spPr>
+          <a:xfrm>
+            <a:off x="761695" y="2450592"/>
+            <a:ext cx="888797" cy="685800"/>
+          </a:xfrm>
+          <a:prstGeom prst="roundRect">
+            <a:avLst>
+              <a:gd name="adj" fmla="val 11067"/>
+            </a:avLst>
+          </a:prstGeom>
+          <a:solidFill>
+            <a:srgbClr val="FFFFFF"/>
+          </a:solidFill>
+          <a:ln w="38100">
+            <a:solidFill>
+              <a:srgbClr val="1F7F7A"/>
+            </a:solidFill>
+            <a:prstDash val="dash"/>
+          </a:ln>
+        </p:spPr>
+      </p:sp>
+      <p:sp>
+        <p:nvSpPr>
+          <p:cNvPr id="22" name="Text 19"/>
+          <p:cNvSpPr txBox="1"/>
+          <p:nvPr/>
+        </p:nvSpPr>
+        <p:spPr>
+          <a:xfrm>
+            <a:off x="761695" y="2527402"/>
+            <a:ext cx="888797" cy="254203"/>
+          </a:xfrm>
+          <a:prstGeom prst="rect">
+            <a:avLst/>
+          </a:prstGeom>
+          <a:noFill/>
+          <a:ln/>
+        </p:spPr>
+        <p:txBody>
+          <a:bodyPr wrap="square" lIns="0" tIns="0" rIns="0" bIns="0" rtlCol="0" anchor="t"/>
+          <a:lstStyle/>
+          <a:p>
+            <a:pPr algn="ctr" indent="0" marL="0">
+              <a:buNone/>
+            </a:pPr>
+            <a:r>
+              <a:rPr lang="en-US" sz="1400" b="1" dirty="0">
+                <a:solidFill>
+                  <a:srgbClr val="1F7F7A"/>
+                </a:solidFill>
+                <a:latin typeface="Arial" pitchFamily="34" charset="0"/>
+                <a:ea typeface="Arial" pitchFamily="34" charset="-122"/>
+                <a:cs typeface="Arial" pitchFamily="34" charset="-120"/>
+              </a:rPr>
+              <a:t>TCM</a:t>
+            </a:r>
+            <a:endParaRPr lang="en-US" sz="1400" dirty="0"/>
+          </a:p>
+        </p:txBody>
+      </p:sp>
+      <p:sp>
+        <p:nvSpPr>
+          <p:cNvPr id="23" name="Text 20"/>
+          <p:cNvSpPr txBox="1"/>
+          <p:nvPr/>
+        </p:nvSpPr>
+        <p:spPr>
+          <a:xfrm>
+            <a:off x="761695" y="2806294"/>
+            <a:ext cx="888797" cy="317297"/>
+          </a:xfrm>
+          <a:prstGeom prst="rect">
+            <a:avLst/>
+          </a:prstGeom>
+          <a:noFill/>
+          <a:ln/>
+        </p:spPr>
+        <p:txBody>
+          <a:bodyPr wrap="square" lIns="0" tIns="0" rIns="0" bIns="0" rtlCol="0" anchor="t"/>
+          <a:lstStyle/>
+          <a:p>
+            <a:pPr algn="ctr" indent="0" marL="0">
+              <a:lnSpc>
+                <a:spcPct val="115000"/>
+              </a:lnSpc>
+              <a:buNone/>
+            </a:pPr>
+            <a:r>
+              <a:rPr lang="en-US" sz="1000" dirty="0">
+                <a:solidFill>
+                  <a:srgbClr val="4A5568"/>
+                </a:solidFill>
+                <a:latin typeface="Arial" pitchFamily="34" charset="0"/>
+                <a:ea typeface="Arial" pitchFamily="34" charset="-122"/>
+                <a:cs typeface="Arial" pitchFamily="34" charset="-120"/>
+              </a:rPr>
+              <a:t>ITCM + DTCM</a:t>
+            </a:r>
+            <a:endParaRPr lang="en-US" sz="1000" dirty="0"/>
+          </a:p>
+          <a:p>
+            <a:pPr algn="ctr" indent="0" marL="0">
+              <a:lnSpc>
+                <a:spcPct val="115000"/>
+              </a:lnSpc>
+              <a:buNone/>
+            </a:pPr>
+            <a:r>
+              <a:rPr lang="en-US" sz="1000" dirty="0">
+                <a:solidFill>
+                  <a:srgbClr val="4A5568"/>
+                </a:solidFill>
+                <a:latin typeface="Arial" pitchFamily="34" charset="0"/>
+                <a:ea typeface="Arial" pitchFamily="34" charset="-122"/>
+                <a:cs typeface="Arial" pitchFamily="34" charset="-120"/>
+              </a:rPr>
+              <a:t>예산 ≤280부터</a:t>
+            </a:r>
+            <a:endParaRPr lang="en-US" sz="1000" dirty="0"/>
+          </a:p>
+        </p:txBody>
+      </p:sp>
+      <p:sp>
+        <p:nvSpPr>
+          <p:cNvPr id="24" name="Shape 21"/>
+          <p:cNvSpPr/>
+          <p:nvPr/>
+        </p:nvSpPr>
+        <p:spPr>
+          <a:xfrm>
+            <a:off x="1587398" y="2387498"/>
+            <a:ext cx="127102" cy="127102"/>
+          </a:xfrm>
+          <a:prstGeom prst="ellipse">
+            <a:avLst/>
+          </a:prstGeom>
+          <a:solidFill>
+            <a:srgbClr val="E8A33D"/>
+          </a:solidFill>
+          <a:ln/>
+        </p:spPr>
+      </p:sp>
+      <p:sp>
+        <p:nvSpPr>
+          <p:cNvPr id="25" name="Shape 22"/>
+          <p:cNvSpPr/>
+          <p:nvPr/>
+        </p:nvSpPr>
+        <p:spPr>
+          <a:xfrm>
+            <a:off x="1777594" y="2450592"/>
+            <a:ext cx="1397203" cy="685800"/>
+          </a:xfrm>
+          <a:prstGeom prst="roundRect">
+            <a:avLst>
+              <a:gd name="adj" fmla="val 11067"/>
+            </a:avLst>
+          </a:prstGeom>
+          <a:solidFill>
+            <a:srgbClr val="0F1B2D"/>
+          </a:solidFill>
+          <a:ln/>
+        </p:spPr>
+      </p:sp>
+      <p:sp>
+        <p:nvSpPr>
+          <p:cNvPr id="26" name="Text 23"/>
+          <p:cNvSpPr txBox="1"/>
+          <p:nvPr/>
+        </p:nvSpPr>
+        <p:spPr>
+          <a:xfrm>
+            <a:off x="1777594" y="2514600"/>
+            <a:ext cx="1397203" cy="279806"/>
+          </a:xfrm>
+          <a:prstGeom prst="rect">
+            <a:avLst/>
+          </a:prstGeom>
+          <a:noFill/>
+          <a:ln/>
+        </p:spPr>
+        <p:txBody>
+          <a:bodyPr wrap="square" lIns="0" tIns="0" rIns="0" bIns="0" rtlCol="0" anchor="t"/>
+          <a:lstStyle/>
+          <a:p>
+            <a:pPr algn="ctr" indent="0" marL="0">
+              <a:buNone/>
+            </a:pPr>
+            <a:r>
+              <a:rPr lang="en-US" sz="1600" b="1" dirty="0">
+                <a:solidFill>
+                  <a:srgbClr val="FFFFFF"/>
+                </a:solidFill>
+                <a:latin typeface="Arial" pitchFamily="34" charset="0"/>
+                <a:ea typeface="Arial" pitchFamily="34" charset="-122"/>
+                <a:cs typeface="Arial" pitchFamily="34" charset="-120"/>
+              </a:rPr>
+              <a:t>Cortex-M4</a:t>
+            </a:r>
+            <a:endParaRPr lang="en-US" sz="1600" dirty="0"/>
+          </a:p>
+        </p:txBody>
+      </p:sp>
+      <p:sp>
+        <p:nvSpPr>
+          <p:cNvPr id="27" name="Text 24"/>
+          <p:cNvSpPr txBox="1"/>
+          <p:nvPr/>
+        </p:nvSpPr>
+        <p:spPr>
+          <a:xfrm>
+            <a:off x="1777594" y="2844698"/>
+            <a:ext cx="1397203" cy="190195"/>
+          </a:xfrm>
+          <a:prstGeom prst="rect">
+            <a:avLst/>
+          </a:prstGeom>
+          <a:noFill/>
+          <a:ln/>
+        </p:spPr>
+        <p:txBody>
+          <a:bodyPr wrap="square" lIns="0" tIns="0" rIns="0" bIns="0" rtlCol="0" anchor="t"/>
+          <a:lstStyle/>
+          <a:p>
+            <a:pPr algn="ctr" indent="0" marL="0">
+              <a:buNone/>
+            </a:pPr>
+            <a:r>
+              <a:rPr lang="en-US" sz="1050" dirty="0">
+                <a:solidFill>
+                  <a:srgbClr val="BFD8D5"/>
+                </a:solidFill>
+                <a:latin typeface="Arial" pitchFamily="34" charset="0"/>
+                <a:ea typeface="Arial" pitchFamily="34" charset="-122"/>
+                <a:cs typeface="Arial" pitchFamily="34" charset="-120"/>
+              </a:rPr>
+              <a:t>FPU · NVIC</a:t>
+            </a:r>
+            <a:endParaRPr lang="en-US" sz="1050" dirty="0"/>
+          </a:p>
+        </p:txBody>
+      </p:sp>
+      <p:sp>
+        <p:nvSpPr>
+          <p:cNvPr id="28" name="Shape 25"/>
+          <p:cNvSpPr/>
+          <p:nvPr/>
+        </p:nvSpPr>
+        <p:spPr>
+          <a:xfrm>
+            <a:off x="3492094" y="2450592"/>
+            <a:ext cx="952805" cy="685800"/>
+          </a:xfrm>
+          <a:prstGeom prst="roundRect">
+            <a:avLst>
+              <a:gd name="adj" fmla="val 11067"/>
+            </a:avLst>
+          </a:prstGeom>
+          <a:solidFill>
+            <a:srgbClr val="0F1B2D"/>
+          </a:solidFill>
+          <a:ln/>
+        </p:spPr>
+      </p:sp>
+      <p:sp>
+        <p:nvSpPr>
+          <p:cNvPr id="29" name="Text 26"/>
+          <p:cNvSpPr txBox="1"/>
+          <p:nvPr/>
+        </p:nvSpPr>
+        <p:spPr>
+          <a:xfrm>
+            <a:off x="3492094" y="2514600"/>
+            <a:ext cx="952805" cy="279806"/>
+          </a:xfrm>
+          <a:prstGeom prst="rect">
+            <a:avLst/>
+          </a:prstGeom>
+          <a:noFill/>
+          <a:ln/>
+        </p:spPr>
+        <p:txBody>
+          <a:bodyPr wrap="square" lIns="0" tIns="0" rIns="0" bIns="0" rtlCol="0" anchor="t"/>
+          <a:lstStyle/>
+          <a:p>
+            <a:pPr algn="ctr" indent="0" marL="0">
+              <a:buNone/>
+            </a:pPr>
+            <a:r>
+              <a:rPr lang="en-US" sz="1600" b="1" dirty="0">
+                <a:solidFill>
+                  <a:srgbClr val="FFFFFF"/>
+                </a:solidFill>
+                <a:latin typeface="Arial" pitchFamily="34" charset="0"/>
+                <a:ea typeface="Arial" pitchFamily="34" charset="-122"/>
+                <a:cs typeface="Arial" pitchFamily="34" charset="-120"/>
+              </a:rPr>
+              <a:t>DMA</a:t>
+            </a:r>
+            <a:endParaRPr lang="en-US" sz="1600" dirty="0"/>
+          </a:p>
+        </p:txBody>
+      </p:sp>
+      <p:sp>
+        <p:nvSpPr>
+          <p:cNvPr id="30" name="Text 27"/>
+          <p:cNvSpPr txBox="1"/>
+          <p:nvPr/>
+        </p:nvSpPr>
+        <p:spPr>
+          <a:xfrm>
+            <a:off x="3492094" y="2844698"/>
+            <a:ext cx="952805" cy="190195"/>
+          </a:xfrm>
+          <a:prstGeom prst="rect">
+            <a:avLst/>
+          </a:prstGeom>
+          <a:noFill/>
+          <a:ln/>
+        </p:spPr>
+        <p:txBody>
+          <a:bodyPr wrap="square" lIns="0" tIns="0" rIns="0" bIns="0" rtlCol="0" anchor="t"/>
+          <a:lstStyle/>
+          <a:p>
+            <a:pPr algn="ctr" indent="0" marL="0">
+              <a:buNone/>
+            </a:pPr>
+            <a:r>
+              <a:rPr lang="en-US" sz="1050" dirty="0">
+                <a:solidFill>
+                  <a:srgbClr val="BFD8D5"/>
+                </a:solidFill>
+                <a:latin typeface="Arial" pitchFamily="34" charset="0"/>
+                <a:ea typeface="Arial" pitchFamily="34" charset="-122"/>
+                <a:cs typeface="Arial" pitchFamily="34" charset="-120"/>
+              </a:rPr>
+              <a:t>burst 1–16</a:t>
+            </a:r>
+            <a:endParaRPr lang="en-US" sz="1050" dirty="0"/>
+          </a:p>
+        </p:txBody>
+      </p:sp>
+      <p:sp>
+        <p:nvSpPr>
+          <p:cNvPr id="31" name="Shape 28"/>
+          <p:cNvSpPr/>
+          <p:nvPr/>
+        </p:nvSpPr>
+        <p:spPr>
+          <a:xfrm>
+            <a:off x="4381805" y="2387498"/>
+            <a:ext cx="127102" cy="127102"/>
+          </a:xfrm>
+          <a:prstGeom prst="ellipse">
+            <a:avLst/>
+          </a:prstGeom>
+          <a:solidFill>
+            <a:srgbClr val="E8A33D"/>
+          </a:solidFill>
+          <a:ln/>
+        </p:spPr>
+      </p:sp>
+      <p:sp>
+        <p:nvSpPr>
+          <p:cNvPr id="32" name="Shape 29"/>
+          <p:cNvSpPr/>
+          <p:nvPr/>
+        </p:nvSpPr>
+        <p:spPr>
+          <a:xfrm>
+            <a:off x="4699102" y="2450592"/>
+            <a:ext cx="888797" cy="685800"/>
+          </a:xfrm>
+          <a:prstGeom prst="roundRect">
+            <a:avLst>
+              <a:gd name="adj" fmla="val 11067"/>
+            </a:avLst>
+          </a:prstGeom>
+          <a:solidFill>
+            <a:srgbClr val="FFFFFF"/>
+          </a:solidFill>
+          <a:ln w="38100">
+            <a:solidFill>
+              <a:srgbClr val="B8791F"/>
+            </a:solidFill>
+            <a:prstDash val="dash"/>
+          </a:ln>
+        </p:spPr>
+      </p:sp>
+      <p:sp>
+        <p:nvSpPr>
+          <p:cNvPr id="33" name="Text 30"/>
+          <p:cNvSpPr txBox="1"/>
+          <p:nvPr/>
+        </p:nvSpPr>
+        <p:spPr>
+          <a:xfrm>
+            <a:off x="4699102" y="2527402"/>
+            <a:ext cx="888797" cy="254203"/>
+          </a:xfrm>
+          <a:prstGeom prst="rect">
+            <a:avLst/>
+          </a:prstGeom>
+          <a:noFill/>
+          <a:ln/>
+        </p:spPr>
+        <p:txBody>
+          <a:bodyPr wrap="square" lIns="0" tIns="0" rIns="0" bIns="0" rtlCol="0" anchor="t"/>
+          <a:lstStyle/>
+          <a:p>
+            <a:pPr algn="ctr" indent="0" marL="0">
+              <a:buNone/>
+            </a:pPr>
+            <a:r>
+              <a:rPr lang="en-US" sz="1400" b="1" dirty="0">
+                <a:solidFill>
+                  <a:srgbClr val="B8791F"/>
+                </a:solidFill>
+                <a:latin typeface="Arial" pitchFamily="34" charset="0"/>
+                <a:ea typeface="Arial" pitchFamily="34" charset="-122"/>
+                <a:cs typeface="Arial" pitchFamily="34" charset="-120"/>
+              </a:rPr>
+              <a:t>MAC</a:t>
+            </a:r>
+            <a:endParaRPr lang="en-US" sz="1400" dirty="0"/>
+          </a:p>
+        </p:txBody>
+      </p:sp>
+      <p:sp>
+        <p:nvSpPr>
+          <p:cNvPr id="34" name="Text 31"/>
+          <p:cNvSpPr txBox="1"/>
+          <p:nvPr/>
+        </p:nvSpPr>
+        <p:spPr>
+          <a:xfrm>
+            <a:off x="4699102" y="2806294"/>
+            <a:ext cx="888797" cy="317297"/>
+          </a:xfrm>
+          <a:prstGeom prst="rect">
+            <a:avLst/>
+          </a:prstGeom>
+          <a:noFill/>
+          <a:ln/>
+        </p:spPr>
+        <p:txBody>
+          <a:bodyPr wrap="square" lIns="0" tIns="0" rIns="0" bIns="0" rtlCol="0" anchor="t"/>
+          <a:lstStyle/>
+          <a:p>
+            <a:pPr algn="ctr" indent="0" marL="0">
+              <a:lnSpc>
+                <a:spcPct val="115000"/>
+              </a:lnSpc>
+              <a:buNone/>
+            </a:pPr>
+            <a:r>
+              <a:rPr lang="en-US" sz="1000" dirty="0">
+                <a:solidFill>
+                  <a:srgbClr val="4A5568"/>
+                </a:solidFill>
+                <a:latin typeface="Arial" pitchFamily="34" charset="0"/>
+                <a:ea typeface="Arial" pitchFamily="34" charset="-122"/>
+                <a:cs typeface="Arial" pitchFamily="34" charset="-120"/>
+              </a:rPr>
+              <a:t>INT8 가속기</a:t>
+            </a:r>
+            <a:endParaRPr lang="en-US" sz="1000" dirty="0"/>
+          </a:p>
+          <a:p>
+            <a:pPr algn="ctr" indent="0" marL="0">
+              <a:lnSpc>
+                <a:spcPct val="115000"/>
+              </a:lnSpc>
+              <a:buNone/>
+            </a:pPr>
+            <a:r>
+              <a:rPr lang="en-US" sz="1000" dirty="0">
+                <a:solidFill>
+                  <a:srgbClr val="4A5568"/>
+                </a:solidFill>
+                <a:latin typeface="Arial" pitchFamily="34" charset="0"/>
+                <a:ea typeface="Arial" pitchFamily="34" charset="-122"/>
+                <a:cs typeface="Arial" pitchFamily="34" charset="-120"/>
+              </a:rPr>
+              <a:t>예산 ≤470부터</a:t>
+            </a:r>
+            <a:endParaRPr lang="en-US" sz="1000" dirty="0"/>
+          </a:p>
+        </p:txBody>
+      </p:sp>
+      <p:sp>
+        <p:nvSpPr>
+          <p:cNvPr id="35" name="Shape 32"/>
+          <p:cNvSpPr/>
+          <p:nvPr/>
+        </p:nvSpPr>
+        <p:spPr>
+          <a:xfrm>
+            <a:off x="5524805" y="2387498"/>
+            <a:ext cx="127102" cy="127102"/>
+          </a:xfrm>
+          <a:prstGeom prst="ellipse">
+            <a:avLst/>
+          </a:prstGeom>
+          <a:solidFill>
+            <a:srgbClr val="E8A33D"/>
+          </a:solidFill>
+          <a:ln/>
+        </p:spPr>
+      </p:sp>
+      <p:sp>
+        <p:nvSpPr>
+          <p:cNvPr id="36" name="Shape 33"/>
+          <p:cNvSpPr/>
+          <p:nvPr/>
+        </p:nvSpPr>
+        <p:spPr>
+          <a:xfrm>
+            <a:off x="761695" y="3556102"/>
+            <a:ext cx="4826203" cy="330098"/>
+          </a:xfrm>
+          <a:prstGeom prst="roundRect">
+            <a:avLst>
+              <a:gd name="adj" fmla="val 19114"/>
+            </a:avLst>
+          </a:prstGeom>
+          <a:solidFill>
+            <a:srgbClr val="4A5568"/>
+          </a:solidFill>
+          <a:ln/>
+        </p:spPr>
+      </p:sp>
+      <p:sp>
+        <p:nvSpPr>
+          <p:cNvPr id="37" name="Text 34"/>
+          <p:cNvSpPr txBox="1"/>
+          <p:nvPr/>
+        </p:nvSpPr>
+        <p:spPr>
+          <a:xfrm>
+            <a:off x="761695" y="3556102"/>
+            <a:ext cx="4826203" cy="330098"/>
+          </a:xfrm>
+          <a:prstGeom prst="rect">
+            <a:avLst/>
+          </a:prstGeom>
+          <a:noFill/>
+          <a:ln/>
+        </p:spPr>
+        <p:txBody>
+          <a:bodyPr wrap="square" lIns="0" tIns="0" rIns="0" bIns="0" rtlCol="0" anchor="ctr"/>
+          <a:lstStyle/>
+          <a:p>
+            <a:pPr algn="ctr" indent="0" marL="0">
+              <a:buNone/>
+            </a:pPr>
+            <a:r>
+              <a:rPr lang="en-US" sz="1300" b="1" dirty="0">
+                <a:solidFill>
+                  <a:srgbClr val="FFFFFF"/>
+                </a:solidFill>
+                <a:latin typeface="Arial" pitchFamily="34" charset="0"/>
+                <a:ea typeface="Arial" pitchFamily="34" charset="-122"/>
+                <a:cs typeface="Arial" pitchFamily="34" charset="-120"/>
+              </a:rPr>
+              <a:t>AHB 매트릭스 — 마스터 간 경합을 cycle 단위로</a:t>
+            </a:r>
+            <a:endParaRPr lang="en-US" sz="1300" dirty="0"/>
+          </a:p>
+        </p:txBody>
+      </p:sp>
+      <p:sp>
+        <p:nvSpPr>
+          <p:cNvPr id="38" name="Shape 35"/>
+          <p:cNvSpPr/>
+          <p:nvPr/>
+        </p:nvSpPr>
+        <p:spPr>
+          <a:xfrm>
+            <a:off x="761695" y="4317797"/>
+            <a:ext cx="1270102" cy="634594"/>
+          </a:xfrm>
+          <a:prstGeom prst="roundRect">
+            <a:avLst>
+              <a:gd name="adj" fmla="val 11960"/>
             </a:avLst>
           </a:prstGeom>
           <a:solidFill>
@@ -21534,14 +22112,14 @@
       </p:sp>
       <p:sp>
         <p:nvSpPr>
-          <p:cNvPr id="23" name="Text 20"/>
+          <p:cNvPr id="39" name="Text 36"/>
           <p:cNvSpPr txBox="1"/>
           <p:nvPr/>
         </p:nvSpPr>
         <p:spPr>
           <a:xfrm>
-            <a:off x="2057400" y="2216506"/>
-            <a:ext cx="672998" cy="304495"/>
+            <a:off x="761695" y="4393692"/>
+            <a:ext cx="1270102" cy="254203"/>
           </a:xfrm>
           <a:prstGeom prst="rect">
             <a:avLst/>
@@ -21554,13 +22132,10 @@
           <a:lstStyle/>
           <a:p>
             <a:pPr algn="ctr" indent="0" marL="0">
-              <a:lnSpc>
-                <a:spcPct val="110000"/>
-              </a:lnSpc>
-              <a:buNone/>
-            </a:pPr>
-            <a:r>
-              <a:rPr lang="en-US" sz="950" b="1" dirty="0">
+              <a:buNone/>
+            </a:pPr>
+            <a:r>
+              <a:rPr lang="en-US" sz="1400" b="1" dirty="0">
                 <a:solidFill>
                   <a:srgbClr val="0F1B2D"/>
                 </a:solidFill>
@@ -21568,19 +22143,38 @@
                 <a:ea typeface="Arial" pitchFamily="34" charset="-122"/>
                 <a:cs typeface="Arial" pitchFamily="34" charset="-120"/>
               </a:rPr>
-              <a:t>ITCM</a:t>
-            </a:r>
-            <a:endParaRPr lang="en-US" sz="950" dirty="0"/>
-          </a:p>
+              <a:t>Flash</a:t>
+            </a:r>
+            <a:endParaRPr lang="en-US" sz="1400" dirty="0"/>
+          </a:p>
+        </p:txBody>
+      </p:sp>
+      <p:sp>
+        <p:nvSpPr>
+          <p:cNvPr id="40" name="Text 37"/>
+          <p:cNvSpPr txBox="1"/>
+          <p:nvPr/>
+        </p:nvSpPr>
+        <p:spPr>
+          <a:xfrm>
+            <a:off x="761695" y="4673498"/>
+            <a:ext cx="1270102" cy="190195"/>
+          </a:xfrm>
+          <a:prstGeom prst="rect">
+            <a:avLst/>
+          </a:prstGeom>
+          <a:noFill/>
+          <a:ln/>
+        </p:spPr>
+        <p:txBody>
+          <a:bodyPr wrap="square" lIns="0" tIns="0" rIns="0" bIns="0" rtlCol="0" anchor="t"/>
+          <a:lstStyle/>
           <a:p>
             <a:pPr algn="ctr" indent="0" marL="0">
-              <a:lnSpc>
-                <a:spcPct val="110000"/>
-              </a:lnSpc>
-              <a:buNone/>
-            </a:pPr>
-            <a:r>
-              <a:rPr lang="en-US" sz="950" dirty="0">
+              <a:buNone/>
+            </a:pPr>
+            <a:r>
+              <a:rPr lang="en-US" sz="1000" dirty="0">
                 <a:solidFill>
                   <a:srgbClr val="4A5568"/>
                 </a:solidFill>
@@ -21588,22 +22182,22 @@
                 <a:ea typeface="Arial" pitchFamily="34" charset="-122"/>
                 <a:cs typeface="Arial" pitchFamily="34" charset="-120"/>
               </a:rPr>
-              <a:t>16–64 KB</a:t>
-            </a:r>
-            <a:endParaRPr lang="en-US" sz="950" dirty="0"/>
-          </a:p>
-        </p:txBody>
-      </p:sp>
-      <p:sp>
-        <p:nvSpPr>
-          <p:cNvPr id="24" name="Shape 21"/>
-          <p:cNvSpPr/>
-          <p:nvPr/>
-        </p:nvSpPr>
-        <p:spPr>
-          <a:xfrm>
-            <a:off x="2673706" y="2139696"/>
-            <a:ext cx="114300" cy="114300"/>
+              <a:t>512 KB · WS/prefetch</a:t>
+            </a:r>
+            <a:endParaRPr lang="en-US" sz="1000" dirty="0"/>
+          </a:p>
+        </p:txBody>
+      </p:sp>
+      <p:sp>
+        <p:nvSpPr>
+          <p:cNvPr id="41" name="Shape 38"/>
+          <p:cNvSpPr/>
+          <p:nvPr/>
+        </p:nvSpPr>
+        <p:spPr>
+          <a:xfrm>
+            <a:off x="1968703" y="4254703"/>
+            <a:ext cx="127102" cy="127102"/>
           </a:xfrm>
           <a:prstGeom prst="ellipse">
             <a:avLst/>
@@ -21616,18 +22210,18 @@
       </p:sp>
       <p:sp>
         <p:nvSpPr>
-          <p:cNvPr id="25" name="Shape 22"/>
-          <p:cNvSpPr/>
-          <p:nvPr/>
-        </p:nvSpPr>
-        <p:spPr>
-          <a:xfrm>
-            <a:off x="2057400" y="2564892"/>
-            <a:ext cx="672998" cy="330098"/>
+          <p:cNvPr id="42" name="Shape 39"/>
+          <p:cNvSpPr/>
+          <p:nvPr/>
+        </p:nvSpPr>
+        <p:spPr>
+          <a:xfrm>
+            <a:off x="2349094" y="4317797"/>
+            <a:ext cx="1714500" cy="634594"/>
           </a:xfrm>
           <a:prstGeom prst="roundRect">
             <a:avLst>
-              <a:gd name="adj" fmla="val 15512"/>
+              <a:gd name="adj" fmla="val 11960"/>
             </a:avLst>
           </a:prstGeom>
           <a:solidFill>
@@ -21643,14 +22237,37 @@
       </p:sp>
       <p:sp>
         <p:nvSpPr>
-          <p:cNvPr id="26" name="Text 23"/>
+          <p:cNvPr id="43" name="Shape 40"/>
+          <p:cNvSpPr/>
+          <p:nvPr/>
+        </p:nvSpPr>
+        <p:spPr>
+          <a:xfrm>
+            <a:off x="3206801" y="4317797"/>
+            <a:ext cx="0" cy="634594"/>
+          </a:xfrm>
+          <a:prstGeom prst="line">
+            <a:avLst/>
+          </a:prstGeom>
+          <a:noFill/>
+          <a:ln w="19050">
+            <a:solidFill>
+              <a:srgbClr val="D9DEE6"/>
+            </a:solidFill>
+            <a:prstDash val="solid"/>
+          </a:ln>
+        </p:spPr>
+      </p:sp>
+      <p:sp>
+        <p:nvSpPr>
+          <p:cNvPr id="44" name="Text 41"/>
           <p:cNvSpPr txBox="1"/>
           <p:nvPr/>
         </p:nvSpPr>
         <p:spPr>
           <a:xfrm>
-            <a:off x="2057400" y="2584094"/>
-            <a:ext cx="672998" cy="304495"/>
+            <a:off x="2349094" y="4393692"/>
+            <a:ext cx="856793" cy="254203"/>
           </a:xfrm>
           <a:prstGeom prst="rect">
             <a:avLst/>
@@ -21663,13 +22280,10 @@
           <a:lstStyle/>
           <a:p>
             <a:pPr algn="ctr" indent="0" marL="0">
-              <a:lnSpc>
-                <a:spcPct val="110000"/>
-              </a:lnSpc>
-              <a:buNone/>
-            </a:pPr>
-            <a:r>
-              <a:rPr lang="en-US" sz="950" b="1" dirty="0">
+              <a:buNone/>
+            </a:pPr>
+            <a:r>
+              <a:rPr lang="en-US" sz="1300" b="1" dirty="0">
                 <a:solidFill>
                   <a:srgbClr val="0F1B2D"/>
                 </a:solidFill>
@@ -21677,19 +22291,77 @@
                 <a:ea typeface="Arial" pitchFamily="34" charset="-122"/>
                 <a:cs typeface="Arial" pitchFamily="34" charset="-120"/>
               </a:rPr>
-              <a:t>DTCM</a:t>
-            </a:r>
-            <a:endParaRPr lang="en-US" sz="950" dirty="0"/>
-          </a:p>
+              <a:t>SRAM0</a:t>
+            </a:r>
+            <a:endParaRPr lang="en-US" sz="1300" dirty="0"/>
+          </a:p>
+        </p:txBody>
+      </p:sp>
+      <p:sp>
+        <p:nvSpPr>
+          <p:cNvPr id="45" name="Text 42"/>
+          <p:cNvSpPr txBox="1"/>
+          <p:nvPr/>
+        </p:nvSpPr>
+        <p:spPr>
+          <a:xfrm>
+            <a:off x="3206801" y="4393692"/>
+            <a:ext cx="856793" cy="254203"/>
+          </a:xfrm>
+          <a:prstGeom prst="rect">
+            <a:avLst/>
+          </a:prstGeom>
+          <a:noFill/>
+          <a:ln/>
+        </p:spPr>
+        <p:txBody>
+          <a:bodyPr wrap="square" lIns="0" tIns="0" rIns="0" bIns="0" rtlCol="0" anchor="t"/>
+          <a:lstStyle/>
           <a:p>
             <a:pPr algn="ctr" indent="0" marL="0">
-              <a:lnSpc>
-                <a:spcPct val="110000"/>
-              </a:lnSpc>
-              <a:buNone/>
-            </a:pPr>
-            <a:r>
-              <a:rPr lang="en-US" sz="950" dirty="0">
+              <a:buNone/>
+            </a:pPr>
+            <a:r>
+              <a:rPr lang="en-US" sz="1300" b="1" dirty="0">
+                <a:solidFill>
+                  <a:srgbClr val="0F1B2D"/>
+                </a:solidFill>
+                <a:latin typeface="Arial" pitchFamily="34" charset="0"/>
+                <a:ea typeface="Arial" pitchFamily="34" charset="-122"/>
+                <a:cs typeface="Arial" pitchFamily="34" charset="-120"/>
+              </a:rPr>
+              <a:t>SRAM1</a:t>
+            </a:r>
+            <a:endParaRPr lang="en-US" sz="1300" dirty="0"/>
+          </a:p>
+        </p:txBody>
+      </p:sp>
+      <p:sp>
+        <p:nvSpPr>
+          <p:cNvPr id="46" name="Text 43"/>
+          <p:cNvSpPr txBox="1"/>
+          <p:nvPr/>
+        </p:nvSpPr>
+        <p:spPr>
+          <a:xfrm>
+            <a:off x="2349094" y="4673498"/>
+            <a:ext cx="1714500" cy="190195"/>
+          </a:xfrm>
+          <a:prstGeom prst="rect">
+            <a:avLst/>
+          </a:prstGeom>
+          <a:noFill/>
+          <a:ln/>
+        </p:spPr>
+        <p:txBody>
+          <a:bodyPr wrap="square" lIns="0" tIns="0" rIns="0" bIns="0" rtlCol="0" anchor="t"/>
+          <a:lstStyle/>
+          <a:p>
+            <a:pPr algn="ctr" indent="0" marL="0">
+              <a:buNone/>
+            </a:pPr>
+            <a:r>
+              <a:rPr lang="en-US" sz="1000" dirty="0">
                 <a:solidFill>
                   <a:srgbClr val="4A5568"/>
                 </a:solidFill>
@@ -21697,22 +22369,22 @@
                 <a:ea typeface="Arial" pitchFamily="34" charset="-122"/>
                 <a:cs typeface="Arial" pitchFamily="34" charset="-120"/>
               </a:rPr>
-              <a:t>16–64 KB</a:t>
-            </a:r>
-            <a:endParaRPr lang="en-US" sz="950" dirty="0"/>
-          </a:p>
-        </p:txBody>
-      </p:sp>
-      <p:sp>
-        <p:nvSpPr>
-          <p:cNvPr id="27" name="Shape 24"/>
-          <p:cNvSpPr/>
-          <p:nvPr/>
-        </p:nvSpPr>
-        <p:spPr>
-          <a:xfrm>
-            <a:off x="2673706" y="2508199"/>
-            <a:ext cx="114300" cy="114300"/>
+              <a:t>64 KB × 2 · CPU·DMA 공유</a:t>
+            </a:r>
+            <a:endParaRPr lang="en-US" sz="1000" dirty="0"/>
+          </a:p>
+        </p:txBody>
+      </p:sp>
+      <p:sp>
+        <p:nvSpPr>
+          <p:cNvPr id="47" name="Shape 44"/>
+          <p:cNvSpPr/>
+          <p:nvPr/>
+        </p:nvSpPr>
+        <p:spPr>
+          <a:xfrm>
+            <a:off x="4000500" y="4254703"/>
+            <a:ext cx="127102" cy="127102"/>
           </a:xfrm>
           <a:prstGeom prst="ellipse">
             <a:avLst/>
@@ -21725,18 +22397,18 @@
       </p:sp>
       <p:sp>
         <p:nvSpPr>
-          <p:cNvPr id="28" name="Shape 25"/>
-          <p:cNvSpPr/>
-          <p:nvPr/>
-        </p:nvSpPr>
-        <p:spPr>
-          <a:xfrm>
-            <a:off x="856793" y="3022092"/>
-            <a:ext cx="952805" cy="254203"/>
+          <p:cNvPr id="48" name="Shape 45"/>
+          <p:cNvSpPr/>
+          <p:nvPr/>
+        </p:nvSpPr>
+        <p:spPr>
+          <a:xfrm>
+            <a:off x="4381805" y="4317797"/>
+            <a:ext cx="1206094" cy="634594"/>
           </a:xfrm>
           <a:prstGeom prst="roundRect">
             <a:avLst>
-              <a:gd name="adj" fmla="val 50000"/>
+              <a:gd name="adj" fmla="val 11960"/>
             </a:avLst>
           </a:prstGeom>
           <a:solidFill>
@@ -21752,30 +22424,30 @@
       </p:sp>
       <p:sp>
         <p:nvSpPr>
-          <p:cNvPr id="29" name="Text 26"/>
+          <p:cNvPr id="49" name="Text 46"/>
           <p:cNvSpPr txBox="1"/>
           <p:nvPr/>
         </p:nvSpPr>
         <p:spPr>
           <a:xfrm>
-            <a:off x="856793" y="3022092"/>
-            <a:ext cx="952805" cy="254203"/>
-          </a:xfrm>
-          <a:prstGeom prst="rect">
-            <a:avLst/>
-          </a:prstGeom>
-          <a:noFill/>
-          <a:ln/>
-        </p:spPr>
-        <p:txBody>
-          <a:bodyPr wrap="square" lIns="0" tIns="0" rIns="0" bIns="0" rtlCol="0" anchor="ctr"/>
+            <a:off x="4381805" y="4393692"/>
+            <a:ext cx="1206094" cy="254203"/>
+          </a:xfrm>
+          <a:prstGeom prst="rect">
+            <a:avLst/>
+          </a:prstGeom>
+          <a:noFill/>
+          <a:ln/>
+        </p:spPr>
+        <p:txBody>
+          <a:bodyPr wrap="square" lIns="0" tIns="0" rIns="0" bIns="0" rtlCol="0" anchor="t"/>
           <a:lstStyle/>
           <a:p>
             <a:pPr algn="ctr" indent="0" marL="0">
               <a:buNone/>
             </a:pPr>
             <a:r>
-              <a:rPr lang="en-US" sz="950" b="1" dirty="0">
+              <a:rPr lang="en-US" sz="1400" b="1" dirty="0">
                 <a:solidFill>
                   <a:srgbClr val="0F1B2D"/>
                 </a:solidFill>
@@ -21783,667 +22455,11 @@
                 <a:ea typeface="Arial" pitchFamily="34" charset="-122"/>
                 <a:cs typeface="Arial" pitchFamily="34" charset="-120"/>
               </a:rPr>
-              <a:t>I-Cache 0–4 KB</a:t>
-            </a:r>
-            <a:endParaRPr lang="en-US" sz="950" dirty="0"/>
-          </a:p>
-        </p:txBody>
-      </p:sp>
-      <p:sp>
-        <p:nvSpPr>
-          <p:cNvPr id="30" name="Shape 27"/>
-          <p:cNvSpPr/>
-          <p:nvPr/>
-        </p:nvSpPr>
-        <p:spPr>
-          <a:xfrm>
-            <a:off x="1752905" y="2965399"/>
-            <a:ext cx="114300" cy="114300"/>
-          </a:xfrm>
-          <a:prstGeom prst="ellipse">
-            <a:avLst/>
-          </a:prstGeom>
-          <a:solidFill>
-            <a:srgbClr val="E8A33D"/>
-          </a:solidFill>
-          <a:ln/>
-        </p:spPr>
-      </p:sp>
-      <p:sp>
-        <p:nvSpPr>
-          <p:cNvPr id="31" name="Shape 28"/>
-          <p:cNvSpPr/>
-          <p:nvPr/>
-        </p:nvSpPr>
-        <p:spPr>
-          <a:xfrm>
-            <a:off x="3047695" y="2197303"/>
-            <a:ext cx="1015898" cy="698602"/>
-          </a:xfrm>
-          <a:prstGeom prst="roundRect">
-            <a:avLst>
-              <a:gd name="adj" fmla="val 10864"/>
-            </a:avLst>
-          </a:prstGeom>
-          <a:solidFill>
-            <a:srgbClr val="0F1B2D"/>
-          </a:solidFill>
-          <a:ln/>
-        </p:spPr>
-      </p:sp>
-      <p:sp>
-        <p:nvSpPr>
-          <p:cNvPr id="32" name="Text 29"/>
-          <p:cNvSpPr txBox="1"/>
-          <p:nvPr/>
-        </p:nvSpPr>
-        <p:spPr>
-          <a:xfrm>
-            <a:off x="3047695" y="2286000"/>
-            <a:ext cx="1015898" cy="254203"/>
-          </a:xfrm>
-          <a:prstGeom prst="rect">
-            <a:avLst/>
-          </a:prstGeom>
-          <a:noFill/>
-          <a:ln/>
-        </p:spPr>
-        <p:txBody>
-          <a:bodyPr wrap="square" lIns="0" tIns="0" rIns="0" bIns="0" rtlCol="0" anchor="t"/>
-          <a:lstStyle/>
-          <a:p>
-            <a:pPr algn="ctr" indent="0" marL="0">
-              <a:buNone/>
-            </a:pPr>
-            <a:r>
-              <a:rPr lang="en-US" sz="1400" b="1" dirty="0">
-                <a:solidFill>
-                  <a:srgbClr val="FFFFFF"/>
-                </a:solidFill>
-                <a:latin typeface="Arial" pitchFamily="34" charset="0"/>
-                <a:ea typeface="Arial" pitchFamily="34" charset="-122"/>
-                <a:cs typeface="Arial" pitchFamily="34" charset="-120"/>
-              </a:rPr>
-              <a:t>DMA</a:t>
+              <a:t>주변장치</a:t>
             </a:r>
             <a:endParaRPr lang="en-US" sz="1400" dirty="0"/>
           </a:p>
         </p:txBody>
-      </p:sp>
-      <p:sp>
-        <p:nvSpPr>
-          <p:cNvPr id="33" name="Text 30"/>
-          <p:cNvSpPr txBox="1"/>
-          <p:nvPr/>
-        </p:nvSpPr>
-        <p:spPr>
-          <a:xfrm>
-            <a:off x="3047695" y="2564892"/>
-            <a:ext cx="1015898" cy="317297"/>
-          </a:xfrm>
-          <a:prstGeom prst="rect">
-            <a:avLst/>
-          </a:prstGeom>
-          <a:noFill/>
-          <a:ln/>
-        </p:spPr>
-        <p:txBody>
-          <a:bodyPr wrap="square" lIns="0" tIns="0" rIns="0" bIns="0" rtlCol="0" anchor="t"/>
-          <a:lstStyle/>
-          <a:p>
-            <a:pPr algn="ctr" indent="0" marL="0">
-              <a:lnSpc>
-                <a:spcPct val="115000"/>
-              </a:lnSpc>
-              <a:buNone/>
-            </a:pPr>
-            <a:r>
-              <a:rPr lang="en-US" sz="1000" dirty="0">
-                <a:solidFill>
-                  <a:srgbClr val="BFD8D5"/>
-                </a:solidFill>
-                <a:latin typeface="Arial" pitchFamily="34" charset="0"/>
-                <a:ea typeface="Arial" pitchFamily="34" charset="-122"/>
-                <a:cs typeface="Arial" pitchFamily="34" charset="-120"/>
-              </a:rPr>
-              <a:t>2ch · burst 1–16</a:t>
-            </a:r>
-            <a:endParaRPr lang="en-US" sz="1000" dirty="0"/>
-          </a:p>
-          <a:p>
-            <a:pPr algn="ctr" indent="0" marL="0">
-              <a:lnSpc>
-                <a:spcPct val="115000"/>
-              </a:lnSpc>
-              <a:buNone/>
-            </a:pPr>
-            <a:r>
-              <a:rPr lang="en-US" sz="1000" dirty="0">
-                <a:solidFill>
-                  <a:srgbClr val="BFD8D5"/>
-                </a:solidFill>
-                <a:latin typeface="Arial" pitchFamily="34" charset="0"/>
-                <a:ea typeface="Arial" pitchFamily="34" charset="-122"/>
-                <a:cs typeface="Arial" pitchFamily="34" charset="-120"/>
-              </a:rPr>
-              <a:t>오디오 → SRAM</a:t>
-            </a:r>
-            <a:endParaRPr lang="en-US" sz="1000" dirty="0"/>
-          </a:p>
-        </p:txBody>
-      </p:sp>
-      <p:sp>
-        <p:nvSpPr>
-          <p:cNvPr id="34" name="Shape 31"/>
-          <p:cNvSpPr/>
-          <p:nvPr/>
-        </p:nvSpPr>
-        <p:spPr>
-          <a:xfrm>
-            <a:off x="4006901" y="2139696"/>
-            <a:ext cx="114300" cy="114300"/>
-          </a:xfrm>
-          <a:prstGeom prst="ellipse">
-            <a:avLst/>
-          </a:prstGeom>
-          <a:solidFill>
-            <a:srgbClr val="E8A33D"/>
-          </a:solidFill>
-          <a:ln/>
-        </p:spPr>
-      </p:sp>
-      <p:sp>
-        <p:nvSpPr>
-          <p:cNvPr id="35" name="Shape 32"/>
-          <p:cNvSpPr/>
-          <p:nvPr/>
-        </p:nvSpPr>
-        <p:spPr>
-          <a:xfrm>
-            <a:off x="4444898" y="2197303"/>
-            <a:ext cx="1206094" cy="698602"/>
-          </a:xfrm>
-          <a:prstGeom prst="roundRect">
-            <a:avLst>
-              <a:gd name="adj" fmla="val 10864"/>
-            </a:avLst>
-          </a:prstGeom>
-          <a:solidFill>
-            <a:srgbClr val="FFFFFF"/>
-          </a:solidFill>
-          <a:ln w="28575">
-            <a:solidFill>
-              <a:srgbClr val="B8791F"/>
-            </a:solidFill>
-            <a:prstDash val="dash"/>
-          </a:ln>
-        </p:spPr>
-      </p:sp>
-      <p:sp>
-        <p:nvSpPr>
-          <p:cNvPr id="36" name="Text 33"/>
-          <p:cNvSpPr txBox="1"/>
-          <p:nvPr/>
-        </p:nvSpPr>
-        <p:spPr>
-          <a:xfrm>
-            <a:off x="4444898" y="2286000"/>
-            <a:ext cx="1206094" cy="254203"/>
-          </a:xfrm>
-          <a:prstGeom prst="rect">
-            <a:avLst/>
-          </a:prstGeom>
-          <a:noFill/>
-          <a:ln/>
-        </p:spPr>
-        <p:txBody>
-          <a:bodyPr wrap="square" lIns="0" tIns="0" rIns="0" bIns="0" rtlCol="0" anchor="t"/>
-          <a:lstStyle/>
-          <a:p>
-            <a:pPr algn="ctr" indent="0" marL="0">
-              <a:buNone/>
-            </a:pPr>
-            <a:r>
-              <a:rPr lang="en-US" sz="1400" b="1" dirty="0">
-                <a:solidFill>
-                  <a:srgbClr val="B8791F"/>
-                </a:solidFill>
-                <a:latin typeface="Arial" pitchFamily="34" charset="0"/>
-                <a:ea typeface="Arial" pitchFamily="34" charset="-122"/>
-                <a:cs typeface="Arial" pitchFamily="34" charset="-120"/>
-              </a:rPr>
-              <a:t>MAC 가속기</a:t>
-            </a:r>
-            <a:endParaRPr lang="en-US" sz="1400" dirty="0"/>
-          </a:p>
-        </p:txBody>
-      </p:sp>
-      <p:sp>
-        <p:nvSpPr>
-          <p:cNvPr id="37" name="Text 34"/>
-          <p:cNvSpPr txBox="1"/>
-          <p:nvPr/>
-        </p:nvSpPr>
-        <p:spPr>
-          <a:xfrm>
-            <a:off x="4444898" y="2553005"/>
-            <a:ext cx="1206094" cy="317297"/>
-          </a:xfrm>
-          <a:prstGeom prst="rect">
-            <a:avLst/>
-          </a:prstGeom>
-          <a:noFill/>
-          <a:ln/>
-        </p:spPr>
-        <p:txBody>
-          <a:bodyPr wrap="square" lIns="0" tIns="0" rIns="0" bIns="0" rtlCol="0" anchor="t"/>
-          <a:lstStyle/>
-          <a:p>
-            <a:pPr algn="ctr" indent="0" marL="0">
-              <a:lnSpc>
-                <a:spcPct val="115000"/>
-              </a:lnSpc>
-              <a:buNone/>
-            </a:pPr>
-            <a:r>
-              <a:rPr lang="en-US" sz="950" dirty="0">
-                <a:solidFill>
-                  <a:srgbClr val="4A5568"/>
-                </a:solidFill>
-                <a:latin typeface="Arial" pitchFamily="34" charset="0"/>
-                <a:ea typeface="Arial" pitchFamily="34" charset="-122"/>
-                <a:cs typeface="Arial" pitchFamily="34" charset="-120"/>
-              </a:rPr>
-              <a:t>INT8 dot-product</a:t>
-            </a:r>
-            <a:endParaRPr lang="en-US" sz="950" dirty="0"/>
-          </a:p>
-          <a:p>
-            <a:pPr algn="ctr" indent="0" marL="0">
-              <a:lnSpc>
-                <a:spcPct val="115000"/>
-              </a:lnSpc>
-              <a:buNone/>
-            </a:pPr>
-            <a:r>
-              <a:rPr lang="en-US" sz="950" dirty="0">
-                <a:solidFill>
-                  <a:srgbClr val="4A5568"/>
-                </a:solidFill>
-                <a:latin typeface="Arial" pitchFamily="34" charset="0"/>
-                <a:ea typeface="Arial" pitchFamily="34" charset="-122"/>
-                <a:cs typeface="Arial" pitchFamily="34" charset="-120"/>
-              </a:rPr>
-              <a:t>옵션 (예산 ≤470)</a:t>
-            </a:r>
-            <a:endParaRPr lang="en-US" sz="950" dirty="0"/>
-          </a:p>
-        </p:txBody>
-      </p:sp>
-      <p:sp>
-        <p:nvSpPr>
-          <p:cNvPr id="38" name="Shape 35"/>
-          <p:cNvSpPr/>
-          <p:nvPr/>
-        </p:nvSpPr>
-        <p:spPr>
-          <a:xfrm>
-            <a:off x="5594299" y="2139696"/>
-            <a:ext cx="114300" cy="114300"/>
-          </a:xfrm>
-          <a:prstGeom prst="ellipse">
-            <a:avLst/>
-          </a:prstGeom>
-          <a:solidFill>
-            <a:srgbClr val="E8A33D"/>
-          </a:solidFill>
-          <a:ln/>
-        </p:spPr>
-      </p:sp>
-      <p:sp>
-        <p:nvSpPr>
-          <p:cNvPr id="39" name="Shape 36"/>
-          <p:cNvSpPr/>
-          <p:nvPr/>
-        </p:nvSpPr>
-        <p:spPr>
-          <a:xfrm>
-            <a:off x="698602" y="3429000"/>
-            <a:ext cx="4953305" cy="330098"/>
-          </a:xfrm>
-          <a:prstGeom prst="roundRect">
-            <a:avLst>
-              <a:gd name="adj" fmla="val 19114"/>
-            </a:avLst>
-          </a:prstGeom>
-          <a:solidFill>
-            <a:srgbClr val="2FA6A0"/>
-          </a:solidFill>
-          <a:ln/>
-        </p:spPr>
-      </p:sp>
-      <p:sp>
-        <p:nvSpPr>
-          <p:cNvPr id="40" name="Text 37"/>
-          <p:cNvSpPr txBox="1"/>
-          <p:nvPr/>
-        </p:nvSpPr>
-        <p:spPr>
-          <a:xfrm>
-            <a:off x="698602" y="3429000"/>
-            <a:ext cx="4953305" cy="330098"/>
-          </a:xfrm>
-          <a:prstGeom prst="rect">
-            <a:avLst/>
-          </a:prstGeom>
-          <a:noFill/>
-          <a:ln/>
-        </p:spPr>
-        <p:txBody>
-          <a:bodyPr wrap="square" lIns="0" tIns="0" rIns="0" bIns="0" rtlCol="0" anchor="ctr"/>
-          <a:lstStyle/>
-          <a:p>
-            <a:pPr algn="ctr" indent="0" marL="0">
-              <a:buNone/>
-            </a:pPr>
-            <a:r>
-              <a:rPr lang="en-US" sz="1200" b="1" dirty="0">
-                <a:solidFill>
-                  <a:srgbClr val="FFFFFF"/>
-                </a:solidFill>
-                <a:latin typeface="Arial" pitchFamily="34" charset="0"/>
-                <a:ea typeface="Arial" pitchFamily="34" charset="-122"/>
-                <a:cs typeface="Arial" pitchFamily="34" charset="-120"/>
-              </a:rPr>
-              <a:t>AHB 매트릭스 · 마스터 3개의 경합을 cycle 단위로 모델링</a:t>
-            </a:r>
-            <a:endParaRPr lang="en-US" sz="1200" dirty="0"/>
-          </a:p>
-        </p:txBody>
-      </p:sp>
-      <p:sp>
-        <p:nvSpPr>
-          <p:cNvPr id="41" name="Shape 38"/>
-          <p:cNvSpPr/>
-          <p:nvPr/>
-        </p:nvSpPr>
-        <p:spPr>
-          <a:xfrm>
-            <a:off x="698602" y="4076395"/>
-            <a:ext cx="1143000" cy="508406"/>
-          </a:xfrm>
-          <a:prstGeom prst="roundRect">
-            <a:avLst>
-              <a:gd name="adj" fmla="val 14928"/>
-            </a:avLst>
-          </a:prstGeom>
-          <a:solidFill>
-            <a:srgbClr val="FFFFFF"/>
-          </a:solidFill>
-          <a:ln w="19050">
-            <a:solidFill>
-              <a:srgbClr val="0F1B2D"/>
-            </a:solidFill>
-            <a:prstDash val="solid"/>
-          </a:ln>
-        </p:spPr>
-      </p:sp>
-      <p:sp>
-        <p:nvSpPr>
-          <p:cNvPr id="42" name="Text 39"/>
-          <p:cNvSpPr txBox="1"/>
-          <p:nvPr/>
-        </p:nvSpPr>
-        <p:spPr>
-          <a:xfrm>
-            <a:off x="698602" y="4127602"/>
-            <a:ext cx="1143000" cy="190195"/>
-          </a:xfrm>
-          <a:prstGeom prst="rect">
-            <a:avLst/>
-          </a:prstGeom>
-          <a:noFill/>
-          <a:ln/>
-        </p:spPr>
-        <p:txBody>
-          <a:bodyPr wrap="square" lIns="0" tIns="0" rIns="0" bIns="0" rtlCol="0" anchor="t"/>
-          <a:lstStyle/>
-          <a:p>
-            <a:pPr algn="ctr" indent="0" marL="0">
-              <a:buNone/>
-            </a:pPr>
-            <a:r>
-              <a:rPr lang="en-US" sz="1100" b="1" dirty="0">
-                <a:solidFill>
-                  <a:srgbClr val="0F1B2D"/>
-                </a:solidFill>
-                <a:latin typeface="Arial" pitchFamily="34" charset="0"/>
-                <a:ea typeface="Arial" pitchFamily="34" charset="-122"/>
-                <a:cs typeface="Arial" pitchFamily="34" charset="-120"/>
-              </a:rPr>
-              <a:t>Flash 512 KB</a:t>
-            </a:r>
-            <a:endParaRPr lang="en-US" sz="1100" dirty="0"/>
-          </a:p>
-        </p:txBody>
-      </p:sp>
-      <p:sp>
-        <p:nvSpPr>
-          <p:cNvPr id="43" name="Text 40"/>
-          <p:cNvSpPr txBox="1"/>
-          <p:nvPr/>
-        </p:nvSpPr>
-        <p:spPr>
-          <a:xfrm>
-            <a:off x="698602" y="4356202"/>
-            <a:ext cx="1143000" cy="177394"/>
-          </a:xfrm>
-          <a:prstGeom prst="rect">
-            <a:avLst/>
-          </a:prstGeom>
-          <a:noFill/>
-          <a:ln/>
-        </p:spPr>
-        <p:txBody>
-          <a:bodyPr wrap="square" lIns="0" tIns="0" rIns="0" bIns="0" rtlCol="0" anchor="t"/>
-          <a:lstStyle/>
-          <a:p>
-            <a:pPr algn="ctr" indent="0" marL="0">
-              <a:buNone/>
-            </a:pPr>
-            <a:r>
-              <a:rPr lang="en-US" sz="950" dirty="0">
-                <a:solidFill>
-                  <a:srgbClr val="4A5568"/>
-                </a:solidFill>
-                <a:latin typeface="Arial" pitchFamily="34" charset="0"/>
-                <a:ea typeface="Arial" pitchFamily="34" charset="-122"/>
-                <a:cs typeface="Arial" pitchFamily="34" charset="-120"/>
-              </a:rPr>
-              <a:t>WS 6→4 · prefetch</a:t>
-            </a:r>
-            <a:endParaRPr lang="en-US" sz="950" dirty="0"/>
-          </a:p>
-        </p:txBody>
-      </p:sp>
-      <p:sp>
-        <p:nvSpPr>
-          <p:cNvPr id="44" name="Shape 41"/>
-          <p:cNvSpPr/>
-          <p:nvPr/>
-        </p:nvSpPr>
-        <p:spPr>
-          <a:xfrm>
-            <a:off x="1783994" y="4019702"/>
-            <a:ext cx="114300" cy="114300"/>
-          </a:xfrm>
-          <a:prstGeom prst="ellipse">
-            <a:avLst/>
-          </a:prstGeom>
-          <a:solidFill>
-            <a:srgbClr val="E8A33D"/>
-          </a:solidFill>
-          <a:ln/>
-        </p:spPr>
-      </p:sp>
-      <p:sp>
-        <p:nvSpPr>
-          <p:cNvPr id="45" name="Shape 42"/>
-          <p:cNvSpPr/>
-          <p:nvPr/>
-        </p:nvSpPr>
-        <p:spPr>
-          <a:xfrm>
-            <a:off x="2095805" y="4076395"/>
-            <a:ext cx="457200" cy="508406"/>
-          </a:xfrm>
-          <a:prstGeom prst="roundRect">
-            <a:avLst>
-              <a:gd name="adj" fmla="val 13800"/>
-            </a:avLst>
-          </a:prstGeom>
-          <a:solidFill>
-            <a:srgbClr val="FFFFFF"/>
-          </a:solidFill>
-          <a:ln w="19050">
-            <a:solidFill>
-              <a:srgbClr val="0F1B2D"/>
-            </a:solidFill>
-            <a:prstDash val="solid"/>
-          </a:ln>
-        </p:spPr>
-      </p:sp>
-      <p:sp>
-        <p:nvSpPr>
-          <p:cNvPr id="46" name="Text 43"/>
-          <p:cNvSpPr txBox="1"/>
-          <p:nvPr/>
-        </p:nvSpPr>
-        <p:spPr>
-          <a:xfrm>
-            <a:off x="2095805" y="4076395"/>
-            <a:ext cx="457200" cy="508406"/>
-          </a:xfrm>
-          <a:prstGeom prst="rect">
-            <a:avLst/>
-          </a:prstGeom>
-          <a:noFill/>
-          <a:ln/>
-        </p:spPr>
-        <p:txBody>
-          <a:bodyPr wrap="square" lIns="0" tIns="0" rIns="0" bIns="0" rtlCol="0" anchor="ctr"/>
-          <a:lstStyle/>
-          <a:p>
-            <a:pPr algn="ctr" indent="0" marL="0">
-              <a:buNone/>
-            </a:pPr>
-            <a:r>
-              <a:rPr lang="en-US" sz="950" b="1" dirty="0">
-                <a:solidFill>
-                  <a:srgbClr val="0F1B2D"/>
-                </a:solidFill>
-                <a:latin typeface="Arial" pitchFamily="34" charset="0"/>
-                <a:ea typeface="Arial" pitchFamily="34" charset="-122"/>
-                <a:cs typeface="Arial" pitchFamily="34" charset="-120"/>
-              </a:rPr>
-              <a:t>SRAM0</a:t>
-            </a:r>
-            <a:endParaRPr lang="en-US" sz="950" dirty="0"/>
-          </a:p>
-        </p:txBody>
-      </p:sp>
-      <p:sp>
-        <p:nvSpPr>
-          <p:cNvPr id="47" name="Shape 44"/>
-          <p:cNvSpPr/>
-          <p:nvPr/>
-        </p:nvSpPr>
-        <p:spPr>
-          <a:xfrm>
-            <a:off x="2603297" y="4076395"/>
-            <a:ext cx="457200" cy="508406"/>
-          </a:xfrm>
-          <a:prstGeom prst="roundRect">
-            <a:avLst>
-              <a:gd name="adj" fmla="val 13800"/>
-            </a:avLst>
-          </a:prstGeom>
-          <a:solidFill>
-            <a:srgbClr val="FFFFFF"/>
-          </a:solidFill>
-          <a:ln w="19050">
-            <a:solidFill>
-              <a:srgbClr val="0F1B2D"/>
-            </a:solidFill>
-            <a:prstDash val="solid"/>
-          </a:ln>
-        </p:spPr>
-      </p:sp>
-      <p:sp>
-        <p:nvSpPr>
-          <p:cNvPr id="48" name="Text 45"/>
-          <p:cNvSpPr txBox="1"/>
-          <p:nvPr/>
-        </p:nvSpPr>
-        <p:spPr>
-          <a:xfrm>
-            <a:off x="2603297" y="4076395"/>
-            <a:ext cx="457200" cy="508406"/>
-          </a:xfrm>
-          <a:prstGeom prst="rect">
-            <a:avLst/>
-          </a:prstGeom>
-          <a:noFill/>
-          <a:ln/>
-        </p:spPr>
-        <p:txBody>
-          <a:bodyPr wrap="square" lIns="0" tIns="0" rIns="0" bIns="0" rtlCol="0" anchor="ctr"/>
-          <a:lstStyle/>
-          <a:p>
-            <a:pPr algn="ctr" indent="0" marL="0">
-              <a:buNone/>
-            </a:pPr>
-            <a:r>
-              <a:rPr lang="en-US" sz="950" b="1" dirty="0">
-                <a:solidFill>
-                  <a:srgbClr val="0F1B2D"/>
-                </a:solidFill>
-                <a:latin typeface="Arial" pitchFamily="34" charset="0"/>
-                <a:ea typeface="Arial" pitchFamily="34" charset="-122"/>
-                <a:cs typeface="Arial" pitchFamily="34" charset="-120"/>
-              </a:rPr>
-              <a:t>SRAM1</a:t>
-            </a:r>
-            <a:endParaRPr lang="en-US" sz="950" dirty="0"/>
-          </a:p>
-        </p:txBody>
-      </p:sp>
-      <p:sp>
-        <p:nvSpPr>
-          <p:cNvPr id="49" name="Shape 46"/>
-          <p:cNvSpPr/>
-          <p:nvPr/>
-        </p:nvSpPr>
-        <p:spPr>
-          <a:xfrm>
-            <a:off x="3111703" y="4076395"/>
-            <a:ext cx="457200" cy="508406"/>
-          </a:xfrm>
-          <a:prstGeom prst="roundRect">
-            <a:avLst>
-              <a:gd name="adj" fmla="val 13800"/>
-            </a:avLst>
-          </a:prstGeom>
-          <a:solidFill>
-            <a:srgbClr val="FFFFFF"/>
-          </a:solidFill>
-          <a:ln w="19050">
-            <a:solidFill>
-              <a:srgbClr val="0F1B2D"/>
-            </a:solidFill>
-            <a:prstDash val="solid"/>
-          </a:ln>
-        </p:spPr>
       </p:sp>
       <p:sp>
         <p:nvSpPr>
@@ -22453,133 +22469,47 @@
         </p:nvSpPr>
         <p:spPr>
           <a:xfrm>
-            <a:off x="3111703" y="4076395"/>
-            <a:ext cx="457200" cy="508406"/>
-          </a:xfrm>
-          <a:prstGeom prst="rect">
-            <a:avLst/>
-          </a:prstGeom>
-          <a:noFill/>
-          <a:ln/>
-        </p:spPr>
-        <p:txBody>
-          <a:bodyPr wrap="square" lIns="0" tIns="0" rIns="0" bIns="0" rtlCol="0" anchor="ctr"/>
+            <a:off x="4381805" y="4673498"/>
+            <a:ext cx="1206094" cy="190195"/>
+          </a:xfrm>
+          <a:prstGeom prst="rect">
+            <a:avLst/>
+          </a:prstGeom>
+          <a:noFill/>
+          <a:ln/>
+        </p:spPr>
+        <p:txBody>
+          <a:bodyPr wrap="square" lIns="0" tIns="0" rIns="0" bIns="0" rtlCol="0" anchor="t"/>
           <a:lstStyle/>
           <a:p>
             <a:pPr algn="ctr" indent="0" marL="0">
               <a:buNone/>
             </a:pPr>
             <a:r>
-              <a:rPr lang="en-US" sz="950" b="1" dirty="0">
-                <a:solidFill>
-                  <a:srgbClr val="0F1B2D"/>
-                </a:solidFill>
-                <a:latin typeface="Arial" pitchFamily="34" charset="0"/>
-                <a:ea typeface="Arial" pitchFamily="34" charset="-122"/>
-                <a:cs typeface="Arial" pitchFamily="34" charset="-120"/>
-              </a:rPr>
-              <a:t>SRAM2</a:t>
-            </a:r>
-            <a:endParaRPr lang="en-US" sz="950" dirty="0"/>
-          </a:p>
-        </p:txBody>
-      </p:sp>
-      <p:sp>
-        <p:nvSpPr>
-          <p:cNvPr id="51" name="Shape 48"/>
-          <p:cNvSpPr/>
-          <p:nvPr/>
-        </p:nvSpPr>
-        <p:spPr>
-          <a:xfrm>
-            <a:off x="3619195" y="4076395"/>
-            <a:ext cx="457200" cy="508406"/>
-          </a:xfrm>
-          <a:prstGeom prst="roundRect">
-            <a:avLst>
-              <a:gd name="adj" fmla="val 13800"/>
-            </a:avLst>
-          </a:prstGeom>
-          <a:solidFill>
-            <a:srgbClr val="FFFFFF"/>
-          </a:solidFill>
-          <a:ln w="28575">
-            <a:solidFill>
-              <a:srgbClr val="B8791F"/>
-            </a:solidFill>
-            <a:prstDash val="dash"/>
-          </a:ln>
-        </p:spPr>
-      </p:sp>
-      <p:sp>
-        <p:nvSpPr>
-          <p:cNvPr id="52" name="Text 49"/>
+              <a:rPr lang="en-US" sz="1000" dirty="0">
+                <a:solidFill>
+                  <a:srgbClr val="4A5568"/>
+                </a:solidFill>
+                <a:latin typeface="Arial" pitchFamily="34" charset="0"/>
+                <a:ea typeface="Arial" pitchFamily="34" charset="-122"/>
+                <a:cs typeface="Arial" pitchFamily="34" charset="-120"/>
+              </a:rPr>
+              <a:t>Timer · Audio · I/O</a:t>
+            </a:r>
+            <a:endParaRPr lang="en-US" sz="1000" dirty="0"/>
+          </a:p>
+        </p:txBody>
+      </p:sp>
+      <p:sp>
+        <p:nvSpPr>
+          <p:cNvPr id="51" name="Text 48"/>
           <p:cNvSpPr txBox="1"/>
           <p:nvPr/>
         </p:nvSpPr>
         <p:spPr>
           <a:xfrm>
-            <a:off x="3619195" y="4076395"/>
-            <a:ext cx="457200" cy="508406"/>
-          </a:xfrm>
-          <a:prstGeom prst="rect">
-            <a:avLst/>
-          </a:prstGeom>
-          <a:noFill/>
-          <a:ln/>
-        </p:spPr>
-        <p:txBody>
-          <a:bodyPr wrap="square" lIns="0" tIns="0" rIns="0" bIns="0" rtlCol="0" anchor="ctr"/>
-          <a:lstStyle/>
-          <a:p>
-            <a:pPr algn="ctr" indent="0" marL="0">
-              <a:buNone/>
-            </a:pPr>
-            <a:r>
-              <a:rPr lang="en-US" sz="950" b="1" dirty="0">
-                <a:solidFill>
-                  <a:srgbClr val="B8791F"/>
-                </a:solidFill>
-                <a:latin typeface="Arial" pitchFamily="34" charset="0"/>
-                <a:ea typeface="Arial" pitchFamily="34" charset="-122"/>
-                <a:cs typeface="Arial" pitchFamily="34" charset="-120"/>
-              </a:rPr>
-              <a:t>SRAM3</a:t>
-            </a:r>
-            <a:endParaRPr lang="en-US" sz="950" dirty="0"/>
-          </a:p>
-        </p:txBody>
-      </p:sp>
-      <p:sp>
-        <p:nvSpPr>
-          <p:cNvPr id="53" name="Shape 50"/>
-          <p:cNvSpPr/>
-          <p:nvPr/>
-        </p:nvSpPr>
-        <p:spPr>
-          <a:xfrm>
-            <a:off x="4019702" y="4019702"/>
-            <a:ext cx="114300" cy="114300"/>
-          </a:xfrm>
-          <a:prstGeom prst="ellipse">
-            <a:avLst/>
-          </a:prstGeom>
-          <a:solidFill>
-            <a:srgbClr val="E8A33D"/>
-          </a:solidFill>
-          <a:ln/>
-        </p:spPr>
-      </p:sp>
-      <p:sp>
-        <p:nvSpPr>
-          <p:cNvPr id="54" name="Text 51"/>
-          <p:cNvSpPr txBox="1"/>
-          <p:nvPr/>
-        </p:nvSpPr>
-        <p:spPr>
-          <a:xfrm>
-            <a:off x="2095805" y="4622292"/>
-            <a:ext cx="1981505" cy="177394"/>
+            <a:off x="660197" y="5143500"/>
+            <a:ext cx="5079492" cy="228600"/>
           </a:xfrm>
           <a:prstGeom prst="rect">
             <a:avLst/>
@@ -22591,11 +22521,25 @@
           <a:bodyPr wrap="square" lIns="0" tIns="0" rIns="0" bIns="0" rtlCol="0" anchor="t"/>
           <a:lstStyle/>
           <a:p>
-            <a:pPr algn="ctr" indent="0" marL="0">
-              <a:buNone/>
-            </a:pPr>
-            <a:r>
-              <a:rPr lang="en-US" sz="950" dirty="0">
+            <a:pPr algn="l" indent="0" marL="0">
+              <a:buNone/>
+            </a:pPr>
+            <a:r>
+              <a:rPr lang="en-US" sz="1050" dirty="0">
+                <a:solidFill>
+                  <a:srgbClr val="E8A33D"/>
+                </a:solidFill>
+                <a:latin typeface="Arial" pitchFamily="34" charset="0"/>
+                <a:ea typeface="Arial" pitchFamily="34" charset="-122"/>
+                <a:cs typeface="Arial" pitchFamily="34" charset="-120"/>
+              </a:rPr>
+              <a:t>● </a:t>
+            </a:r>
+            <a:pPr algn="l" indent="0" marL="0">
+              <a:buNone/>
+            </a:pPr>
+            <a:r>
+              <a:rPr lang="en-US" sz="1050" dirty="0">
                 <a:solidFill>
                   <a:srgbClr val="4A5568"/>
                 </a:solidFill>
@@ -22603,259 +22547,15 @@
                 <a:ea typeface="Arial" pitchFamily="34" charset="-122"/>
                 <a:cs typeface="Arial" pitchFamily="34" charset="-120"/>
               </a:rPr>
-              <a:t>64 KB 뱅크 × 2–4 · 독립 포트</a:t>
-            </a:r>
-            <a:endParaRPr lang="en-US" sz="950" dirty="0"/>
-          </a:p>
-        </p:txBody>
-      </p:sp>
-      <p:sp>
-        <p:nvSpPr>
-          <p:cNvPr id="55" name="Shape 52"/>
-          <p:cNvSpPr/>
-          <p:nvPr/>
-        </p:nvSpPr>
-        <p:spPr>
-          <a:xfrm>
-            <a:off x="4381805" y="4076395"/>
-            <a:ext cx="1270102" cy="508406"/>
-          </a:xfrm>
-          <a:prstGeom prst="roundRect">
-            <a:avLst>
-              <a:gd name="adj" fmla="val 14928"/>
-            </a:avLst>
-          </a:prstGeom>
-          <a:solidFill>
-            <a:srgbClr val="FFFFFF"/>
-          </a:solidFill>
-          <a:ln w="19050">
-            <a:solidFill>
-              <a:srgbClr val="0F1B2D"/>
-            </a:solidFill>
-            <a:prstDash val="solid"/>
-          </a:ln>
-        </p:spPr>
-      </p:sp>
-      <p:sp>
-        <p:nvSpPr>
-          <p:cNvPr id="56" name="Text 53"/>
-          <p:cNvSpPr txBox="1"/>
-          <p:nvPr/>
-        </p:nvSpPr>
-        <p:spPr>
-          <a:xfrm>
-            <a:off x="4381805" y="4127602"/>
-            <a:ext cx="1270102" cy="190195"/>
-          </a:xfrm>
-          <a:prstGeom prst="rect">
-            <a:avLst/>
-          </a:prstGeom>
-          <a:noFill/>
-          <a:ln/>
-        </p:spPr>
-        <p:txBody>
-          <a:bodyPr wrap="square" lIns="0" tIns="0" rIns="0" bIns="0" rtlCol="0" anchor="t"/>
-          <a:lstStyle/>
-          <a:p>
-            <a:pPr algn="ctr" indent="0" marL="0">
-              <a:buNone/>
-            </a:pPr>
-            <a:r>
-              <a:rPr lang="en-US" sz="1100" b="1" dirty="0">
-                <a:solidFill>
-                  <a:srgbClr val="0F1B2D"/>
-                </a:solidFill>
-                <a:latin typeface="Arial" pitchFamily="34" charset="0"/>
-                <a:ea typeface="Arial" pitchFamily="34" charset="-122"/>
-                <a:cs typeface="Arial" pitchFamily="34" charset="-120"/>
-              </a:rPr>
-              <a:t>주변장치</a:t>
-            </a:r>
-            <a:endParaRPr lang="en-US" sz="1100" dirty="0"/>
-          </a:p>
-        </p:txBody>
-      </p:sp>
-      <p:sp>
-        <p:nvSpPr>
-          <p:cNvPr id="57" name="Text 54"/>
-          <p:cNvSpPr txBox="1"/>
-          <p:nvPr/>
-        </p:nvSpPr>
-        <p:spPr>
-          <a:xfrm>
-            <a:off x="4381805" y="4317797"/>
-            <a:ext cx="1270102" cy="254203"/>
-          </a:xfrm>
-          <a:prstGeom prst="rect">
-            <a:avLst/>
-          </a:prstGeom>
-          <a:noFill/>
-          <a:ln/>
-        </p:spPr>
-        <p:txBody>
-          <a:bodyPr wrap="square" lIns="0" tIns="0" rIns="0" bIns="0" rtlCol="0" anchor="t"/>
-          <a:lstStyle/>
-          <a:p>
-            <a:pPr algn="ctr" indent="0" marL="0">
-              <a:lnSpc>
-                <a:spcPct val="115000"/>
-              </a:lnSpc>
-              <a:buNone/>
-            </a:pPr>
-            <a:r>
-              <a:rPr lang="en-US" sz="800" dirty="0">
-                <a:solidFill>
-                  <a:srgbClr val="4A5568"/>
-                </a:solidFill>
-                <a:latin typeface="Arial" pitchFamily="34" charset="0"/>
-                <a:ea typeface="Arial" pitchFamily="34" charset="-122"/>
-                <a:cs typeface="Arial" pitchFamily="34" charset="-120"/>
-              </a:rPr>
-              <a:t>Timer 1 kHz · Audio in</a:t>
-            </a:r>
-            <a:endParaRPr lang="en-US" sz="800" dirty="0"/>
-          </a:p>
-          <a:p>
-            <a:pPr algn="ctr" indent="0" marL="0">
-              <a:lnSpc>
-                <a:spcPct val="115000"/>
-              </a:lnSpc>
-              <a:buNone/>
-            </a:pPr>
-            <a:r>
-              <a:rPr lang="en-US" sz="800" dirty="0">
-                <a:solidFill>
-                  <a:srgbClr val="4A5568"/>
-                </a:solidFill>
-                <a:latin typeface="Arial" pitchFamily="34" charset="0"/>
-                <a:ea typeface="Arial" pitchFamily="34" charset="-122"/>
-                <a:cs typeface="Arial" pitchFamily="34" charset="-120"/>
-              </a:rPr>
-              <a:t>Sensor · Actuator</a:t>
-            </a:r>
-            <a:endParaRPr lang="en-US" sz="800" dirty="0"/>
-          </a:p>
-        </p:txBody>
-      </p:sp>
-      <p:sp>
-        <p:nvSpPr>
-          <p:cNvPr id="58" name="Text 55"/>
-          <p:cNvSpPr txBox="1"/>
-          <p:nvPr/>
-        </p:nvSpPr>
-        <p:spPr>
-          <a:xfrm>
-            <a:off x="660197" y="4876495"/>
-            <a:ext cx="5079492" cy="571500"/>
-          </a:xfrm>
-          <a:prstGeom prst="rect">
-            <a:avLst/>
-          </a:prstGeom>
-          <a:noFill/>
-          <a:ln/>
-        </p:spPr>
-        <p:txBody>
-          <a:bodyPr wrap="square" lIns="0" tIns="0" rIns="0" bIns="0" rtlCol="0" anchor="t"/>
-          <a:lstStyle/>
-          <a:p>
-            <a:pPr algn="l" indent="0" marL="0">
-              <a:lnSpc>
-                <a:spcPct val="130000"/>
-              </a:lnSpc>
-              <a:buNone/>
-            </a:pPr>
-            <a:r>
-              <a:rPr lang="en-US" sz="1000" dirty="0">
-                <a:solidFill>
-                  <a:srgbClr val="E8A33D"/>
-                </a:solidFill>
-                <a:latin typeface="Arial" pitchFamily="34" charset="0"/>
-                <a:ea typeface="Arial" pitchFamily="34" charset="-122"/>
-                <a:cs typeface="Arial" pitchFamily="34" charset="-120"/>
-              </a:rPr>
-              <a:t>● </a:t>
-            </a:r>
-            <a:pPr algn="l" indent="0" marL="0">
-              <a:lnSpc>
-                <a:spcPct val="130000"/>
-              </a:lnSpc>
-              <a:buNone/>
-            </a:pPr>
-            <a:r>
-              <a:rPr lang="en-US" sz="1000" dirty="0">
-                <a:solidFill>
-                  <a:srgbClr val="4A5568"/>
-                </a:solidFill>
-                <a:latin typeface="Arial" pitchFamily="34" charset="0"/>
-                <a:ea typeface="Arial" pitchFamily="34" charset="-122"/>
-                <a:cs typeface="Arial" pitchFamily="34" charset="-120"/>
-              </a:rPr>
-              <a:t>config knob — 면적 예산 안에서 AI가 선택:</a:t>
-            </a:r>
-            <a:endParaRPr lang="en-US" sz="1000" dirty="0"/>
-          </a:p>
-          <a:p>
-            <a:pPr algn="l" indent="0" marL="0">
-              <a:lnSpc>
-                <a:spcPct val="130000"/>
-              </a:lnSpc>
-              <a:buNone/>
-            </a:pPr>
-            <a:r>
-              <a:rPr lang="en-US" sz="1000" dirty="0">
-                <a:solidFill>
-                  <a:srgbClr val="4A5568"/>
-                </a:solidFill>
-                <a:latin typeface="Arial" pitchFamily="34" charset="0"/>
-                <a:ea typeface="Arial" pitchFamily="34" charset="-122"/>
-                <a:cs typeface="Arial" pitchFamily="34" charset="-120"/>
-              </a:rPr>
-              <a:t>TCM 크기 · SRAM 뱅크 수 · I-Cache · Flash WS/prefetch · DMA burst · MAC 유무</a:t>
-            </a:r>
-            <a:endParaRPr lang="en-US" sz="1000" dirty="0"/>
-          </a:p>
-          <a:p>
-            <a:pPr algn="l" indent="0" marL="0">
-              <a:lnSpc>
-                <a:spcPct val="130000"/>
-              </a:lnSpc>
-              <a:buNone/>
-            </a:pPr>
-            <a:r>
-              <a:rPr lang="en-US" sz="1000" dirty="0">
-                <a:solidFill>
-                  <a:srgbClr val="B8791F"/>
-                </a:solidFill>
-                <a:latin typeface="Arial" pitchFamily="34" charset="0"/>
-                <a:ea typeface="Arial" pitchFamily="34" charset="-122"/>
-                <a:cs typeface="Arial" pitchFamily="34" charset="-120"/>
-              </a:rPr>
-              <a:t>- - </a:t>
-            </a:r>
-            <a:pPr algn="l" indent="0" marL="0">
-              <a:lnSpc>
-                <a:spcPct val="130000"/>
-              </a:lnSpc>
-              <a:buNone/>
-            </a:pPr>
-            <a:r>
-              <a:rPr lang="en-US" sz="1000" dirty="0">
-                <a:solidFill>
-                  <a:srgbClr val="4A5568"/>
-                </a:solidFill>
-                <a:latin typeface="Arial" pitchFamily="34" charset="0"/>
-                <a:ea typeface="Arial" pitchFamily="34" charset="-122"/>
-                <a:cs typeface="Arial" pitchFamily="34" charset="-120"/>
-              </a:rPr>
-              <a:t>점선 = 예산에 따라 있거나 없는 블록 · 바탕 구조는 공통</a:t>
-            </a:r>
-            <a:endParaRPr lang="en-US" sz="1000" dirty="0"/>
-          </a:p>
-        </p:txBody>
-      </p:sp>
-      <p:sp>
-        <p:nvSpPr>
-          <p:cNvPr id="59" name="Shape 56"/>
+              <a:t>config knob — 크기·개수·burst·WS를 AI가 예산 안에서 선택</a:t>
+            </a:r>
+            <a:endParaRPr lang="en-US" sz="1050" dirty="0"/>
+          </a:p>
+        </p:txBody>
+      </p:sp>
+      <p:sp>
+        <p:nvSpPr>
+          <p:cNvPr id="52" name="Shape 49"/>
           <p:cNvSpPr/>
           <p:nvPr/>
         </p:nvSpPr>
@@ -22877,7 +22577,7 @@
       </p:sp>
       <p:sp>
         <p:nvSpPr>
-          <p:cNvPr id="60" name="Text 57"/>
+          <p:cNvPr id="53" name="Text 50"/>
           <p:cNvSpPr txBox="1"/>
           <p:nvPr/>
         </p:nvSpPr>
@@ -22916,7 +22616,7 @@
       </p:sp>
       <p:sp>
         <p:nvSpPr>
-          <p:cNvPr id="61" name="Shape 58"/>
+          <p:cNvPr id="54" name="Shape 51"/>
           <p:cNvSpPr/>
           <p:nvPr/>
         </p:nvSpPr>
@@ -22939,7 +22639,7 @@
       </p:sp>
       <p:sp>
         <p:nvSpPr>
-          <p:cNvPr id="62" name="Shape 59"/>
+          <p:cNvPr id="55" name="Shape 52"/>
           <p:cNvSpPr/>
           <p:nvPr/>
         </p:nvSpPr>
@@ -22962,7 +22662,7 @@
       </p:sp>
       <p:sp>
         <p:nvSpPr>
-          <p:cNvPr id="63" name="Shape 60"/>
+          <p:cNvPr id="56" name="Shape 53"/>
           <p:cNvSpPr/>
           <p:nvPr/>
         </p:nvSpPr>
@@ -22985,7 +22685,7 @@
       </p:sp>
       <p:sp>
         <p:nvSpPr>
-          <p:cNvPr id="64" name="Shape 61"/>
+          <p:cNvPr id="57" name="Shape 54"/>
           <p:cNvSpPr/>
           <p:nvPr/>
         </p:nvSpPr>
@@ -23008,7 +22708,7 @@
       </p:sp>
       <p:sp>
         <p:nvSpPr>
-          <p:cNvPr id="65" name="Shape 62"/>
+          <p:cNvPr id="58" name="Shape 55"/>
           <p:cNvSpPr/>
           <p:nvPr/>
         </p:nvSpPr>
@@ -23031,7 +22731,7 @@
       </p:sp>
       <p:sp>
         <p:nvSpPr>
-          <p:cNvPr id="66" name="Shape 63"/>
+          <p:cNvPr id="59" name="Shape 56"/>
           <p:cNvSpPr/>
           <p:nvPr/>
         </p:nvSpPr>
@@ -23054,7 +22754,7 @@
       </p:sp>
       <p:sp>
         <p:nvSpPr>
-          <p:cNvPr id="67" name="Shape 64"/>
+          <p:cNvPr id="60" name="Shape 57"/>
           <p:cNvSpPr/>
           <p:nvPr/>
         </p:nvSpPr>
@@ -23077,7 +22777,7 @@
       </p:sp>
       <p:sp>
         <p:nvSpPr>
-          <p:cNvPr id="68" name="Shape 65"/>
+          <p:cNvPr id="61" name="Shape 58"/>
           <p:cNvSpPr/>
           <p:nvPr/>
         </p:nvSpPr>
@@ -23100,7 +22800,7 @@
       </p:sp>
       <p:sp>
         <p:nvSpPr>
-          <p:cNvPr id="69" name="Shape 66"/>
+          <p:cNvPr id="62" name="Shape 59"/>
           <p:cNvSpPr/>
           <p:nvPr/>
         </p:nvSpPr>
@@ -23123,7 +22823,7 @@
       </p:sp>
       <p:sp>
         <p:nvSpPr>
-          <p:cNvPr id="70" name="Shape 67"/>
+          <p:cNvPr id="63" name="Shape 60"/>
           <p:cNvSpPr/>
           <p:nvPr/>
         </p:nvSpPr>
@@ -23146,7 +22846,7 @@
       </p:sp>
       <p:sp>
         <p:nvSpPr>
-          <p:cNvPr id="71" name="Shape 68"/>
+          <p:cNvPr id="64" name="Shape 61"/>
           <p:cNvSpPr/>
           <p:nvPr/>
         </p:nvSpPr>
@@ -23169,7 +22869,7 @@
       </p:sp>
       <p:sp>
         <p:nvSpPr>
-          <p:cNvPr id="72" name="Shape 69"/>
+          <p:cNvPr id="65" name="Shape 62"/>
           <p:cNvSpPr/>
           <p:nvPr/>
         </p:nvSpPr>
@@ -23192,7 +22892,7 @@
       </p:sp>
       <p:sp>
         <p:nvSpPr>
-          <p:cNvPr id="73" name="Shape 70"/>
+          <p:cNvPr id="66" name="Shape 63"/>
           <p:cNvSpPr/>
           <p:nvPr/>
         </p:nvSpPr>
@@ -23215,7 +22915,7 @@
       </p:sp>
       <p:sp>
         <p:nvSpPr>
-          <p:cNvPr id="74" name="Shape 71"/>
+          <p:cNvPr id="67" name="Shape 64"/>
           <p:cNvSpPr/>
           <p:nvPr/>
         </p:nvSpPr>
@@ -23238,7 +22938,7 @@
       </p:sp>
       <p:sp>
         <p:nvSpPr>
-          <p:cNvPr id="75" name="Shape 72"/>
+          <p:cNvPr id="68" name="Shape 65"/>
           <p:cNvSpPr/>
           <p:nvPr/>
         </p:nvSpPr>
@@ -23261,7 +22961,7 @@
       </p:sp>
       <p:sp>
         <p:nvSpPr>
-          <p:cNvPr id="76" name="Shape 73"/>
+          <p:cNvPr id="69" name="Shape 66"/>
           <p:cNvSpPr/>
           <p:nvPr/>
         </p:nvSpPr>
@@ -23284,7 +22984,7 @@
       </p:sp>
       <p:sp>
         <p:nvSpPr>
-          <p:cNvPr id="77" name="Shape 74"/>
+          <p:cNvPr id="70" name="Shape 67"/>
           <p:cNvSpPr/>
           <p:nvPr/>
         </p:nvSpPr>
@@ -23307,7 +23007,7 @@
       </p:sp>
       <p:sp>
         <p:nvSpPr>
-          <p:cNvPr id="78" name="Shape 75"/>
+          <p:cNvPr id="71" name="Shape 68"/>
           <p:cNvSpPr/>
           <p:nvPr/>
         </p:nvSpPr>
@@ -23330,7 +23030,7 @@
       </p:sp>
       <p:sp>
         <p:nvSpPr>
-          <p:cNvPr id="79" name="Shape 76"/>
+          <p:cNvPr id="72" name="Shape 69"/>
           <p:cNvSpPr/>
           <p:nvPr/>
         </p:nvSpPr>
@@ -23353,7 +23053,7 @@
       </p:sp>
       <p:sp>
         <p:nvSpPr>
-          <p:cNvPr id="80" name="Shape 77"/>
+          <p:cNvPr id="73" name="Shape 70"/>
           <p:cNvSpPr/>
           <p:nvPr/>
         </p:nvSpPr>
@@ -23376,7 +23076,7 @@
       </p:sp>
       <p:sp>
         <p:nvSpPr>
-          <p:cNvPr id="81" name="Shape 78"/>
+          <p:cNvPr id="74" name="Shape 71"/>
           <p:cNvSpPr/>
           <p:nvPr/>
         </p:nvSpPr>
@@ -23399,7 +23099,7 @@
       </p:sp>
       <p:sp>
         <p:nvSpPr>
-          <p:cNvPr id="82" name="Shape 79"/>
+          <p:cNvPr id="75" name="Shape 72"/>
           <p:cNvSpPr/>
           <p:nvPr/>
         </p:nvSpPr>
@@ -23422,7 +23122,7 @@
       </p:sp>
       <p:sp>
         <p:nvSpPr>
-          <p:cNvPr id="83" name="Shape 80"/>
+          <p:cNvPr id="76" name="Shape 73"/>
           <p:cNvSpPr/>
           <p:nvPr/>
         </p:nvSpPr>
@@ -23445,7 +23145,7 @@
       </p:sp>
       <p:sp>
         <p:nvSpPr>
-          <p:cNvPr id="84" name="Shape 81"/>
+          <p:cNvPr id="77" name="Shape 74"/>
           <p:cNvSpPr/>
           <p:nvPr/>
         </p:nvSpPr>
@@ -23468,7 +23168,7 @@
       </p:sp>
       <p:sp>
         <p:nvSpPr>
-          <p:cNvPr id="85" name="Shape 82"/>
+          <p:cNvPr id="78" name="Shape 75"/>
           <p:cNvSpPr/>
           <p:nvPr/>
         </p:nvSpPr>
@@ -23491,7 +23191,7 @@
       </p:sp>
       <p:sp>
         <p:nvSpPr>
-          <p:cNvPr id="86" name="Shape 83"/>
+          <p:cNvPr id="79" name="Shape 76"/>
           <p:cNvSpPr/>
           <p:nvPr/>
         </p:nvSpPr>
@@ -23514,7 +23214,7 @@
       </p:sp>
       <p:sp>
         <p:nvSpPr>
-          <p:cNvPr id="87" name="Shape 84"/>
+          <p:cNvPr id="80" name="Shape 77"/>
           <p:cNvSpPr/>
           <p:nvPr/>
         </p:nvSpPr>
@@ -23537,7 +23237,7 @@
       </p:sp>
       <p:sp>
         <p:nvSpPr>
-          <p:cNvPr id="88" name="Shape 85"/>
+          <p:cNvPr id="81" name="Shape 78"/>
           <p:cNvSpPr/>
           <p:nvPr/>
         </p:nvSpPr>
@@ -23560,7 +23260,7 @@
       </p:sp>
       <p:sp>
         <p:nvSpPr>
-          <p:cNvPr id="89" name="Shape 86"/>
+          <p:cNvPr id="82" name="Shape 79"/>
           <p:cNvSpPr/>
           <p:nvPr/>
         </p:nvSpPr>
@@ -23583,7 +23283,7 @@
       </p:sp>
       <p:sp>
         <p:nvSpPr>
-          <p:cNvPr id="90" name="Shape 87"/>
+          <p:cNvPr id="83" name="Shape 80"/>
           <p:cNvSpPr/>
           <p:nvPr/>
         </p:nvSpPr>
@@ -23606,7 +23306,7 @@
       </p:sp>
       <p:sp>
         <p:nvSpPr>
-          <p:cNvPr id="91" name="Shape 88"/>
+          <p:cNvPr id="84" name="Shape 81"/>
           <p:cNvSpPr/>
           <p:nvPr/>
         </p:nvSpPr>
@@ -23629,7 +23329,7 @@
       </p:sp>
       <p:sp>
         <p:nvSpPr>
-          <p:cNvPr id="92" name="Shape 89"/>
+          <p:cNvPr id="85" name="Shape 82"/>
           <p:cNvSpPr/>
           <p:nvPr/>
         </p:nvSpPr>
@@ -23652,7 +23352,7 @@
       </p:sp>
       <p:sp>
         <p:nvSpPr>
-          <p:cNvPr id="93" name="Shape 90"/>
+          <p:cNvPr id="86" name="Shape 83"/>
           <p:cNvSpPr/>
           <p:nvPr/>
         </p:nvSpPr>
@@ -23675,7 +23375,7 @@
       </p:sp>
       <p:sp>
         <p:nvSpPr>
-          <p:cNvPr id="94" name="Shape 91"/>
+          <p:cNvPr id="87" name="Shape 84"/>
           <p:cNvSpPr/>
           <p:nvPr/>
         </p:nvSpPr>
@@ -23698,7 +23398,7 @@
       </p:sp>
       <p:sp>
         <p:nvSpPr>
-          <p:cNvPr id="95" name="Shape 92"/>
+          <p:cNvPr id="88" name="Shape 85"/>
           <p:cNvSpPr/>
           <p:nvPr/>
         </p:nvSpPr>
@@ -23721,7 +23421,7 @@
       </p:sp>
       <p:sp>
         <p:nvSpPr>
-          <p:cNvPr id="96" name="Shape 93"/>
+          <p:cNvPr id="89" name="Shape 86"/>
           <p:cNvSpPr/>
           <p:nvPr/>
         </p:nvSpPr>
@@ -23744,7 +23444,7 @@
       </p:sp>
       <p:sp>
         <p:nvSpPr>
-          <p:cNvPr id="97" name="Shape 94"/>
+          <p:cNvPr id="90" name="Shape 87"/>
           <p:cNvSpPr/>
           <p:nvPr/>
         </p:nvSpPr>
@@ -23767,7 +23467,7 @@
       </p:sp>
       <p:sp>
         <p:nvSpPr>
-          <p:cNvPr id="98" name="Shape 95"/>
+          <p:cNvPr id="91" name="Shape 88"/>
           <p:cNvSpPr/>
           <p:nvPr/>
         </p:nvSpPr>
@@ -23790,7 +23490,7 @@
       </p:sp>
       <p:sp>
         <p:nvSpPr>
-          <p:cNvPr id="99" name="Shape 96"/>
+          <p:cNvPr id="92" name="Shape 89"/>
           <p:cNvSpPr/>
           <p:nvPr/>
         </p:nvSpPr>
@@ -23813,7 +23513,7 @@
       </p:sp>
       <p:sp>
         <p:nvSpPr>
-          <p:cNvPr id="100" name="Shape 97"/>
+          <p:cNvPr id="93" name="Shape 90"/>
           <p:cNvSpPr/>
           <p:nvPr/>
         </p:nvSpPr>
@@ -23836,7 +23536,7 @@
       </p:sp>
       <p:sp>
         <p:nvSpPr>
-          <p:cNvPr id="101" name="Shape 98"/>
+          <p:cNvPr id="94" name="Shape 91"/>
           <p:cNvSpPr/>
           <p:nvPr/>
         </p:nvSpPr>
@@ -23859,7 +23559,7 @@
       </p:sp>
       <p:sp>
         <p:nvSpPr>
-          <p:cNvPr id="102" name="Shape 99"/>
+          <p:cNvPr id="95" name="Shape 92"/>
           <p:cNvSpPr/>
           <p:nvPr/>
         </p:nvSpPr>
@@ -23882,7 +23582,7 @@
       </p:sp>
       <p:sp>
         <p:nvSpPr>
-          <p:cNvPr id="103" name="Shape 100"/>
+          <p:cNvPr id="96" name="Shape 93"/>
           <p:cNvSpPr/>
           <p:nvPr/>
         </p:nvSpPr>
@@ -23905,7 +23605,7 @@
       </p:sp>
       <p:sp>
         <p:nvSpPr>
-          <p:cNvPr id="104" name="Shape 101"/>
+          <p:cNvPr id="97" name="Shape 94"/>
           <p:cNvSpPr/>
           <p:nvPr/>
         </p:nvSpPr>
@@ -23928,7 +23628,7 @@
       </p:sp>
       <p:sp>
         <p:nvSpPr>
-          <p:cNvPr id="105" name="Shape 102"/>
+          <p:cNvPr id="98" name="Shape 95"/>
           <p:cNvSpPr/>
           <p:nvPr/>
         </p:nvSpPr>
@@ -23955,7 +23655,7 @@
       </p:sp>
       <p:sp>
         <p:nvSpPr>
-          <p:cNvPr id="106" name="Text 103"/>
+          <p:cNvPr id="99" name="Text 96"/>
           <p:cNvSpPr txBox="1"/>
           <p:nvPr/>
         </p:nvSpPr>
@@ -24017,7 +23717,7 @@
       </p:sp>
       <p:sp>
         <p:nvSpPr>
-          <p:cNvPr id="107" name="Shape 104"/>
+          <p:cNvPr id="100" name="Shape 97"/>
           <p:cNvSpPr/>
           <p:nvPr/>
         </p:nvSpPr>
@@ -24037,7 +23737,7 @@
       </p:sp>
       <p:sp>
         <p:nvSpPr>
-          <p:cNvPr id="108" name="Shape 105"/>
+          <p:cNvPr id="101" name="Shape 98"/>
           <p:cNvSpPr/>
           <p:nvPr/>
         </p:nvSpPr>
@@ -24064,7 +23764,7 @@
       </p:sp>
       <p:sp>
         <p:nvSpPr>
-          <p:cNvPr id="109" name="Text 106"/>
+          <p:cNvPr id="102" name="Text 99"/>
           <p:cNvSpPr txBox="1"/>
           <p:nvPr/>
         </p:nvSpPr>
@@ -24126,7 +23826,7 @@
       </p:sp>
       <p:sp>
         <p:nvSpPr>
-          <p:cNvPr id="110" name="Shape 107"/>
+          <p:cNvPr id="103" name="Shape 100"/>
           <p:cNvSpPr/>
           <p:nvPr/>
         </p:nvSpPr>
@@ -24146,7 +23846,7 @@
       </p:sp>
       <p:sp>
         <p:nvSpPr>
-          <p:cNvPr id="111" name="Shape 108"/>
+          <p:cNvPr id="104" name="Shape 101"/>
           <p:cNvSpPr/>
           <p:nvPr/>
         </p:nvSpPr>
@@ -24173,7 +23873,7 @@
       </p:sp>
       <p:sp>
         <p:nvSpPr>
-          <p:cNvPr id="112" name="Text 109"/>
+          <p:cNvPr id="105" name="Text 102"/>
           <p:cNvSpPr txBox="1"/>
           <p:nvPr/>
         </p:nvSpPr>
@@ -24235,7 +23935,7 @@
       </p:sp>
       <p:sp>
         <p:nvSpPr>
-          <p:cNvPr id="113" name="Shape 110"/>
+          <p:cNvPr id="106" name="Shape 103"/>
           <p:cNvSpPr/>
           <p:nvPr/>
         </p:nvSpPr>
@@ -24259,7 +23959,7 @@
       </p:sp>
       <p:sp>
         <p:nvSpPr>
-          <p:cNvPr id="114" name="Shape 111"/>
+          <p:cNvPr id="107" name="Shape 104"/>
           <p:cNvSpPr/>
           <p:nvPr/>
         </p:nvSpPr>
@@ -24281,7 +23981,7 @@
       </p:sp>
       <p:sp>
         <p:nvSpPr>
-          <p:cNvPr id="115" name="Text 112"/>
+          <p:cNvPr id="108" name="Text 105"/>
           <p:cNvSpPr txBox="1"/>
           <p:nvPr/>
         </p:nvSpPr>
@@ -24320,7 +24020,7 @@
       </p:sp>
       <p:sp>
         <p:nvSpPr>
-          <p:cNvPr id="116" name="Shape 113"/>
+          <p:cNvPr id="109" name="Shape 106"/>
           <p:cNvSpPr/>
           <p:nvPr/>
         </p:nvSpPr>
@@ -24342,7 +24042,7 @@
       </p:sp>
       <p:sp>
         <p:nvSpPr>
-          <p:cNvPr id="117" name="Text 114"/>
+          <p:cNvPr id="110" name="Text 107"/>
           <p:cNvSpPr txBox="1"/>
           <p:nvPr/>
         </p:nvSpPr>
@@ -24381,7 +24081,7 @@
       </p:sp>
       <p:sp>
         <p:nvSpPr>
-          <p:cNvPr id="118" name="Text 115"/>
+          <p:cNvPr id="111" name="Text 108"/>
           <p:cNvSpPr txBox="1"/>
           <p:nvPr/>
         </p:nvSpPr>
@@ -24420,7 +24120,7 @@
       </p:sp>
       <p:sp>
         <p:nvSpPr>
-          <p:cNvPr id="119" name="Text 116"/>
+          <p:cNvPr id="112" name="Text 109"/>
           <p:cNvSpPr txBox="1"/>
           <p:nvPr/>
         </p:nvSpPr>
@@ -24459,7 +24159,7 @@
       </p:sp>
       <p:sp>
         <p:nvSpPr>
-          <p:cNvPr id="120" name="Shape 117"/>
+          <p:cNvPr id="113" name="Shape 110"/>
           <p:cNvSpPr/>
           <p:nvPr/>
         </p:nvSpPr>
@@ -24486,7 +24186,7 @@
       </p:sp>
       <p:sp>
         <p:nvSpPr>
-          <p:cNvPr id="121" name="Shape 118"/>
+          <p:cNvPr id="114" name="Shape 111"/>
           <p:cNvSpPr/>
           <p:nvPr/>
         </p:nvSpPr>
@@ -24506,7 +24206,7 @@
       </p:sp>
       <p:sp>
         <p:nvSpPr>
-          <p:cNvPr id="122" name="Text 119"/>
+          <p:cNvPr id="115" name="Text 112"/>
           <p:cNvSpPr txBox="1"/>
           <p:nvPr/>
         </p:nvSpPr>
@@ -24559,7 +24259,7 @@
       </p:sp>
       <p:sp>
         <p:nvSpPr>
-          <p:cNvPr id="123" name="Shape 120"/>
+          <p:cNvPr id="116" name="Shape 113"/>
           <p:cNvSpPr/>
           <p:nvPr/>
         </p:nvSpPr>
@@ -24586,7 +24286,7 @@
       </p:sp>
       <p:sp>
         <p:nvSpPr>
-          <p:cNvPr id="124" name="Shape 121"/>
+          <p:cNvPr id="117" name="Shape 114"/>
           <p:cNvSpPr/>
           <p:nvPr/>
         </p:nvSpPr>
@@ -24606,7 +24306,7 @@
       </p:sp>
       <p:sp>
         <p:nvSpPr>
-          <p:cNvPr id="125" name="Text 122"/>
+          <p:cNvPr id="118" name="Text 115"/>
           <p:cNvSpPr txBox="1"/>
           <p:nvPr/>
         </p:nvSpPr>
@@ -24659,7 +24359,7 @@
       </p:sp>
       <p:sp>
         <p:nvSpPr>
-          <p:cNvPr id="126" name="Shape 123"/>
+          <p:cNvPr id="119" name="Shape 116"/>
           <p:cNvSpPr/>
           <p:nvPr/>
         </p:nvSpPr>
@@ -24686,7 +24386,7 @@
       </p:sp>
       <p:sp>
         <p:nvSpPr>
-          <p:cNvPr id="127" name="Shape 124"/>
+          <p:cNvPr id="120" name="Shape 117"/>
           <p:cNvSpPr/>
           <p:nvPr/>
         </p:nvSpPr>
@@ -24706,7 +24406,7 @@
       </p:sp>
       <p:sp>
         <p:nvSpPr>
-          <p:cNvPr id="128" name="Text 125"/>
+          <p:cNvPr id="121" name="Text 118"/>
           <p:cNvSpPr txBox="1"/>
           <p:nvPr/>
         </p:nvSpPr>

</xml_diff>

<commit_message>
Presentation: platform slide — existing assets vs newly modeled (MAC, PoC peripherals, analysis outputs)
Co-Authored-By: Claude Fable 5.1 <noreply@anthropic.com>
Claude-Session: https://claude.ai/code/session_01Gd73gUzQvBcmrEGA3YWYHu
</commit_message>
<xml_diff>
--- a/docs/presentation/deck_basic_fonts.pptx
+++ b/docs/presentation/deck_basic_fonts.pptx
@@ -1224,7 +1224,7 @@
           <a:p>
             <a:r>
               <a:rPr lang="en-US" dirty="0"/>
-              <a:t>40초. 세 숫자만 말한다. 모델링 범위는 손으로 훑는 정도. gem5/Fast Model 질문: gem5는 Cortex-M 미지원, Fast Model은 LT라 cycle 분석 불가.</a:t>
+              <a:t>40초. 세 숫자만 말한다. 아래는 '코어·메모리·버스는 기존 자산, 이번에 더한 것은 MAC 가속기·PoC 주변장치·분석 출력'을 한 문장으로. gem5/Fast Model 질문: gem5는 Cortex-M 미지원, Fast Model은 LT라 cycle 분석 불가.</a:t>
             </a:r>
             <a:endParaRPr lang="en-US" dirty="0"/>
           </a:p>
@@ -15805,14 +15805,41 @@
       </p:sp>
       <p:sp>
         <p:nvSpPr>
-          <p:cNvPr id="18" name="Text 15"/>
+          <p:cNvPr id="18" name="Shape 15"/>
+          <p:cNvSpPr/>
+          <p:nvPr/>
+        </p:nvSpPr>
+        <p:spPr>
+          <a:xfrm>
+            <a:off x="508406" y="4063594"/>
+            <a:ext cx="2667305" cy="1904695"/>
+          </a:xfrm>
+          <a:prstGeom prst="roundRect">
+            <a:avLst>
+              <a:gd name="adj" fmla="val 4657"/>
+            </a:avLst>
+          </a:prstGeom>
+          <a:solidFill>
+            <a:srgbClr val="FFFFFF"/>
+          </a:solidFill>
+          <a:ln w="12700">
+            <a:solidFill>
+              <a:srgbClr val="D9DEE6"/>
+            </a:solidFill>
+            <a:prstDash val="solid"/>
+          </a:ln>
+        </p:spPr>
+      </p:sp>
+      <p:sp>
+        <p:nvSpPr>
+          <p:cNvPr id="19" name="Text 16"/>
           <p:cNvSpPr txBox="1"/>
           <p:nvPr/>
         </p:nvSpPr>
         <p:spPr>
           <a:xfrm>
-            <a:off x="508406" y="4000500"/>
-            <a:ext cx="3810305" cy="254203"/>
+            <a:off x="698602" y="4241902"/>
+            <a:ext cx="2286000" cy="202997"/>
           </a:xfrm>
           <a:prstGeom prst="rect">
             <a:avLst/>
@@ -15828,7 +15855,49 @@
               <a:buNone/>
             </a:pPr>
             <a:r>
-              <a:rPr lang="en-US" sz="1500" b="1" dirty="0">
+              <a:rPr lang="en-US" sz="1200" b="1" dirty="0">
+                <a:solidFill>
+                  <a:srgbClr val="6B7280"/>
+                </a:solidFill>
+                <a:latin typeface="Arial" pitchFamily="34" charset="0"/>
+                <a:ea typeface="Arial" pitchFamily="34" charset="-122"/>
+                <a:cs typeface="Arial" pitchFamily="34" charset="-120"/>
+              </a:rPr>
+              <a:t>기존 자산 · 그대로 사용</a:t>
+            </a:r>
+            <a:endParaRPr lang="en-US" sz="1200" dirty="0"/>
+          </a:p>
+        </p:txBody>
+      </p:sp>
+      <p:sp>
+        <p:nvSpPr>
+          <p:cNvPr id="20" name="Text 17"/>
+          <p:cNvSpPr txBox="1"/>
+          <p:nvPr/>
+        </p:nvSpPr>
+        <p:spPr>
+          <a:xfrm>
+            <a:off x="698602" y="4520794"/>
+            <a:ext cx="2349094" cy="825703"/>
+          </a:xfrm>
+          <a:prstGeom prst="rect">
+            <a:avLst/>
+          </a:prstGeom>
+          <a:noFill/>
+          <a:ln/>
+        </p:spPr>
+        <p:txBody>
+          <a:bodyPr wrap="square" lIns="0" tIns="0" rIns="0" bIns="0" rtlCol="0" anchor="t"/>
+          <a:lstStyle/>
+          <a:p>
+            <a:pPr algn="l" indent="0" marL="0">
+              <a:lnSpc>
+                <a:spcPct val="150000"/>
+              </a:lnSpc>
+              <a:buNone/>
+            </a:pPr>
+            <a:r>
+              <a:rPr lang="en-US" sz="1250" dirty="0">
                 <a:solidFill>
                   <a:srgbClr val="4A5568"/>
                 </a:solidFill>
@@ -15836,22 +15905,101 @@
                 <a:ea typeface="Arial" pitchFamily="34" charset="-122"/>
                 <a:cs typeface="Arial" pitchFamily="34" charset="-120"/>
               </a:rPr>
-              <a:t>모델링 범위</a:t>
-            </a:r>
-            <a:endParaRPr lang="en-US" sz="1500" dirty="0"/>
-          </a:p>
-        </p:txBody>
-      </p:sp>
-      <p:sp>
-        <p:nvSpPr>
-          <p:cNvPr id="19" name="Shape 16"/>
-          <p:cNvSpPr/>
-          <p:nvPr/>
-        </p:nvSpPr>
-        <p:spPr>
-          <a:xfrm>
-            <a:off x="508406" y="4381805"/>
-            <a:ext cx="2679192" cy="1587398"/>
+              <a:t>CM4 코어 (NVIC·FPU)</a:t>
+            </a:r>
+            <a:endParaRPr lang="en-US" sz="1250" dirty="0"/>
+          </a:p>
+          <a:p>
+            <a:pPr algn="l" indent="0" marL="0">
+              <a:lnSpc>
+                <a:spcPct val="150000"/>
+              </a:lnSpc>
+              <a:buNone/>
+            </a:pPr>
+            <a:r>
+              <a:rPr lang="en-US" sz="1250" dirty="0">
+                <a:solidFill>
+                  <a:srgbClr val="4A5568"/>
+                </a:solidFill>
+                <a:latin typeface="Arial" pitchFamily="34" charset="0"/>
+                <a:ea typeface="Arial" pitchFamily="34" charset="-122"/>
+                <a:cs typeface="Arial" pitchFamily="34" charset="-120"/>
+              </a:rPr>
+              <a:t>TCM · SRAM · Flash · I-Cache</a:t>
+            </a:r>
+            <a:endParaRPr lang="en-US" sz="1250" dirty="0"/>
+          </a:p>
+          <a:p>
+            <a:pPr algn="l" indent="0" marL="0">
+              <a:lnSpc>
+                <a:spcPct val="150000"/>
+              </a:lnSpc>
+              <a:buNone/>
+            </a:pPr>
+            <a:r>
+              <a:rPr lang="en-US" sz="1250" dirty="0">
+                <a:solidFill>
+                  <a:srgbClr val="4A5568"/>
+                </a:solidFill>
+                <a:latin typeface="Arial" pitchFamily="34" charset="0"/>
+                <a:ea typeface="Arial" pitchFamily="34" charset="-122"/>
+                <a:cs typeface="Arial" pitchFamily="34" charset="-120"/>
+              </a:rPr>
+              <a:t>AHB 매트릭스 · DMA · Timer</a:t>
+            </a:r>
+            <a:endParaRPr lang="en-US" sz="1250" dirty="0"/>
+          </a:p>
+        </p:txBody>
+      </p:sp>
+      <p:sp>
+        <p:nvSpPr>
+          <p:cNvPr id="21" name="Text 18"/>
+          <p:cNvSpPr txBox="1"/>
+          <p:nvPr/>
+        </p:nvSpPr>
+        <p:spPr>
+          <a:xfrm>
+            <a:off x="3353105" y="4063594"/>
+            <a:ext cx="5079492" cy="228600"/>
+          </a:xfrm>
+          <a:prstGeom prst="rect">
+            <a:avLst/>
+          </a:prstGeom>
+          <a:noFill/>
+          <a:ln/>
+        </p:spPr>
+        <p:txBody>
+          <a:bodyPr wrap="square" lIns="0" tIns="0" rIns="0" bIns="0" rtlCol="0" anchor="t"/>
+          <a:lstStyle/>
+          <a:p>
+            <a:pPr algn="l" indent="0" marL="0">
+              <a:buNone/>
+            </a:pPr>
+            <a:r>
+              <a:rPr lang="en-US" sz="1400" b="1" dirty="0">
+                <a:solidFill>
+                  <a:srgbClr val="B8791F"/>
+                </a:solidFill>
+                <a:latin typeface="Arial" pitchFamily="34" charset="0"/>
+                <a:ea typeface="Arial" pitchFamily="34" charset="-122"/>
+                <a:cs typeface="Arial" pitchFamily="34" charset="-120"/>
+              </a:rPr>
+              <a:t>이번 과제에서 추가 모델링</a:t>
+            </a:r>
+            <a:endParaRPr lang="en-US" sz="1400" dirty="0"/>
+          </a:p>
+        </p:txBody>
+      </p:sp>
+      <p:sp>
+        <p:nvSpPr>
+          <p:cNvPr id="22" name="Shape 19"/>
+          <p:cNvSpPr/>
+          <p:nvPr/>
+        </p:nvSpPr>
+        <p:spPr>
+          <a:xfrm>
+            <a:off x="3353105" y="4381805"/>
+            <a:ext cx="2691994" cy="1587398"/>
           </a:xfrm>
           <a:prstGeom prst="roundRect">
             <a:avLst>
@@ -15871,34 +16019,34 @@
       </p:sp>
       <p:sp>
         <p:nvSpPr>
-          <p:cNvPr id="20" name="Shape 17"/>
-          <p:cNvSpPr/>
-          <p:nvPr/>
-        </p:nvSpPr>
-        <p:spPr>
-          <a:xfrm>
-            <a:off x="685800" y="4546397"/>
-            <a:ext cx="254203" cy="254203"/>
-          </a:xfrm>
-          <a:prstGeom prst="ellipse">
+          <p:cNvPr id="23" name="Shape 20"/>
+          <p:cNvSpPr/>
+          <p:nvPr/>
+        </p:nvSpPr>
+        <p:spPr>
+          <a:xfrm>
+            <a:off x="3353105" y="4381805"/>
+            <a:ext cx="2691994" cy="38405"/>
+          </a:xfrm>
+          <a:prstGeom prst="rect">
             <a:avLst/>
           </a:prstGeom>
           <a:solidFill>
-            <a:srgbClr val="B8791F"/>
+            <a:srgbClr val="E8A33D"/>
           </a:solidFill>
           <a:ln/>
         </p:spPr>
       </p:sp>
       <p:sp>
         <p:nvSpPr>
-          <p:cNvPr id="21" name="Text 18"/>
+          <p:cNvPr id="24" name="Text 21"/>
           <p:cNvSpPr txBox="1"/>
           <p:nvPr/>
         </p:nvSpPr>
         <p:spPr>
           <a:xfrm>
-            <a:off x="1028700" y="4533595"/>
-            <a:ext cx="2044598" cy="279806"/>
+            <a:off x="3530498" y="4546397"/>
+            <a:ext cx="2336292" cy="254203"/>
           </a:xfrm>
           <a:prstGeom prst="rect">
             <a:avLst/>
@@ -15914,7 +16062,7 @@
               <a:buNone/>
             </a:pPr>
             <a:r>
-              <a:rPr lang="en-US" sz="1600" b="1" dirty="0">
+              <a:rPr lang="en-US" sz="1500" b="1" dirty="0">
                 <a:solidFill>
                   <a:srgbClr val="0F1B2D"/>
                 </a:solidFill>
@@ -15922,22 +16070,22 @@
                 <a:ea typeface="Arial" pitchFamily="34" charset="-122"/>
                 <a:cs typeface="Arial" pitchFamily="34" charset="-120"/>
               </a:rPr>
-              <a:t>코어</a:t>
-            </a:r>
-            <a:endParaRPr lang="en-US" sz="1600" dirty="0"/>
-          </a:p>
-        </p:txBody>
-      </p:sp>
-      <p:sp>
-        <p:nvSpPr>
-          <p:cNvPr id="22" name="Text 19"/>
+              <a:t>MAC 가속기</a:t>
+            </a:r>
+            <a:endParaRPr lang="en-US" sz="1500" dirty="0"/>
+          </a:p>
+        </p:txBody>
+      </p:sp>
+      <p:sp>
+        <p:nvSpPr>
+          <p:cNvPr id="25" name="Text 22"/>
           <p:cNvSpPr txBox="1"/>
           <p:nvPr/>
         </p:nvSpPr>
         <p:spPr>
           <a:xfrm>
-            <a:off x="685800" y="4927702"/>
-            <a:ext cx="2324405" cy="888797"/>
+            <a:off x="3530498" y="4863694"/>
+            <a:ext cx="2336292" cy="952805"/>
           </a:xfrm>
           <a:prstGeom prst="rect">
             <a:avLst/>
@@ -15951,12 +16099,12 @@
           <a:p>
             <a:pPr algn="l" indent="0" marL="0">
               <a:lnSpc>
-                <a:spcPct val="130000"/>
+                <a:spcPct val="135000"/>
               </a:lnSpc>
               <a:buNone/>
             </a:pPr>
             <a:r>
-              <a:rPr lang="en-US" sz="1250" dirty="0">
+              <a:rPr lang="en-US" sz="1200" dirty="0">
                 <a:solidFill>
                   <a:srgbClr val="4A5568"/>
                 </a:solidFill>
@@ -15964,22 +16112,22 @@
                 <a:ea typeface="Arial" pitchFamily="34" charset="-122"/>
                 <a:cs typeface="Arial" pitchFamily="34" charset="-120"/>
               </a:rPr>
-              <a:t>CM4 3단 인오더 파이프라인, 명령어별 cycle, NVIC, FPU</a:t>
-            </a:r>
-            <a:endParaRPr lang="en-US" sz="1250" dirty="0"/>
-          </a:p>
-        </p:txBody>
-      </p:sp>
-      <p:sp>
-        <p:nvSpPr>
-          <p:cNvPr id="23" name="Shape 20"/>
-          <p:cNvSpPr/>
-          <p:nvPr/>
-        </p:nvSpPr>
-        <p:spPr>
-          <a:xfrm>
-            <a:off x="3340303" y="4381805"/>
-            <a:ext cx="2679192" cy="1587398"/>
+              <a:t>INT8 dot-product 버스 마스터 · 레지스터 맵 · 완료 IRQ · 면적 비용</a:t>
+            </a:r>
+            <a:endParaRPr lang="en-US" sz="1200" dirty="0"/>
+          </a:p>
+        </p:txBody>
+      </p:sp>
+      <p:sp>
+        <p:nvSpPr>
+          <p:cNvPr id="26" name="Shape 23"/>
+          <p:cNvSpPr/>
+          <p:nvPr/>
+        </p:nvSpPr>
+        <p:spPr>
+          <a:xfrm>
+            <a:off x="6172200" y="4381805"/>
+            <a:ext cx="2691994" cy="1587398"/>
           </a:xfrm>
           <a:prstGeom prst="roundRect">
             <a:avLst>
@@ -15999,34 +16147,34 @@
       </p:sp>
       <p:sp>
         <p:nvSpPr>
-          <p:cNvPr id="24" name="Shape 21"/>
-          <p:cNvSpPr/>
-          <p:nvPr/>
-        </p:nvSpPr>
-        <p:spPr>
-          <a:xfrm>
-            <a:off x="3517697" y="4546397"/>
-            <a:ext cx="254203" cy="254203"/>
-          </a:xfrm>
-          <a:prstGeom prst="ellipse">
+          <p:cNvPr id="27" name="Shape 24"/>
+          <p:cNvSpPr/>
+          <p:nvPr/>
+        </p:nvSpPr>
+        <p:spPr>
+          <a:xfrm>
+            <a:off x="6172200" y="4381805"/>
+            <a:ext cx="2691994" cy="38405"/>
+          </a:xfrm>
+          <a:prstGeom prst="rect">
             <a:avLst/>
           </a:prstGeom>
           <a:solidFill>
-            <a:srgbClr val="B8791F"/>
+            <a:srgbClr val="E8A33D"/>
           </a:solidFill>
           <a:ln/>
         </p:spPr>
       </p:sp>
       <p:sp>
         <p:nvSpPr>
-          <p:cNvPr id="25" name="Text 22"/>
+          <p:cNvPr id="28" name="Text 25"/>
           <p:cNvSpPr txBox="1"/>
           <p:nvPr/>
         </p:nvSpPr>
         <p:spPr>
           <a:xfrm>
-            <a:off x="3860597" y="4533595"/>
-            <a:ext cx="2044598" cy="279806"/>
+            <a:off x="6349594" y="4546397"/>
+            <a:ext cx="2336292" cy="254203"/>
           </a:xfrm>
           <a:prstGeom prst="rect">
             <a:avLst/>
@@ -16042,7 +16190,7 @@
               <a:buNone/>
             </a:pPr>
             <a:r>
-              <a:rPr lang="en-US" sz="1600" b="1" dirty="0">
+              <a:rPr lang="en-US" sz="1500" b="1" dirty="0">
                 <a:solidFill>
                   <a:srgbClr val="0F1B2D"/>
                 </a:solidFill>
@@ -16050,22 +16198,22 @@
                 <a:ea typeface="Arial" pitchFamily="34" charset="-122"/>
                 <a:cs typeface="Arial" pitchFamily="34" charset="-120"/>
               </a:rPr>
-              <a:t>메모리</a:t>
-            </a:r>
-            <a:endParaRPr lang="en-US" sz="1600" dirty="0"/>
-          </a:p>
-        </p:txBody>
-      </p:sp>
-      <p:sp>
-        <p:nvSpPr>
-          <p:cNvPr id="26" name="Text 23"/>
+              <a:t>PoC 주변장치</a:t>
+            </a:r>
+            <a:endParaRPr lang="en-US" sz="1500" dirty="0"/>
+          </a:p>
+        </p:txBody>
+      </p:sp>
+      <p:sp>
+        <p:nvSpPr>
+          <p:cNvPr id="29" name="Text 26"/>
           <p:cNvSpPr txBox="1"/>
           <p:nvPr/>
         </p:nvSpPr>
         <p:spPr>
           <a:xfrm>
-            <a:off x="3517697" y="4927702"/>
-            <a:ext cx="2324405" cy="888797"/>
+            <a:off x="6349594" y="4863694"/>
+            <a:ext cx="2336292" cy="952805"/>
           </a:xfrm>
           <a:prstGeom prst="rect">
             <a:avLst/>
@@ -16079,12 +16227,12 @@
           <a:p>
             <a:pPr algn="l" indent="0" marL="0">
               <a:lnSpc>
-                <a:spcPct val="130000"/>
+                <a:spcPct val="135000"/>
               </a:lnSpc>
               <a:buNone/>
             </a:pPr>
             <a:r>
-              <a:rPr lang="en-US" sz="1250" dirty="0">
+              <a:rPr lang="en-US" sz="1200" dirty="0">
                 <a:solidFill>
                   <a:srgbClr val="4A5568"/>
                 </a:solidFill>
@@ -16092,22 +16240,22 @@
                 <a:ea typeface="Arial" pitchFamily="34" charset="-122"/>
                 <a:cs typeface="Arial" pitchFamily="34" charset="-120"/>
               </a:rPr>
-              <a:t>TCM, 독립 SRAM 뱅크, Flash wait state·prefetch, I-Cache</a:t>
-            </a:r>
-            <a:endParaRPr lang="en-US" sz="1250" dirty="0"/>
-          </a:p>
-        </p:txBody>
-      </p:sp>
-      <p:sp>
-        <p:nvSpPr>
-          <p:cNvPr id="27" name="Shape 24"/>
-          <p:cNvSpPr/>
-          <p:nvPr/>
-        </p:nvSpPr>
-        <p:spPr>
-          <a:xfrm>
-            <a:off x="6172200" y="4381805"/>
-            <a:ext cx="2679192" cy="1587398"/>
+              <a:t>오디오 입력(16 kHz → DMA) · 센서/액추에이터 · 결과·마커 출력</a:t>
+            </a:r>
+            <a:endParaRPr lang="en-US" sz="1200" dirty="0"/>
+          </a:p>
+        </p:txBody>
+      </p:sp>
+      <p:sp>
+        <p:nvSpPr>
+          <p:cNvPr id="30" name="Shape 27"/>
+          <p:cNvSpPr/>
+          <p:nvPr/>
+        </p:nvSpPr>
+        <p:spPr>
+          <a:xfrm>
+            <a:off x="8991295" y="4381805"/>
+            <a:ext cx="2691994" cy="1587398"/>
           </a:xfrm>
           <a:prstGeom prst="roundRect">
             <a:avLst>
@@ -16127,34 +16275,34 @@
       </p:sp>
       <p:sp>
         <p:nvSpPr>
-          <p:cNvPr id="28" name="Shape 25"/>
-          <p:cNvSpPr/>
-          <p:nvPr/>
-        </p:nvSpPr>
-        <p:spPr>
-          <a:xfrm>
-            <a:off x="6349594" y="4546397"/>
-            <a:ext cx="254203" cy="254203"/>
-          </a:xfrm>
-          <a:prstGeom prst="ellipse">
+          <p:cNvPr id="31" name="Shape 28"/>
+          <p:cNvSpPr/>
+          <p:nvPr/>
+        </p:nvSpPr>
+        <p:spPr>
+          <a:xfrm>
+            <a:off x="8991295" y="4381805"/>
+            <a:ext cx="2691994" cy="38405"/>
+          </a:xfrm>
+          <a:prstGeom prst="rect">
             <a:avLst/>
           </a:prstGeom>
           <a:solidFill>
-            <a:srgbClr val="B8791F"/>
+            <a:srgbClr val="E8A33D"/>
           </a:solidFill>
           <a:ln/>
         </p:spPr>
       </p:sp>
       <p:sp>
         <p:nvSpPr>
-          <p:cNvPr id="29" name="Text 26"/>
+          <p:cNvPr id="32" name="Text 29"/>
           <p:cNvSpPr txBox="1"/>
           <p:nvPr/>
         </p:nvSpPr>
         <p:spPr>
           <a:xfrm>
-            <a:off x="6692494" y="4533595"/>
-            <a:ext cx="2044598" cy="279806"/>
+            <a:off x="9169603" y="4546397"/>
+            <a:ext cx="2336292" cy="254203"/>
           </a:xfrm>
           <a:prstGeom prst="rect">
             <a:avLst/>
@@ -16170,7 +16318,7 @@
               <a:buNone/>
             </a:pPr>
             <a:r>
-              <a:rPr lang="en-US" sz="1600" b="1" dirty="0">
+              <a:rPr lang="en-US" sz="1500" b="1" dirty="0">
                 <a:solidFill>
                   <a:srgbClr val="0F1B2D"/>
                 </a:solidFill>
@@ -16178,22 +16326,22 @@
                 <a:ea typeface="Arial" pitchFamily="34" charset="-122"/>
                 <a:cs typeface="Arial" pitchFamily="34" charset="-120"/>
               </a:rPr>
-              <a:t>버스</a:t>
-            </a:r>
-            <a:endParaRPr lang="en-US" sz="1600" dirty="0"/>
-          </a:p>
-        </p:txBody>
-      </p:sp>
-      <p:sp>
-        <p:nvSpPr>
-          <p:cNvPr id="30" name="Text 27"/>
+              <a:t>분석 출력 확장</a:t>
+            </a:r>
+            <a:endParaRPr lang="en-US" sz="1500" dirty="0"/>
+          </a:p>
+        </p:txBody>
+      </p:sp>
+      <p:sp>
+        <p:nvSpPr>
+          <p:cNvPr id="33" name="Text 30"/>
           <p:cNvSpPr txBox="1"/>
           <p:nvPr/>
         </p:nvSpPr>
         <p:spPr>
           <a:xfrm>
-            <a:off x="6349594" y="4927702"/>
-            <a:ext cx="2324405" cy="888797"/>
+            <a:off x="9169603" y="4863694"/>
+            <a:ext cx="2336292" cy="952805"/>
           </a:xfrm>
           <a:prstGeom prst="rect">
             <a:avLst/>
@@ -16207,12 +16355,12 @@
           <a:p>
             <a:pPr algn="l" indent="0" marL="0">
               <a:lnSpc>
-                <a:spcPct val="130000"/>
+                <a:spcPct val="135000"/>
               </a:lnSpc>
               <a:buNone/>
             </a:pPr>
             <a:r>
-              <a:rPr lang="en-US" sz="1250" dirty="0">
+              <a:rPr lang="en-US" sz="1200" dirty="0">
                 <a:solidFill>
                   <a:srgbClr val="4A5568"/>
                 </a:solidFill>
@@ -16220,137 +16368,9 @@
                 <a:ea typeface="Arial" pitchFamily="34" charset="-122"/>
                 <a:cs typeface="Arial" pitchFamily="34" charset="-120"/>
               </a:rPr>
-              <a:t>AHB 매트릭스, 마스터 간 실제 경합 지연</a:t>
-            </a:r>
-            <a:endParaRPr lang="en-US" sz="1250" dirty="0"/>
-          </a:p>
-        </p:txBody>
-      </p:sp>
-      <p:sp>
-        <p:nvSpPr>
-          <p:cNvPr id="31" name="Shape 28"/>
-          <p:cNvSpPr/>
-          <p:nvPr/>
-        </p:nvSpPr>
-        <p:spPr>
-          <a:xfrm>
-            <a:off x="9004097" y="4381805"/>
-            <a:ext cx="2679192" cy="1587398"/>
-          </a:xfrm>
-          <a:prstGeom prst="roundRect">
-            <a:avLst>
-              <a:gd name="adj" fmla="val 5588"/>
-            </a:avLst>
-          </a:prstGeom>
-          <a:solidFill>
-            <a:srgbClr val="F2F4F7"/>
-          </a:solidFill>
-          <a:ln w="12700">
-            <a:solidFill>
-              <a:srgbClr val="D9DEE6"/>
-            </a:solidFill>
-            <a:prstDash val="solid"/>
-          </a:ln>
-        </p:spPr>
-      </p:sp>
-      <p:sp>
-        <p:nvSpPr>
-          <p:cNvPr id="32" name="Shape 29"/>
-          <p:cNvSpPr/>
-          <p:nvPr/>
-        </p:nvSpPr>
-        <p:spPr>
-          <a:xfrm>
-            <a:off x="9181490" y="4546397"/>
-            <a:ext cx="254203" cy="254203"/>
-          </a:xfrm>
-          <a:prstGeom prst="ellipse">
-            <a:avLst/>
-          </a:prstGeom>
-          <a:solidFill>
-            <a:srgbClr val="B8791F"/>
-          </a:solidFill>
-          <a:ln/>
-        </p:spPr>
-      </p:sp>
-      <p:sp>
-        <p:nvSpPr>
-          <p:cNvPr id="33" name="Text 30"/>
-          <p:cNvSpPr txBox="1"/>
-          <p:nvPr/>
-        </p:nvSpPr>
-        <p:spPr>
-          <a:xfrm>
-            <a:off x="9524390" y="4533595"/>
-            <a:ext cx="2044598" cy="279806"/>
-          </a:xfrm>
-          <a:prstGeom prst="rect">
-            <a:avLst/>
-          </a:prstGeom>
-          <a:noFill/>
-          <a:ln/>
-        </p:spPr>
-        <p:txBody>
-          <a:bodyPr wrap="square" lIns="0" tIns="0" rIns="0" bIns="0" rtlCol="0" anchor="t"/>
-          <a:lstStyle/>
-          <a:p>
-            <a:pPr algn="l" indent="0" marL="0">
-              <a:buNone/>
-            </a:pPr>
-            <a:r>
-              <a:rPr lang="en-US" sz="1600" b="1" dirty="0">
-                <a:solidFill>
-                  <a:srgbClr val="0F1B2D"/>
-                </a:solidFill>
-                <a:latin typeface="Arial" pitchFamily="34" charset="0"/>
-                <a:ea typeface="Arial" pitchFamily="34" charset="-122"/>
-                <a:cs typeface="Arial" pitchFamily="34" charset="-120"/>
-              </a:rPr>
-              <a:t>주변장치</a:t>
-            </a:r>
-            <a:endParaRPr lang="en-US" sz="1600" dirty="0"/>
-          </a:p>
-        </p:txBody>
-      </p:sp>
-      <p:sp>
-        <p:nvSpPr>
-          <p:cNvPr id="34" name="Text 31"/>
-          <p:cNvSpPr txBox="1"/>
-          <p:nvPr/>
-        </p:nvSpPr>
-        <p:spPr>
-          <a:xfrm>
-            <a:off x="9181490" y="4927702"/>
-            <a:ext cx="2324405" cy="888797"/>
-          </a:xfrm>
-          <a:prstGeom prst="rect">
-            <a:avLst/>
-          </a:prstGeom>
-          <a:noFill/>
-          <a:ln/>
-        </p:spPr>
-        <p:txBody>
-          <a:bodyPr wrap="square" lIns="0" tIns="0" rIns="0" bIns="0" rtlCol="0" anchor="t"/>
-          <a:lstStyle/>
-          <a:p>
-            <a:pPr algn="l" indent="0" marL="0">
-              <a:lnSpc>
-                <a:spcPct val="130000"/>
-              </a:lnSpc>
-              <a:buNone/>
-            </a:pPr>
-            <a:r>
-              <a:rPr lang="en-US" sz="1250" dirty="0">
-                <a:solidFill>
-                  <a:srgbClr val="4A5568"/>
-                </a:solidFill>
-                <a:latin typeface="Arial" pitchFamily="34" charset="0"/>
-                <a:ea typeface="Arial" pitchFamily="34" charset="-122"/>
-                <a:cs typeface="Arial" pitchFamily="34" charset="-120"/>
-              </a:rPr>
-              <a:t>DMA(burst), Timer, 오디오 입력, 센서·액추에이터, MAC 가속기</a:t>
-            </a:r>
-            <a:endParaRPr lang="en-US" sz="1250" dirty="0"/>
+              <a:t>callgrind 이벤트: 메모리 영역별 접근·스톨·버스 대기 · FST: PC·함수·버스 신호</a:t>
+            </a:r>
+            <a:endParaRPr lang="en-US" sz="1200" dirty="0"/>
           </a:p>
         </p:txBody>
       </p:sp>

</xml_diff>

<commit_message>
Presentation: platform slide — core/DMA/Timer/MAC/peripherals modeled this project; memory & bus existing
Co-Authored-By: Claude Fable 5.1 <noreply@anthropic.com>
Claude-Session: https://claude.ai/code/session_01Gd73gUzQvBcmrEGA3YWYHu
</commit_message>
<xml_diff>
--- a/docs/presentation/deck_basic_fonts.pptx
+++ b/docs/presentation/deck_basic_fonts.pptx
@@ -1224,7 +1224,7 @@
           <a:p>
             <a:r>
               <a:rPr lang="en-US" dirty="0"/>
-              <a:t>40초. 세 숫자만 말한다. 아래는 '코어·메모리·버스는 기존 자산, 이번에 더한 것은 MAC 가속기·PoC 주변장치·분석 출력'을 한 문장으로. gem5/Fast Model 질문: gem5는 Cortex-M 미지원, Fast Model은 LT라 cycle 분석 불가.</a:t>
+              <a:t>40초. 세 숫자만 말한다. 아래는 '메모리·버스는 기존 자산, 코어·DMA·Timer·MAC·PoC 주변장치는 이번 과제에서 모델링'을 한 문장으로. gem5/Fast Model 질문: gem5는 Cortex-M 미지원, Fast Model은 LT라 cycle 분석 불가.</a:t>
             </a:r>
             <a:endParaRPr lang="en-US" dirty="0"/>
           </a:p>
@@ -15812,7 +15812,7 @@
         <p:spPr>
           <a:xfrm>
             <a:off x="508406" y="4063594"/>
-            <a:ext cx="2667305" cy="1904695"/>
+            <a:ext cx="2286000" cy="1904695"/>
           </a:xfrm>
           <a:prstGeom prst="roundRect">
             <a:avLst>
@@ -15839,7 +15839,7 @@
         <p:spPr>
           <a:xfrm>
             <a:off x="698602" y="4241902"/>
-            <a:ext cx="2286000" cy="202997"/>
+            <a:ext cx="1904695" cy="202997"/>
           </a:xfrm>
           <a:prstGeom prst="rect">
             <a:avLst/>
@@ -15878,7 +15878,7 @@
         <p:spPr>
           <a:xfrm>
             <a:off x="698602" y="4520794"/>
-            <a:ext cx="2349094" cy="825703"/>
+            <a:ext cx="1968703" cy="825703"/>
           </a:xfrm>
           <a:prstGeom prst="rect">
             <a:avLst/>
@@ -15905,7 +15905,7 @@
                 <a:ea typeface="Arial" pitchFamily="34" charset="-122"/>
                 <a:cs typeface="Arial" pitchFamily="34" charset="-120"/>
               </a:rPr>
-              <a:t>CM4 코어 (NVIC·FPU)</a:t>
+              <a:t>메모리 모델</a:t>
             </a:r>
             <a:endParaRPr lang="en-US" sz="1250" dirty="0"/>
           </a:p>
@@ -15925,7 +15925,7 @@
                 <a:ea typeface="Arial" pitchFamily="34" charset="-122"/>
                 <a:cs typeface="Arial" pitchFamily="34" charset="-120"/>
               </a:rPr>
-              <a:t>TCM · SRAM · Flash · I-Cache</a:t>
+              <a:t>TCM · SRAM · Flash</a:t>
             </a:r>
             <a:endParaRPr lang="en-US" sz="1250" dirty="0"/>
           </a:p>
@@ -15945,7 +15945,7 @@
                 <a:ea typeface="Arial" pitchFamily="34" charset="-122"/>
                 <a:cs typeface="Arial" pitchFamily="34" charset="-120"/>
               </a:rPr>
-              <a:t>AHB 매트릭스 · DMA · Timer</a:t>
+              <a:t>I-Cache · AHB 매트릭스</a:t>
             </a:r>
             <a:endParaRPr lang="en-US" sz="1250" dirty="0"/>
           </a:p>
@@ -15959,7 +15959,7 @@
         </p:nvSpPr>
         <p:spPr>
           <a:xfrm>
-            <a:off x="3353105" y="4063594"/>
+            <a:off x="2971800" y="4063594"/>
             <a:ext cx="5079492" cy="228600"/>
           </a:xfrm>
           <a:prstGeom prst="rect">
@@ -15984,7 +15984,7 @@
                 <a:ea typeface="Arial" pitchFamily="34" charset="-122"/>
                 <a:cs typeface="Arial" pitchFamily="34" charset="-120"/>
               </a:rPr>
-              <a:t>이번 과제에서 추가 모델링</a:t>
+              <a:t>이번 과제에서 모델링</a:t>
             </a:r>
             <a:endParaRPr lang="en-US" sz="1400" dirty="0"/>
           </a:p>
@@ -15998,8 +15998,8 @@
         </p:nvSpPr>
         <p:spPr>
           <a:xfrm>
-            <a:off x="3353105" y="4381805"/>
-            <a:ext cx="2691994" cy="1587398"/>
+            <a:off x="2971800" y="4381805"/>
+            <a:ext cx="2819095" cy="1587398"/>
           </a:xfrm>
           <a:prstGeom prst="roundRect">
             <a:avLst>
@@ -16025,8 +16025,8 @@
         </p:nvSpPr>
         <p:spPr>
           <a:xfrm>
-            <a:off x="3353105" y="4381805"/>
-            <a:ext cx="2691994" cy="38405"/>
+            <a:off x="2971800" y="4381805"/>
+            <a:ext cx="2819095" cy="38405"/>
           </a:xfrm>
           <a:prstGeom prst="rect">
             <a:avLst/>
@@ -16045,8 +16045,8 @@
         </p:nvSpPr>
         <p:spPr>
           <a:xfrm>
-            <a:off x="3530498" y="4546397"/>
-            <a:ext cx="2336292" cy="254203"/>
+            <a:off x="3149194" y="4546397"/>
+            <a:ext cx="2463394" cy="254203"/>
           </a:xfrm>
           <a:prstGeom prst="rect">
             <a:avLst/>
@@ -16070,7 +16070,7 @@
                 <a:ea typeface="Arial" pitchFamily="34" charset="-122"/>
                 <a:cs typeface="Arial" pitchFamily="34" charset="-120"/>
               </a:rPr>
-              <a:t>MAC 가속기</a:t>
+              <a:t>Cortex-M4 코어</a:t>
             </a:r>
             <a:endParaRPr lang="en-US" sz="1500" dirty="0"/>
           </a:p>
@@ -16084,8 +16084,8 @@
         </p:nvSpPr>
         <p:spPr>
           <a:xfrm>
-            <a:off x="3530498" y="4863694"/>
-            <a:ext cx="2336292" cy="952805"/>
+            <a:off x="3149194" y="4863694"/>
+            <a:ext cx="2463394" cy="952805"/>
           </a:xfrm>
           <a:prstGeom prst="rect">
             <a:avLst/>
@@ -16112,7 +16112,7 @@
                 <a:ea typeface="Arial" pitchFamily="34" charset="-122"/>
                 <a:cs typeface="Arial" pitchFamily="34" charset="-120"/>
               </a:rPr>
-              <a:t>INT8 dot-product 버스 마스터 · 레지스터 맵 · 완료 IRQ · 면적 비용</a:t>
+              <a:t>3단 인오더 파이프라인 · 명령어별 cycle · NVIC · FPU — CoreMark 정합성 99.7%</a:t>
             </a:r>
             <a:endParaRPr lang="en-US" sz="1200" dirty="0"/>
           </a:p>
@@ -16126,8 +16126,8 @@
         </p:nvSpPr>
         <p:spPr>
           <a:xfrm>
-            <a:off x="6172200" y="4381805"/>
-            <a:ext cx="2691994" cy="1587398"/>
+            <a:off x="5917997" y="4381805"/>
+            <a:ext cx="2819095" cy="1587398"/>
           </a:xfrm>
           <a:prstGeom prst="roundRect">
             <a:avLst>
@@ -16153,8 +16153,8 @@
         </p:nvSpPr>
         <p:spPr>
           <a:xfrm>
-            <a:off x="6172200" y="4381805"/>
-            <a:ext cx="2691994" cy="38405"/>
+            <a:off x="5917997" y="4381805"/>
+            <a:ext cx="2819095" cy="38405"/>
           </a:xfrm>
           <a:prstGeom prst="rect">
             <a:avLst/>
@@ -16173,8 +16173,8 @@
         </p:nvSpPr>
         <p:spPr>
           <a:xfrm>
-            <a:off x="6349594" y="4546397"/>
-            <a:ext cx="2336292" cy="254203"/>
+            <a:off x="6096305" y="4546397"/>
+            <a:ext cx="2463394" cy="254203"/>
           </a:xfrm>
           <a:prstGeom prst="rect">
             <a:avLst/>
@@ -16198,7 +16198,7 @@
                 <a:ea typeface="Arial" pitchFamily="34" charset="-122"/>
                 <a:cs typeface="Arial" pitchFamily="34" charset="-120"/>
               </a:rPr>
-              <a:t>PoC 주변장치</a:t>
+              <a:t>DMA · Timer</a:t>
             </a:r>
             <a:endParaRPr lang="en-US" sz="1500" dirty="0"/>
           </a:p>
@@ -16212,8 +16212,8 @@
         </p:nvSpPr>
         <p:spPr>
           <a:xfrm>
-            <a:off x="6349594" y="4863694"/>
-            <a:ext cx="2336292" cy="952805"/>
+            <a:off x="6096305" y="4863694"/>
+            <a:ext cx="2463394" cy="952805"/>
           </a:xfrm>
           <a:prstGeom prst="rect">
             <a:avLst/>
@@ -16240,7 +16240,7 @@
                 <a:ea typeface="Arial" pitchFamily="34" charset="-122"/>
                 <a:cs typeface="Arial" pitchFamily="34" charset="-120"/>
               </a:rPr>
-              <a:t>오디오 입력(16 kHz → DMA) · 센서/액추에이터 · 결과·마커 출력</a:t>
+              <a:t>burst 전송 · 채널 · 완료 IRQ / 1 kHz 제어 타이머 · ISR 지연 측정</a:t>
             </a:r>
             <a:endParaRPr lang="en-US" sz="1200" dirty="0"/>
           </a:p>
@@ -16254,8 +16254,8 @@
         </p:nvSpPr>
         <p:spPr>
           <a:xfrm>
-            <a:off x="8991295" y="4381805"/>
-            <a:ext cx="2691994" cy="1587398"/>
+            <a:off x="8864194" y="4381805"/>
+            <a:ext cx="2819095" cy="1587398"/>
           </a:xfrm>
           <a:prstGeom prst="roundRect">
             <a:avLst>
@@ -16281,8 +16281,8 @@
         </p:nvSpPr>
         <p:spPr>
           <a:xfrm>
-            <a:off x="8991295" y="4381805"/>
-            <a:ext cx="2691994" cy="38405"/>
+            <a:off x="8864194" y="4381805"/>
+            <a:ext cx="2819095" cy="38405"/>
           </a:xfrm>
           <a:prstGeom prst="rect">
             <a:avLst/>
@@ -16301,8 +16301,8 @@
         </p:nvSpPr>
         <p:spPr>
           <a:xfrm>
-            <a:off x="9169603" y="4546397"/>
-            <a:ext cx="2336292" cy="254203"/>
+            <a:off x="9042502" y="4546397"/>
+            <a:ext cx="2463394" cy="254203"/>
           </a:xfrm>
           <a:prstGeom prst="rect">
             <a:avLst/>
@@ -16326,7 +16326,7 @@
                 <a:ea typeface="Arial" pitchFamily="34" charset="-122"/>
                 <a:cs typeface="Arial" pitchFamily="34" charset="-120"/>
               </a:rPr>
-              <a:t>분석 출력 확장</a:t>
+              <a:t>MAC 가속기 · PoC 주변장치</a:t>
             </a:r>
             <a:endParaRPr lang="en-US" sz="1500" dirty="0"/>
           </a:p>
@@ -16340,8 +16340,8 @@
         </p:nvSpPr>
         <p:spPr>
           <a:xfrm>
-            <a:off x="9169603" y="4863694"/>
-            <a:ext cx="2336292" cy="952805"/>
+            <a:off x="9042502" y="4863694"/>
+            <a:ext cx="2463394" cy="952805"/>
           </a:xfrm>
           <a:prstGeom prst="rect">
             <a:avLst/>
@@ -16368,7 +16368,7 @@
                 <a:ea typeface="Arial" pitchFamily="34" charset="-122"/>
                 <a:cs typeface="Arial" pitchFamily="34" charset="-120"/>
               </a:rPr>
-              <a:t>callgrind 이벤트: 메모리 영역별 접근·스톨·버스 대기 · FST: PC·함수·버스 신호</a:t>
+              <a:t>INT8 dot-product 버스 마스터 · 완료 IRQ / 오디오 입력 · 센서·액추에이터</a:t>
             </a:r>
             <a:endParaRPr lang="en-US" sz="1200" dirty="0"/>
           </a:p>

</xml_diff>

<commit_message>
Presentation: results slide — per-point cycle/area deltas, perf+area tables by HW structure, 300min→10min tile; impact slide — qualitative/quantitative + next band
Co-Authored-By: Claude Fable 5.1 <noreply@anthropic.com>
Claude-Session: https://claude.ai/code/session_01Gd73gUzQvBcmrEGA3YWYHu
</commit_message>
<xml_diff>
--- a/docs/presentation/deck_basic_fonts.pptx
+++ b/docs/presentation/deck_basic_fonts.pptx
@@ -602,7 +602,7 @@
           <a:p>
             <a:r>
               <a:rPr lang="en-US" dirty="0"/>
-              <a:t>60초. 회색 점(사람 출발점)→주황 점(AI 도착점) 화살표가 'AI가 HW도 SW도 바꿨다'는 증거. 점선은 헤드라인. 실측 후 그림 교체. 검은 박스의 HW 변경 목록이 co-optimization의 실체.</a:t>
+              <a:t>60초. 왼쪽 그림: 회색 점(초기)→주황 점(루프 결과) 화살표 옆 숫자를 읽는다. 오른쪽 위 표 = 성능, 아래 표 = 면적, 같은 세 구조. 검은 타일 '에뮬 300분 → 10분'은 실험 1회 기준 — 11장 정량 효과(하루 반복 횟수·탐색 기간)의 근거가 된다. 신뢰성 질문이 오면 세 번째 타일: 모든 실험이 bit-exact와 ISR 제약을 통과했고 아닌 것은 자동 폐기.</a:t>
             </a:r>
             <a:endParaRPr lang="en-US" dirty="0"/>
           </a:p>
@@ -690,7 +690,7 @@
           <a:p>
             <a:r>
               <a:rPr lang="en-US" dirty="0"/>
-              <a:t>45초. 정량 칸은 PoC 수치로. 교육·실무 칸의 대괄호는 제안 — 실제 교과목명·적용 프로젝트로 교체.
+              <a:t>30초. 정량 칸 첫 줄(300분→10분)이 10장 검은 타일의 파생. 나머지 대괄호는 PoC 실측. '다음' 띠는 한 문장으로 읽고 감사 인사.
 제목 후보:
 1. 실리콘보다 먼저 — Cycle-level 가상 플랫폼과 파형 기반 프로파일러 위에서 AI가 도는 HW-SW Co-Optimization
 2. 파형에서 최적화까지 — 실리콘을 기다리지 않는 HW·SW 공동 최적화 루프
@@ -2509,7 +2509,7 @@
         <p:spPr>
           <a:xfrm>
             <a:off x="508406" y="1015898"/>
-            <a:ext cx="11175797" cy="761695"/>
+            <a:ext cx="11175797" cy="508406"/>
           </a:xfrm>
           <a:prstGeom prst="rect">
             <a:avLst/>
@@ -2528,7 +2528,7 @@
               <a:buNone/>
             </a:pPr>
             <a:r>
-              <a:rPr lang="en-US" sz="2100" b="1" dirty="0">
+              <a:rPr lang="en-US" sz="2600" b="1" dirty="0">
                 <a:solidFill>
                   <a:srgbClr val="0F1B2D"/>
                 </a:solidFill>
@@ -2536,9 +2536,9 @@
                 <a:ea typeface="Arial" pitchFamily="34" charset="-122"/>
                 <a:cs typeface="Arial" pitchFamily="34" charset="-120"/>
               </a:rPr>
-              <a:t>[헤드라인 — 예) 예산 280에서 AI가 고른 HW+SW가 예산 470의 사람 출발점보다 빠름: 면적 −40%, 같은 성능]</a:t>
-            </a:r>
-            <a:endParaRPr lang="en-US" sz="2100" dirty="0"/>
+              <a:t>세 가지 HW 구조 모두에서, 같은 정확도로 cycle −[__]% · 면적 −[__]%</a:t>
+            </a:r>
+            <a:endParaRPr lang="en-US" sz="2600" dirty="0"/>
           </a:p>
         </p:txBody>
       </p:sp>
@@ -2550,12 +2550,12 @@
         </p:nvSpPr>
         <p:spPr>
           <a:xfrm>
-            <a:off x="508406" y="1904695"/>
-            <a:ext cx="6096305" cy="3301898"/>
+            <a:off x="508406" y="1714500"/>
+            <a:ext cx="6096305" cy="4063594"/>
           </a:xfrm>
           <a:prstGeom prst="roundRect">
             <a:avLst>
-              <a:gd name="adj" fmla="val 3074"/>
+              <a:gd name="adj" fmla="val 2498"/>
             </a:avLst>
           </a:prstGeom>
           <a:solidFill>
@@ -2577,7 +2577,7 @@
         </p:nvSpPr>
         <p:spPr>
           <a:xfrm>
-            <a:off x="1143000" y="4762195"/>
+            <a:off x="1143000" y="4953305"/>
             <a:ext cx="5206594" cy="0"/>
           </a:xfrm>
           <a:prstGeom prst="line">
@@ -2600,7 +2600,7 @@
         </p:nvSpPr>
         <p:spPr>
           <a:xfrm flipV="1">
-            <a:off x="1143000" y="2221992"/>
+            <a:off x="1143000" y="2413102"/>
             <a:ext cx="0" cy="2540203"/>
           </a:xfrm>
           <a:prstGeom prst="line">
@@ -2623,7 +2623,7 @@
         </p:nvSpPr>
         <p:spPr>
           <a:xfrm>
-            <a:off x="2413102" y="2286000"/>
+            <a:off x="2413102" y="2476195"/>
             <a:ext cx="0" cy="2476195"/>
           </a:xfrm>
           <a:prstGeom prst="line">
@@ -2646,7 +2646,7 @@
         </p:nvSpPr>
         <p:spPr>
           <a:xfrm>
-            <a:off x="3683203" y="2286000"/>
+            <a:off x="3683203" y="2476195"/>
             <a:ext cx="0" cy="2476195"/>
           </a:xfrm>
           <a:prstGeom prst="line">
@@ -2669,7 +2669,7 @@
         </p:nvSpPr>
         <p:spPr>
           <a:xfrm>
-            <a:off x="5778094" y="2286000"/>
+            <a:off x="5778094" y="2476195"/>
             <a:ext cx="0" cy="2476195"/>
           </a:xfrm>
           <a:prstGeom prst="line">
@@ -2692,7 +2692,7 @@
         </p:nvSpPr>
         <p:spPr>
           <a:xfrm>
-            <a:off x="2197303" y="2768803"/>
+            <a:off x="2197303" y="2958998"/>
             <a:ext cx="177394" cy="177394"/>
           </a:xfrm>
           <a:prstGeom prst="ellipse">
@@ -2712,7 +2712,7 @@
         </p:nvSpPr>
         <p:spPr>
           <a:xfrm>
-            <a:off x="3467405" y="3403397"/>
+            <a:off x="3467405" y="3593592"/>
             <a:ext cx="177394" cy="177394"/>
           </a:xfrm>
           <a:prstGeom prst="ellipse">
@@ -2732,7 +2732,7 @@
         </p:nvSpPr>
         <p:spPr>
           <a:xfrm>
-            <a:off x="5562295" y="4006901"/>
+            <a:off x="5562295" y="4197096"/>
             <a:ext cx="177394" cy="177394"/>
           </a:xfrm>
           <a:prstGeom prst="ellipse">
@@ -2752,7 +2752,7 @@
         </p:nvSpPr>
         <p:spPr>
           <a:xfrm flipV="1">
-            <a:off x="1854403" y="2958998"/>
+            <a:off x="1854403" y="3149194"/>
             <a:ext cx="381305" cy="737006"/>
           </a:xfrm>
           <a:prstGeom prst="line">
@@ -2776,7 +2776,7 @@
         </p:nvSpPr>
         <p:spPr>
           <a:xfrm>
-            <a:off x="1752905" y="3593592"/>
+            <a:off x="1752905" y="3784702"/>
             <a:ext cx="202997" cy="202997"/>
           </a:xfrm>
           <a:prstGeom prst="ellipse">
@@ -2796,7 +2796,7 @@
         </p:nvSpPr>
         <p:spPr>
           <a:xfrm flipV="1">
-            <a:off x="3060497" y="3593592"/>
+            <a:off x="3060497" y="3784702"/>
             <a:ext cx="444398" cy="737006"/>
           </a:xfrm>
           <a:prstGeom prst="line">
@@ -2820,7 +2820,7 @@
         </p:nvSpPr>
         <p:spPr>
           <a:xfrm>
-            <a:off x="2958998" y="4229100"/>
+            <a:off x="2958998" y="4419295"/>
             <a:ext cx="202997" cy="202997"/>
           </a:xfrm>
           <a:prstGeom prst="ellipse">
@@ -2840,7 +2840,7 @@
         </p:nvSpPr>
         <p:spPr>
           <a:xfrm flipV="1">
-            <a:off x="5169103" y="4190695"/>
+            <a:off x="5169103" y="4381805"/>
             <a:ext cx="431597" cy="418795"/>
           </a:xfrm>
           <a:prstGeom prst="line">
@@ -2864,7 +2864,7 @@
         </p:nvSpPr>
         <p:spPr>
           <a:xfrm>
-            <a:off x="5067605" y="4507992"/>
+            <a:off x="5067605" y="4699102"/>
             <a:ext cx="202997" cy="202997"/>
           </a:xfrm>
           <a:prstGeom prst="ellipse">
@@ -2884,7 +2884,7 @@
         </p:nvSpPr>
         <p:spPr>
           <a:xfrm flipV="1">
-            <a:off x="3060497" y="4095598"/>
+            <a:off x="3060497" y="4285793"/>
             <a:ext cx="2590495" cy="235001"/>
           </a:xfrm>
           <a:prstGeom prst="line">
@@ -2907,8 +2907,8 @@
         </p:nvSpPr>
         <p:spPr>
           <a:xfrm>
-            <a:off x="634594" y="2018995"/>
-            <a:ext cx="1904695" cy="190195"/>
+            <a:off x="2387498" y="3276295"/>
+            <a:ext cx="1143000" cy="405994"/>
           </a:xfrm>
           <a:prstGeom prst="rect">
             <a:avLst/>
@@ -2921,20 +2921,43 @@
           <a:lstStyle/>
           <a:p>
             <a:pPr algn="l" indent="0" marL="0">
-              <a:buNone/>
-            </a:pPr>
-            <a:r>
-              <a:rPr lang="en-US" sz="1150" dirty="0">
-                <a:solidFill>
-                  <a:srgbClr val="6B7280"/>
-                </a:solidFill>
-                <a:latin typeface="Arial" pitchFamily="34" charset="0"/>
-                <a:ea typeface="Arial" pitchFamily="34" charset="-122"/>
-                <a:cs typeface="Arial" pitchFamily="34" charset="-120"/>
-              </a:rPr>
-              <a:t>추론 cycle ↑</a:t>
-            </a:r>
-            <a:endParaRPr lang="en-US" sz="1150" dirty="0"/>
+              <a:lnSpc>
+                <a:spcPct val="120000"/>
+              </a:lnSpc>
+              <a:buNone/>
+            </a:pPr>
+            <a:r>
+              <a:rPr lang="en-US" sz="1200" b="1" dirty="0">
+                <a:solidFill>
+                  <a:srgbClr val="B8791F"/>
+                </a:solidFill>
+                <a:latin typeface="Arial" pitchFamily="34" charset="0"/>
+                <a:ea typeface="Arial" pitchFamily="34" charset="-122"/>
+                <a:cs typeface="Arial" pitchFamily="34" charset="-120"/>
+              </a:rPr>
+              <a:t>cycle −[__]%</a:t>
+            </a:r>
+            <a:endParaRPr lang="en-US" sz="1200" dirty="0"/>
+          </a:p>
+          <a:p>
+            <a:pPr algn="l" indent="0" marL="0">
+              <a:lnSpc>
+                <a:spcPct val="120000"/>
+              </a:lnSpc>
+              <a:buNone/>
+            </a:pPr>
+            <a:r>
+              <a:rPr lang="en-US" sz="1200" b="1" dirty="0">
+                <a:solidFill>
+                  <a:srgbClr val="B8791F"/>
+                </a:solidFill>
+                <a:latin typeface="Arial" pitchFamily="34" charset="0"/>
+                <a:ea typeface="Arial" pitchFamily="34" charset="-122"/>
+                <a:cs typeface="Arial" pitchFamily="34" charset="-120"/>
+              </a:rPr>
+              <a:t>면적 −[__]%</a:t>
+            </a:r>
+            <a:endParaRPr lang="en-US" sz="1200" dirty="0"/>
           </a:p>
         </p:txBody>
       </p:sp>
@@ -2946,8 +2969,8 @@
         </p:nvSpPr>
         <p:spPr>
           <a:xfrm>
-            <a:off x="4507992" y="4953305"/>
-            <a:ext cx="1904695" cy="190195"/>
+            <a:off x="3657600" y="4000500"/>
+            <a:ext cx="1143000" cy="405994"/>
           </a:xfrm>
           <a:prstGeom prst="rect">
             <a:avLst/>
@@ -2959,21 +2982,44 @@
           <a:bodyPr wrap="square" lIns="0" tIns="0" rIns="0" bIns="0" rtlCol="0" anchor="t"/>
           <a:lstStyle/>
           <a:p>
-            <a:pPr algn="r" indent="0" marL="0">
-              <a:buNone/>
-            </a:pPr>
-            <a:r>
-              <a:rPr lang="en-US" sz="1150" dirty="0">
-                <a:solidFill>
-                  <a:srgbClr val="6B7280"/>
-                </a:solidFill>
-                <a:latin typeface="Arial" pitchFamily="34" charset="0"/>
-                <a:ea typeface="Arial" pitchFamily="34" charset="-122"/>
-                <a:cs typeface="Arial" pitchFamily="34" charset="-120"/>
-              </a:rPr>
-              <a:t>면적 (상대) →</a:t>
-            </a:r>
-            <a:endParaRPr lang="en-US" sz="1150" dirty="0"/>
+            <a:pPr algn="l" indent="0" marL="0">
+              <a:lnSpc>
+                <a:spcPct val="120000"/>
+              </a:lnSpc>
+              <a:buNone/>
+            </a:pPr>
+            <a:r>
+              <a:rPr lang="en-US" sz="1200" b="1" dirty="0">
+                <a:solidFill>
+                  <a:srgbClr val="B8791F"/>
+                </a:solidFill>
+                <a:latin typeface="Arial" pitchFamily="34" charset="0"/>
+                <a:ea typeface="Arial" pitchFamily="34" charset="-122"/>
+                <a:cs typeface="Arial" pitchFamily="34" charset="-120"/>
+              </a:rPr>
+              <a:t>cycle −[__]%</a:t>
+            </a:r>
+            <a:endParaRPr lang="en-US" sz="1200" dirty="0"/>
+          </a:p>
+          <a:p>
+            <a:pPr algn="l" indent="0" marL="0">
+              <a:lnSpc>
+                <a:spcPct val="120000"/>
+              </a:lnSpc>
+              <a:buNone/>
+            </a:pPr>
+            <a:r>
+              <a:rPr lang="en-US" sz="1200" b="1" dirty="0">
+                <a:solidFill>
+                  <a:srgbClr val="B8791F"/>
+                </a:solidFill>
+                <a:latin typeface="Arial" pitchFamily="34" charset="0"/>
+                <a:ea typeface="Arial" pitchFamily="34" charset="-122"/>
+                <a:cs typeface="Arial" pitchFamily="34" charset="-120"/>
+              </a:rPr>
+              <a:t>면적 −[__]%</a:t>
+            </a:r>
+            <a:endParaRPr lang="en-US" sz="1200" dirty="0"/>
           </a:p>
         </p:txBody>
       </p:sp>
@@ -2985,8 +3031,8 @@
         </p:nvSpPr>
         <p:spPr>
           <a:xfrm>
-            <a:off x="2095805" y="4813402"/>
-            <a:ext cx="634594" cy="190195"/>
+            <a:off x="4063594" y="4584802"/>
+            <a:ext cx="1143000" cy="405994"/>
           </a:xfrm>
           <a:prstGeom prst="rect">
             <a:avLst/>
@@ -2998,21 +3044,44 @@
           <a:bodyPr wrap="square" lIns="0" tIns="0" rIns="0" bIns="0" rtlCol="0" anchor="t"/>
           <a:lstStyle/>
           <a:p>
-            <a:pPr algn="ctr" indent="0" marL="0">
-              <a:buNone/>
-            </a:pPr>
-            <a:r>
-              <a:rPr lang="en-US" sz="1150" dirty="0">
-                <a:solidFill>
-                  <a:srgbClr val="6B7280"/>
-                </a:solidFill>
-                <a:latin typeface="Arial" pitchFamily="34" charset="0"/>
-                <a:ea typeface="Arial" pitchFamily="34" charset="-122"/>
-                <a:cs typeface="Arial" pitchFamily="34" charset="-120"/>
-              </a:rPr>
-              <a:t>≤170</a:t>
-            </a:r>
-            <a:endParaRPr lang="en-US" sz="1150" dirty="0"/>
+            <a:pPr algn="l" indent="0" marL="0">
+              <a:lnSpc>
+                <a:spcPct val="120000"/>
+              </a:lnSpc>
+              <a:buNone/>
+            </a:pPr>
+            <a:r>
+              <a:rPr lang="en-US" sz="1200" b="1" dirty="0">
+                <a:solidFill>
+                  <a:srgbClr val="B8791F"/>
+                </a:solidFill>
+                <a:latin typeface="Arial" pitchFamily="34" charset="0"/>
+                <a:ea typeface="Arial" pitchFamily="34" charset="-122"/>
+                <a:cs typeface="Arial" pitchFamily="34" charset="-120"/>
+              </a:rPr>
+              <a:t>cycle −[__]%</a:t>
+            </a:r>
+            <a:endParaRPr lang="en-US" sz="1200" dirty="0"/>
+          </a:p>
+          <a:p>
+            <a:pPr algn="l" indent="0" marL="0">
+              <a:lnSpc>
+                <a:spcPct val="120000"/>
+              </a:lnSpc>
+              <a:buNone/>
+            </a:pPr>
+            <a:r>
+              <a:rPr lang="en-US" sz="1200" b="1" dirty="0">
+                <a:solidFill>
+                  <a:srgbClr val="B8791F"/>
+                </a:solidFill>
+                <a:latin typeface="Arial" pitchFamily="34" charset="0"/>
+                <a:ea typeface="Arial" pitchFamily="34" charset="-122"/>
+                <a:cs typeface="Arial" pitchFamily="34" charset="-120"/>
+              </a:rPr>
+              <a:t>면적 −[__]%</a:t>
+            </a:r>
+            <a:endParaRPr lang="en-US" sz="1200" dirty="0"/>
           </a:p>
         </p:txBody>
       </p:sp>
@@ -3024,8 +3093,8 @@
         </p:nvSpPr>
         <p:spPr>
           <a:xfrm>
-            <a:off x="3364992" y="4813402"/>
-            <a:ext cx="634594" cy="190195"/>
+            <a:off x="634594" y="1828800"/>
+            <a:ext cx="1904695" cy="190195"/>
           </a:xfrm>
           <a:prstGeom prst="rect">
             <a:avLst/>
@@ -3037,7 +3106,7 @@
           <a:bodyPr wrap="square" lIns="0" tIns="0" rIns="0" bIns="0" rtlCol="0" anchor="t"/>
           <a:lstStyle/>
           <a:p>
-            <a:pPr algn="ctr" indent="0" marL="0">
+            <a:pPr algn="l" indent="0" marL="0">
               <a:buNone/>
             </a:pPr>
             <a:r>
@@ -3049,7 +3118,7 @@
                 <a:ea typeface="Arial" pitchFamily="34" charset="-122"/>
                 <a:cs typeface="Arial" pitchFamily="34" charset="-120"/>
               </a:rPr>
-              <a:t>≤280</a:t>
+              <a:t>추론 cycle ↑</a:t>
             </a:r>
             <a:endParaRPr lang="en-US" sz="1150" dirty="0"/>
           </a:p>
@@ -3063,8 +3132,8 @@
         </p:nvSpPr>
         <p:spPr>
           <a:xfrm>
-            <a:off x="5460797" y="4813402"/>
-            <a:ext cx="634594" cy="190195"/>
+            <a:off x="4507992" y="5460797"/>
+            <a:ext cx="1904695" cy="190195"/>
           </a:xfrm>
           <a:prstGeom prst="rect">
             <a:avLst/>
@@ -3076,7 +3145,7 @@
           <a:bodyPr wrap="square" lIns="0" tIns="0" rIns="0" bIns="0" rtlCol="0" anchor="t"/>
           <a:lstStyle/>
           <a:p>
-            <a:pPr algn="ctr" indent="0" marL="0">
+            <a:pPr algn="r" indent="0" marL="0">
               <a:buNone/>
             </a:pPr>
             <a:r>
@@ -3088,7 +3157,7 @@
                 <a:ea typeface="Arial" pitchFamily="34" charset="-122"/>
                 <a:cs typeface="Arial" pitchFamily="34" charset="-120"/>
               </a:rPr>
-              <a:t>≤470</a:t>
+              <a:t>면적 (상대) →</a:t>
             </a:r>
             <a:endParaRPr lang="en-US" sz="1150" dirty="0"/>
           </a:p>
@@ -3102,7 +3171,124 @@
         </p:nvSpPr>
         <p:spPr>
           <a:xfrm>
-            <a:off x="4317797" y="2286000"/>
+            <a:off x="1904695" y="5003597"/>
+            <a:ext cx="1015898" cy="190195"/>
+          </a:xfrm>
+          <a:prstGeom prst="rect">
+            <a:avLst/>
+          </a:prstGeom>
+          <a:noFill/>
+          <a:ln/>
+        </p:spPr>
+        <p:txBody>
+          <a:bodyPr wrap="square" lIns="0" tIns="0" rIns="0" bIns="0" rtlCol="0" anchor="t"/>
+          <a:lstStyle/>
+          <a:p>
+            <a:pPr algn="ctr" indent="0" marL="0">
+              <a:buNone/>
+            </a:pPr>
+            <a:r>
+              <a:rPr lang="en-US" sz="1100" dirty="0">
+                <a:solidFill>
+                  <a:srgbClr val="6B7280"/>
+                </a:solidFill>
+                <a:latin typeface="Arial" pitchFamily="34" charset="0"/>
+                <a:ea typeface="Arial" pitchFamily="34" charset="-122"/>
+                <a:cs typeface="Arial" pitchFamily="34" charset="-120"/>
+              </a:rPr>
+              <a:t>Base · ≤170</a:t>
+            </a:r>
+            <a:endParaRPr lang="en-US" sz="1100" dirty="0"/>
+          </a:p>
+        </p:txBody>
+      </p:sp>
+      <p:sp>
+        <p:nvSpPr>
+          <p:cNvPr id="28" name="Text 25"/>
+          <p:cNvSpPr txBox="1"/>
+          <p:nvPr/>
+        </p:nvSpPr>
+        <p:spPr>
+          <a:xfrm>
+            <a:off x="3174797" y="5003597"/>
+            <a:ext cx="1015898" cy="190195"/>
+          </a:xfrm>
+          <a:prstGeom prst="rect">
+            <a:avLst/>
+          </a:prstGeom>
+          <a:noFill/>
+          <a:ln/>
+        </p:spPr>
+        <p:txBody>
+          <a:bodyPr wrap="square" lIns="0" tIns="0" rIns="0" bIns="0" rtlCol="0" anchor="t"/>
+          <a:lstStyle/>
+          <a:p>
+            <a:pPr algn="ctr" indent="0" marL="0">
+              <a:buNone/>
+            </a:pPr>
+            <a:r>
+              <a:rPr lang="en-US" sz="1100" dirty="0">
+                <a:solidFill>
+                  <a:srgbClr val="6B7280"/>
+                </a:solidFill>
+                <a:latin typeface="Arial" pitchFamily="34" charset="0"/>
+                <a:ea typeface="Arial" pitchFamily="34" charset="-122"/>
+                <a:cs typeface="Arial" pitchFamily="34" charset="-120"/>
+              </a:rPr>
+              <a:t>+TCM · ≤280</a:t>
+            </a:r>
+            <a:endParaRPr lang="en-US" sz="1100" dirty="0"/>
+          </a:p>
+        </p:txBody>
+      </p:sp>
+      <p:sp>
+        <p:nvSpPr>
+          <p:cNvPr id="29" name="Text 26"/>
+          <p:cNvSpPr txBox="1"/>
+          <p:nvPr/>
+        </p:nvSpPr>
+        <p:spPr>
+          <a:xfrm>
+            <a:off x="5143500" y="5003597"/>
+            <a:ext cx="1270102" cy="190195"/>
+          </a:xfrm>
+          <a:prstGeom prst="rect">
+            <a:avLst/>
+          </a:prstGeom>
+          <a:noFill/>
+          <a:ln/>
+        </p:spPr>
+        <p:txBody>
+          <a:bodyPr wrap="square" lIns="0" tIns="0" rIns="0" bIns="0" rtlCol="0" anchor="t"/>
+          <a:lstStyle/>
+          <a:p>
+            <a:pPr algn="ctr" indent="0" marL="0">
+              <a:buNone/>
+            </a:pPr>
+            <a:r>
+              <a:rPr lang="en-US" sz="1100" dirty="0">
+                <a:solidFill>
+                  <a:srgbClr val="6B7280"/>
+                </a:solidFill>
+                <a:latin typeface="Arial" pitchFamily="34" charset="0"/>
+                <a:ea typeface="Arial" pitchFamily="34" charset="-122"/>
+                <a:cs typeface="Arial" pitchFamily="34" charset="-120"/>
+              </a:rPr>
+              <a:t>+TCM+MAC · ≤470</a:t>
+            </a:r>
+            <a:endParaRPr lang="en-US" sz="1100" dirty="0"/>
+          </a:p>
+        </p:txBody>
+      </p:sp>
+      <p:sp>
+        <p:nvSpPr>
+          <p:cNvPr id="30" name="Text 27"/>
+          <p:cNvSpPr txBox="1"/>
+          <p:nvPr/>
+        </p:nvSpPr>
+        <p:spPr>
+          <a:xfrm>
+            <a:off x="4317797" y="2476195"/>
             <a:ext cx="2158898" cy="698602"/>
           </a:xfrm>
           <a:prstGeom prst="rect">
@@ -3147,9 +3333,11 @@
                 <a:ea typeface="Arial" pitchFamily="34" charset="-122"/>
                 <a:cs typeface="Arial" pitchFamily="34" charset="-120"/>
               </a:rPr>
-              <a:t>사람이 정한 HW + 기본 SW
-</a:t>
-            </a:r>
+              <a:t>사람이 정한 HW + 기본 SW</a:t>
+            </a:r>
+            <a:endParaRPr lang="en-US" sz="1150" dirty="0"/>
+          </a:p>
+          <a:p>
             <a:pPr algn="l" indent="0" marL="0">
               <a:lnSpc>
                 <a:spcPct val="140000"/>
@@ -3182,9 +3370,11 @@
                 <a:ea typeface="Arial" pitchFamily="34" charset="-122"/>
                 <a:cs typeface="Arial" pitchFamily="34" charset="-120"/>
               </a:rPr>
-              <a:t>AI가 HW·SW 함께 선택
-</a:t>
-            </a:r>
+              <a:t>AI가 HW·SW 함께 선택</a:t>
+            </a:r>
+            <a:endParaRPr lang="en-US" sz="1150" dirty="0"/>
+          </a:p>
+          <a:p>
             <a:pPr algn="l" indent="0" marL="0">
               <a:lnSpc>
                 <a:spcPct val="140000"/>
@@ -3217,7 +3407,7 @@
                 <a:ea typeface="Arial" pitchFamily="34" charset="-122"/>
                 <a:cs typeface="Arial" pitchFamily="34" charset="-120"/>
               </a:rPr>
-              <a:t>같은 성능, 면적 −__%</a:t>
+              <a:t>+TCM 결과 = +MAC 초기 성능</a:t>
             </a:r>
             <a:endParaRPr lang="en-US" sz="1150" dirty="0"/>
           </a:p>
@@ -3225,13 +3415,13 @@
       </p:sp>
       <p:sp>
         <p:nvSpPr>
-          <p:cNvPr id="28" name="Text 25"/>
+          <p:cNvPr id="31" name="Text 28"/>
           <p:cNvSpPr txBox="1"/>
           <p:nvPr/>
         </p:nvSpPr>
         <p:spPr>
           <a:xfrm>
-            <a:off x="1270102" y="2286000"/>
+            <a:off x="1270102" y="2476195"/>
             <a:ext cx="2540203" cy="190195"/>
           </a:xfrm>
           <a:prstGeom prst="rect">
@@ -3277,18 +3467,17 @@
           </p:nvPr>
         </p:nvGraphicFramePr>
         <p:xfrm>
-          <a:off x="6858000" y="1904695"/>
-          <a:ext cx="4826203" cy="914400"/>
+          <a:off x="6832397" y="1714500"/>
+          <a:ext cx="4850892" cy="914400"/>
         </p:xfrm>
         <a:graphic>
           <a:graphicData uri="http://schemas.openxmlformats.org/drawingml/2006/table">
             <a:tbl>
               <a:tblPr/>
               <a:tblGrid>
-                <a:gridCol w="1270102"/>
-                <a:gridCol w="1206094"/>
-                <a:gridCol w="1047902"/>
-                <a:gridCol w="1302106"/>
+                <a:gridCol w="1904695"/>
+                <a:gridCol w="1333195"/>
+                <a:gridCol w="1613002"/>
               </a:tblGrid>
               <a:tr h="355702">
                 <a:tc>
@@ -3308,7 +3497,7 @@
                           <a:ea typeface="Arial" pitchFamily="34" charset="-122"/>
                           <a:cs typeface="Arial" pitchFamily="34" charset="-120"/>
                         </a:rPr>
-                        <a:t>면적 예산</a:t>
+                        <a:t>HW 구조</a:t>
                       </a:r>
                       <a:endParaRPr lang="en-US" sz="1200" dirty="0">
                         <a:latin typeface="Arial" charset="0"/>
@@ -3376,7 +3565,7 @@
                           <a:ea typeface="Arial" pitchFamily="34" charset="-122"/>
                           <a:cs typeface="Arial" pitchFamily="34" charset="-120"/>
                         </a:rPr>
-                        <a:t>사람 HW + 기본 SW</a:t>
+                        <a:t>초기 성능 (cycle)</a:t>
                       </a:r>
                       <a:endParaRPr lang="en-US" sz="1200" dirty="0">
                         <a:latin typeface="Arial" charset="0"/>
@@ -3444,75 +3633,7 @@
                           <a:ea typeface="Arial" pitchFamily="34" charset="-122"/>
                           <a:cs typeface="Arial" pitchFamily="34" charset="-120"/>
                         </a:rPr>
-                        <a:t>AI · SW만</a:t>
-                      </a:r>
-                      <a:endParaRPr lang="en-US" sz="1200" dirty="0">
-                        <a:latin typeface="Arial" charset="0"/>
-                        <a:ea typeface="Arial" charset="0"/>
-                        <a:cs typeface="Arial" charset="0"/>
-                      </a:endParaRPr>
-                    </a:p>
-                  </a:txBody>
-                  <a:tcPr marL="127000" marR="127000" marT="76200" marB="76200" anchor="ctr">
-                    <a:lnL w="9525" cap="flat" cmpd="sng" algn="ctr">
-                      <a:solidFill>
-                        <a:srgbClr val="D9DEE6"/>
-                      </a:solidFill>
-                      <a:prstDash val="solid"/>
-                      <a:round/>
-                      <a:headEnd type="none" w="med" len="med"/>
-                      <a:tailEnd type="none" w="med" len="med"/>
-                    </a:lnL>
-                    <a:lnR w="9525" cap="flat" cmpd="sng" algn="ctr">
-                      <a:solidFill>
-                        <a:srgbClr val="D9DEE6"/>
-                      </a:solidFill>
-                      <a:prstDash val="solid"/>
-                      <a:round/>
-                      <a:headEnd type="none" w="med" len="med"/>
-                      <a:tailEnd type="none" w="med" len="med"/>
-                    </a:lnR>
-                    <a:lnT w="9525" cap="flat" cmpd="sng" algn="ctr">
-                      <a:solidFill>
-                        <a:srgbClr val="D9DEE6"/>
-                      </a:solidFill>
-                      <a:prstDash val="solid"/>
-                      <a:round/>
-                      <a:headEnd type="none" w="med" len="med"/>
-                      <a:tailEnd type="none" w="med" len="med"/>
-                    </a:lnT>
-                    <a:lnB w="9525" cap="flat" cmpd="sng" algn="ctr">
-                      <a:solidFill>
-                        <a:srgbClr val="D9DEE6"/>
-                      </a:solidFill>
-                      <a:prstDash val="solid"/>
-                      <a:round/>
-                      <a:headEnd type="none" w="med" len="med"/>
-                      <a:tailEnd type="none" w="med" len="med"/>
-                    </a:lnB>
-                    <a:solidFill>
-                      <a:srgbClr val="0F1B2D"/>
-                    </a:solidFill>
-                  </a:tcPr>
-                </a:tc>
-                <a:tc>
-                  <a:txBody>
-                    <a:bodyPr/>
-                    <a:lstStyle/>
-                    <a:p>
-                      <a:pPr algn="l" indent="0" marL="0">
-                        <a:buNone/>
-                      </a:pPr>
-                      <a:r>
-                        <a:rPr lang="en-US" sz="1200" b="1" dirty="0">
-                          <a:solidFill>
-                            <a:srgbClr val="FFFFFF"/>
-                          </a:solidFill>
-                          <a:latin typeface="Arial" pitchFamily="34" charset="0"/>
-                          <a:ea typeface="Arial" pitchFamily="34" charset="-122"/>
-                          <a:cs typeface="Arial" pitchFamily="34" charset="-120"/>
-                        </a:rPr>
-                        <a:t>AI · HW+SW</a:t>
+                        <a:t>최적화 루프 결과</a:t>
                       </a:r>
                       <a:endParaRPr lang="en-US" sz="1200" dirty="0">
                         <a:latin typeface="Arial" charset="0"/>
@@ -3582,7 +3703,7 @@
                           <a:ea typeface="Arial" pitchFamily="34" charset="-122"/>
                           <a:cs typeface="Arial" pitchFamily="34" charset="-120"/>
                         </a:rPr>
-                        <a:t>≤ 170</a:t>
+                        <a:t>Base</a:t>
                       </a:r>
                       <a:endParaRPr lang="en-US" sz="1200" dirty="0">
                         <a:latin typeface="Arial" charset="0"/>
@@ -3710,83 +3831,15 @@
                         <a:buNone/>
                       </a:pPr>
                       <a:r>
-                        <a:rPr lang="en-US" sz="1200" dirty="0">
+                        <a:rPr lang="en-US" sz="1200" b="1" dirty="0">
                           <a:solidFill>
-                            <a:srgbClr val="0F1B2D"/>
+                            <a:srgbClr val="B8791F"/>
                           </a:solidFill>
                           <a:latin typeface="Arial" pitchFamily="34" charset="0"/>
                           <a:ea typeface="Arial" pitchFamily="34" charset="-122"/>
                           <a:cs typeface="Arial" pitchFamily="34" charset="-120"/>
                         </a:rPr>
-                        <a:t>−__%</a:t>
-                      </a:r>
-                      <a:endParaRPr lang="en-US" sz="1200" dirty="0">
-                        <a:latin typeface="Arial" charset="0"/>
-                        <a:ea typeface="Arial" charset="0"/>
-                        <a:cs typeface="Arial" charset="0"/>
-                      </a:endParaRPr>
-                    </a:p>
-                  </a:txBody>
-                  <a:tcPr marL="127000" marR="127000" marT="76200" marB="76200" anchor="ctr">
-                    <a:lnL w="9525" cap="flat" cmpd="sng" algn="ctr">
-                      <a:solidFill>
-                        <a:srgbClr val="D9DEE6"/>
-                      </a:solidFill>
-                      <a:prstDash val="solid"/>
-                      <a:round/>
-                      <a:headEnd type="none" w="med" len="med"/>
-                      <a:tailEnd type="none" w="med" len="med"/>
-                    </a:lnL>
-                    <a:lnR w="9525" cap="flat" cmpd="sng" algn="ctr">
-                      <a:solidFill>
-                        <a:srgbClr val="D9DEE6"/>
-                      </a:solidFill>
-                      <a:prstDash val="solid"/>
-                      <a:round/>
-                      <a:headEnd type="none" w="med" len="med"/>
-                      <a:tailEnd type="none" w="med" len="med"/>
-                    </a:lnR>
-                    <a:lnT w="9525" cap="flat" cmpd="sng" algn="ctr">
-                      <a:solidFill>
-                        <a:srgbClr val="D9DEE6"/>
-                      </a:solidFill>
-                      <a:prstDash val="solid"/>
-                      <a:round/>
-                      <a:headEnd type="none" w="med" len="med"/>
-                      <a:tailEnd type="none" w="med" len="med"/>
-                    </a:lnT>
-                    <a:lnB w="9525" cap="flat" cmpd="sng" algn="ctr">
-                      <a:solidFill>
-                        <a:srgbClr val="D9DEE6"/>
-                      </a:solidFill>
-                      <a:prstDash val="solid"/>
-                      <a:round/>
-                      <a:headEnd type="none" w="med" len="med"/>
-                      <a:tailEnd type="none" w="med" len="med"/>
-                    </a:lnB>
-                    <a:solidFill>
-                      <a:srgbClr val="FFFFFF"/>
-                    </a:solidFill>
-                  </a:tcPr>
-                </a:tc>
-                <a:tc>
-                  <a:txBody>
-                    <a:bodyPr/>
-                    <a:lstStyle/>
-                    <a:p>
-                      <a:pPr algn="l" indent="0" marL="0">
-                        <a:buNone/>
-                      </a:pPr>
-                      <a:r>
-                        <a:rPr lang="en-US" sz="1200" dirty="0">
-                          <a:solidFill>
-                            <a:srgbClr val="0F1B2D"/>
-                          </a:solidFill>
-                          <a:latin typeface="Arial" pitchFamily="34" charset="0"/>
-                          <a:ea typeface="Arial" pitchFamily="34" charset="-122"/>
-                          <a:cs typeface="Arial" pitchFamily="34" charset="-120"/>
-                        </a:rPr>
-                        <a:t>−__% · 면적 [___]</a:t>
+                        <a:t>[___] M · −[__]%</a:t>
                       </a:r>
                       <a:endParaRPr lang="en-US" sz="1200" dirty="0">
                         <a:latin typeface="Arial" charset="0"/>
@@ -3856,7 +3909,862 @@
                           <a:ea typeface="Arial" pitchFamily="34" charset="-122"/>
                           <a:cs typeface="Arial" pitchFamily="34" charset="-120"/>
                         </a:rPr>
-                        <a:t>≤ 280</a:t>
+                        <a:t>Base + TCM</a:t>
+                      </a:r>
+                      <a:endParaRPr lang="en-US" sz="1200" dirty="0">
+                        <a:latin typeface="Arial" charset="0"/>
+                        <a:ea typeface="Arial" charset="0"/>
+                        <a:cs typeface="Arial" charset="0"/>
+                      </a:endParaRPr>
+                    </a:p>
+                  </a:txBody>
+                  <a:tcPr marL="127000" marR="127000" marT="76200" marB="76200" anchor="ctr">
+                    <a:lnL w="9525" cap="flat" cmpd="sng" algn="ctr">
+                      <a:solidFill>
+                        <a:srgbClr val="D9DEE6"/>
+                      </a:solidFill>
+                      <a:prstDash val="solid"/>
+                      <a:round/>
+                      <a:headEnd type="none" w="med" len="med"/>
+                      <a:tailEnd type="none" w="med" len="med"/>
+                    </a:lnL>
+                    <a:lnR w="9525" cap="flat" cmpd="sng" algn="ctr">
+                      <a:solidFill>
+                        <a:srgbClr val="D9DEE6"/>
+                      </a:solidFill>
+                      <a:prstDash val="solid"/>
+                      <a:round/>
+                      <a:headEnd type="none" w="med" len="med"/>
+                      <a:tailEnd type="none" w="med" len="med"/>
+                    </a:lnR>
+                    <a:lnT w="9525" cap="flat" cmpd="sng" algn="ctr">
+                      <a:solidFill>
+                        <a:srgbClr val="D9DEE6"/>
+                      </a:solidFill>
+                      <a:prstDash val="solid"/>
+                      <a:round/>
+                      <a:headEnd type="none" w="med" len="med"/>
+                      <a:tailEnd type="none" w="med" len="med"/>
+                    </a:lnT>
+                    <a:lnB w="9525" cap="flat" cmpd="sng" algn="ctr">
+                      <a:solidFill>
+                        <a:srgbClr val="D9DEE6"/>
+                      </a:solidFill>
+                      <a:prstDash val="solid"/>
+                      <a:round/>
+                      <a:headEnd type="none" w="med" len="med"/>
+                      <a:tailEnd type="none" w="med" len="med"/>
+                    </a:lnB>
+                    <a:solidFill>
+                      <a:srgbClr val="F2F4F7"/>
+                    </a:solidFill>
+                  </a:tcPr>
+                </a:tc>
+                <a:tc>
+                  <a:txBody>
+                    <a:bodyPr/>
+                    <a:lstStyle/>
+                    <a:p>
+                      <a:pPr algn="l" indent="0" marL="0">
+                        <a:buNone/>
+                      </a:pPr>
+                      <a:r>
+                        <a:rPr lang="en-US" sz="1200" dirty="0">
+                          <a:solidFill>
+                            <a:srgbClr val="0F1B2D"/>
+                          </a:solidFill>
+                          <a:latin typeface="Arial" pitchFamily="34" charset="0"/>
+                          <a:ea typeface="Arial" pitchFamily="34" charset="-122"/>
+                          <a:cs typeface="Arial" pitchFamily="34" charset="-120"/>
+                        </a:rPr>
+                        <a:t>[___] M</a:t>
+                      </a:r>
+                      <a:endParaRPr lang="en-US" sz="1200" dirty="0">
+                        <a:latin typeface="Arial" charset="0"/>
+                        <a:ea typeface="Arial" charset="0"/>
+                        <a:cs typeface="Arial" charset="0"/>
+                      </a:endParaRPr>
+                    </a:p>
+                  </a:txBody>
+                  <a:tcPr marL="127000" marR="127000" marT="76200" marB="76200" anchor="ctr">
+                    <a:lnL w="9525" cap="flat" cmpd="sng" algn="ctr">
+                      <a:solidFill>
+                        <a:srgbClr val="D9DEE6"/>
+                      </a:solidFill>
+                      <a:prstDash val="solid"/>
+                      <a:round/>
+                      <a:headEnd type="none" w="med" len="med"/>
+                      <a:tailEnd type="none" w="med" len="med"/>
+                    </a:lnL>
+                    <a:lnR w="9525" cap="flat" cmpd="sng" algn="ctr">
+                      <a:solidFill>
+                        <a:srgbClr val="D9DEE6"/>
+                      </a:solidFill>
+                      <a:prstDash val="solid"/>
+                      <a:round/>
+                      <a:headEnd type="none" w="med" len="med"/>
+                      <a:tailEnd type="none" w="med" len="med"/>
+                    </a:lnR>
+                    <a:lnT w="9525" cap="flat" cmpd="sng" algn="ctr">
+                      <a:solidFill>
+                        <a:srgbClr val="D9DEE6"/>
+                      </a:solidFill>
+                      <a:prstDash val="solid"/>
+                      <a:round/>
+                      <a:headEnd type="none" w="med" len="med"/>
+                      <a:tailEnd type="none" w="med" len="med"/>
+                    </a:lnT>
+                    <a:lnB w="9525" cap="flat" cmpd="sng" algn="ctr">
+                      <a:solidFill>
+                        <a:srgbClr val="D9DEE6"/>
+                      </a:solidFill>
+                      <a:prstDash val="solid"/>
+                      <a:round/>
+                      <a:headEnd type="none" w="med" len="med"/>
+                      <a:tailEnd type="none" w="med" len="med"/>
+                    </a:lnB>
+                    <a:solidFill>
+                      <a:srgbClr val="F2F4F7"/>
+                    </a:solidFill>
+                  </a:tcPr>
+                </a:tc>
+                <a:tc>
+                  <a:txBody>
+                    <a:bodyPr/>
+                    <a:lstStyle/>
+                    <a:p>
+                      <a:pPr algn="l" indent="0" marL="0">
+                        <a:buNone/>
+                      </a:pPr>
+                      <a:r>
+                        <a:rPr lang="en-US" sz="1200" b="1" dirty="0">
+                          <a:solidFill>
+                            <a:srgbClr val="B8791F"/>
+                          </a:solidFill>
+                          <a:latin typeface="Arial" pitchFamily="34" charset="0"/>
+                          <a:ea typeface="Arial" pitchFamily="34" charset="-122"/>
+                          <a:cs typeface="Arial" pitchFamily="34" charset="-120"/>
+                        </a:rPr>
+                        <a:t>[___] M · −[__]%</a:t>
+                      </a:r>
+                      <a:endParaRPr lang="en-US" sz="1200" dirty="0">
+                        <a:latin typeface="Arial" charset="0"/>
+                        <a:ea typeface="Arial" charset="0"/>
+                        <a:cs typeface="Arial" charset="0"/>
+                      </a:endParaRPr>
+                    </a:p>
+                  </a:txBody>
+                  <a:tcPr marL="127000" marR="127000" marT="76200" marB="76200" anchor="ctr">
+                    <a:lnL w="9525" cap="flat" cmpd="sng" algn="ctr">
+                      <a:solidFill>
+                        <a:srgbClr val="D9DEE6"/>
+                      </a:solidFill>
+                      <a:prstDash val="solid"/>
+                      <a:round/>
+                      <a:headEnd type="none" w="med" len="med"/>
+                      <a:tailEnd type="none" w="med" len="med"/>
+                    </a:lnL>
+                    <a:lnR w="9525" cap="flat" cmpd="sng" algn="ctr">
+                      <a:solidFill>
+                        <a:srgbClr val="D9DEE6"/>
+                      </a:solidFill>
+                      <a:prstDash val="solid"/>
+                      <a:round/>
+                      <a:headEnd type="none" w="med" len="med"/>
+                      <a:tailEnd type="none" w="med" len="med"/>
+                    </a:lnR>
+                    <a:lnT w="9525" cap="flat" cmpd="sng" algn="ctr">
+                      <a:solidFill>
+                        <a:srgbClr val="D9DEE6"/>
+                      </a:solidFill>
+                      <a:prstDash val="solid"/>
+                      <a:round/>
+                      <a:headEnd type="none" w="med" len="med"/>
+                      <a:tailEnd type="none" w="med" len="med"/>
+                    </a:lnT>
+                    <a:lnB w="9525" cap="flat" cmpd="sng" algn="ctr">
+                      <a:solidFill>
+                        <a:srgbClr val="D9DEE6"/>
+                      </a:solidFill>
+                      <a:prstDash val="solid"/>
+                      <a:round/>
+                      <a:headEnd type="none" w="med" len="med"/>
+                      <a:tailEnd type="none" w="med" len="med"/>
+                    </a:lnB>
+                    <a:solidFill>
+                      <a:srgbClr val="F2F4F7"/>
+                    </a:solidFill>
+                  </a:tcPr>
+                </a:tc>
+              </a:tr>
+              <a:tr h="355702">
+                <a:tc>
+                  <a:txBody>
+                    <a:bodyPr/>
+                    <a:lstStyle/>
+                    <a:p>
+                      <a:pPr algn="l" indent="0" marL="0">
+                        <a:buNone/>
+                      </a:pPr>
+                      <a:r>
+                        <a:rPr lang="en-US" sz="1200" dirty="0">
+                          <a:solidFill>
+                            <a:srgbClr val="0F1B2D"/>
+                          </a:solidFill>
+                          <a:latin typeface="Arial" pitchFamily="34" charset="0"/>
+                          <a:ea typeface="Arial" pitchFamily="34" charset="-122"/>
+                          <a:cs typeface="Arial" pitchFamily="34" charset="-120"/>
+                        </a:rPr>
+                        <a:t>Base + TCM + MAC</a:t>
+                      </a:r>
+                      <a:endParaRPr lang="en-US" sz="1200" dirty="0">
+                        <a:latin typeface="Arial" charset="0"/>
+                        <a:ea typeface="Arial" charset="0"/>
+                        <a:cs typeface="Arial" charset="0"/>
+                      </a:endParaRPr>
+                    </a:p>
+                  </a:txBody>
+                  <a:tcPr marL="127000" marR="127000" marT="76200" marB="76200" anchor="ctr">
+                    <a:lnL w="9525" cap="flat" cmpd="sng" algn="ctr">
+                      <a:solidFill>
+                        <a:srgbClr val="D9DEE6"/>
+                      </a:solidFill>
+                      <a:prstDash val="solid"/>
+                      <a:round/>
+                      <a:headEnd type="none" w="med" len="med"/>
+                      <a:tailEnd type="none" w="med" len="med"/>
+                    </a:lnL>
+                    <a:lnR w="9525" cap="flat" cmpd="sng" algn="ctr">
+                      <a:solidFill>
+                        <a:srgbClr val="D9DEE6"/>
+                      </a:solidFill>
+                      <a:prstDash val="solid"/>
+                      <a:round/>
+                      <a:headEnd type="none" w="med" len="med"/>
+                      <a:tailEnd type="none" w="med" len="med"/>
+                    </a:lnR>
+                    <a:lnT w="9525" cap="flat" cmpd="sng" algn="ctr">
+                      <a:solidFill>
+                        <a:srgbClr val="D9DEE6"/>
+                      </a:solidFill>
+                      <a:prstDash val="solid"/>
+                      <a:round/>
+                      <a:headEnd type="none" w="med" len="med"/>
+                      <a:tailEnd type="none" w="med" len="med"/>
+                    </a:lnT>
+                    <a:lnB w="9525" cap="flat" cmpd="sng" algn="ctr">
+                      <a:solidFill>
+                        <a:srgbClr val="D9DEE6"/>
+                      </a:solidFill>
+                      <a:prstDash val="solid"/>
+                      <a:round/>
+                      <a:headEnd type="none" w="med" len="med"/>
+                      <a:tailEnd type="none" w="med" len="med"/>
+                    </a:lnB>
+                    <a:solidFill>
+                      <a:srgbClr val="FFFFFF"/>
+                    </a:solidFill>
+                  </a:tcPr>
+                </a:tc>
+                <a:tc>
+                  <a:txBody>
+                    <a:bodyPr/>
+                    <a:lstStyle/>
+                    <a:p>
+                      <a:pPr algn="l" indent="0" marL="0">
+                        <a:buNone/>
+                      </a:pPr>
+                      <a:r>
+                        <a:rPr lang="en-US" sz="1200" dirty="0">
+                          <a:solidFill>
+                            <a:srgbClr val="0F1B2D"/>
+                          </a:solidFill>
+                          <a:latin typeface="Arial" pitchFamily="34" charset="0"/>
+                          <a:ea typeface="Arial" pitchFamily="34" charset="-122"/>
+                          <a:cs typeface="Arial" pitchFamily="34" charset="-120"/>
+                        </a:rPr>
+                        <a:t>[___] M</a:t>
+                      </a:r>
+                      <a:endParaRPr lang="en-US" sz="1200" dirty="0">
+                        <a:latin typeface="Arial" charset="0"/>
+                        <a:ea typeface="Arial" charset="0"/>
+                        <a:cs typeface="Arial" charset="0"/>
+                      </a:endParaRPr>
+                    </a:p>
+                  </a:txBody>
+                  <a:tcPr marL="127000" marR="127000" marT="76200" marB="76200" anchor="ctr">
+                    <a:lnL w="9525" cap="flat" cmpd="sng" algn="ctr">
+                      <a:solidFill>
+                        <a:srgbClr val="D9DEE6"/>
+                      </a:solidFill>
+                      <a:prstDash val="solid"/>
+                      <a:round/>
+                      <a:headEnd type="none" w="med" len="med"/>
+                      <a:tailEnd type="none" w="med" len="med"/>
+                    </a:lnL>
+                    <a:lnR w="9525" cap="flat" cmpd="sng" algn="ctr">
+                      <a:solidFill>
+                        <a:srgbClr val="D9DEE6"/>
+                      </a:solidFill>
+                      <a:prstDash val="solid"/>
+                      <a:round/>
+                      <a:headEnd type="none" w="med" len="med"/>
+                      <a:tailEnd type="none" w="med" len="med"/>
+                    </a:lnR>
+                    <a:lnT w="9525" cap="flat" cmpd="sng" algn="ctr">
+                      <a:solidFill>
+                        <a:srgbClr val="D9DEE6"/>
+                      </a:solidFill>
+                      <a:prstDash val="solid"/>
+                      <a:round/>
+                      <a:headEnd type="none" w="med" len="med"/>
+                      <a:tailEnd type="none" w="med" len="med"/>
+                    </a:lnT>
+                    <a:lnB w="9525" cap="flat" cmpd="sng" algn="ctr">
+                      <a:solidFill>
+                        <a:srgbClr val="D9DEE6"/>
+                      </a:solidFill>
+                      <a:prstDash val="solid"/>
+                      <a:round/>
+                      <a:headEnd type="none" w="med" len="med"/>
+                      <a:tailEnd type="none" w="med" len="med"/>
+                    </a:lnB>
+                    <a:solidFill>
+                      <a:srgbClr val="FFFFFF"/>
+                    </a:solidFill>
+                  </a:tcPr>
+                </a:tc>
+                <a:tc>
+                  <a:txBody>
+                    <a:bodyPr/>
+                    <a:lstStyle/>
+                    <a:p>
+                      <a:pPr algn="l" indent="0" marL="0">
+                        <a:buNone/>
+                      </a:pPr>
+                      <a:r>
+                        <a:rPr lang="en-US" sz="1200" b="1" dirty="0">
+                          <a:solidFill>
+                            <a:srgbClr val="B8791F"/>
+                          </a:solidFill>
+                          <a:latin typeface="Arial" pitchFamily="34" charset="0"/>
+                          <a:ea typeface="Arial" pitchFamily="34" charset="-122"/>
+                          <a:cs typeface="Arial" pitchFamily="34" charset="-120"/>
+                        </a:rPr>
+                        <a:t>[___] M · −[__]%</a:t>
+                      </a:r>
+                      <a:endParaRPr lang="en-US" sz="1200" dirty="0">
+                        <a:latin typeface="Arial" charset="0"/>
+                        <a:ea typeface="Arial" charset="0"/>
+                        <a:cs typeface="Arial" charset="0"/>
+                      </a:endParaRPr>
+                    </a:p>
+                  </a:txBody>
+                  <a:tcPr marL="127000" marR="127000" marT="76200" marB="76200" anchor="ctr">
+                    <a:lnL w="9525" cap="flat" cmpd="sng" algn="ctr">
+                      <a:solidFill>
+                        <a:srgbClr val="D9DEE6"/>
+                      </a:solidFill>
+                      <a:prstDash val="solid"/>
+                      <a:round/>
+                      <a:headEnd type="none" w="med" len="med"/>
+                      <a:tailEnd type="none" w="med" len="med"/>
+                    </a:lnL>
+                    <a:lnR w="9525" cap="flat" cmpd="sng" algn="ctr">
+                      <a:solidFill>
+                        <a:srgbClr val="D9DEE6"/>
+                      </a:solidFill>
+                      <a:prstDash val="solid"/>
+                      <a:round/>
+                      <a:headEnd type="none" w="med" len="med"/>
+                      <a:tailEnd type="none" w="med" len="med"/>
+                    </a:lnR>
+                    <a:lnT w="9525" cap="flat" cmpd="sng" algn="ctr">
+                      <a:solidFill>
+                        <a:srgbClr val="D9DEE6"/>
+                      </a:solidFill>
+                      <a:prstDash val="solid"/>
+                      <a:round/>
+                      <a:headEnd type="none" w="med" len="med"/>
+                      <a:tailEnd type="none" w="med" len="med"/>
+                    </a:lnT>
+                    <a:lnB w="9525" cap="flat" cmpd="sng" algn="ctr">
+                      <a:solidFill>
+                        <a:srgbClr val="D9DEE6"/>
+                      </a:solidFill>
+                      <a:prstDash val="solid"/>
+                      <a:round/>
+                      <a:headEnd type="none" w="med" len="med"/>
+                      <a:tailEnd type="none" w="med" len="med"/>
+                    </a:lnB>
+                    <a:solidFill>
+                      <a:srgbClr val="FFFFFF"/>
+                    </a:solidFill>
+                  </a:tcPr>
+                </a:tc>
+              </a:tr>
+            </a:tbl>
+          </a:graphicData>
+        </a:graphic>
+      </p:graphicFrame>
+      <p:graphicFrame>
+        <p:nvGraphicFramePr>
+          <p:cNvPr id="21" name="Table 1"/>
+          <p:cNvGraphicFramePr>
+            <a:graphicFrameLocks noGrp="1"/>
+          </p:cNvGraphicFramePr>
+          <p:nvPr>
+            <p:extLst>
+              <p:ext uri="{D42A27DB-BD31-4B8C-83A1-F6EECF244321}">
+                <p14:modId xmlns:p14="http://schemas.microsoft.com/office/powerpoint/2010/main" val="1579011935"/>
+              </p:ext>
+            </p:extLst>
+          </p:nvPr>
+        </p:nvGraphicFramePr>
+        <p:xfrm>
+          <a:off x="6832397" y="3556102"/>
+          <a:ext cx="4850892" cy="914400"/>
+        </p:xfrm>
+        <a:graphic>
+          <a:graphicData uri="http://schemas.openxmlformats.org/drawingml/2006/table">
+            <a:tbl>
+              <a:tblPr/>
+              <a:tblGrid>
+                <a:gridCol w="1904695"/>
+                <a:gridCol w="1333195"/>
+                <a:gridCol w="1613002"/>
+              </a:tblGrid>
+              <a:tr h="355702">
+                <a:tc>
+                  <a:txBody>
+                    <a:bodyPr/>
+                    <a:lstStyle/>
+                    <a:p>
+                      <a:pPr algn="l" indent="0" marL="0">
+                        <a:buNone/>
+                      </a:pPr>
+                      <a:r>
+                        <a:rPr lang="en-US" sz="1200" b="1" dirty="0">
+                          <a:solidFill>
+                            <a:srgbClr val="FFFFFF"/>
+                          </a:solidFill>
+                          <a:latin typeface="Arial" pitchFamily="34" charset="0"/>
+                          <a:ea typeface="Arial" pitchFamily="34" charset="-122"/>
+                          <a:cs typeface="Arial" pitchFamily="34" charset="-120"/>
+                        </a:rPr>
+                        <a:t>HW 구조</a:t>
+                      </a:r>
+                      <a:endParaRPr lang="en-US" sz="1200" dirty="0">
+                        <a:latin typeface="Arial" charset="0"/>
+                        <a:ea typeface="Arial" charset="0"/>
+                        <a:cs typeface="Arial" charset="0"/>
+                      </a:endParaRPr>
+                    </a:p>
+                  </a:txBody>
+                  <a:tcPr marL="127000" marR="127000" marT="76200" marB="76200" anchor="ctr">
+                    <a:lnL w="9525" cap="flat" cmpd="sng" algn="ctr">
+                      <a:solidFill>
+                        <a:srgbClr val="D9DEE6"/>
+                      </a:solidFill>
+                      <a:prstDash val="solid"/>
+                      <a:round/>
+                      <a:headEnd type="none" w="med" len="med"/>
+                      <a:tailEnd type="none" w="med" len="med"/>
+                    </a:lnL>
+                    <a:lnR w="9525" cap="flat" cmpd="sng" algn="ctr">
+                      <a:solidFill>
+                        <a:srgbClr val="D9DEE6"/>
+                      </a:solidFill>
+                      <a:prstDash val="solid"/>
+                      <a:round/>
+                      <a:headEnd type="none" w="med" len="med"/>
+                      <a:tailEnd type="none" w="med" len="med"/>
+                    </a:lnR>
+                    <a:lnT w="9525" cap="flat" cmpd="sng" algn="ctr">
+                      <a:solidFill>
+                        <a:srgbClr val="D9DEE6"/>
+                      </a:solidFill>
+                      <a:prstDash val="solid"/>
+                      <a:round/>
+                      <a:headEnd type="none" w="med" len="med"/>
+                      <a:tailEnd type="none" w="med" len="med"/>
+                    </a:lnT>
+                    <a:lnB w="9525" cap="flat" cmpd="sng" algn="ctr">
+                      <a:solidFill>
+                        <a:srgbClr val="D9DEE6"/>
+                      </a:solidFill>
+                      <a:prstDash val="solid"/>
+                      <a:round/>
+                      <a:headEnd type="none" w="med" len="med"/>
+                      <a:tailEnd type="none" w="med" len="med"/>
+                    </a:lnB>
+                    <a:solidFill>
+                      <a:srgbClr val="0F1B2D"/>
+                    </a:solidFill>
+                  </a:tcPr>
+                </a:tc>
+                <a:tc>
+                  <a:txBody>
+                    <a:bodyPr/>
+                    <a:lstStyle/>
+                    <a:p>
+                      <a:pPr algn="l" indent="0" marL="0">
+                        <a:buNone/>
+                      </a:pPr>
+                      <a:r>
+                        <a:rPr lang="en-US" sz="1200" b="1" dirty="0">
+                          <a:solidFill>
+                            <a:srgbClr val="FFFFFF"/>
+                          </a:solidFill>
+                          <a:latin typeface="Arial" pitchFamily="34" charset="0"/>
+                          <a:ea typeface="Arial" pitchFamily="34" charset="-122"/>
+                          <a:cs typeface="Arial" pitchFamily="34" charset="-120"/>
+                        </a:rPr>
+                        <a:t>초기 면적 (상대)</a:t>
+                      </a:r>
+                      <a:endParaRPr lang="en-US" sz="1200" dirty="0">
+                        <a:latin typeface="Arial" charset="0"/>
+                        <a:ea typeface="Arial" charset="0"/>
+                        <a:cs typeface="Arial" charset="0"/>
+                      </a:endParaRPr>
+                    </a:p>
+                  </a:txBody>
+                  <a:tcPr marL="127000" marR="127000" marT="76200" marB="76200" anchor="ctr">
+                    <a:lnL w="9525" cap="flat" cmpd="sng" algn="ctr">
+                      <a:solidFill>
+                        <a:srgbClr val="D9DEE6"/>
+                      </a:solidFill>
+                      <a:prstDash val="solid"/>
+                      <a:round/>
+                      <a:headEnd type="none" w="med" len="med"/>
+                      <a:tailEnd type="none" w="med" len="med"/>
+                    </a:lnL>
+                    <a:lnR w="9525" cap="flat" cmpd="sng" algn="ctr">
+                      <a:solidFill>
+                        <a:srgbClr val="D9DEE6"/>
+                      </a:solidFill>
+                      <a:prstDash val="solid"/>
+                      <a:round/>
+                      <a:headEnd type="none" w="med" len="med"/>
+                      <a:tailEnd type="none" w="med" len="med"/>
+                    </a:lnR>
+                    <a:lnT w="9525" cap="flat" cmpd="sng" algn="ctr">
+                      <a:solidFill>
+                        <a:srgbClr val="D9DEE6"/>
+                      </a:solidFill>
+                      <a:prstDash val="solid"/>
+                      <a:round/>
+                      <a:headEnd type="none" w="med" len="med"/>
+                      <a:tailEnd type="none" w="med" len="med"/>
+                    </a:lnT>
+                    <a:lnB w="9525" cap="flat" cmpd="sng" algn="ctr">
+                      <a:solidFill>
+                        <a:srgbClr val="D9DEE6"/>
+                      </a:solidFill>
+                      <a:prstDash val="solid"/>
+                      <a:round/>
+                      <a:headEnd type="none" w="med" len="med"/>
+                      <a:tailEnd type="none" w="med" len="med"/>
+                    </a:lnB>
+                    <a:solidFill>
+                      <a:srgbClr val="0F1B2D"/>
+                    </a:solidFill>
+                  </a:tcPr>
+                </a:tc>
+                <a:tc>
+                  <a:txBody>
+                    <a:bodyPr/>
+                    <a:lstStyle/>
+                    <a:p>
+                      <a:pPr algn="l" indent="0" marL="0">
+                        <a:buNone/>
+                      </a:pPr>
+                      <a:r>
+                        <a:rPr lang="en-US" sz="1200" b="1" dirty="0">
+                          <a:solidFill>
+                            <a:srgbClr val="FFFFFF"/>
+                          </a:solidFill>
+                          <a:latin typeface="Arial" pitchFamily="34" charset="0"/>
+                          <a:ea typeface="Arial" pitchFamily="34" charset="-122"/>
+                          <a:cs typeface="Arial" pitchFamily="34" charset="-120"/>
+                        </a:rPr>
+                        <a:t>최적화 루프 결과</a:t>
+                      </a:r>
+                      <a:endParaRPr lang="en-US" sz="1200" dirty="0">
+                        <a:latin typeface="Arial" charset="0"/>
+                        <a:ea typeface="Arial" charset="0"/>
+                        <a:cs typeface="Arial" charset="0"/>
+                      </a:endParaRPr>
+                    </a:p>
+                  </a:txBody>
+                  <a:tcPr marL="127000" marR="127000" marT="76200" marB="76200" anchor="ctr">
+                    <a:lnL w="9525" cap="flat" cmpd="sng" algn="ctr">
+                      <a:solidFill>
+                        <a:srgbClr val="D9DEE6"/>
+                      </a:solidFill>
+                      <a:prstDash val="solid"/>
+                      <a:round/>
+                      <a:headEnd type="none" w="med" len="med"/>
+                      <a:tailEnd type="none" w="med" len="med"/>
+                    </a:lnL>
+                    <a:lnR w="9525" cap="flat" cmpd="sng" algn="ctr">
+                      <a:solidFill>
+                        <a:srgbClr val="D9DEE6"/>
+                      </a:solidFill>
+                      <a:prstDash val="solid"/>
+                      <a:round/>
+                      <a:headEnd type="none" w="med" len="med"/>
+                      <a:tailEnd type="none" w="med" len="med"/>
+                    </a:lnR>
+                    <a:lnT w="9525" cap="flat" cmpd="sng" algn="ctr">
+                      <a:solidFill>
+                        <a:srgbClr val="D9DEE6"/>
+                      </a:solidFill>
+                      <a:prstDash val="solid"/>
+                      <a:round/>
+                      <a:headEnd type="none" w="med" len="med"/>
+                      <a:tailEnd type="none" w="med" len="med"/>
+                    </a:lnT>
+                    <a:lnB w="9525" cap="flat" cmpd="sng" algn="ctr">
+                      <a:solidFill>
+                        <a:srgbClr val="D9DEE6"/>
+                      </a:solidFill>
+                      <a:prstDash val="solid"/>
+                      <a:round/>
+                      <a:headEnd type="none" w="med" len="med"/>
+                      <a:tailEnd type="none" w="med" len="med"/>
+                    </a:lnB>
+                    <a:solidFill>
+                      <a:srgbClr val="0F1B2D"/>
+                    </a:solidFill>
+                  </a:tcPr>
+                </a:tc>
+              </a:tr>
+              <a:tr h="355702">
+                <a:tc>
+                  <a:txBody>
+                    <a:bodyPr/>
+                    <a:lstStyle/>
+                    <a:p>
+                      <a:pPr algn="l" indent="0" marL="0">
+                        <a:buNone/>
+                      </a:pPr>
+                      <a:r>
+                        <a:rPr lang="en-US" sz="1200" dirty="0">
+                          <a:solidFill>
+                            <a:srgbClr val="0F1B2D"/>
+                          </a:solidFill>
+                          <a:latin typeface="Arial" pitchFamily="34" charset="0"/>
+                          <a:ea typeface="Arial" pitchFamily="34" charset="-122"/>
+                          <a:cs typeface="Arial" pitchFamily="34" charset="-120"/>
+                        </a:rPr>
+                        <a:t>Base</a:t>
+                      </a:r>
+                      <a:endParaRPr lang="en-US" sz="1200" dirty="0">
+                        <a:latin typeface="Arial" charset="0"/>
+                        <a:ea typeface="Arial" charset="0"/>
+                        <a:cs typeface="Arial" charset="0"/>
+                      </a:endParaRPr>
+                    </a:p>
+                  </a:txBody>
+                  <a:tcPr marL="127000" marR="127000" marT="76200" marB="76200" anchor="ctr">
+                    <a:lnL w="9525" cap="flat" cmpd="sng" algn="ctr">
+                      <a:solidFill>
+                        <a:srgbClr val="D9DEE6"/>
+                      </a:solidFill>
+                      <a:prstDash val="solid"/>
+                      <a:round/>
+                      <a:headEnd type="none" w="med" len="med"/>
+                      <a:tailEnd type="none" w="med" len="med"/>
+                    </a:lnL>
+                    <a:lnR w="9525" cap="flat" cmpd="sng" algn="ctr">
+                      <a:solidFill>
+                        <a:srgbClr val="D9DEE6"/>
+                      </a:solidFill>
+                      <a:prstDash val="solid"/>
+                      <a:round/>
+                      <a:headEnd type="none" w="med" len="med"/>
+                      <a:tailEnd type="none" w="med" len="med"/>
+                    </a:lnR>
+                    <a:lnT w="9525" cap="flat" cmpd="sng" algn="ctr">
+                      <a:solidFill>
+                        <a:srgbClr val="D9DEE6"/>
+                      </a:solidFill>
+                      <a:prstDash val="solid"/>
+                      <a:round/>
+                      <a:headEnd type="none" w="med" len="med"/>
+                      <a:tailEnd type="none" w="med" len="med"/>
+                    </a:lnT>
+                    <a:lnB w="9525" cap="flat" cmpd="sng" algn="ctr">
+                      <a:solidFill>
+                        <a:srgbClr val="D9DEE6"/>
+                      </a:solidFill>
+                      <a:prstDash val="solid"/>
+                      <a:round/>
+                      <a:headEnd type="none" w="med" len="med"/>
+                      <a:tailEnd type="none" w="med" len="med"/>
+                    </a:lnB>
+                    <a:solidFill>
+                      <a:srgbClr val="FFFFFF"/>
+                    </a:solidFill>
+                  </a:tcPr>
+                </a:tc>
+                <a:tc>
+                  <a:txBody>
+                    <a:bodyPr/>
+                    <a:lstStyle/>
+                    <a:p>
+                      <a:pPr algn="l" indent="0" marL="0">
+                        <a:buNone/>
+                      </a:pPr>
+                      <a:r>
+                        <a:rPr lang="en-US" sz="1200" dirty="0">
+                          <a:solidFill>
+                            <a:srgbClr val="0F1B2D"/>
+                          </a:solidFill>
+                          <a:latin typeface="Arial" pitchFamily="34" charset="0"/>
+                          <a:ea typeface="Arial" pitchFamily="34" charset="-122"/>
+                          <a:cs typeface="Arial" pitchFamily="34" charset="-120"/>
+                        </a:rPr>
+                        <a:t>[___]</a:t>
+                      </a:r>
+                      <a:endParaRPr lang="en-US" sz="1200" dirty="0">
+                        <a:latin typeface="Arial" charset="0"/>
+                        <a:ea typeface="Arial" charset="0"/>
+                        <a:cs typeface="Arial" charset="0"/>
+                      </a:endParaRPr>
+                    </a:p>
+                  </a:txBody>
+                  <a:tcPr marL="127000" marR="127000" marT="76200" marB="76200" anchor="ctr">
+                    <a:lnL w="9525" cap="flat" cmpd="sng" algn="ctr">
+                      <a:solidFill>
+                        <a:srgbClr val="D9DEE6"/>
+                      </a:solidFill>
+                      <a:prstDash val="solid"/>
+                      <a:round/>
+                      <a:headEnd type="none" w="med" len="med"/>
+                      <a:tailEnd type="none" w="med" len="med"/>
+                    </a:lnL>
+                    <a:lnR w="9525" cap="flat" cmpd="sng" algn="ctr">
+                      <a:solidFill>
+                        <a:srgbClr val="D9DEE6"/>
+                      </a:solidFill>
+                      <a:prstDash val="solid"/>
+                      <a:round/>
+                      <a:headEnd type="none" w="med" len="med"/>
+                      <a:tailEnd type="none" w="med" len="med"/>
+                    </a:lnR>
+                    <a:lnT w="9525" cap="flat" cmpd="sng" algn="ctr">
+                      <a:solidFill>
+                        <a:srgbClr val="D9DEE6"/>
+                      </a:solidFill>
+                      <a:prstDash val="solid"/>
+                      <a:round/>
+                      <a:headEnd type="none" w="med" len="med"/>
+                      <a:tailEnd type="none" w="med" len="med"/>
+                    </a:lnT>
+                    <a:lnB w="9525" cap="flat" cmpd="sng" algn="ctr">
+                      <a:solidFill>
+                        <a:srgbClr val="D9DEE6"/>
+                      </a:solidFill>
+                      <a:prstDash val="solid"/>
+                      <a:round/>
+                      <a:headEnd type="none" w="med" len="med"/>
+                      <a:tailEnd type="none" w="med" len="med"/>
+                    </a:lnB>
+                    <a:solidFill>
+                      <a:srgbClr val="FFFFFF"/>
+                    </a:solidFill>
+                  </a:tcPr>
+                </a:tc>
+                <a:tc>
+                  <a:txBody>
+                    <a:bodyPr/>
+                    <a:lstStyle/>
+                    <a:p>
+                      <a:pPr algn="l" indent="0" marL="0">
+                        <a:buNone/>
+                      </a:pPr>
+                      <a:r>
+                        <a:rPr lang="en-US" sz="1200" b="1" dirty="0">
+                          <a:solidFill>
+                            <a:srgbClr val="B8791F"/>
+                          </a:solidFill>
+                          <a:latin typeface="Arial" pitchFamily="34" charset="0"/>
+                          <a:ea typeface="Arial" pitchFamily="34" charset="-122"/>
+                          <a:cs typeface="Arial" pitchFamily="34" charset="-120"/>
+                        </a:rPr>
+                        <a:t>[___] · −[__]%</a:t>
+                      </a:r>
+                      <a:endParaRPr lang="en-US" sz="1200" dirty="0">
+                        <a:latin typeface="Arial" charset="0"/>
+                        <a:ea typeface="Arial" charset="0"/>
+                        <a:cs typeface="Arial" charset="0"/>
+                      </a:endParaRPr>
+                    </a:p>
+                  </a:txBody>
+                  <a:tcPr marL="127000" marR="127000" marT="76200" marB="76200" anchor="ctr">
+                    <a:lnL w="9525" cap="flat" cmpd="sng" algn="ctr">
+                      <a:solidFill>
+                        <a:srgbClr val="D9DEE6"/>
+                      </a:solidFill>
+                      <a:prstDash val="solid"/>
+                      <a:round/>
+                      <a:headEnd type="none" w="med" len="med"/>
+                      <a:tailEnd type="none" w="med" len="med"/>
+                    </a:lnL>
+                    <a:lnR w="9525" cap="flat" cmpd="sng" algn="ctr">
+                      <a:solidFill>
+                        <a:srgbClr val="D9DEE6"/>
+                      </a:solidFill>
+                      <a:prstDash val="solid"/>
+                      <a:round/>
+                      <a:headEnd type="none" w="med" len="med"/>
+                      <a:tailEnd type="none" w="med" len="med"/>
+                    </a:lnR>
+                    <a:lnT w="9525" cap="flat" cmpd="sng" algn="ctr">
+                      <a:solidFill>
+                        <a:srgbClr val="D9DEE6"/>
+                      </a:solidFill>
+                      <a:prstDash val="solid"/>
+                      <a:round/>
+                      <a:headEnd type="none" w="med" len="med"/>
+                      <a:tailEnd type="none" w="med" len="med"/>
+                    </a:lnT>
+                    <a:lnB w="9525" cap="flat" cmpd="sng" algn="ctr">
+                      <a:solidFill>
+                        <a:srgbClr val="D9DEE6"/>
+                      </a:solidFill>
+                      <a:prstDash val="solid"/>
+                      <a:round/>
+                      <a:headEnd type="none" w="med" len="med"/>
+                      <a:tailEnd type="none" w="med" len="med"/>
+                    </a:lnB>
+                    <a:solidFill>
+                      <a:srgbClr val="FFFFFF"/>
+                    </a:solidFill>
+                  </a:tcPr>
+                </a:tc>
+              </a:tr>
+              <a:tr h="355702">
+                <a:tc>
+                  <a:txBody>
+                    <a:bodyPr/>
+                    <a:lstStyle/>
+                    <a:p>
+                      <a:pPr algn="l" indent="0" marL="0">
+                        <a:buNone/>
+                      </a:pPr>
+                      <a:r>
+                        <a:rPr lang="en-US" sz="1200" dirty="0">
+                          <a:solidFill>
+                            <a:srgbClr val="0F1B2D"/>
+                          </a:solidFill>
+                          <a:latin typeface="Arial" pitchFamily="34" charset="0"/>
+                          <a:ea typeface="Arial" pitchFamily="34" charset="-122"/>
+                          <a:cs typeface="Arial" pitchFamily="34" charset="-120"/>
+                        </a:rPr>
+                        <a:t>Base + TCM</a:t>
                       </a:r>
                       <a:endParaRPr lang="en-US" sz="1200" dirty="0">
                         <a:latin typeface="Arial" charset="0"/>
@@ -3984,83 +4892,15 @@
                         <a:buNone/>
                       </a:pPr>
                       <a:r>
-                        <a:rPr lang="en-US" sz="1200" dirty="0">
+                        <a:rPr lang="en-US" sz="1200" b="1" dirty="0">
                           <a:solidFill>
-                            <a:srgbClr val="0F1B2D"/>
+                            <a:srgbClr val="B8791F"/>
                           </a:solidFill>
                           <a:latin typeface="Arial" pitchFamily="34" charset="0"/>
                           <a:ea typeface="Arial" pitchFamily="34" charset="-122"/>
                           <a:cs typeface="Arial" pitchFamily="34" charset="-120"/>
                         </a:rPr>
-                        <a:t>−__%</a:t>
-                      </a:r>
-                      <a:endParaRPr lang="en-US" sz="1200" dirty="0">
-                        <a:latin typeface="Arial" charset="0"/>
-                        <a:ea typeface="Arial" charset="0"/>
-                        <a:cs typeface="Arial" charset="0"/>
-                      </a:endParaRPr>
-                    </a:p>
-                  </a:txBody>
-                  <a:tcPr marL="127000" marR="127000" marT="76200" marB="76200" anchor="ctr">
-                    <a:lnL w="9525" cap="flat" cmpd="sng" algn="ctr">
-                      <a:solidFill>
-                        <a:srgbClr val="D9DEE6"/>
-                      </a:solidFill>
-                      <a:prstDash val="solid"/>
-                      <a:round/>
-                      <a:headEnd type="none" w="med" len="med"/>
-                      <a:tailEnd type="none" w="med" len="med"/>
-                    </a:lnL>
-                    <a:lnR w="9525" cap="flat" cmpd="sng" algn="ctr">
-                      <a:solidFill>
-                        <a:srgbClr val="D9DEE6"/>
-                      </a:solidFill>
-                      <a:prstDash val="solid"/>
-                      <a:round/>
-                      <a:headEnd type="none" w="med" len="med"/>
-                      <a:tailEnd type="none" w="med" len="med"/>
-                    </a:lnR>
-                    <a:lnT w="9525" cap="flat" cmpd="sng" algn="ctr">
-                      <a:solidFill>
-                        <a:srgbClr val="D9DEE6"/>
-                      </a:solidFill>
-                      <a:prstDash val="solid"/>
-                      <a:round/>
-                      <a:headEnd type="none" w="med" len="med"/>
-                      <a:tailEnd type="none" w="med" len="med"/>
-                    </a:lnT>
-                    <a:lnB w="9525" cap="flat" cmpd="sng" algn="ctr">
-                      <a:solidFill>
-                        <a:srgbClr val="D9DEE6"/>
-                      </a:solidFill>
-                      <a:prstDash val="solid"/>
-                      <a:round/>
-                      <a:headEnd type="none" w="med" len="med"/>
-                      <a:tailEnd type="none" w="med" len="med"/>
-                    </a:lnB>
-                    <a:solidFill>
-                      <a:srgbClr val="F2F4F7"/>
-                    </a:solidFill>
-                  </a:tcPr>
-                </a:tc>
-                <a:tc>
-                  <a:txBody>
-                    <a:bodyPr/>
-                    <a:lstStyle/>
-                    <a:p>
-                      <a:pPr algn="l" indent="0" marL="0">
-                        <a:buNone/>
-                      </a:pPr>
-                      <a:r>
-                        <a:rPr lang="en-US" sz="1200" dirty="0">
-                          <a:solidFill>
-                            <a:srgbClr val="0F1B2D"/>
-                          </a:solidFill>
-                          <a:latin typeface="Arial" pitchFamily="34" charset="0"/>
-                          <a:ea typeface="Arial" pitchFamily="34" charset="-122"/>
-                          <a:cs typeface="Arial" pitchFamily="34" charset="-120"/>
-                        </a:rPr>
-                        <a:t>−__% · 면적 [___]</a:t>
+                        <a:t>[___] · −[__]%</a:t>
                       </a:r>
                       <a:endParaRPr lang="en-US" sz="1200" dirty="0">
                         <a:latin typeface="Arial" charset="0"/>
@@ -4130,7 +4970,7 @@
                           <a:ea typeface="Arial" pitchFamily="34" charset="-122"/>
                           <a:cs typeface="Arial" pitchFamily="34" charset="-120"/>
                         </a:rPr>
-                        <a:t>≤ 470</a:t>
+                        <a:t>Base + TCM + MAC</a:t>
                       </a:r>
                       <a:endParaRPr lang="en-US" sz="1200" dirty="0">
                         <a:latin typeface="Arial" charset="0"/>
@@ -4258,83 +5098,15 @@
                         <a:buNone/>
                       </a:pPr>
                       <a:r>
-                        <a:rPr lang="en-US" sz="1200" dirty="0">
+                        <a:rPr lang="en-US" sz="1200" b="1" dirty="0">
                           <a:solidFill>
-                            <a:srgbClr val="0F1B2D"/>
+                            <a:srgbClr val="B8791F"/>
                           </a:solidFill>
                           <a:latin typeface="Arial" pitchFamily="34" charset="0"/>
                           <a:ea typeface="Arial" pitchFamily="34" charset="-122"/>
                           <a:cs typeface="Arial" pitchFamily="34" charset="-120"/>
                         </a:rPr>
-                        <a:t>−__%</a:t>
-                      </a:r>
-                      <a:endParaRPr lang="en-US" sz="1200" dirty="0">
-                        <a:latin typeface="Arial" charset="0"/>
-                        <a:ea typeface="Arial" charset="0"/>
-                        <a:cs typeface="Arial" charset="0"/>
-                      </a:endParaRPr>
-                    </a:p>
-                  </a:txBody>
-                  <a:tcPr marL="127000" marR="127000" marT="76200" marB="76200" anchor="ctr">
-                    <a:lnL w="9525" cap="flat" cmpd="sng" algn="ctr">
-                      <a:solidFill>
-                        <a:srgbClr val="D9DEE6"/>
-                      </a:solidFill>
-                      <a:prstDash val="solid"/>
-                      <a:round/>
-                      <a:headEnd type="none" w="med" len="med"/>
-                      <a:tailEnd type="none" w="med" len="med"/>
-                    </a:lnL>
-                    <a:lnR w="9525" cap="flat" cmpd="sng" algn="ctr">
-                      <a:solidFill>
-                        <a:srgbClr val="D9DEE6"/>
-                      </a:solidFill>
-                      <a:prstDash val="solid"/>
-                      <a:round/>
-                      <a:headEnd type="none" w="med" len="med"/>
-                      <a:tailEnd type="none" w="med" len="med"/>
-                    </a:lnR>
-                    <a:lnT w="9525" cap="flat" cmpd="sng" algn="ctr">
-                      <a:solidFill>
-                        <a:srgbClr val="D9DEE6"/>
-                      </a:solidFill>
-                      <a:prstDash val="solid"/>
-                      <a:round/>
-                      <a:headEnd type="none" w="med" len="med"/>
-                      <a:tailEnd type="none" w="med" len="med"/>
-                    </a:lnT>
-                    <a:lnB w="9525" cap="flat" cmpd="sng" algn="ctr">
-                      <a:solidFill>
-                        <a:srgbClr val="D9DEE6"/>
-                      </a:solidFill>
-                      <a:prstDash val="solid"/>
-                      <a:round/>
-                      <a:headEnd type="none" w="med" len="med"/>
-                      <a:tailEnd type="none" w="med" len="med"/>
-                    </a:lnB>
-                    <a:solidFill>
-                      <a:srgbClr val="FFFFFF"/>
-                    </a:solidFill>
-                  </a:tcPr>
-                </a:tc>
-                <a:tc>
-                  <a:txBody>
-                    <a:bodyPr/>
-                    <a:lstStyle/>
-                    <a:p>
-                      <a:pPr algn="l" indent="0" marL="0">
-                        <a:buNone/>
-                      </a:pPr>
-                      <a:r>
-                        <a:rPr lang="en-US" sz="1200" dirty="0">
-                          <a:solidFill>
-                            <a:srgbClr val="0F1B2D"/>
-                          </a:solidFill>
-                          <a:latin typeface="Arial" pitchFamily="34" charset="0"/>
-                          <a:ea typeface="Arial" pitchFamily="34" charset="-122"/>
-                          <a:cs typeface="Arial" pitchFamily="34" charset="-120"/>
-                        </a:rPr>
-                        <a:t>−__% · 면적 [___]</a:t>
+                        <a:t>[___] · −[__]%</a:t>
                       </a:r>
                       <a:endParaRPr lang="en-US" sz="1200" dirty="0">
                         <a:latin typeface="Arial" charset="0"/>
@@ -4392,137 +5164,14 @@
       </p:graphicFrame>
       <p:sp>
         <p:nvSpPr>
-          <p:cNvPr id="30" name="Shape 26"/>
-          <p:cNvSpPr/>
-          <p:nvPr/>
-        </p:nvSpPr>
-        <p:spPr>
-          <a:xfrm>
-            <a:off x="6858000" y="3492094"/>
-            <a:ext cx="4826203" cy="825703"/>
-          </a:xfrm>
-          <a:prstGeom prst="roundRect">
-            <a:avLst>
-              <a:gd name="adj" fmla="val 9192"/>
-            </a:avLst>
-          </a:prstGeom>
-          <a:solidFill>
-            <a:srgbClr val="0F1B2D"/>
-          </a:solidFill>
-          <a:ln/>
-        </p:spPr>
-      </p:sp>
-      <p:sp>
-        <p:nvSpPr>
-          <p:cNvPr id="31" name="Text 27"/>
-          <p:cNvSpPr txBox="1"/>
-          <p:nvPr/>
-        </p:nvSpPr>
-        <p:spPr>
-          <a:xfrm>
-            <a:off x="7035394" y="3593592"/>
-            <a:ext cx="4444898" cy="190195"/>
-          </a:xfrm>
-          <a:prstGeom prst="rect">
-            <a:avLst/>
-          </a:prstGeom>
-          <a:noFill/>
-          <a:ln/>
-        </p:spPr>
-        <p:txBody>
-          <a:bodyPr wrap="square" lIns="0" tIns="0" rIns="0" bIns="0" rtlCol="0" anchor="t"/>
-          <a:lstStyle/>
-          <a:p>
-            <a:pPr algn="l" indent="0" marL="0">
-              <a:buNone/>
-            </a:pPr>
-            <a:r>
-              <a:rPr lang="en-US" sz="1150" dirty="0">
-                <a:solidFill>
-                  <a:srgbClr val="8FA3B8"/>
-                </a:solidFill>
-                <a:latin typeface="Arial" pitchFamily="34" charset="0"/>
-                <a:ea typeface="Arial" pitchFamily="34" charset="-122"/>
-                <a:cs typeface="Arial" pitchFamily="34" charset="-120"/>
-              </a:rPr>
-              <a:t>AI가 실제로 바꾼 HW (예산 ≤280 예시)</a:t>
-            </a:r>
-            <a:endParaRPr lang="en-US" sz="1150" dirty="0"/>
-          </a:p>
-        </p:txBody>
-      </p:sp>
-      <p:sp>
-        <p:nvSpPr>
-          <p:cNvPr id="32" name="Text 28"/>
-          <p:cNvSpPr txBox="1"/>
-          <p:nvPr/>
-        </p:nvSpPr>
-        <p:spPr>
-          <a:xfrm>
-            <a:off x="7035394" y="3810305"/>
-            <a:ext cx="4444898" cy="444398"/>
-          </a:xfrm>
-          <a:prstGeom prst="rect">
-            <a:avLst/>
-          </a:prstGeom>
-          <a:noFill/>
-          <a:ln/>
-        </p:spPr>
-        <p:txBody>
-          <a:bodyPr wrap="square" lIns="0" tIns="0" rIns="0" bIns="0" rtlCol="0" anchor="t"/>
-          <a:lstStyle/>
-          <a:p>
-            <a:pPr algn="l" indent="0" marL="0">
-              <a:lnSpc>
-                <a:spcPct val="135000"/>
-              </a:lnSpc>
-              <a:buNone/>
-            </a:pPr>
-            <a:r>
-              <a:rPr lang="en-US" sz="1250" dirty="0">
-                <a:solidFill>
-                  <a:srgbClr val="F5F4EE"/>
-                </a:solidFill>
-                <a:latin typeface="Courier New" pitchFamily="34" charset="0"/>
-                <a:ea typeface="Courier New" pitchFamily="34" charset="-122"/>
-                <a:cs typeface="Courier New" pitchFamily="34" charset="-120"/>
-              </a:rPr>
-              <a:t>[SRAM 3뱅크 → 2뱅크 · I-cache 4K → 없음</a:t>
-            </a:r>
-            <a:endParaRPr lang="en-US" sz="1250" dirty="0"/>
-          </a:p>
-          <a:p>
-            <a:pPr algn="l" indent="0" marL="0">
-              <a:lnSpc>
-                <a:spcPct val="135000"/>
-              </a:lnSpc>
-              <a:buNone/>
-            </a:pPr>
-            <a:r>
-              <a:rPr lang="en-US" sz="1250" dirty="0">
-                <a:solidFill>
-                  <a:srgbClr val="F5F4EE"/>
-                </a:solidFill>
-                <a:latin typeface="Courier New" pitchFamily="34" charset="0"/>
-                <a:ea typeface="Courier New" pitchFamily="34" charset="-122"/>
-                <a:cs typeface="Courier New" pitchFamily="34" charset="-120"/>
-              </a:rPr>
-              <a:t>Flash prefetch on · DMA burst 1 → 8]</a:t>
-            </a:r>
-            <a:endParaRPr lang="en-US" sz="1250" dirty="0"/>
-          </a:p>
-        </p:txBody>
-      </p:sp>
-      <p:sp>
-        <p:nvSpPr>
-          <p:cNvPr id="33" name="Shape 29"/>
-          <p:cNvSpPr/>
-          <p:nvPr/>
-        </p:nvSpPr>
-        <p:spPr>
-          <a:xfrm>
-            <a:off x="6858000" y="4507992"/>
-            <a:ext cx="1548994" cy="698602"/>
+          <p:cNvPr id="34" name="Shape 29"/>
+          <p:cNvSpPr/>
+          <p:nvPr/>
+        </p:nvSpPr>
+        <p:spPr>
+          <a:xfrm>
+            <a:off x="6832397" y="5270602"/>
+            <a:ext cx="1904695" cy="698602"/>
           </a:xfrm>
           <a:prstGeom prst="roundRect">
             <a:avLst>
@@ -4530,26 +5179,21 @@
             </a:avLst>
           </a:prstGeom>
           <a:solidFill>
-            <a:srgbClr val="F2F4F7"/>
+            <a:srgbClr val="0F1B2D"/>
           </a:solidFill>
-          <a:ln w="12700">
-            <a:solidFill>
-              <a:srgbClr val="D9DEE6"/>
-            </a:solidFill>
-            <a:prstDash val="solid"/>
-          </a:ln>
-        </p:spPr>
-      </p:sp>
-      <p:sp>
-        <p:nvSpPr>
-          <p:cNvPr id="34" name="Text 30"/>
+          <a:ln/>
+        </p:spPr>
+      </p:sp>
+      <p:sp>
+        <p:nvSpPr>
+          <p:cNvPr id="35" name="Text 30"/>
           <p:cNvSpPr txBox="1"/>
           <p:nvPr/>
         </p:nvSpPr>
         <p:spPr>
           <a:xfrm>
-            <a:off x="6985102" y="4597603"/>
-            <a:ext cx="1295705" cy="177394"/>
+            <a:off x="6972300" y="5359298"/>
+            <a:ext cx="1714500" cy="177394"/>
           </a:xfrm>
           <a:prstGeom prst="rect">
             <a:avLst/>
@@ -4567,13 +5211,13 @@
             <a:r>
               <a:rPr lang="en-US" sz="1050" dirty="0">
                 <a:solidFill>
-                  <a:srgbClr val="6B7280"/>
-                </a:solidFill>
-                <a:latin typeface="Arial" pitchFamily="34" charset="0"/>
-                <a:ea typeface="Arial" pitchFamily="34" charset="-122"/>
-                <a:cs typeface="Arial" pitchFamily="34" charset="-120"/>
-              </a:rPr>
-              <a:t>AI 반복 · 소요</a:t>
+                  <a:srgbClr val="8FA3B8"/>
+                </a:solidFill>
+                <a:latin typeface="Arial" pitchFamily="34" charset="0"/>
+                <a:ea typeface="Arial" pitchFamily="34" charset="-122"/>
+                <a:cs typeface="Arial" pitchFamily="34" charset="-120"/>
+              </a:rPr>
+              <a:t>실험 1회 · 에뮬레이터 대비</a:t>
             </a:r>
             <a:endParaRPr lang="en-US" sz="1050" dirty="0"/>
           </a:p>
@@ -4581,14 +5225,14 @@
       </p:sp>
       <p:sp>
         <p:nvSpPr>
-          <p:cNvPr id="35" name="Text 31"/>
+          <p:cNvPr id="36" name="Text 31"/>
           <p:cNvSpPr txBox="1"/>
           <p:nvPr/>
         </p:nvSpPr>
         <p:spPr>
           <a:xfrm>
-            <a:off x="6985102" y="4800600"/>
-            <a:ext cx="1295705" cy="317297"/>
+            <a:off x="6972300" y="5575097"/>
+            <a:ext cx="1714500" cy="317297"/>
           </a:xfrm>
           <a:prstGeom prst="rect">
             <a:avLst/>
@@ -4604,30 +5248,58 @@
               <a:buNone/>
             </a:pPr>
             <a:r>
-              <a:rPr lang="en-US" sz="1600" b="1" dirty="0">
-                <a:solidFill>
-                  <a:srgbClr val="0F1B2D"/>
-                </a:solidFill>
-                <a:latin typeface="Arial" pitchFamily="34" charset="0"/>
-                <a:ea typeface="Arial" pitchFamily="34" charset="-122"/>
-                <a:cs typeface="Arial" pitchFamily="34" charset="-120"/>
-              </a:rPr>
-              <a:t>[__]회 · [_]h</a:t>
-            </a:r>
-            <a:endParaRPr lang="en-US" sz="1600" dirty="0"/>
-          </a:p>
-        </p:txBody>
-      </p:sp>
-      <p:sp>
-        <p:nvSpPr>
-          <p:cNvPr id="36" name="Shape 32"/>
-          <p:cNvSpPr/>
-          <p:nvPr/>
-        </p:nvSpPr>
-        <p:spPr>
-          <a:xfrm>
-            <a:off x="8495690" y="4507992"/>
-            <a:ext cx="1548994" cy="698602"/>
+              <a:rPr lang="en-US" sz="1700" b="1" strike="sngStrike" dirty="0">
+                <a:solidFill>
+                  <a:srgbClr val="8FA3B8"/>
+                </a:solidFill>
+                <a:latin typeface="Arial" pitchFamily="34" charset="0"/>
+                <a:ea typeface="Arial" pitchFamily="34" charset="-122"/>
+                <a:cs typeface="Arial" pitchFamily="34" charset="-120"/>
+              </a:rPr>
+              <a:t>300분</a:t>
+            </a:r>
+            <a:pPr algn="l" indent="0" marL="0">
+              <a:buNone/>
+            </a:pPr>
+            <a:r>
+              <a:rPr lang="en-US" sz="1700" b="1" dirty="0">
+                <a:solidFill>
+                  <a:srgbClr val="FFFFFF"/>
+                </a:solidFill>
+                <a:latin typeface="Arial" pitchFamily="34" charset="0"/>
+                <a:ea typeface="Arial" pitchFamily="34" charset="-122"/>
+                <a:cs typeface="Arial" pitchFamily="34" charset="-120"/>
+              </a:rPr>
+              <a:t> → </a:t>
+            </a:r>
+            <a:pPr algn="l" indent="0" marL="0">
+              <a:buNone/>
+            </a:pPr>
+            <a:r>
+              <a:rPr lang="en-US" sz="1700" b="1" dirty="0">
+                <a:solidFill>
+                  <a:srgbClr val="2FA6A0"/>
+                </a:solidFill>
+                <a:latin typeface="Arial" pitchFamily="34" charset="0"/>
+                <a:ea typeface="Arial" pitchFamily="34" charset="-122"/>
+                <a:cs typeface="Arial" pitchFamily="34" charset="-120"/>
+              </a:rPr>
+              <a:t>10분</a:t>
+            </a:r>
+            <a:endParaRPr lang="en-US" sz="1700" dirty="0"/>
+          </a:p>
+        </p:txBody>
+      </p:sp>
+      <p:sp>
+        <p:nvSpPr>
+          <p:cNvPr id="37" name="Shape 32"/>
+          <p:cNvSpPr/>
+          <p:nvPr/>
+        </p:nvSpPr>
+        <p:spPr>
+          <a:xfrm>
+            <a:off x="8838590" y="5270602"/>
+            <a:ext cx="1371600" cy="698602"/>
           </a:xfrm>
           <a:prstGeom prst="roundRect">
             <a:avLst>
@@ -4647,14 +5319,14 @@
       </p:sp>
       <p:sp>
         <p:nvSpPr>
-          <p:cNvPr id="37" name="Text 33"/>
+          <p:cNvPr id="38" name="Text 33"/>
           <p:cNvSpPr txBox="1"/>
           <p:nvPr/>
         </p:nvSpPr>
         <p:spPr>
           <a:xfrm>
-            <a:off x="8622792" y="4597603"/>
-            <a:ext cx="1295705" cy="177394"/>
+            <a:off x="8952890" y="5359298"/>
+            <a:ext cx="1206094" cy="177394"/>
           </a:xfrm>
           <a:prstGeom prst="rect">
             <a:avLst/>
@@ -4670,7 +5342,7 @@
               <a:buNone/>
             </a:pPr>
             <a:r>
-              <a:rPr lang="en-US" sz="1050" dirty="0">
+              <a:rPr lang="en-US" sz="1000" dirty="0">
                 <a:solidFill>
                   <a:srgbClr val="6B7280"/>
                 </a:solidFill>
@@ -4678,22 +5350,22 @@
                 <a:ea typeface="Arial" pitchFamily="34" charset="-122"/>
                 <a:cs typeface="Arial" pitchFamily="34" charset="-120"/>
               </a:rPr>
-              <a:t>사람 대비</a:t>
-            </a:r>
-            <a:endParaRPr lang="en-US" sz="1050" dirty="0"/>
-          </a:p>
-        </p:txBody>
-      </p:sp>
-      <p:sp>
-        <p:nvSpPr>
-          <p:cNvPr id="38" name="Text 34"/>
+              <a:t>AI 반복 · 사람 검토</a:t>
+            </a:r>
+            <a:endParaRPr lang="en-US" sz="1000" dirty="0"/>
+          </a:p>
+        </p:txBody>
+      </p:sp>
+      <p:sp>
+        <p:nvSpPr>
+          <p:cNvPr id="39" name="Text 34"/>
           <p:cNvSpPr txBox="1"/>
           <p:nvPr/>
         </p:nvSpPr>
         <p:spPr>
           <a:xfrm>
-            <a:off x="8622792" y="4800600"/>
-            <a:ext cx="1295705" cy="317297"/>
+            <a:off x="8952890" y="5575097"/>
+            <a:ext cx="1206094" cy="317297"/>
           </a:xfrm>
           <a:prstGeom prst="rect">
             <a:avLst/>
@@ -4709,7 +5381,7 @@
               <a:buNone/>
             </a:pPr>
             <a:r>
-              <a:rPr lang="en-US" sz="1600" b="1" dirty="0">
+              <a:rPr lang="en-US" sz="1500" b="1" dirty="0">
                 <a:solidFill>
                   <a:srgbClr val="0F1B2D"/>
                 </a:solidFill>
@@ -4717,22 +5389,22 @@
                 <a:ea typeface="Arial" pitchFamily="34" charset="-122"/>
                 <a:cs typeface="Arial" pitchFamily="34" charset="-120"/>
               </a:rPr>
-              <a:t>[_]일 → [_]h</a:t>
-            </a:r>
-            <a:endParaRPr lang="en-US" sz="1600" dirty="0"/>
-          </a:p>
-        </p:txBody>
-      </p:sp>
-      <p:sp>
-        <p:nvSpPr>
-          <p:cNvPr id="39" name="Shape 35"/>
-          <p:cNvSpPr/>
-          <p:nvPr/>
-        </p:nvSpPr>
-        <p:spPr>
-          <a:xfrm>
-            <a:off x="10134295" y="4507992"/>
-            <a:ext cx="1548994" cy="698602"/>
+              <a:t>[__] · [__]회</a:t>
+            </a:r>
+            <a:endParaRPr lang="en-US" sz="1500" dirty="0"/>
+          </a:p>
+        </p:txBody>
+      </p:sp>
+      <p:sp>
+        <p:nvSpPr>
+          <p:cNvPr id="40" name="Shape 35"/>
+          <p:cNvSpPr/>
+          <p:nvPr/>
+        </p:nvSpPr>
+        <p:spPr>
+          <a:xfrm>
+            <a:off x="10311689" y="5270602"/>
+            <a:ext cx="1371600" cy="698602"/>
           </a:xfrm>
           <a:prstGeom prst="roundRect">
             <a:avLst>
@@ -4752,14 +5424,14 @@
       </p:sp>
       <p:sp>
         <p:nvSpPr>
-          <p:cNvPr id="40" name="Text 36"/>
+          <p:cNvPr id="41" name="Text 36"/>
           <p:cNvSpPr txBox="1"/>
           <p:nvPr/>
         </p:nvSpPr>
         <p:spPr>
           <a:xfrm>
-            <a:off x="10261397" y="4597603"/>
-            <a:ext cx="1295705" cy="177394"/>
+            <a:off x="10425989" y="5359298"/>
+            <a:ext cx="1206094" cy="177394"/>
           </a:xfrm>
           <a:prstGeom prst="rect">
             <a:avLst/>
@@ -4775,7 +5447,7 @@
               <a:buNone/>
             </a:pPr>
             <a:r>
-              <a:rPr lang="en-US" sz="1050" dirty="0">
+              <a:rPr lang="en-US" sz="1000" dirty="0">
                 <a:solidFill>
                   <a:srgbClr val="6B7280"/>
                 </a:solidFill>
@@ -4783,22 +5455,22 @@
                 <a:ea typeface="Arial" pitchFamily="34" charset="-122"/>
                 <a:cs typeface="Arial" pitchFamily="34" charset="-120"/>
               </a:rPr>
-              <a:t>골든 불일치 폐기</a:t>
-            </a:r>
-            <a:endParaRPr lang="en-US" sz="1050" dirty="0"/>
-          </a:p>
-        </p:txBody>
-      </p:sp>
-      <p:sp>
-        <p:nvSpPr>
-          <p:cNvPr id="41" name="Text 37"/>
+              <a:t>bit-exact · ISR 제약</a:t>
+            </a:r>
+            <a:endParaRPr lang="en-US" sz="1000" dirty="0"/>
+          </a:p>
+        </p:txBody>
+      </p:sp>
+      <p:sp>
+        <p:nvSpPr>
+          <p:cNvPr id="42" name="Text 37"/>
           <p:cNvSpPr txBox="1"/>
           <p:nvPr/>
         </p:nvSpPr>
         <p:spPr>
           <a:xfrm>
-            <a:off x="10261397" y="4800600"/>
-            <a:ext cx="1295705" cy="317297"/>
+            <a:off x="10425989" y="5575097"/>
+            <a:ext cx="1206094" cy="317297"/>
           </a:xfrm>
           <a:prstGeom prst="rect">
             <a:avLst/>
@@ -4814,7 +5486,7 @@
               <a:buNone/>
             </a:pPr>
             <a:r>
-              <a:rPr lang="en-US" sz="1600" b="1" dirty="0">
+              <a:rPr lang="en-US" sz="1500" b="1" dirty="0">
                 <a:solidFill>
                   <a:srgbClr val="0F1B2D"/>
                 </a:solidFill>
@@ -4822,68 +5494,9 @@
                 <a:ea typeface="Arial" pitchFamily="34" charset="-122"/>
                 <a:cs typeface="Arial" pitchFamily="34" charset="-120"/>
               </a:rPr>
-              <a:t>[__] / [__]</a:t>
-            </a:r>
-            <a:endParaRPr lang="en-US" sz="1600" dirty="0"/>
-          </a:p>
-        </p:txBody>
-      </p:sp>
-      <p:sp>
-        <p:nvSpPr>
-          <p:cNvPr id="42" name="Text 38"/>
-          <p:cNvSpPr txBox="1"/>
-          <p:nvPr/>
-        </p:nvSpPr>
-        <p:spPr>
-          <a:xfrm>
-            <a:off x="508406" y="5397703"/>
-            <a:ext cx="11175797" cy="508406"/>
-          </a:xfrm>
-          <a:prstGeom prst="rect">
-            <a:avLst/>
-          </a:prstGeom>
-          <a:noFill/>
-          <a:ln/>
-        </p:spPr>
-        <p:txBody>
-          <a:bodyPr wrap="square" lIns="0" tIns="0" rIns="0" bIns="0" rtlCol="0" anchor="t"/>
-          <a:lstStyle/>
-          <a:p>
-            <a:pPr algn="l" indent="0" marL="0">
-              <a:lnSpc>
-                <a:spcPct val="135000"/>
-              </a:lnSpc>
-              <a:buNone/>
-            </a:pPr>
-            <a:r>
-              <a:rPr lang="en-US" sz="1200" b="1" dirty="0">
-                <a:solidFill>
-                  <a:srgbClr val="4A5568"/>
-                </a:solidFill>
-                <a:latin typeface="Arial" pitchFamily="34" charset="0"/>
-                <a:ea typeface="Arial" pitchFamily="34" charset="-122"/>
-                <a:cs typeface="Arial" pitchFamily="34" charset="-120"/>
-              </a:rPr>
-              <a:t>신뢰성</a:t>
-            </a:r>
-            <a:pPr algn="l" indent="0" marL="0">
-              <a:lnSpc>
-                <a:spcPct val="135000"/>
-              </a:lnSpc>
-              <a:buNone/>
-            </a:pPr>
-            <a:r>
-              <a:rPr lang="en-US" sz="1200" dirty="0">
-                <a:solidFill>
-                  <a:srgbClr val="4A5568"/>
-                </a:solidFill>
-                <a:latin typeface="Arial" pitchFamily="34" charset="0"/>
-                <a:ea typeface="Arial" pitchFamily="34" charset="-122"/>
-                <a:cs typeface="Arial" pitchFamily="34" charset="-120"/>
-              </a:rPr>
-              <a:t> — 모든 점은 출력 bit-exact · ISR ≤ 20 µs · overrun 0 통과. 모델 정합성 99.7%, 추론 커널 TFLite와 bit-exact, 실험마다 git rev·config 해시 기록. 예산 안의 HW 구성은 AI가 선택.</a:t>
-            </a:r>
-            <a:endParaRPr lang="en-US" sz="1200" dirty="0"/>
+              <a:t>전 실험 통과</a:t>
+            </a:r>
+            <a:endParaRPr lang="en-US" sz="1500" dirty="0"/>
           </a:p>
         </p:txBody>
       </p:sp>
@@ -5029,11 +5642,11 @@
         <p:spPr>
           <a:xfrm>
             <a:off x="508406" y="1904695"/>
-            <a:ext cx="3606394" cy="3301898"/>
+            <a:ext cx="5499202" cy="3047695"/>
           </a:xfrm>
           <a:prstGeom prst="roundRect">
             <a:avLst>
-              <a:gd name="adj" fmla="val 3074"/>
+              <a:gd name="adj" fmla="val 3330"/>
             </a:avLst>
           </a:prstGeom>
           <a:solidFill>
@@ -5056,7 +5669,7 @@
         <p:spPr>
           <a:xfrm>
             <a:off x="508406" y="1904695"/>
-            <a:ext cx="3606394" cy="38405"/>
+            <a:ext cx="5499202" cy="38405"/>
           </a:xfrm>
           <a:prstGeom prst="rect">
             <a:avLst/>
@@ -5075,8 +5688,8 @@
         </p:nvSpPr>
         <p:spPr>
           <a:xfrm>
-            <a:off x="737006" y="2107692"/>
-            <a:ext cx="3149194" cy="291694"/>
+            <a:off x="787298" y="2133295"/>
+            <a:ext cx="4940503" cy="317297"/>
           </a:xfrm>
           <a:prstGeom prst="rect">
             <a:avLst/>
@@ -5092,7 +5705,7 @@
               <a:buNone/>
             </a:pPr>
             <a:r>
-              <a:rPr lang="en-US" sz="1700" b="1" dirty="0">
+              <a:rPr lang="en-US" sz="1900" b="1" dirty="0">
                 <a:solidFill>
                   <a:srgbClr val="0F1B2D"/>
                 </a:solidFill>
@@ -5102,7 +5715,7 @@
               </a:rPr>
               <a:t>정성적 효과</a:t>
             </a:r>
-            <a:endParaRPr lang="en-US" sz="1700" dirty="0"/>
+            <a:endParaRPr lang="en-US" sz="1900" dirty="0"/>
           </a:p>
         </p:txBody>
       </p:sp>
@@ -5114,8 +5727,8 @@
         </p:nvSpPr>
         <p:spPr>
           <a:xfrm>
-            <a:off x="737006" y="2514600"/>
-            <a:ext cx="3149194" cy="2540203"/>
+            <a:off x="787298" y="2564892"/>
+            <a:ext cx="4940503" cy="2286000"/>
           </a:xfrm>
           <a:prstGeom prst="rect">
             <a:avLst/>
@@ -5138,7 +5751,7 @@
               <a:buChar char="•"/>
             </a:pPr>
             <a:r>
-              <a:rPr lang="en-US" sz="1300" dirty="0">
+              <a:rPr lang="en-US" sz="1500" dirty="0">
                 <a:solidFill>
                   <a:srgbClr val="4A5568"/>
                 </a:solidFill>
@@ -5146,9 +5759,9 @@
                 <a:ea typeface="Arial" pitchFamily="34" charset="-122"/>
                 <a:cs typeface="Arial" pitchFamily="34" charset="-120"/>
               </a:rPr>
-              <a:t>HW-SW 최적화까지 실리콘 전에 — 기존 FPGA·에뮬 흐름 앞에 추가되는 단계</a:t>
-            </a:r>
-            <a:endParaRPr lang="en-US" sz="1300" dirty="0"/>
+              <a:t>HW·SW 최적화까지 실리콘 전에 — 기존 FPGA·에뮬레이터 흐름 앞에 추가되는 단계</a:t>
+            </a:r>
+            <a:endParaRPr lang="en-US" sz="1500" dirty="0"/>
           </a:p>
           <a:p>
             <a:pPr marL="342900" indent="-342900">
@@ -5162,7 +5775,7 @@
               <a:buChar char="•"/>
             </a:pPr>
             <a:r>
-              <a:rPr lang="en-US" sz="1300" dirty="0">
+              <a:rPr lang="en-US" sz="1500" dirty="0">
                 <a:solidFill>
                   <a:srgbClr val="4A5568"/>
                 </a:solidFill>
@@ -5170,9 +5783,9 @@
                 <a:ea typeface="Arial" pitchFamily="34" charset="-122"/>
                 <a:cs typeface="Arial" pitchFamily="34" charset="-120"/>
               </a:rPr>
-              <a:t>"왜 느린가"에 근거(프로파일·경합 창)로 답함</a:t>
-            </a:r>
-            <a:endParaRPr lang="en-US" sz="1300" dirty="0"/>
+              <a:t>"왜 느린가"에 프로파일·경합 창이라는 근거로 답함</a:t>
+            </a:r>
+            <a:endParaRPr lang="en-US" sz="1500" dirty="0"/>
           </a:p>
           <a:p>
             <a:pPr marL="342900" indent="-342900">
@@ -5186,7 +5799,7 @@
               <a:buChar char="•"/>
             </a:pPr>
             <a:r>
-              <a:rPr lang="en-US" sz="1300" dirty="0">
+              <a:rPr lang="en-US" sz="1500" dirty="0">
                 <a:solidFill>
                   <a:srgbClr val="4A5568"/>
                 </a:solidFill>
@@ -5194,9 +5807,9 @@
                 <a:ea typeface="Arial" pitchFamily="34" charset="-122"/>
                 <a:cs typeface="Arial" pitchFamily="34" charset="-120"/>
               </a:rPr>
-              <a:t>HW 결정에 면적 비용이 항상 따라붙음</a:t>
-            </a:r>
-            <a:endParaRPr lang="en-US" sz="1300" dirty="0"/>
+              <a:t>HW 결정에 면적 비용이 항상 따라붙어 공짜 답이 없음</a:t>
+            </a:r>
+            <a:endParaRPr lang="en-US" sz="1500" dirty="0"/>
           </a:p>
           <a:p>
             <a:pPr marL="342900" indent="-342900">
@@ -5210,7 +5823,7 @@
               <a:buChar char="•"/>
             </a:pPr>
             <a:r>
-              <a:rPr lang="en-US" sz="1300" dirty="0">
+              <a:rPr lang="en-US" sz="1500" dirty="0">
                 <a:solidFill>
                   <a:srgbClr val="4A5568"/>
                 </a:solidFill>
@@ -5218,9 +5831,9 @@
                 <a:ea typeface="Arial" pitchFamily="34" charset="-122"/>
                 <a:cs typeface="Arial" pitchFamily="34" charset="-120"/>
               </a:rPr>
-              <a:t>사람은 검토자로, 반복은 AI로 역할 분리</a:t>
-            </a:r>
-            <a:endParaRPr lang="en-US" sz="1300" dirty="0"/>
+              <a:t>반복은 AI, 검토·승인은 사람 — 역할이 분리됨</a:t>
+            </a:r>
+            <a:endParaRPr lang="en-US" sz="1500" dirty="0"/>
           </a:p>
         </p:txBody>
       </p:sp>
@@ -5232,12 +5845,12 @@
         </p:nvSpPr>
         <p:spPr>
           <a:xfrm>
-            <a:off x="4292194" y="1904695"/>
-            <a:ext cx="3606394" cy="3301898"/>
+            <a:off x="6185002" y="1904695"/>
+            <a:ext cx="5499202" cy="3047695"/>
           </a:xfrm>
           <a:prstGeom prst="roundRect">
             <a:avLst>
-              <a:gd name="adj" fmla="val 3074"/>
+              <a:gd name="adj" fmla="val 3330"/>
             </a:avLst>
           </a:prstGeom>
           <a:solidFill>
@@ -5259,8 +5872,8 @@
         </p:nvSpPr>
         <p:spPr>
           <a:xfrm>
-            <a:off x="4292194" y="1904695"/>
-            <a:ext cx="3606394" cy="38405"/>
+            <a:off x="6185002" y="1904695"/>
+            <a:ext cx="5499202" cy="38405"/>
           </a:xfrm>
           <a:prstGeom prst="rect">
             <a:avLst/>
@@ -5279,8 +5892,8 @@
         </p:nvSpPr>
         <p:spPr>
           <a:xfrm>
-            <a:off x="4520794" y="2107692"/>
-            <a:ext cx="3149194" cy="291694"/>
+            <a:off x="6463894" y="2133295"/>
+            <a:ext cx="4940503" cy="317297"/>
           </a:xfrm>
           <a:prstGeom prst="rect">
             <a:avLst/>
@@ -5296,7 +5909,7 @@
               <a:buNone/>
             </a:pPr>
             <a:r>
-              <a:rPr lang="en-US" sz="1700" b="1" dirty="0">
+              <a:rPr lang="en-US" sz="1900" b="1" dirty="0">
                 <a:solidFill>
                   <a:srgbClr val="0F1B2D"/>
                 </a:solidFill>
@@ -5306,7 +5919,7 @@
               </a:rPr>
               <a:t>정량적 효과</a:t>
             </a:r>
-            <a:endParaRPr lang="en-US" sz="1700" dirty="0"/>
+            <a:endParaRPr lang="en-US" sz="1900" dirty="0"/>
           </a:p>
         </p:txBody>
       </p:sp>
@@ -5318,8 +5931,8 @@
         </p:nvSpPr>
         <p:spPr>
           <a:xfrm>
-            <a:off x="4520794" y="2514600"/>
-            <a:ext cx="3149194" cy="2540203"/>
+            <a:off x="6463894" y="2564892"/>
+            <a:ext cx="4940503" cy="2286000"/>
           </a:xfrm>
           <a:prstGeom prst="rect">
             <a:avLst/>
@@ -5342,7 +5955,7 @@
               <a:buChar char="•"/>
             </a:pPr>
             <a:r>
-              <a:rPr lang="en-US" sz="1300" dirty="0">
+              <a:rPr lang="en-US" sz="1500" dirty="0">
                 <a:solidFill>
                   <a:srgbClr val="4A5568"/>
                 </a:solidFill>
@@ -5350,9 +5963,9 @@
                 <a:ea typeface="Arial" pitchFamily="34" charset="-122"/>
                 <a:cs typeface="Arial" pitchFamily="34" charset="-120"/>
               </a:rPr>
-              <a:t>탐색 시간 [사람 __일 → AI __시간]</a:t>
-            </a:r>
-            <a:endParaRPr lang="en-US" sz="1300" dirty="0"/>
+              <a:t>실험 1회 에뮬레이터 300분 → 10분, 같은 시간에 30배 더 많은 시도</a:t>
+            </a:r>
+            <a:endParaRPr lang="en-US" sz="1500" dirty="0"/>
           </a:p>
           <a:p>
             <a:pPr marL="342900" indent="-342900">
@@ -5366,7 +5979,7 @@
               <a:buChar char="•"/>
             </a:pPr>
             <a:r>
-              <a:rPr lang="en-US" sz="1300" dirty="0">
+              <a:rPr lang="en-US" sz="1500" dirty="0">
                 <a:solidFill>
                   <a:srgbClr val="4A5568"/>
                 </a:solidFill>
@@ -5374,9 +5987,9 @@
                 <a:ea typeface="Arial" pitchFamily="34" charset="-122"/>
                 <a:cs typeface="Arial" pitchFamily="34" charset="-120"/>
               </a:rPr>
-              <a:t>추론 cycle [베이스라인 대비 −__%]</a:t>
-            </a:r>
-            <a:endParaRPr lang="en-US" sz="1300" dirty="0"/>
+              <a:t>하루 [__]회 반복 — 사람이 손으로 하면 [__]회</a:t>
+            </a:r>
+            <a:endParaRPr lang="en-US" sz="1500" dirty="0"/>
           </a:p>
           <a:p>
             <a:pPr marL="342900" indent="-342900">
@@ -5390,7 +6003,7 @@
               <a:buChar char="•"/>
             </a:pPr>
             <a:r>
-              <a:rPr lang="en-US" sz="1300" dirty="0">
+              <a:rPr lang="en-US" sz="1500" dirty="0">
                 <a:solidFill>
                   <a:srgbClr val="4A5568"/>
                 </a:solidFill>
@@ -5398,9 +6011,9 @@
                 <a:ea typeface="Arial" pitchFamily="34" charset="-122"/>
                 <a:cs typeface="Arial" pitchFamily="34" charset="-120"/>
               </a:rPr>
-              <a:t>같은 성능에 면적 [−__%]</a:t>
-            </a:r>
-            <a:endParaRPr lang="en-US" sz="1300" dirty="0"/>
+              <a:t>같은 SW·같은 정확도로 추론 cycle −[__]%, 면적 −[__]%</a:t>
+            </a:r>
+            <a:endParaRPr lang="en-US" sz="1500" dirty="0"/>
           </a:p>
           <a:p>
             <a:pPr marL="342900" indent="-342900">
@@ -5414,7 +6027,7 @@
               <a:buChar char="•"/>
             </a:pPr>
             <a:r>
-              <a:rPr lang="en-US" sz="1300" dirty="0">
+              <a:rPr lang="en-US" sz="1500" dirty="0">
                 <a:solidFill>
                   <a:srgbClr val="4A5568"/>
                 </a:solidFill>
@@ -5422,9 +6035,9 @@
                 <a:ea typeface="Arial" pitchFamily="34" charset="-122"/>
                 <a:cs typeface="Arial" pitchFamily="34" charset="-120"/>
               </a:rPr>
-              <a:t>실험 1회 [__초], 하루 [__]회</a:t>
-            </a:r>
-            <a:endParaRPr lang="en-US" sz="1300" dirty="0"/>
+              <a:t>탐색 기간 [__]일 → [__]시간</a:t>
+            </a:r>
+            <a:endParaRPr lang="en-US" sz="1500" dirty="0"/>
           </a:p>
         </p:txBody>
       </p:sp>
@@ -5436,38 +6049,13 @@
         </p:nvSpPr>
         <p:spPr>
           <a:xfrm>
-            <a:off x="8076895" y="1904695"/>
-            <a:ext cx="3606394" cy="3301898"/>
+            <a:off x="508406" y="5143500"/>
+            <a:ext cx="11175797" cy="761695"/>
           </a:xfrm>
           <a:prstGeom prst="roundRect">
             <a:avLst>
-              <a:gd name="adj" fmla="val 3074"/>
+              <a:gd name="adj" fmla="val 13325"/>
             </a:avLst>
-          </a:prstGeom>
-          <a:solidFill>
-            <a:srgbClr val="F2F4F7"/>
-          </a:solidFill>
-          <a:ln w="12700">
-            <a:solidFill>
-              <a:srgbClr val="D9DEE6"/>
-            </a:solidFill>
-            <a:prstDash val="solid"/>
-          </a:ln>
-        </p:spPr>
-      </p:sp>
-      <p:sp>
-        <p:nvSpPr>
-          <p:cNvPr id="15" name="Shape 12"/>
-          <p:cNvSpPr/>
-          <p:nvPr/>
-        </p:nvSpPr>
-        <p:spPr>
-          <a:xfrm>
-            <a:off x="8076895" y="1904695"/>
-            <a:ext cx="3606394" cy="38405"/>
-          </a:xfrm>
-          <a:prstGeom prst="rect">
-            <a:avLst/>
           </a:prstGeom>
           <a:solidFill>
             <a:srgbClr val="0F1B2D"/>
@@ -5477,40 +6065,82 @@
       </p:sp>
       <p:sp>
         <p:nvSpPr>
+          <p:cNvPr id="15" name="Text 12"/>
+          <p:cNvSpPr txBox="1"/>
+          <p:nvPr/>
+        </p:nvSpPr>
+        <p:spPr>
+          <a:xfrm>
+            <a:off x="737006" y="5143500"/>
+            <a:ext cx="698602" cy="761695"/>
+          </a:xfrm>
+          <a:prstGeom prst="rect">
+            <a:avLst/>
+          </a:prstGeom>
+          <a:noFill/>
+          <a:ln/>
+        </p:spPr>
+        <p:txBody>
+          <a:bodyPr wrap="square" lIns="0" tIns="0" rIns="0" bIns="0" rtlCol="0" anchor="ctr"/>
+          <a:lstStyle/>
+          <a:p>
+            <a:pPr algn="l" indent="0" marL="0">
+              <a:buNone/>
+            </a:pPr>
+            <a:r>
+              <a:rPr lang="en-US" sz="1300" dirty="0">
+                <a:solidFill>
+                  <a:srgbClr val="8FA3B8"/>
+                </a:solidFill>
+                <a:latin typeface="Arial" pitchFamily="34" charset="0"/>
+                <a:ea typeface="Arial" pitchFamily="34" charset="-122"/>
+                <a:cs typeface="Arial" pitchFamily="34" charset="-120"/>
+              </a:rPr>
+              <a:t>다음</a:t>
+            </a:r>
+            <a:endParaRPr lang="en-US" sz="1300" dirty="0"/>
+          </a:p>
+        </p:txBody>
+      </p:sp>
+      <p:sp>
+        <p:nvSpPr>
           <p:cNvPr id="16" name="Text 13"/>
           <p:cNvSpPr txBox="1"/>
           <p:nvPr/>
         </p:nvSpPr>
         <p:spPr>
           <a:xfrm>
-            <a:off x="8305495" y="2107692"/>
-            <a:ext cx="3149194" cy="291694"/>
-          </a:xfrm>
-          <a:prstGeom prst="rect">
-            <a:avLst/>
-          </a:prstGeom>
-          <a:noFill/>
-          <a:ln/>
-        </p:spPr>
-        <p:txBody>
-          <a:bodyPr wrap="square" lIns="0" tIns="0" rIns="0" bIns="0" rtlCol="0" anchor="t"/>
+            <a:off x="1460297" y="5143500"/>
+            <a:ext cx="7619695" cy="761695"/>
+          </a:xfrm>
+          <a:prstGeom prst="rect">
+            <a:avLst/>
+          </a:prstGeom>
+          <a:noFill/>
+          <a:ln/>
+        </p:spPr>
+        <p:txBody>
+          <a:bodyPr wrap="square" lIns="0" tIns="0" rIns="0" bIns="0" rtlCol="0" anchor="ctr"/>
           <a:lstStyle/>
           <a:p>
             <a:pPr algn="l" indent="0" marL="0">
-              <a:buNone/>
-            </a:pPr>
-            <a:r>
-              <a:rPr lang="en-US" sz="1700" b="1" dirty="0">
-                <a:solidFill>
-                  <a:srgbClr val="0F1B2D"/>
-                </a:solidFill>
-                <a:latin typeface="Arial" pitchFamily="34" charset="0"/>
-                <a:ea typeface="Arial" pitchFamily="34" charset="-122"/>
-                <a:cs typeface="Arial" pitchFamily="34" charset="-120"/>
-              </a:rPr>
-              <a:t>교육 · 실무 연계</a:t>
-            </a:r>
-            <a:endParaRPr lang="en-US" sz="1700" dirty="0"/>
+              <a:lnSpc>
+                <a:spcPct val="135000"/>
+              </a:lnSpc>
+              <a:buNone/>
+            </a:pPr>
+            <a:r>
+              <a:rPr lang="en-US" sz="1350" dirty="0">
+                <a:solidFill>
+                  <a:srgbClr val="F5F4EE"/>
+                </a:solidFill>
+                <a:latin typeface="Arial" pitchFamily="34" charset="0"/>
+                <a:ea typeface="Arial" pitchFamily="34" charset="-122"/>
+                <a:cs typeface="Arial" pitchFamily="34" charset="-120"/>
+              </a:rPr>
+              <a:t>실제 과제 워크로드 투입 · RTL 파형과 WaveScope 교차 검증으로 정합성 관리 · HW knob 범위 확대(버스 우선순위·캐시 정책)</a:t>
+            </a:r>
+            <a:endParaRPr lang="en-US" sz="1350" dirty="0"/>
           </a:p>
         </p:txBody>
       </p:sp>
@@ -5522,120 +6152,26 @@
         </p:nvSpPr>
         <p:spPr>
           <a:xfrm>
-            <a:off x="8305495" y="2514600"/>
-            <a:ext cx="3149194" cy="2540203"/>
-          </a:xfrm>
-          <a:prstGeom prst="rect">
-            <a:avLst/>
-          </a:prstGeom>
-          <a:noFill/>
-          <a:ln/>
-        </p:spPr>
-        <p:txBody>
-          <a:bodyPr wrap="square" lIns="0" tIns="0" rIns="0" bIns="0" rtlCol="0" anchor="t"/>
-          <a:lstStyle/>
-          <a:p>
-            <a:pPr marL="342900" indent="-342900">
-              <a:lnSpc>
-                <a:spcPct val="125000"/>
-              </a:lnSpc>
-              <a:spcAft>
-                <a:spcPts val="600"/>
-              </a:spcAft>
-              <a:buSzPct val="100000"/>
-              <a:buChar char="•"/>
-            </a:pPr>
-            <a:r>
-              <a:rPr lang="en-US" sz="1300" dirty="0">
-                <a:solidFill>
-                  <a:srgbClr val="4A5568"/>
-                </a:solidFill>
-                <a:latin typeface="Arial" pitchFamily="34" charset="0"/>
-                <a:ea typeface="Arial" pitchFamily="34" charset="-122"/>
-                <a:cs typeface="Arial" pitchFamily="34" charset="-120"/>
-              </a:rPr>
-              <a:t>[교과목: 컴퓨터구조 · 임베디드 · SoC 설계 — 메모리 계층·버스 경합을 실험으로 체득]</a:t>
-            </a:r>
-            <a:endParaRPr lang="en-US" sz="1300" dirty="0"/>
-          </a:p>
-          <a:p>
-            <a:pPr marL="342900" indent="-342900">
-              <a:lnSpc>
-                <a:spcPct val="125000"/>
-              </a:lnSpc>
-              <a:spcAft>
-                <a:spcPts val="600"/>
-              </a:spcAft>
-              <a:buSzPct val="100000"/>
-              <a:buChar char="•"/>
-            </a:pPr>
-            <a:r>
-              <a:rPr lang="en-US" sz="1300" dirty="0">
-                <a:solidFill>
-                  <a:srgbClr val="4A5568"/>
-                </a:solidFill>
-                <a:latin typeface="Arial" pitchFamily="34" charset="0"/>
-                <a:ea typeface="Arial" pitchFamily="34" charset="-122"/>
-                <a:cs typeface="Arial" pitchFamily="34" charset="-120"/>
-              </a:rPr>
-              <a:t>[실무: 신규 SoC 펌웨어 선개발, RTL 파형(WaveScope) 교차 검증에 즉시 적용]</a:t>
-            </a:r>
-            <a:endParaRPr lang="en-US" sz="1300" dirty="0"/>
-          </a:p>
-          <a:p>
-            <a:pPr marL="342900" indent="-342900">
-              <a:lnSpc>
-                <a:spcPct val="125000"/>
-              </a:lnSpc>
-              <a:spcAft>
-                <a:spcPts val="600"/>
-              </a:spcAft>
-              <a:buSzPct val="100000"/>
-              <a:buChar char="•"/>
-            </a:pPr>
-            <a:r>
-              <a:rPr lang="en-US" sz="1300" dirty="0">
-                <a:solidFill>
-                  <a:srgbClr val="4A5568"/>
-                </a:solidFill>
-                <a:latin typeface="Arial" pitchFamily="34" charset="0"/>
-                <a:ea typeface="Arial" pitchFamily="34" charset="-122"/>
-                <a:cs typeface="Arial" pitchFamily="34" charset="-120"/>
-              </a:rPr>
-              <a:t>[다음: RISC-V·멀티코어, 실제 프로젝트 워크로드 투입]</a:t>
-            </a:r>
-            <a:endParaRPr lang="en-US" sz="1300" dirty="0"/>
-          </a:p>
-        </p:txBody>
-      </p:sp>
-      <p:sp>
-        <p:nvSpPr>
-          <p:cNvPr id="18" name="Text 15"/>
-          <p:cNvSpPr txBox="1"/>
-          <p:nvPr/>
-        </p:nvSpPr>
-        <p:spPr>
-          <a:xfrm>
-            <a:off x="508406" y="5587898"/>
-            <a:ext cx="5079492" cy="317297"/>
-          </a:xfrm>
-          <a:prstGeom prst="rect">
-            <a:avLst/>
-          </a:prstGeom>
-          <a:noFill/>
-          <a:ln/>
-        </p:spPr>
-        <p:txBody>
-          <a:bodyPr wrap="square" lIns="0" tIns="0" rIns="0" bIns="0" rtlCol="0" anchor="t"/>
-          <a:lstStyle/>
-          <a:p>
-            <a:pPr algn="l" indent="0" marL="0">
-              <a:buNone/>
-            </a:pPr>
-            <a:r>
-              <a:rPr lang="en-US" sz="1700" b="1" dirty="0">
-                <a:solidFill>
-                  <a:srgbClr val="0F1B2D"/>
+            <a:off x="9271102" y="5143500"/>
+            <a:ext cx="2221992" cy="761695"/>
+          </a:xfrm>
+          <a:prstGeom prst="rect">
+            <a:avLst/>
+          </a:prstGeom>
+          <a:noFill/>
+          <a:ln/>
+        </p:spPr>
+        <p:txBody>
+          <a:bodyPr wrap="square" lIns="0" tIns="0" rIns="0" bIns="0" rtlCol="0" anchor="ctr"/>
+          <a:lstStyle/>
+          <a:p>
+            <a:pPr algn="r" indent="0" marL="0">
+              <a:buNone/>
+            </a:pPr>
+            <a:r>
+              <a:rPr lang="en-US" sz="1500" b="1" dirty="0">
+                <a:solidFill>
+                  <a:srgbClr val="FFFFFF"/>
                 </a:solidFill>
                 <a:latin typeface="Arial" pitchFamily="34" charset="0"/>
                 <a:ea typeface="Arial" pitchFamily="34" charset="-122"/>
@@ -5643,46 +6179,7 @@
               </a:rPr>
               <a:t>감사합니다 · Q&amp;A</a:t>
             </a:r>
-            <a:endParaRPr lang="en-US" sz="1700" dirty="0"/>
-          </a:p>
-        </p:txBody>
-      </p:sp>
-      <p:sp>
-        <p:nvSpPr>
-          <p:cNvPr id="19" name="Text 16"/>
-          <p:cNvSpPr txBox="1"/>
-          <p:nvPr/>
-        </p:nvSpPr>
-        <p:spPr>
-          <a:xfrm>
-            <a:off x="6603797" y="5650992"/>
-            <a:ext cx="5079492" cy="254203"/>
-          </a:xfrm>
-          <a:prstGeom prst="rect">
-            <a:avLst/>
-          </a:prstGeom>
-          <a:noFill/>
-          <a:ln/>
-        </p:spPr>
-        <p:txBody>
-          <a:bodyPr wrap="square" lIns="0" tIns="0" rIns="0" bIns="0" rtlCol="0" anchor="t"/>
-          <a:lstStyle/>
-          <a:p>
-            <a:pPr algn="r" indent="0" marL="0">
-              <a:buNone/>
-            </a:pPr>
-            <a:r>
-              <a:rPr lang="en-US" sz="1300" dirty="0">
-                <a:solidFill>
-                  <a:srgbClr val="6B7280"/>
-                </a:solidFill>
-                <a:latin typeface="Arial" pitchFamily="34" charset="0"/>
-                <a:ea typeface="Arial" pitchFamily="34" charset="-122"/>
-                <a:cs typeface="Arial" pitchFamily="34" charset="-120"/>
-              </a:rPr>
-              <a:t>[발표자 이름] · [이메일]</a:t>
-            </a:r>
-            <a:endParaRPr lang="en-US" sz="1300" dirty="0"/>
+            <a:endParaRPr lang="en-US" sz="1500" dirty="0"/>
           </a:p>
         </p:txBody>
       </p:sp>

</xml_diff>

<commit_message>
Presentation: define relative area unit on results slide (SRAM 1 KB = 1, block coefficients) + Q&A
Co-Authored-By: Claude Fable 5.1 <noreply@anthropic.com>
Claude-Session: https://claude.ai/code/session_01Gd73gUzQvBcmrEGA3YWYHu
</commit_message>
<xml_diff>
--- a/docs/presentation/deck_basic_fonts.pptx
+++ b/docs/presentation/deck_basic_fonts.pptx
@@ -602,7 +602,7 @@
           <a:p>
             <a:r>
               <a:rPr lang="en-US" dirty="0"/>
-              <a:t>60초. 왼쪽 그림: 회색 점(초기)→주황 점(루프 결과) 화살표 옆 숫자를 읽는다. 오른쪽 위 표 = 성능, 아래 표 = 면적, 같은 세 구조. 검은 타일 '에뮬 300분 → 10분'은 실험 1회 기준 — 11장 정량 효과(하루 반복 횟수·탐색 기간)의 근거가 된다. 신뢰성 질문이 오면 세 번째 타일: 모든 실험이 bit-exact와 ISR 제약을 통과했고 아닌 것은 자동 폐기.</a:t>
+              <a:t>60초. 왼쪽 그림: 회색 점(초기)→주황 점(루프 결과) 화살표 옆 숫자를 읽는다. 오른쪽 위 표 = 성능, 아래 표 = 면적, 같은 세 구조. 검은 타일 '에뮬 300분 → 10분'은 실험 1회 기준 — 11장 정량 효과(하루 반복 횟수·탐색 기간)의 근거가 된다. 면적 단위 질문이 오면 맨 아래 각주: SRAM 1 KB = 1인 상대 단위, 블록 계수의 합. 신뢰성 질문이 오면 세 번째 타일: 모든 실험이 bit-exact와 ISR 제약을 통과했고 아닌 것은 자동 폐기.</a:t>
             </a:r>
             <a:endParaRPr lang="en-US" dirty="0"/>
           </a:p>
@@ -2528,7 +2528,7 @@
               <a:buNone/>
             </a:pPr>
             <a:r>
-              <a:rPr lang="en-US" sz="2600" b="1" dirty="0">
+              <a:rPr lang="en-US" sz="2300" b="1" dirty="0">
                 <a:solidFill>
                   <a:srgbClr val="0F1B2D"/>
                 </a:solidFill>
@@ -2536,9 +2536,9 @@
                 <a:ea typeface="Arial" pitchFamily="34" charset="-122"/>
                 <a:cs typeface="Arial" pitchFamily="34" charset="-120"/>
               </a:rPr>
-              <a:t>세 가지 HW 구조 모두 정확도 손실 없이 cycle −[__]~[__]%, 면적 −[__]~[__]%</a:t>
-            </a:r>
-            <a:endParaRPr lang="en-US" sz="2600" dirty="0"/>
+              <a:t>세 가지 HW 구조 모두 정확도 손실 없이 cycle −[__]~[__]% · 면적 −[__]~[__]%</a:t>
+            </a:r>
+            <a:endParaRPr lang="en-US" sz="2300" dirty="0"/>
           </a:p>
         </p:txBody>
       </p:sp>
@@ -5497,6 +5497,99 @@
               <a:t>전 실험 통과</a:t>
             </a:r>
             <a:endParaRPr lang="en-US" sz="1500" dirty="0"/>
+          </a:p>
+        </p:txBody>
+      </p:sp>
+      <p:sp>
+        <p:nvSpPr>
+          <p:cNvPr id="43" name="Text 38"/>
+          <p:cNvSpPr txBox="1"/>
+          <p:nvPr/>
+        </p:nvSpPr>
+        <p:spPr>
+          <a:xfrm>
+            <a:off x="508406" y="5905195"/>
+            <a:ext cx="11175797" cy="381305"/>
+          </a:xfrm>
+          <a:prstGeom prst="rect">
+            <a:avLst/>
+          </a:prstGeom>
+          <a:noFill/>
+          <a:ln/>
+        </p:spPr>
+        <p:txBody>
+          <a:bodyPr wrap="square" lIns="0" tIns="0" rIns="0" bIns="0" rtlCol="0" anchor="t"/>
+          <a:lstStyle/>
+          <a:p>
+            <a:pPr algn="l" indent="0" marL="0">
+              <a:lnSpc>
+                <a:spcPct val="130000"/>
+              </a:lnSpc>
+              <a:buNone/>
+            </a:pPr>
+            <a:r>
+              <a:rPr lang="en-US" sz="1100" b="1" dirty="0">
+                <a:solidFill>
+                  <a:srgbClr val="4A5568"/>
+                </a:solidFill>
+                <a:latin typeface="Arial" pitchFamily="34" charset="0"/>
+                <a:ea typeface="Arial" pitchFamily="34" charset="-122"/>
+                <a:cs typeface="Arial" pitchFamily="34" charset="-120"/>
+              </a:rPr>
+              <a:t>면적(상대)</a:t>
+            </a:r>
+            <a:pPr algn="l" indent="0" marL="0">
+              <a:lnSpc>
+                <a:spcPct val="130000"/>
+              </a:lnSpc>
+              <a:buNone/>
+            </a:pPr>
+            <a:r>
+              <a:rPr lang="en-US" sz="1100" dirty="0">
+                <a:solidFill>
+                  <a:srgbClr val="6B7280"/>
+                </a:solidFill>
+                <a:latin typeface="Arial" pitchFamily="34" charset="0"/>
+                <a:ea typeface="Arial" pitchFamily="34" charset="-122"/>
+                <a:cs typeface="Arial" pitchFamily="34" charset="-120"/>
+              </a:rPr>
+              <a:t> = 구성 블록 비용의 합, </a:t>
+            </a:r>
+            <a:pPr algn="l" indent="0" marL="0">
+              <a:lnSpc>
+                <a:spcPct val="130000"/>
+              </a:lnSpc>
+              <a:buNone/>
+            </a:pPr>
+            <a:r>
+              <a:rPr lang="en-US" sz="1100" b="1" dirty="0">
+                <a:solidFill>
+                  <a:srgbClr val="4A5568"/>
+                </a:solidFill>
+                <a:latin typeface="Arial" pitchFamily="34" charset="0"/>
+                <a:ea typeface="Arial" pitchFamily="34" charset="-122"/>
+                <a:cs typeface="Arial" pitchFamily="34" charset="-120"/>
+              </a:rPr>
+              <a:t>SRAM 1 KB = 1</a:t>
+            </a:r>
+            <a:pPr algn="l" indent="0" marL="0">
+              <a:lnSpc>
+                <a:spcPct val="130000"/>
+              </a:lnSpc>
+              <a:buNone/>
+            </a:pPr>
+            <a:r>
+              <a:rPr lang="en-US" sz="1100" dirty="0">
+                <a:solidFill>
+                  <a:srgbClr val="6B7280"/>
+                </a:solidFill>
+                <a:latin typeface="Arial" pitchFamily="34" charset="0"/>
+                <a:ea typeface="Arial" pitchFamily="34" charset="-122"/>
+                <a:cs typeface="Arial" pitchFamily="34" charset="-120"/>
+              </a:rPr>
+              <a:t> 기준 — TCM 1.1/KB · I-Cache 2.5/KB · Flash prefetch 1.5 · DMA 0.8/ch · MAC 4 + 1.2/lane. 공개 자료(CACTI 계열) 비율이며 mm²가 아님 · 예산 170/280/470도 같은 단위</a:t>
+            </a:r>
+            <a:endParaRPr lang="en-US" sz="1100" dirty="0"/>
           </a:p>
         </p:txBody>
       </p:sp>

</xml_diff>

<commit_message>
Presentation: simpler area-unit footnote (assumed relative IP areas, replaceable)
Co-Authored-By: Claude Fable 5.1 <noreply@anthropic.com>
Claude-Session: https://claude.ai/code/session_01Gd73gUzQvBcmrEGA3YWYHu
</commit_message>
<xml_diff>
--- a/docs/presentation/deck_basic_fonts.pptx
+++ b/docs/presentation/deck_basic_fonts.pptx
@@ -5509,7 +5509,7 @@
         <p:spPr>
           <a:xfrm>
             <a:off x="508406" y="5905195"/>
-            <a:ext cx="11175797" cy="381305"/>
+            <a:ext cx="11175797" cy="254203"/>
           </a:xfrm>
           <a:prstGeom prst="rect">
             <a:avLst/>
@@ -5522,9 +5522,6 @@
           <a:lstStyle/>
           <a:p>
             <a:pPr algn="l" indent="0" marL="0">
-              <a:lnSpc>
-                <a:spcPct val="130000"/>
-              </a:lnSpc>
               <a:buNone/>
             </a:pPr>
             <a:r>
@@ -5539,9 +5536,6 @@
               <a:t>면적(상대)</a:t>
             </a:r>
             <a:pPr algn="l" indent="0" marL="0">
-              <a:lnSpc>
-                <a:spcPct val="130000"/>
-              </a:lnSpc>
               <a:buNone/>
             </a:pPr>
             <a:r>
@@ -5553,12 +5547,9 @@
                 <a:ea typeface="Arial" pitchFamily="34" charset="-122"/>
                 <a:cs typeface="Arial" pitchFamily="34" charset="-120"/>
               </a:rPr>
-              <a:t> = 구성 블록 비용의 합, </a:t>
+              <a:t> = 구성 블록 비용의 합. </a:t>
             </a:r>
             <a:pPr algn="l" indent="0" marL="0">
-              <a:lnSpc>
-                <a:spcPct val="130000"/>
-              </a:lnSpc>
               <a:buNone/>
             </a:pPr>
             <a:r>
@@ -5573,9 +5564,6 @@
               <a:t>SRAM 1 KB = 1</a:t>
             </a:r>
             <a:pPr algn="l" indent="0" marL="0">
-              <a:lnSpc>
-                <a:spcPct val="130000"/>
-              </a:lnSpc>
               <a:buNone/>
             </a:pPr>
             <a:r>
@@ -5587,7 +5575,7 @@
                 <a:ea typeface="Arial" pitchFamily="34" charset="-122"/>
                 <a:cs typeface="Arial" pitchFamily="34" charset="-120"/>
               </a:rPr>
-              <a:t> 기준 — TCM 1.1/KB · I-Cache 2.5/KB · Flash prefetch 1.5 · DMA 0.8/ch · MAC 4 + 1.2/lane. 공개 자료(CACTI 계열) 비율이며 mm²가 아님 · 예산 170/280/470도 같은 단위</a:t>
+              <a:t>을 기준으로 각 IP의 면적을 대략적인 상대값으로 가정해 PoC 결과를 분석했으며, 실제 수치로 교체 가능</a:t>
             </a:r>
             <a:endParaRPr lang="en-US" sz="1100" dirty="0"/>
           </a:p>

</xml_diff>

<commit_message>
Presentation: results slide — area footnote under chart, loop×4 summary box, RTL/emulator speed tiles; impact bullets aligned
Co-Authored-By: Claude Fable 5.1 <noreply@anthropic.com>
Claude-Session: https://claude.ai/code/session_01Gd73gUzQvBcmrEGA3YWYHu
</commit_message>
<xml_diff>
--- a/docs/presentation/deck_basic_fonts.pptx
+++ b/docs/presentation/deck_basic_fonts.pptx
@@ -602,7 +602,7 @@
           <a:p>
             <a:r>
               <a:rPr lang="en-US" dirty="0"/>
-              <a:t>60초. 왼쪽 그림: 회색 점(초기)→주황 점(루프 결과) 화살표 옆 숫자를 읽는다. 오른쪽 위 표 = 성능, 아래 표 = 면적, 같은 세 구조. 검은 타일 '에뮬 300분 → 10분'은 실험 1회 기준 — 11장 정량 효과(하루 반복 횟수·탐색 기간)의 근거가 된다. 면적 단위 질문이 오면 맨 아래 각주: SRAM 1 KB = 1인 상대 단위, 블록 계수의 합. 신뢰성 질문이 오면 세 번째 타일: 모든 실험이 bit-exact와 ISR 제약을 통과했고 아닌 것은 자동 폐기.</a:t>
+              <a:t>60초. 왼쪽 그림: 회색 점(초기)→주황 점(루프 결과) 화살표 옆 숫자를 읽는다. 오른쪽 위 표 = 성능, 아래 표 = 면적, 같은 세 구조. 아래 검은 박스: 'AI 반복 + 개발자 검토'가 루프 1회이고 4회로 수렴. 오른쪽 두 타일: 실행 1회가 RTL 시뮬 약 60분·에뮬레이터 약 10분 → 1분 이내 — 11장 정량 효과의 근거. 면적 단위 질문이 오면 그래프 아래 각주: SRAM 1 KB = 1인 상대 단위. 신뢰성 질문: 모든 실험이 bit-exact와 ISR 제약을 통과했고 아닌 것은 자동 폐기.</a:t>
             </a:r>
             <a:endParaRPr lang="en-US" dirty="0"/>
           </a:p>
@@ -690,7 +690,7 @@
           <a:p>
             <a:r>
               <a:rPr lang="en-US" dirty="0"/>
-              <a:t>30초. 정량 칸 첫 줄(300분→10분)이 10장 검은 타일의 파생. 나머지 대괄호는 PoC 실측. '다음' 띠는 한 문장으로 읽고 감사 인사.
+              <a:t>30초. 정량 칸 첫 두 줄이 10장 아래 박스·타일의 파생. 나머지 대괄호는 PoC 실측. '다음' 띠는 한 문장으로 읽고 감사 인사.
 제목 후보:
 1. 실리콘보다 먼저 — Cycle-level 가상 플랫폼과 파형 기반 프로파일러 위에서 AI가 도는 HW-SW Co-Optimization
 2. 파형에서 최적화까지 — 실리콘을 기다리지 않는 HW·SW 공동 최적화 루프
@@ -2509,7 +2509,7 @@
         <p:spPr>
           <a:xfrm>
             <a:off x="508406" y="1015898"/>
-            <a:ext cx="11175797" cy="508406"/>
+            <a:ext cx="11175797" cy="381305"/>
           </a:xfrm>
           <a:prstGeom prst="rect">
             <a:avLst/>
@@ -2550,12 +2550,12 @@
         </p:nvSpPr>
         <p:spPr>
           <a:xfrm>
-            <a:off x="508406" y="1714500"/>
-            <a:ext cx="6096305" cy="4063594"/>
+            <a:off x="508406" y="1524305"/>
+            <a:ext cx="6096305" cy="3301898"/>
           </a:xfrm>
           <a:prstGeom prst="roundRect">
             <a:avLst>
-              <a:gd name="adj" fmla="val 2498"/>
+              <a:gd name="adj" fmla="val 3074"/>
             </a:avLst>
           </a:prstGeom>
           <a:solidFill>
@@ -2577,7 +2577,7 @@
         </p:nvSpPr>
         <p:spPr>
           <a:xfrm>
-            <a:off x="1143000" y="4953305"/>
+            <a:off x="1143000" y="4381805"/>
             <a:ext cx="5206594" cy="0"/>
           </a:xfrm>
           <a:prstGeom prst="line">
@@ -2600,7 +2600,7 @@
         </p:nvSpPr>
         <p:spPr>
           <a:xfrm flipV="1">
-            <a:off x="1143000" y="2413102"/>
+            <a:off x="1143000" y="1841602"/>
             <a:ext cx="0" cy="2540203"/>
           </a:xfrm>
           <a:prstGeom prst="line">
@@ -2623,7 +2623,7 @@
         </p:nvSpPr>
         <p:spPr>
           <a:xfrm>
-            <a:off x="2413102" y="2476195"/>
+            <a:off x="2413102" y="1904695"/>
             <a:ext cx="0" cy="2476195"/>
           </a:xfrm>
           <a:prstGeom prst="line">
@@ -2646,7 +2646,7 @@
         </p:nvSpPr>
         <p:spPr>
           <a:xfrm>
-            <a:off x="3683203" y="2476195"/>
+            <a:off x="3683203" y="1904695"/>
             <a:ext cx="0" cy="2476195"/>
           </a:xfrm>
           <a:prstGeom prst="line">
@@ -2669,7 +2669,7 @@
         </p:nvSpPr>
         <p:spPr>
           <a:xfrm>
-            <a:off x="5778094" y="2476195"/>
+            <a:off x="5778094" y="1904695"/>
             <a:ext cx="0" cy="2476195"/>
           </a:xfrm>
           <a:prstGeom prst="line">
@@ -2692,7 +2692,7 @@
         </p:nvSpPr>
         <p:spPr>
           <a:xfrm>
-            <a:off x="2197303" y="2958998"/>
+            <a:off x="2197303" y="2387498"/>
             <a:ext cx="177394" cy="177394"/>
           </a:xfrm>
           <a:prstGeom prst="ellipse">
@@ -2712,7 +2712,7 @@
         </p:nvSpPr>
         <p:spPr>
           <a:xfrm>
-            <a:off x="3467405" y="3593592"/>
+            <a:off x="3467405" y="3022092"/>
             <a:ext cx="177394" cy="177394"/>
           </a:xfrm>
           <a:prstGeom prst="ellipse">
@@ -2732,7 +2732,7 @@
         </p:nvSpPr>
         <p:spPr>
           <a:xfrm>
-            <a:off x="5562295" y="4197096"/>
+            <a:off x="5562295" y="3625596"/>
             <a:ext cx="177394" cy="177394"/>
           </a:xfrm>
           <a:prstGeom prst="ellipse">
@@ -2752,7 +2752,7 @@
         </p:nvSpPr>
         <p:spPr>
           <a:xfrm flipV="1">
-            <a:off x="1854403" y="3149194"/>
+            <a:off x="1854403" y="2577694"/>
             <a:ext cx="381305" cy="737006"/>
           </a:xfrm>
           <a:prstGeom prst="line">
@@ -2776,7 +2776,7 @@
         </p:nvSpPr>
         <p:spPr>
           <a:xfrm>
-            <a:off x="1752905" y="3784702"/>
+            <a:off x="1752905" y="3213202"/>
             <a:ext cx="202997" cy="202997"/>
           </a:xfrm>
           <a:prstGeom prst="ellipse">
@@ -2796,7 +2796,7 @@
         </p:nvSpPr>
         <p:spPr>
           <a:xfrm flipV="1">
-            <a:off x="3060497" y="3784702"/>
+            <a:off x="3060497" y="3213202"/>
             <a:ext cx="444398" cy="737006"/>
           </a:xfrm>
           <a:prstGeom prst="line">
@@ -2820,7 +2820,7 @@
         </p:nvSpPr>
         <p:spPr>
           <a:xfrm>
-            <a:off x="2958998" y="4419295"/>
+            <a:off x="2958998" y="3847795"/>
             <a:ext cx="202997" cy="202997"/>
           </a:xfrm>
           <a:prstGeom prst="ellipse">
@@ -2840,7 +2840,7 @@
         </p:nvSpPr>
         <p:spPr>
           <a:xfrm flipV="1">
-            <a:off x="5169103" y="4381805"/>
+            <a:off x="5169103" y="3810305"/>
             <a:ext cx="431597" cy="418795"/>
           </a:xfrm>
           <a:prstGeom prst="line">
@@ -2864,7 +2864,7 @@
         </p:nvSpPr>
         <p:spPr>
           <a:xfrm>
-            <a:off x="5067605" y="4699102"/>
+            <a:off x="5067605" y="4127602"/>
             <a:ext cx="202997" cy="202997"/>
           </a:xfrm>
           <a:prstGeom prst="ellipse">
@@ -2884,7 +2884,7 @@
         </p:nvSpPr>
         <p:spPr>
           <a:xfrm flipV="1">
-            <a:off x="3060497" y="4285793"/>
+            <a:off x="3060497" y="3714293"/>
             <a:ext cx="2590495" cy="235001"/>
           </a:xfrm>
           <a:prstGeom prst="line">
@@ -2907,7 +2907,7 @@
         </p:nvSpPr>
         <p:spPr>
           <a:xfrm>
-            <a:off x="2387498" y="3276295"/>
+            <a:off x="2387498" y="2704795"/>
             <a:ext cx="1143000" cy="405994"/>
           </a:xfrm>
           <a:prstGeom prst="rect">
@@ -2969,7 +2969,7 @@
         </p:nvSpPr>
         <p:spPr>
           <a:xfrm>
-            <a:off x="3657600" y="4000500"/>
+            <a:off x="3657600" y="3429000"/>
             <a:ext cx="1143000" cy="405994"/>
           </a:xfrm>
           <a:prstGeom prst="rect">
@@ -3031,7 +3031,7 @@
         </p:nvSpPr>
         <p:spPr>
           <a:xfrm>
-            <a:off x="4063594" y="4584802"/>
+            <a:off x="4063594" y="4013302"/>
             <a:ext cx="1143000" cy="405994"/>
           </a:xfrm>
           <a:prstGeom prst="rect">
@@ -3093,7 +3093,7 @@
         </p:nvSpPr>
         <p:spPr>
           <a:xfrm>
-            <a:off x="634594" y="1828800"/>
+            <a:off x="634594" y="1625803"/>
             <a:ext cx="1904695" cy="190195"/>
           </a:xfrm>
           <a:prstGeom prst="rect">
@@ -3132,7 +3132,7 @@
         </p:nvSpPr>
         <p:spPr>
           <a:xfrm>
-            <a:off x="4507992" y="5460797"/>
+            <a:off x="4546397" y="1625803"/>
             <a:ext cx="1904695" cy="190195"/>
           </a:xfrm>
           <a:prstGeom prst="rect">
@@ -3171,7 +3171,7 @@
         </p:nvSpPr>
         <p:spPr>
           <a:xfrm>
-            <a:off x="1904695" y="5003597"/>
+            <a:off x="1904695" y="4432097"/>
             <a:ext cx="1015898" cy="190195"/>
           </a:xfrm>
           <a:prstGeom prst="rect">
@@ -3210,7 +3210,7 @@
         </p:nvSpPr>
         <p:spPr>
           <a:xfrm>
-            <a:off x="3174797" y="5003597"/>
+            <a:off x="3174797" y="4432097"/>
             <a:ext cx="1015898" cy="190195"/>
           </a:xfrm>
           <a:prstGeom prst="rect">
@@ -3249,7 +3249,7 @@
         </p:nvSpPr>
         <p:spPr>
           <a:xfrm>
-            <a:off x="5143500" y="5003597"/>
+            <a:off x="5143500" y="4432097"/>
             <a:ext cx="1270102" cy="190195"/>
           </a:xfrm>
           <a:prstGeom prst="rect">
@@ -3288,7 +3288,7 @@
         </p:nvSpPr>
         <p:spPr>
           <a:xfrm>
-            <a:off x="4317797" y="2476195"/>
+            <a:off x="4317797" y="1904695"/>
             <a:ext cx="2158898" cy="698602"/>
           </a:xfrm>
           <a:prstGeom prst="rect">
@@ -3421,7 +3421,7 @@
         </p:nvSpPr>
         <p:spPr>
           <a:xfrm>
-            <a:off x="1270102" y="2476195"/>
+            <a:off x="1270102" y="1904695"/>
             <a:ext cx="2540203" cy="190195"/>
           </a:xfrm>
           <a:prstGeom prst="rect">
@@ -3449,6 +3449,99 @@
               <a:t>[예시 — 실측으로 교체]</a:t>
             </a:r>
             <a:endParaRPr lang="en-US" sz="1100" dirty="0"/>
+          </a:p>
+        </p:txBody>
+      </p:sp>
+      <p:sp>
+        <p:nvSpPr>
+          <p:cNvPr id="32" name="Text 29"/>
+          <p:cNvSpPr txBox="1"/>
+          <p:nvPr/>
+        </p:nvSpPr>
+        <p:spPr>
+          <a:xfrm>
+            <a:off x="508406" y="4902098"/>
+            <a:ext cx="6096305" cy="405994"/>
+          </a:xfrm>
+          <a:prstGeom prst="rect">
+            <a:avLst/>
+          </a:prstGeom>
+          <a:noFill/>
+          <a:ln/>
+        </p:spPr>
+        <p:txBody>
+          <a:bodyPr wrap="square" lIns="0" tIns="0" rIns="0" bIns="0" rtlCol="0" anchor="t"/>
+          <a:lstStyle/>
+          <a:p>
+            <a:pPr algn="l" indent="0" marL="0">
+              <a:lnSpc>
+                <a:spcPct val="130000"/>
+              </a:lnSpc>
+              <a:buNone/>
+            </a:pPr>
+            <a:r>
+              <a:rPr lang="en-US" sz="1050" b="1" dirty="0">
+                <a:solidFill>
+                  <a:srgbClr val="4A5568"/>
+                </a:solidFill>
+                <a:latin typeface="Arial" pitchFamily="34" charset="0"/>
+                <a:ea typeface="Arial" pitchFamily="34" charset="-122"/>
+                <a:cs typeface="Arial" pitchFamily="34" charset="-120"/>
+              </a:rPr>
+              <a:t>면적(상대)</a:t>
+            </a:r>
+            <a:pPr algn="l" indent="0" marL="0">
+              <a:lnSpc>
+                <a:spcPct val="130000"/>
+              </a:lnSpc>
+              <a:buNone/>
+            </a:pPr>
+            <a:r>
+              <a:rPr lang="en-US" sz="1050" dirty="0">
+                <a:solidFill>
+                  <a:srgbClr val="6B7280"/>
+                </a:solidFill>
+                <a:latin typeface="Arial" pitchFamily="34" charset="0"/>
+                <a:ea typeface="Arial" pitchFamily="34" charset="-122"/>
+                <a:cs typeface="Arial" pitchFamily="34" charset="-120"/>
+              </a:rPr>
+              <a:t> = 구성 블록 비용의 합. </a:t>
+            </a:r>
+            <a:pPr algn="l" indent="0" marL="0">
+              <a:lnSpc>
+                <a:spcPct val="130000"/>
+              </a:lnSpc>
+              <a:buNone/>
+            </a:pPr>
+            <a:r>
+              <a:rPr lang="en-US" sz="1050" b="1" dirty="0">
+                <a:solidFill>
+                  <a:srgbClr val="4A5568"/>
+                </a:solidFill>
+                <a:latin typeface="Arial" pitchFamily="34" charset="0"/>
+                <a:ea typeface="Arial" pitchFamily="34" charset="-122"/>
+                <a:cs typeface="Arial" pitchFamily="34" charset="-120"/>
+              </a:rPr>
+              <a:t>SRAM 1 KB = 1</a:t>
+            </a:r>
+            <a:pPr algn="l" indent="0" marL="0">
+              <a:lnSpc>
+                <a:spcPct val="130000"/>
+              </a:lnSpc>
+              <a:buNone/>
+            </a:pPr>
+            <a:r>
+              <a:rPr lang="en-US" sz="1050" dirty="0">
+                <a:solidFill>
+                  <a:srgbClr val="6B7280"/>
+                </a:solidFill>
+                <a:latin typeface="Arial" pitchFamily="34" charset="0"/>
+                <a:ea typeface="Arial" pitchFamily="34" charset="-122"/>
+                <a:cs typeface="Arial" pitchFamily="34" charset="-120"/>
+              </a:rPr>
+              <a:t>을 기준으로 각 IP의 면적을 대략적인 상대값으로 가정해 PoC 결과를 분석했으며, 실제 수치로 교체 가능</a:t>
+            </a:r>
+            <a:endParaRPr lang="en-US" sz="1050" dirty="0"/>
           </a:p>
         </p:txBody>
       </p:sp>
@@ -3467,7 +3560,7 @@
           </p:nvPr>
         </p:nvGraphicFramePr>
         <p:xfrm>
-          <a:off x="6832397" y="1714500"/>
+          <a:off x="6832397" y="1524305"/>
           <a:ext cx="4850892" cy="914400"/>
         </p:xfrm>
         <a:graphic>
@@ -3479,7 +3572,7 @@
                 <a:gridCol w="1333195"/>
                 <a:gridCol w="1613002"/>
               </a:tblGrid>
-              <a:tr h="355702">
+              <a:tr h="381305">
                 <a:tc>
                   <a:txBody>
                     <a:bodyPr/>
@@ -3685,7 +3778,7 @@
                   </a:tcPr>
                 </a:tc>
               </a:tr>
-              <a:tr h="355702">
+              <a:tr h="381305">
                 <a:tc>
                   <a:txBody>
                     <a:bodyPr/>
@@ -3891,7 +3984,7 @@
                   </a:tcPr>
                 </a:tc>
               </a:tr>
-              <a:tr h="355702">
+              <a:tr h="381305">
                 <a:tc>
                   <a:txBody>
                     <a:bodyPr/>
@@ -4097,7 +4190,7 @@
                   </a:tcPr>
                 </a:tc>
               </a:tr>
-              <a:tr h="355702">
+              <a:tr h="381305">
                 <a:tc>
                   <a:txBody>
                     <a:bodyPr/>
@@ -4322,7 +4415,7 @@
           </p:nvPr>
         </p:nvGraphicFramePr>
         <p:xfrm>
-          <a:off x="6832397" y="3556102"/>
+          <a:off x="6832397" y="3364992"/>
           <a:ext cx="4850892" cy="914400"/>
         </p:xfrm>
         <a:graphic>
@@ -4334,7 +4427,7 @@
                 <a:gridCol w="1333195"/>
                 <a:gridCol w="1613002"/>
               </a:tblGrid>
-              <a:tr h="355702">
+              <a:tr h="381305">
                 <a:tc>
                   <a:txBody>
                     <a:bodyPr/>
@@ -4540,7 +4633,7 @@
                   </a:tcPr>
                 </a:tc>
               </a:tr>
-              <a:tr h="355702">
+              <a:tr h="381305">
                 <a:tc>
                   <a:txBody>
                     <a:bodyPr/>
@@ -4746,7 +4839,7 @@
                   </a:tcPr>
                 </a:tc>
               </a:tr>
-              <a:tr h="355702">
+              <a:tr h="381305">
                 <a:tc>
                   <a:txBody>
                     <a:bodyPr/>
@@ -4952,7 +5045,7 @@
                   </a:tcPr>
                 </a:tc>
               </a:tr>
-              <a:tr h="355702">
+              <a:tr h="381305">
                 <a:tc>
                   <a:txBody>
                     <a:bodyPr/>
@@ -5164,18 +5257,18 @@
       </p:graphicFrame>
       <p:sp>
         <p:nvSpPr>
-          <p:cNvPr id="34" name="Shape 29"/>
-          <p:cNvSpPr/>
-          <p:nvPr/>
-        </p:nvSpPr>
-        <p:spPr>
-          <a:xfrm>
-            <a:off x="6832397" y="5270602"/>
-            <a:ext cx="1904695" cy="698602"/>
+          <p:cNvPr id="35" name="Shape 30"/>
+          <p:cNvSpPr/>
+          <p:nvPr/>
+        </p:nvSpPr>
+        <p:spPr>
+          <a:xfrm>
+            <a:off x="508406" y="5372100"/>
+            <a:ext cx="6451092" cy="787298"/>
           </a:xfrm>
           <a:prstGeom prst="roundRect">
             <a:avLst>
-              <a:gd name="adj" fmla="val 9031"/>
+              <a:gd name="adj" fmla="val 9640"/>
             </a:avLst>
           </a:prstGeom>
           <a:solidFill>
@@ -5186,53 +5279,14 @@
       </p:sp>
       <p:sp>
         <p:nvSpPr>
-          <p:cNvPr id="35" name="Text 30"/>
-          <p:cNvSpPr txBox="1"/>
-          <p:nvPr/>
-        </p:nvSpPr>
-        <p:spPr>
-          <a:xfrm>
-            <a:off x="6972300" y="5359298"/>
-            <a:ext cx="1714500" cy="177394"/>
-          </a:xfrm>
-          <a:prstGeom prst="rect">
-            <a:avLst/>
-          </a:prstGeom>
-          <a:noFill/>
-          <a:ln/>
-        </p:spPr>
-        <p:txBody>
-          <a:bodyPr wrap="square" lIns="0" tIns="0" rIns="0" bIns="0" rtlCol="0" anchor="t"/>
-          <a:lstStyle/>
-          <a:p>
-            <a:pPr algn="l" indent="0" marL="0">
-              <a:buNone/>
-            </a:pPr>
-            <a:r>
-              <a:rPr lang="en-US" sz="1050" dirty="0">
-                <a:solidFill>
-                  <a:srgbClr val="8FA3B8"/>
-                </a:solidFill>
-                <a:latin typeface="Arial" pitchFamily="34" charset="0"/>
-                <a:ea typeface="Arial" pitchFamily="34" charset="-122"/>
-                <a:cs typeface="Arial" pitchFamily="34" charset="-120"/>
-              </a:rPr>
-              <a:t>실험 1회 · 에뮬레이터 대비</a:t>
-            </a:r>
-            <a:endParaRPr lang="en-US" sz="1050" dirty="0"/>
-          </a:p>
-        </p:txBody>
-      </p:sp>
-      <p:sp>
-        <p:nvSpPr>
           <p:cNvPr id="36" name="Text 31"/>
           <p:cNvSpPr txBox="1"/>
           <p:nvPr/>
         </p:nvSpPr>
         <p:spPr>
           <a:xfrm>
-            <a:off x="6972300" y="5575097"/>
-            <a:ext cx="1714500" cy="317297"/>
+            <a:off x="685800" y="5447995"/>
+            <a:ext cx="6096305" cy="190195"/>
           </a:xfrm>
           <a:prstGeom prst="rect">
             <a:avLst/>
@@ -5248,7 +5302,7 @@
               <a:buNone/>
             </a:pPr>
             <a:r>
-              <a:rPr lang="en-US" sz="1700" b="1" strike="sngStrike" dirty="0">
+              <a:rPr lang="en-US" sz="1100" dirty="0">
                 <a:solidFill>
                   <a:srgbClr val="8FA3B8"/>
                 </a:solidFill>
@@ -5256,54 +5310,96 @@
                 <a:ea typeface="Arial" pitchFamily="34" charset="-122"/>
                 <a:cs typeface="Arial" pitchFamily="34" charset="-120"/>
               </a:rPr>
-              <a:t>300분</a:t>
+              <a:t>AI 반복 최적화 + 개발자 검토 = 루프 1회 · </a:t>
             </a:r>
             <a:pPr algn="l" indent="0" marL="0">
               <a:buNone/>
             </a:pPr>
             <a:r>
-              <a:rPr lang="en-US" sz="1700" b="1" dirty="0">
-                <a:solidFill>
-                  <a:srgbClr val="FFFFFF"/>
-                </a:solidFill>
-                <a:latin typeface="Arial" pitchFamily="34" charset="0"/>
-                <a:ea typeface="Arial" pitchFamily="34" charset="-122"/>
-                <a:cs typeface="Arial" pitchFamily="34" charset="-120"/>
-              </a:rPr>
-              <a:t> → </a:t>
+              <a:rPr lang="en-US" sz="1100" b="1" dirty="0">
+                <a:solidFill>
+                  <a:srgbClr val="E8A33D"/>
+                </a:solidFill>
+                <a:latin typeface="Arial" pitchFamily="34" charset="0"/>
+                <a:ea typeface="Arial" pitchFamily="34" charset="-122"/>
+                <a:cs typeface="Arial" pitchFamily="34" charset="-120"/>
+              </a:rPr>
+              <a:t>4회</a:t>
             </a:r>
             <a:pPr algn="l" indent="0" marL="0">
               <a:buNone/>
             </a:pPr>
             <a:r>
-              <a:rPr lang="en-US" sz="1700" b="1" dirty="0">
-                <a:solidFill>
-                  <a:srgbClr val="2FA6A0"/>
-                </a:solidFill>
-                <a:latin typeface="Arial" pitchFamily="34" charset="0"/>
-                <a:ea typeface="Arial" pitchFamily="34" charset="-122"/>
-                <a:cs typeface="Arial" pitchFamily="34" charset="-120"/>
-              </a:rPr>
-              <a:t>10분</a:t>
-            </a:r>
-            <a:endParaRPr lang="en-US" sz="1700" dirty="0"/>
-          </a:p>
-        </p:txBody>
-      </p:sp>
-      <p:sp>
-        <p:nvSpPr>
-          <p:cNvPr id="37" name="Shape 32"/>
-          <p:cNvSpPr/>
-          <p:nvPr/>
-        </p:nvSpPr>
-        <p:spPr>
-          <a:xfrm>
-            <a:off x="8838590" y="5270602"/>
-            <a:ext cx="1371600" cy="698602"/>
+              <a:rPr lang="en-US" sz="1100" dirty="0">
+                <a:solidFill>
+                  <a:srgbClr val="8FA3B8"/>
+                </a:solidFill>
+                <a:latin typeface="Arial" pitchFamily="34" charset="0"/>
+                <a:ea typeface="Arial" pitchFamily="34" charset="-122"/>
+                <a:cs typeface="Arial" pitchFamily="34" charset="-120"/>
+              </a:rPr>
+              <a:t>로 얻은 결과</a:t>
+            </a:r>
+            <a:endParaRPr lang="en-US" sz="1100" dirty="0"/>
+          </a:p>
+        </p:txBody>
+      </p:sp>
+      <p:sp>
+        <p:nvSpPr>
+          <p:cNvPr id="37" name="Text 32"/>
+          <p:cNvSpPr txBox="1"/>
+          <p:nvPr/>
+        </p:nvSpPr>
+        <p:spPr>
+          <a:xfrm>
+            <a:off x="685800" y="5650992"/>
+            <a:ext cx="6096305" cy="482803"/>
+          </a:xfrm>
+          <a:prstGeom prst="rect">
+            <a:avLst/>
+          </a:prstGeom>
+          <a:noFill/>
+          <a:ln/>
+        </p:spPr>
+        <p:txBody>
+          <a:bodyPr wrap="square" lIns="0" tIns="0" rIns="0" bIns="0" rtlCol="0" anchor="t"/>
+          <a:lstStyle/>
+          <a:p>
+            <a:pPr algn="l" indent="0" marL="0">
+              <a:lnSpc>
+                <a:spcPct val="130000"/>
+              </a:lnSpc>
+              <a:buNone/>
+            </a:pPr>
+            <a:r>
+              <a:rPr lang="en-US" sz="1150" dirty="0">
+                <a:solidFill>
+                  <a:srgbClr val="F5F4EE"/>
+                </a:solidFill>
+                <a:latin typeface="Arial" pitchFamily="34" charset="0"/>
+                <a:ea typeface="Arial" pitchFamily="34" charset="-122"/>
+                <a:cs typeface="Arial" pitchFamily="34" charset="-120"/>
+              </a:rPr>
+              <a:t>루프마다 AI가 실험 [__]회 → 개발자가 근거 검토 · HW 변경 승인 → 다음 루프. 4회 만에 세 구조 모두 수렴 — 총 실험 [__]회 · [__]시간</a:t>
+            </a:r>
+            <a:endParaRPr lang="en-US" sz="1150" dirty="0"/>
+          </a:p>
+        </p:txBody>
+      </p:sp>
+      <p:sp>
+        <p:nvSpPr>
+          <p:cNvPr id="38" name="Shape 33"/>
+          <p:cNvSpPr/>
+          <p:nvPr/>
+        </p:nvSpPr>
+        <p:spPr>
+          <a:xfrm>
+            <a:off x="7188098" y="5372100"/>
+            <a:ext cx="2184502" cy="787298"/>
           </a:xfrm>
           <a:prstGeom prst="roundRect">
             <a:avLst>
-              <a:gd name="adj" fmla="val 9031"/>
+              <a:gd name="adj" fmla="val 9640"/>
             </a:avLst>
           </a:prstGeom>
           <a:solidFill>
@@ -5319,53 +5415,14 @@
       </p:sp>
       <p:sp>
         <p:nvSpPr>
-          <p:cNvPr id="38" name="Text 33"/>
-          <p:cNvSpPr txBox="1"/>
-          <p:nvPr/>
-        </p:nvSpPr>
-        <p:spPr>
-          <a:xfrm>
-            <a:off x="8952890" y="5359298"/>
-            <a:ext cx="1206094" cy="177394"/>
-          </a:xfrm>
-          <a:prstGeom prst="rect">
-            <a:avLst/>
-          </a:prstGeom>
-          <a:noFill/>
-          <a:ln/>
-        </p:spPr>
-        <p:txBody>
-          <a:bodyPr wrap="square" lIns="0" tIns="0" rIns="0" bIns="0" rtlCol="0" anchor="t"/>
-          <a:lstStyle/>
-          <a:p>
-            <a:pPr algn="l" indent="0" marL="0">
-              <a:buNone/>
-            </a:pPr>
-            <a:r>
-              <a:rPr lang="en-US" sz="1000" dirty="0">
-                <a:solidFill>
-                  <a:srgbClr val="6B7280"/>
-                </a:solidFill>
-                <a:latin typeface="Arial" pitchFamily="34" charset="0"/>
-                <a:ea typeface="Arial" pitchFamily="34" charset="-122"/>
-                <a:cs typeface="Arial" pitchFamily="34" charset="-120"/>
-              </a:rPr>
-              <a:t>AI 반복 · 사람 검토</a:t>
-            </a:r>
-            <a:endParaRPr lang="en-US" sz="1000" dirty="0"/>
-          </a:p>
-        </p:txBody>
-      </p:sp>
-      <p:sp>
-        <p:nvSpPr>
           <p:cNvPr id="39" name="Text 34"/>
           <p:cNvSpPr txBox="1"/>
           <p:nvPr/>
         </p:nvSpPr>
         <p:spPr>
           <a:xfrm>
-            <a:off x="8952890" y="5575097"/>
-            <a:ext cx="1206094" cy="317297"/>
+            <a:off x="7340803" y="5460797"/>
+            <a:ext cx="1904695" cy="177394"/>
           </a:xfrm>
           <a:prstGeom prst="rect">
             <a:avLst/>
@@ -5381,7 +5438,60 @@
               <a:buNone/>
             </a:pPr>
             <a:r>
-              <a:rPr lang="en-US" sz="1500" b="1" dirty="0">
+              <a:rPr lang="en-US" sz="1050" dirty="0">
+                <a:solidFill>
+                  <a:srgbClr val="6B7280"/>
+                </a:solidFill>
+                <a:latin typeface="Arial" pitchFamily="34" charset="0"/>
+                <a:ea typeface="Arial" pitchFamily="34" charset="-122"/>
+                <a:cs typeface="Arial" pitchFamily="34" charset="-120"/>
+              </a:rPr>
+              <a:t>RTL 시뮬 대비 · 실행 1회</a:t>
+            </a:r>
+            <a:endParaRPr lang="en-US" sz="1050" dirty="0"/>
+          </a:p>
+        </p:txBody>
+      </p:sp>
+      <p:sp>
+        <p:nvSpPr>
+          <p:cNvPr id="40" name="Text 35"/>
+          <p:cNvSpPr txBox="1"/>
+          <p:nvPr/>
+        </p:nvSpPr>
+        <p:spPr>
+          <a:xfrm>
+            <a:off x="7340803" y="5715000"/>
+            <a:ext cx="1904695" cy="317297"/>
+          </a:xfrm>
+          <a:prstGeom prst="rect">
+            <a:avLst/>
+          </a:prstGeom>
+          <a:noFill/>
+          <a:ln/>
+        </p:spPr>
+        <p:txBody>
+          <a:bodyPr wrap="square" lIns="0" tIns="0" rIns="0" bIns="0" rtlCol="0" anchor="t"/>
+          <a:lstStyle/>
+          <a:p>
+            <a:pPr algn="l" indent="0" marL="0">
+              <a:buNone/>
+            </a:pPr>
+            <a:r>
+              <a:rPr lang="en-US" sz="1600" b="1" strike="sngStrike" dirty="0">
+                <a:solidFill>
+                  <a:srgbClr val="6B7280"/>
+                </a:solidFill>
+                <a:latin typeface="Arial" pitchFamily="34" charset="0"/>
+                <a:ea typeface="Arial" pitchFamily="34" charset="-122"/>
+                <a:cs typeface="Arial" pitchFamily="34" charset="-120"/>
+              </a:rPr>
+              <a:t>약 60분</a:t>
+            </a:r>
+            <a:pPr algn="l" indent="0" marL="0">
+              <a:buNone/>
+            </a:pPr>
+            <a:r>
+              <a:rPr lang="en-US" sz="1600" b="1" dirty="0">
                 <a:solidFill>
                   <a:srgbClr val="0F1B2D"/>
                 </a:solidFill>
@@ -5389,26 +5499,40 @@
                 <a:ea typeface="Arial" pitchFamily="34" charset="-122"/>
                 <a:cs typeface="Arial" pitchFamily="34" charset="-120"/>
               </a:rPr>
-              <a:t>[__] · [__]회</a:t>
-            </a:r>
-            <a:endParaRPr lang="en-US" sz="1500" dirty="0"/>
-          </a:p>
-        </p:txBody>
-      </p:sp>
-      <p:sp>
-        <p:nvSpPr>
-          <p:cNvPr id="40" name="Shape 35"/>
-          <p:cNvSpPr/>
-          <p:nvPr/>
-        </p:nvSpPr>
-        <p:spPr>
-          <a:xfrm>
-            <a:off x="10311689" y="5270602"/>
-            <a:ext cx="1371600" cy="698602"/>
+              <a:t> → </a:t>
+            </a:r>
+            <a:pPr algn="l" indent="0" marL="0">
+              <a:buNone/>
+            </a:pPr>
+            <a:r>
+              <a:rPr lang="en-US" sz="1600" b="1" dirty="0">
+                <a:solidFill>
+                  <a:srgbClr val="1F7F7A"/>
+                </a:solidFill>
+                <a:latin typeface="Arial" pitchFamily="34" charset="0"/>
+                <a:ea typeface="Arial" pitchFamily="34" charset="-122"/>
+                <a:cs typeface="Arial" pitchFamily="34" charset="-120"/>
+              </a:rPr>
+              <a:t>1분 이내</a:t>
+            </a:r>
+            <a:endParaRPr lang="en-US" sz="1600" dirty="0"/>
+          </a:p>
+        </p:txBody>
+      </p:sp>
+      <p:sp>
+        <p:nvSpPr>
+          <p:cNvPr id="41" name="Shape 36"/>
+          <p:cNvSpPr/>
+          <p:nvPr/>
+        </p:nvSpPr>
+        <p:spPr>
+          <a:xfrm>
+            <a:off x="9499702" y="5372100"/>
+            <a:ext cx="2184502" cy="787298"/>
           </a:xfrm>
           <a:prstGeom prst="roundRect">
             <a:avLst>
-              <a:gd name="adj" fmla="val 9031"/>
+              <a:gd name="adj" fmla="val 9640"/>
             </a:avLst>
           </a:prstGeom>
           <a:solidFill>
@@ -5424,53 +5548,14 @@
       </p:sp>
       <p:sp>
         <p:nvSpPr>
-          <p:cNvPr id="41" name="Text 36"/>
-          <p:cNvSpPr txBox="1"/>
-          <p:nvPr/>
-        </p:nvSpPr>
-        <p:spPr>
-          <a:xfrm>
-            <a:off x="10425989" y="5359298"/>
-            <a:ext cx="1206094" cy="177394"/>
-          </a:xfrm>
-          <a:prstGeom prst="rect">
-            <a:avLst/>
-          </a:prstGeom>
-          <a:noFill/>
-          <a:ln/>
-        </p:spPr>
-        <p:txBody>
-          <a:bodyPr wrap="square" lIns="0" tIns="0" rIns="0" bIns="0" rtlCol="0" anchor="t"/>
-          <a:lstStyle/>
-          <a:p>
-            <a:pPr algn="l" indent="0" marL="0">
-              <a:buNone/>
-            </a:pPr>
-            <a:r>
-              <a:rPr lang="en-US" sz="1000" dirty="0">
-                <a:solidFill>
-                  <a:srgbClr val="6B7280"/>
-                </a:solidFill>
-                <a:latin typeface="Arial" pitchFamily="34" charset="0"/>
-                <a:ea typeface="Arial" pitchFamily="34" charset="-122"/>
-                <a:cs typeface="Arial" pitchFamily="34" charset="-120"/>
-              </a:rPr>
-              <a:t>bit-exact · ISR 제약</a:t>
-            </a:r>
-            <a:endParaRPr lang="en-US" sz="1000" dirty="0"/>
-          </a:p>
-        </p:txBody>
-      </p:sp>
-      <p:sp>
-        <p:nvSpPr>
           <p:cNvPr id="42" name="Text 37"/>
           <p:cNvSpPr txBox="1"/>
           <p:nvPr/>
         </p:nvSpPr>
         <p:spPr>
           <a:xfrm>
-            <a:off x="10425989" y="5575097"/>
-            <a:ext cx="1206094" cy="317297"/>
+            <a:off x="9651492" y="5460797"/>
+            <a:ext cx="1904695" cy="177394"/>
           </a:xfrm>
           <a:prstGeom prst="rect">
             <a:avLst/>
@@ -5486,17 +5571,17 @@
               <a:buNone/>
             </a:pPr>
             <a:r>
-              <a:rPr lang="en-US" sz="1500" b="1" dirty="0">
-                <a:solidFill>
-                  <a:srgbClr val="0F1B2D"/>
-                </a:solidFill>
-                <a:latin typeface="Arial" pitchFamily="34" charset="0"/>
-                <a:ea typeface="Arial" pitchFamily="34" charset="-122"/>
-                <a:cs typeface="Arial" pitchFamily="34" charset="-120"/>
-              </a:rPr>
-              <a:t>전 실험 통과</a:t>
-            </a:r>
-            <a:endParaRPr lang="en-US" sz="1500" dirty="0"/>
+              <a:rPr lang="en-US" sz="1050" dirty="0">
+                <a:solidFill>
+                  <a:srgbClr val="6B7280"/>
+                </a:solidFill>
+                <a:latin typeface="Arial" pitchFamily="34" charset="0"/>
+                <a:ea typeface="Arial" pitchFamily="34" charset="-122"/>
+                <a:cs typeface="Arial" pitchFamily="34" charset="-120"/>
+              </a:rPr>
+              <a:t>에뮬레이터 대비 · 실행 1회</a:t>
+            </a:r>
+            <a:endParaRPr lang="en-US" sz="1050" dirty="0"/>
           </a:p>
         </p:txBody>
       </p:sp>
@@ -5508,8 +5593,8 @@
         </p:nvSpPr>
         <p:spPr>
           <a:xfrm>
-            <a:off x="508406" y="5905195"/>
-            <a:ext cx="11175797" cy="254203"/>
+            <a:off x="9651492" y="5715000"/>
+            <a:ext cx="1904695" cy="317297"/>
           </a:xfrm>
           <a:prstGeom prst="rect">
             <a:avLst/>
@@ -5525,59 +5610,45 @@
               <a:buNone/>
             </a:pPr>
             <a:r>
-              <a:rPr lang="en-US" sz="1100" b="1" dirty="0">
-                <a:solidFill>
-                  <a:srgbClr val="4A5568"/>
-                </a:solidFill>
-                <a:latin typeface="Arial" pitchFamily="34" charset="0"/>
-                <a:ea typeface="Arial" pitchFamily="34" charset="-122"/>
-                <a:cs typeface="Arial" pitchFamily="34" charset="-120"/>
-              </a:rPr>
-              <a:t>면적(상대)</a:t>
+              <a:rPr lang="en-US" sz="1600" b="1" strike="sngStrike" dirty="0">
+                <a:solidFill>
+                  <a:srgbClr val="6B7280"/>
+                </a:solidFill>
+                <a:latin typeface="Arial" pitchFamily="34" charset="0"/>
+                <a:ea typeface="Arial" pitchFamily="34" charset="-122"/>
+                <a:cs typeface="Arial" pitchFamily="34" charset="-120"/>
+              </a:rPr>
+              <a:t>약 10분</a:t>
             </a:r>
             <a:pPr algn="l" indent="0" marL="0">
               <a:buNone/>
             </a:pPr>
             <a:r>
-              <a:rPr lang="en-US" sz="1100" dirty="0">
-                <a:solidFill>
-                  <a:srgbClr val="6B7280"/>
-                </a:solidFill>
-                <a:latin typeface="Arial" pitchFamily="34" charset="0"/>
-                <a:ea typeface="Arial" pitchFamily="34" charset="-122"/>
-                <a:cs typeface="Arial" pitchFamily="34" charset="-120"/>
-              </a:rPr>
-              <a:t> = 구성 블록 비용의 합. </a:t>
+              <a:rPr lang="en-US" sz="1600" b="1" dirty="0">
+                <a:solidFill>
+                  <a:srgbClr val="0F1B2D"/>
+                </a:solidFill>
+                <a:latin typeface="Arial" pitchFamily="34" charset="0"/>
+                <a:ea typeface="Arial" pitchFamily="34" charset="-122"/>
+                <a:cs typeface="Arial" pitchFamily="34" charset="-120"/>
+              </a:rPr>
+              <a:t> → </a:t>
             </a:r>
             <a:pPr algn="l" indent="0" marL="0">
               <a:buNone/>
             </a:pPr>
             <a:r>
-              <a:rPr lang="en-US" sz="1100" b="1" dirty="0">
-                <a:solidFill>
-                  <a:srgbClr val="4A5568"/>
-                </a:solidFill>
-                <a:latin typeface="Arial" pitchFamily="34" charset="0"/>
-                <a:ea typeface="Arial" pitchFamily="34" charset="-122"/>
-                <a:cs typeface="Arial" pitchFamily="34" charset="-120"/>
-              </a:rPr>
-              <a:t>SRAM 1 KB = 1</a:t>
-            </a:r>
-            <a:pPr algn="l" indent="0" marL="0">
-              <a:buNone/>
-            </a:pPr>
-            <a:r>
-              <a:rPr lang="en-US" sz="1100" dirty="0">
-                <a:solidFill>
-                  <a:srgbClr val="6B7280"/>
-                </a:solidFill>
-                <a:latin typeface="Arial" pitchFamily="34" charset="0"/>
-                <a:ea typeface="Arial" pitchFamily="34" charset="-122"/>
-                <a:cs typeface="Arial" pitchFamily="34" charset="-120"/>
-              </a:rPr>
-              <a:t>을 기준으로 각 IP의 면적을 대략적인 상대값으로 가정해 PoC 결과를 분석했으며, 실제 수치로 교체 가능</a:t>
-            </a:r>
-            <a:endParaRPr lang="en-US" sz="1100" dirty="0"/>
+              <a:rPr lang="en-US" sz="1600" b="1" dirty="0">
+                <a:solidFill>
+                  <a:srgbClr val="1F7F7A"/>
+                </a:solidFill>
+                <a:latin typeface="Arial" pitchFamily="34" charset="0"/>
+                <a:ea typeface="Arial" pitchFamily="34" charset="-122"/>
+                <a:cs typeface="Arial" pitchFamily="34" charset="-120"/>
+              </a:rPr>
+              <a:t>1분 이내</a:t>
+            </a:r>
+            <a:endParaRPr lang="en-US" sz="1600" dirty="0"/>
           </a:p>
         </p:txBody>
       </p:sp>
@@ -6044,7 +6115,7 @@
                 <a:ea typeface="Arial" pitchFamily="34" charset="-122"/>
                 <a:cs typeface="Arial" pitchFamily="34" charset="-120"/>
               </a:rPr>
-              <a:t>실험 1회 에뮬레이터 300분 → 10분, 같은 시간에 30배 더 많은 시도</a:t>
+              <a:t>실행 1회 1분 이내 — RTL 시뮬레이션 약 60분, 에뮬레이터 약 10분 대비</a:t>
             </a:r>
             <a:endParaRPr lang="en-US" sz="1500" dirty="0"/>
           </a:p>
@@ -6068,7 +6139,7 @@
                 <a:ea typeface="Arial" pitchFamily="34" charset="-122"/>
                 <a:cs typeface="Arial" pitchFamily="34" charset="-120"/>
               </a:rPr>
-              <a:t>하루 [__]회 반복 — 사람이 손으로 하면 [__]회</a:t>
+              <a:t>AI 반복 + 개발자 검토 루프 4회로 수렴 — 총 실험 [__]회 · [__]시간</a:t>
             </a:r>
             <a:endParaRPr lang="en-US" sz="1500" dirty="0"/>
           </a:p>

</xml_diff>

<commit_message>
Presentation: KWS open-source provenance on PoC slide + Q&A
Co-Authored-By: Claude Fable 5.1 <noreply@anthropic.com>
Claude-Session: https://claude.ai/code/session_01Gd73gUzQvBcmrEGA3YWYHu
</commit_message>
<xml_diff>
--- a/docs/presentation/deck_basic_fonts.pptx
+++ b/docs/presentation/deck_basic_fonts.pptx
@@ -1576,7 +1576,7 @@
           <a:p>
             <a:r>
               <a:rPr lang="en-US" dirty="0"/>
-              <a:t>50초. 왼쪽: Base(검정)에 예산 280부터 TCM(청록 점선), 470부터 MAC(주황 점선)이 더해진다. 주황 점이 AI가 고르는 HW knob. 오른쪽: '소리가 들어와서 yes라는 답이 나오는 데 몇 cycle 걸리나'가 측정값. 아래 세 칸이 일부러 심은 상충 관계. 면적 예산 3단계(≤170/≤280/≤470), SW 소스 동일.</a:t>
+              <a:t>50초. 출처 질문: 모델 Arm ML-zoo DS-CNN Small(Hello Edge 논문 구조), 커널 CMSIS-NN 7.0, 전처리 CMSIS-DSP 1.16, 데이터 Google Speech Commands v2. 우리가 만든 것은 HAL·배치 knob·MAC 오프로드 커널·골든 검증·AI 루프. 왼쪽: Base(검정)에 예산 280부터 TCM(청록 점선), 470부터 MAC(주황 점선)이 더해진다. 주황 점이 AI가 고르는 HW knob. 오른쪽: '소리가 들어와서 yes라는 답이 나오는 데 몇 cycle 걸리나'가 측정값. 아래 세 칸이 일부러 심은 상충 관계. 면적 예산 3단계(≤170/≤280/≤470), SW 소스 동일.</a:t>
             </a:r>
             <a:endParaRPr lang="en-US" dirty="0"/>
           </a:p>
@@ -24596,7 +24596,7 @@
                 <a:ea typeface="Arial" pitchFamily="34" charset="-122"/>
                 <a:cs typeface="Arial" pitchFamily="34" charset="-120"/>
               </a:rPr>
-              <a:t>INT8 · 2.7 M MAC</a:t>
+              <a:t>DS-CNN · 2.7 M MAC</a:t>
             </a:r>
             <a:endParaRPr lang="en-US" sz="1400" dirty="0"/>
           </a:p>
@@ -24628,7 +24628,69 @@
       </p:sp>
       <p:sp>
         <p:nvSpPr>
-          <p:cNvPr id="107" name="Shape 104"/>
+          <p:cNvPr id="107" name="Text 104"/>
+          <p:cNvSpPr txBox="1"/>
+          <p:nvPr/>
+        </p:nvSpPr>
+        <p:spPr>
+          <a:xfrm>
+            <a:off x="6096305" y="4038905"/>
+            <a:ext cx="4572000" cy="355702"/>
+          </a:xfrm>
+          <a:prstGeom prst="rect">
+            <a:avLst/>
+          </a:prstGeom>
+          <a:noFill/>
+          <a:ln/>
+        </p:spPr>
+        <p:txBody>
+          <a:bodyPr wrap="square" lIns="0" tIns="0" rIns="0" bIns="0" rtlCol="0" anchor="t"/>
+          <a:lstStyle/>
+          <a:p>
+            <a:pPr algn="l" indent="0" marL="0">
+              <a:lnSpc>
+                <a:spcPct val="130000"/>
+              </a:lnSpc>
+              <a:buNone/>
+            </a:pPr>
+            <a:r>
+              <a:rPr lang="en-US" sz="950" dirty="0">
+                <a:solidFill>
+                  <a:srgbClr val="6B7280"/>
+                </a:solidFill>
+                <a:latin typeface="Arial" pitchFamily="34" charset="0"/>
+                <a:ea typeface="Arial" pitchFamily="34" charset="-122"/>
+                <a:cs typeface="Arial" pitchFamily="34" charset="-120"/>
+              </a:rPr>
+              <a:t>출처 — 모델 Arm ML-zoo DS-CNN Small · 커널 CMSIS-NN · 전처리 CMSIS-DSP</a:t>
+            </a:r>
+            <a:endParaRPr lang="en-US" sz="950" dirty="0"/>
+          </a:p>
+          <a:p>
+            <a:pPr algn="l" indent="0" marL="0">
+              <a:lnSpc>
+                <a:spcPct val="130000"/>
+              </a:lnSpc>
+              <a:buNone/>
+            </a:pPr>
+            <a:r>
+              <a:rPr lang="en-US" sz="950" dirty="0">
+                <a:solidFill>
+                  <a:srgbClr val="6B7280"/>
+                </a:solidFill>
+                <a:latin typeface="Arial" pitchFamily="34" charset="0"/>
+                <a:ea typeface="Arial" pitchFamily="34" charset="-122"/>
+                <a:cs typeface="Arial" pitchFamily="34" charset="-120"/>
+              </a:rPr>
+              <a:t>데이터 Google Speech Commands v2 · 모두 공개 자산 · TFLite 참조와 bit-exact</a:t>
+            </a:r>
+            <a:endParaRPr lang="en-US" sz="950" dirty="0"/>
+          </a:p>
+        </p:txBody>
+      </p:sp>
+      <p:sp>
+        <p:nvSpPr>
+          <p:cNvPr id="108" name="Shape 105"/>
           <p:cNvSpPr/>
           <p:nvPr/>
         </p:nvSpPr>
@@ -24650,7 +24712,7 @@
       </p:sp>
       <p:sp>
         <p:nvSpPr>
-          <p:cNvPr id="108" name="Text 105"/>
+          <p:cNvPr id="109" name="Text 106"/>
           <p:cNvSpPr txBox="1"/>
           <p:nvPr/>
         </p:nvSpPr>
@@ -24689,7 +24751,7 @@
       </p:sp>
       <p:sp>
         <p:nvSpPr>
-          <p:cNvPr id="109" name="Shape 106"/>
+          <p:cNvPr id="110" name="Shape 107"/>
           <p:cNvSpPr/>
           <p:nvPr/>
         </p:nvSpPr>
@@ -24711,7 +24773,7 @@
       </p:sp>
       <p:sp>
         <p:nvSpPr>
-          <p:cNvPr id="110" name="Text 107"/>
+          <p:cNvPr id="111" name="Text 108"/>
           <p:cNvSpPr txBox="1"/>
           <p:nvPr/>
         </p:nvSpPr>
@@ -24750,7 +24812,7 @@
       </p:sp>
       <p:sp>
         <p:nvSpPr>
-          <p:cNvPr id="111" name="Text 108"/>
+          <p:cNvPr id="112" name="Text 109"/>
           <p:cNvSpPr txBox="1"/>
           <p:nvPr/>
         </p:nvSpPr>
@@ -24789,7 +24851,7 @@
       </p:sp>
       <p:sp>
         <p:nvSpPr>
-          <p:cNvPr id="112" name="Text 109"/>
+          <p:cNvPr id="113" name="Text 110"/>
           <p:cNvSpPr txBox="1"/>
           <p:nvPr/>
         </p:nvSpPr>
@@ -24828,7 +24890,7 @@
       </p:sp>
       <p:sp>
         <p:nvSpPr>
-          <p:cNvPr id="113" name="Shape 110"/>
+          <p:cNvPr id="114" name="Shape 111"/>
           <p:cNvSpPr/>
           <p:nvPr/>
         </p:nvSpPr>
@@ -24855,7 +24917,7 @@
       </p:sp>
       <p:sp>
         <p:nvSpPr>
-          <p:cNvPr id="114" name="Shape 111"/>
+          <p:cNvPr id="115" name="Shape 112"/>
           <p:cNvSpPr/>
           <p:nvPr/>
         </p:nvSpPr>
@@ -24875,7 +24937,7 @@
       </p:sp>
       <p:sp>
         <p:nvSpPr>
-          <p:cNvPr id="115" name="Text 112"/>
+          <p:cNvPr id="116" name="Text 113"/>
           <p:cNvSpPr txBox="1"/>
           <p:nvPr/>
         </p:nvSpPr>
@@ -24928,7 +24990,7 @@
       </p:sp>
       <p:sp>
         <p:nvSpPr>
-          <p:cNvPr id="116" name="Shape 113"/>
+          <p:cNvPr id="117" name="Shape 114"/>
           <p:cNvSpPr/>
           <p:nvPr/>
         </p:nvSpPr>
@@ -24955,7 +25017,7 @@
       </p:sp>
       <p:sp>
         <p:nvSpPr>
-          <p:cNvPr id="117" name="Shape 114"/>
+          <p:cNvPr id="118" name="Shape 115"/>
           <p:cNvSpPr/>
           <p:nvPr/>
         </p:nvSpPr>
@@ -24975,7 +25037,7 @@
       </p:sp>
       <p:sp>
         <p:nvSpPr>
-          <p:cNvPr id="118" name="Text 115"/>
+          <p:cNvPr id="119" name="Text 116"/>
           <p:cNvSpPr txBox="1"/>
           <p:nvPr/>
         </p:nvSpPr>
@@ -25028,7 +25090,7 @@
       </p:sp>
       <p:sp>
         <p:nvSpPr>
-          <p:cNvPr id="119" name="Shape 116"/>
+          <p:cNvPr id="120" name="Shape 117"/>
           <p:cNvSpPr/>
           <p:nvPr/>
         </p:nvSpPr>
@@ -25055,7 +25117,7 @@
       </p:sp>
       <p:sp>
         <p:nvSpPr>
-          <p:cNvPr id="120" name="Shape 117"/>
+          <p:cNvPr id="121" name="Shape 118"/>
           <p:cNvSpPr/>
           <p:nvPr/>
         </p:nvSpPr>
@@ -25075,7 +25137,7 @@
       </p:sp>
       <p:sp>
         <p:nvSpPr>
-          <p:cNvPr id="121" name="Text 118"/>
+          <p:cNvPr id="122" name="Text 119"/>
           <p:cNvSpPr txBox="1"/>
           <p:nvPr/>
         </p:nvSpPr>

</xml_diff>